<commit_message>
docs: present final model choices and refresh demo materials
</commit_message>
<xml_diff>
--- a/presentation/SpeechBridge.pptx
+++ b/presentation/SpeechBridge.pptx
@@ -15,9 +15,12 @@
     <p:sldId id="263" r:id="rId9"/>
     <p:sldId id="264" r:id="rId10"/>
     <p:sldId id="265" r:id="rId11"/>
+    <p:sldId id="266" r:id="rId12"/>
+    <p:sldId id="267" r:id="rId13"/>
+    <p:sldId id="268" r:id="rId14"/>
   </p:sldIdLst>
   <p:notesMasterIdLst>
-    <p:notesMasterId r:id="rId12"/>
+    <p:notesMasterId r:id="rId15"/>
   </p:notesMasterIdLst>
   <p:sldSz cx="12192000" cy="6858000"/>
   <p:notesSz cx="6858000" cy="12192000"/>
@@ -599,7 +602,7 @@
           <a:p>
             <a:r>
               <a:rPr lang="en-US" dirty="0"/>
-              <a:t>마무리입니다. SpeechBridge는 번역에서 멈추지 않고 대화의 맥락과 실행할 일을 연결합니다. 전체 소스, 시연 절차, 검증 결과와 배포 전 남은 외부 설정은 GitHub에 정리했습니다. 공개 출시와 실기기 검증이 끝났다고 주장하지 않습니다. 디자인 참고: Canva Pitch Deck 템플릿 목록과 미리캔버스 PPT 목록. 템플릿 자산을 내려받거나 복제하지 않고 앱 팔레트로 새 레이아웃을 작성했습니다.</a:t>
+              <a:t>연결이 끊기면 대기 내용만 Android 보안 저장소 또는 iOS Keychain에 보관합니다. 서버가 응답하면 대기 항목을 제거하고 mutation ID로 재전송 중복을 막습니다. 다중 기기 충돌은 무조건 덮어쓰지 않습니다. 백업은 검증 후 복원하며, 계정 삭제 이력을 다시 적용합니다. 실제 오프라인 UI에서 전송 대기 1건이 재연결 후 자동 저장 완료로 바뀌는 것을 확인했습니다.</a:t>
             </a:r>
             <a:endParaRPr lang="en-US" dirty="0"/>
           </a:p>
@@ -623,6 +626,270 @@
             <a:fld id="{F7021451-1387-4CA6-816F-3879F97B5CBC}" type="slidenum">
               <a:rPr lang="en-US"/>
               <a:t>10</a:t>
+            </a:fld>
+            <a:endParaRPr lang="en-US"/>
+          </a:p>
+        </p:txBody>
+      </p:sp>
+    </p:spTree>
+    <p:extLst>
+      <p:ext uri="{BB962C8B-B14F-4D97-AF65-F5344CB8AC3E}">
+        <p14:creationId xmlns:p14="http://schemas.microsoft.com/office/powerpoint/2010/main" val="1024086991"/>
+      </p:ext>
+    </p:extLst>
+  </p:cSld>
+  <p:clrMapOvr>
+    <a:masterClrMapping/>
+  </p:clrMapOvr>
+</p:notes>
+</file>
+
+<file path=ppt/notesSlides/notesSlide11.xml><?xml version="1.0" encoding="utf-8"?>
+<p:notes xmlns:a="http://schemas.openxmlformats.org/drawingml/2006/main" xmlns:r="http://schemas.openxmlformats.org/officeDocument/2006/relationships" xmlns:p="http://schemas.openxmlformats.org/presentationml/2006/main">
+  <p:cSld>
+    <p:spTree>
+      <p:nvGrpSpPr>
+        <p:cNvPr id="1" name=""/>
+        <p:cNvGrpSpPr/>
+        <p:nvPr/>
+      </p:nvGrpSpPr>
+      <p:grpSpPr>
+        <a:xfrm>
+          <a:off x="0" y="0"/>
+          <a:ext cx="0" cy="0"/>
+          <a:chOff x="0" y="0"/>
+          <a:chExt cx="0" cy="0"/>
+        </a:xfrm>
+      </p:grpSpPr>
+      <p:sp>
+        <p:nvSpPr>
+          <p:cNvPr id="2" name="Slide Image Placeholder 1"/>
+          <p:cNvSpPr>
+            <a:spLocks noGrp="1" noRot="1" noChangeAspect="1"/>
+          </p:cNvSpPr>
+          <p:nvPr>
+            <p:ph type="sldImg"/>
+          </p:nvPr>
+        </p:nvSpPr>
+        <p:spPr/>
+      </p:sp>
+      <p:sp>
+        <p:nvSpPr>
+          <p:cNvPr id="3" name="Notes Placeholder 2"/>
+          <p:cNvSpPr>
+            <a:spLocks noGrp="1"/>
+          </p:cNvSpPr>
+          <p:nvPr>
+            <p:ph type="body" idx="1"/>
+          </p:nvPr>
+        </p:nvSpPr>
+        <p:spPr/>
+        <p:txBody>
+          <a:bodyPr/>
+          <a:lstStyle/>
+          <a:p>
+            <a:r>
+              <a:rPr lang="en-US" dirty="0"/>
+              <a:t>핵심 시연 흐름을 직접 앱에서 조작하고, 최종 저장 결과를 PostgreSQL과 대조했습니다. 서버 테스트와 Android Host 및 iOS 시뮬레이터 회귀를 실행했습니다. 테스트 수가 제품 전체 커버리지나 실사용 정확도를 뜻하지는 않습니다. 음성은 합성 샘플로 파이프라인을 검사했고 실제 마이크, 휴대전화, 청취는 보류 상태입니다. 최신 수치는 저장소의 PRE_RELEASE 문서에서 확인합니다.</a:t>
+            </a:r>
+            <a:endParaRPr lang="en-US" dirty="0"/>
+          </a:p>
+        </p:txBody>
+      </p:sp>
+      <p:sp>
+        <p:nvSpPr>
+          <p:cNvPr id="4" name="Slide Number Placeholder 3"/>
+          <p:cNvSpPr>
+            <a:spLocks noGrp="1"/>
+          </p:cNvSpPr>
+          <p:nvPr>
+            <p:ph type="sldNum" sz="quarter" idx="10"/>
+          </p:nvPr>
+        </p:nvSpPr>
+        <p:spPr/>
+        <p:txBody>
+          <a:bodyPr/>
+          <a:lstStyle/>
+          <a:p>
+            <a:fld id="{F7021451-1387-4CA6-816F-3879F97B5CBC}" type="slidenum">
+              <a:rPr lang="en-US"/>
+              <a:t>11</a:t>
+            </a:fld>
+            <a:endParaRPr lang="en-US"/>
+          </a:p>
+        </p:txBody>
+      </p:sp>
+    </p:spTree>
+    <p:extLst>
+      <p:ext uri="{BB962C8B-B14F-4D97-AF65-F5344CB8AC3E}">
+        <p14:creationId xmlns:p14="http://schemas.microsoft.com/office/powerpoint/2010/main" val="1024086991"/>
+      </p:ext>
+    </p:extLst>
+  </p:cSld>
+  <p:clrMapOvr>
+    <a:masterClrMapping/>
+  </p:clrMapOvr>
+</p:notes>
+</file>
+
+<file path=ppt/notesSlides/notesSlide12.xml><?xml version="1.0" encoding="utf-8"?>
+<p:notes xmlns:a="http://schemas.openxmlformats.org/drawingml/2006/main" xmlns:r="http://schemas.openxmlformats.org/officeDocument/2006/relationships" xmlns:p="http://schemas.openxmlformats.org/presentationml/2006/main">
+  <p:cSld>
+    <p:spTree>
+      <p:nvGrpSpPr>
+        <p:cNvPr id="1" name=""/>
+        <p:cNvGrpSpPr/>
+        <p:nvPr/>
+      </p:nvGrpSpPr>
+      <p:grpSpPr>
+        <a:xfrm>
+          <a:off x="0" y="0"/>
+          <a:ext cx="0" cy="0"/>
+          <a:chOff x="0" y="0"/>
+          <a:chExt cx="0" cy="0"/>
+        </a:xfrm>
+      </p:grpSpPr>
+      <p:sp>
+        <p:nvSpPr>
+          <p:cNvPr id="2" name="Slide Image Placeholder 1"/>
+          <p:cNvSpPr>
+            <a:spLocks noGrp="1" noRot="1" noChangeAspect="1"/>
+          </p:cNvSpPr>
+          <p:nvPr>
+            <p:ph type="sldImg"/>
+          </p:nvPr>
+        </p:nvSpPr>
+        <p:spPr/>
+      </p:sp>
+      <p:sp>
+        <p:nvSpPr>
+          <p:cNvPr id="3" name="Notes Placeholder 2"/>
+          <p:cNvSpPr>
+            <a:spLocks noGrp="1"/>
+          </p:cNvSpPr>
+          <p:nvPr>
+            <p:ph type="body" idx="1"/>
+          </p:nvPr>
+        </p:nvSpPr>
+        <p:spPr/>
+        <p:txBody>
+          <a:bodyPr/>
+          <a:lstStyle/>
+          <a:p>
+            <a:r>
+              <a:rPr lang="en-US" dirty="0"/>
+              <a:t>시연 시작은 프로젝트의 Demo.command입니다. Mac 서버가 실행되고 iOS 시뮬레이터는 시연 계정에 로그인되어 있습니다. 음성 시연이 보류된 자리에서는 키보드 보조 입력으로 표시한 문장을 입력합니다. 원문과 번역을 보여 준 뒤 종료하고 요약을 기다립니다. 할 일 추출 후 근거를 검토하고 완료합니다. 네트워크 장애 시 준비된 기록으로 설명하되 AI가 새로 처리한 것처럼 말하지 않습니다.</a:t>
+            </a:r>
+            <a:endParaRPr lang="en-US" dirty="0"/>
+          </a:p>
+        </p:txBody>
+      </p:sp>
+      <p:sp>
+        <p:nvSpPr>
+          <p:cNvPr id="4" name="Slide Number Placeholder 3"/>
+          <p:cNvSpPr>
+            <a:spLocks noGrp="1"/>
+          </p:cNvSpPr>
+          <p:nvPr>
+            <p:ph type="sldNum" sz="quarter" idx="10"/>
+          </p:nvPr>
+        </p:nvSpPr>
+        <p:spPr/>
+        <p:txBody>
+          <a:bodyPr/>
+          <a:lstStyle/>
+          <a:p>
+            <a:fld id="{F7021451-1387-4CA6-816F-3879F97B5CBC}" type="slidenum">
+              <a:rPr lang="en-US"/>
+              <a:t>12</a:t>
+            </a:fld>
+            <a:endParaRPr lang="en-US"/>
+          </a:p>
+        </p:txBody>
+      </p:sp>
+    </p:spTree>
+    <p:extLst>
+      <p:ext uri="{BB962C8B-B14F-4D97-AF65-F5344CB8AC3E}">
+        <p14:creationId xmlns:p14="http://schemas.microsoft.com/office/powerpoint/2010/main" val="1024086991"/>
+      </p:ext>
+    </p:extLst>
+  </p:cSld>
+  <p:clrMapOvr>
+    <a:masterClrMapping/>
+  </p:clrMapOvr>
+</p:notes>
+</file>
+
+<file path=ppt/notesSlides/notesSlide13.xml><?xml version="1.0" encoding="utf-8"?>
+<p:notes xmlns:a="http://schemas.openxmlformats.org/drawingml/2006/main" xmlns:r="http://schemas.openxmlformats.org/officeDocument/2006/relationships" xmlns:p="http://schemas.openxmlformats.org/presentationml/2006/main">
+  <p:cSld>
+    <p:spTree>
+      <p:nvGrpSpPr>
+        <p:cNvPr id="1" name=""/>
+        <p:cNvGrpSpPr/>
+        <p:nvPr/>
+      </p:nvGrpSpPr>
+      <p:grpSpPr>
+        <a:xfrm>
+          <a:off x="0" y="0"/>
+          <a:ext cx="0" cy="0"/>
+          <a:chOff x="0" y="0"/>
+          <a:chExt cx="0" cy="0"/>
+        </a:xfrm>
+      </p:grpSpPr>
+      <p:sp>
+        <p:nvSpPr>
+          <p:cNvPr id="2" name="Slide Image Placeholder 1"/>
+          <p:cNvSpPr>
+            <a:spLocks noGrp="1" noRot="1" noChangeAspect="1"/>
+          </p:cNvSpPr>
+          <p:nvPr>
+            <p:ph type="sldImg"/>
+          </p:nvPr>
+        </p:nvSpPr>
+        <p:spPr/>
+      </p:sp>
+      <p:sp>
+        <p:nvSpPr>
+          <p:cNvPr id="3" name="Notes Placeholder 2"/>
+          <p:cNvSpPr>
+            <a:spLocks noGrp="1"/>
+          </p:cNvSpPr>
+          <p:nvPr>
+            <p:ph type="body" idx="1"/>
+          </p:nvPr>
+        </p:nvSpPr>
+        <p:spPr/>
+        <p:txBody>
+          <a:bodyPr/>
+          <a:lstStyle/>
+          <a:p>
+            <a:r>
+              <a:rPr lang="en-US" dirty="0"/>
+              <a:t>마무리입니다. SpeechBridge는 번역에서 멈추지 않고 대화의 맥락과 실행할 일을 연결합니다. 전체 소스, 시연 절차, 검증 결과와 배포 전 남은 외부 설정은 GitHub에 정리했습니다. 공개 출시와 실기기 검증이 끝났다고 주장하지 않습니다. 디자인 참고: Canva Pitch Deck 템플릿 목록과 미리캔버스 PPT 목록. 템플릿 자산을 내려받거나 복제하지 않고 앱 팔레트로 새 레이아웃을 작성했습니다.</a:t>
+            </a:r>
+            <a:endParaRPr lang="en-US" dirty="0"/>
+          </a:p>
+        </p:txBody>
+      </p:sp>
+      <p:sp>
+        <p:nvSpPr>
+          <p:cNvPr id="4" name="Slide Number Placeholder 3"/>
+          <p:cNvSpPr>
+            <a:spLocks noGrp="1"/>
+          </p:cNvSpPr>
+          <p:nvPr>
+            <p:ph type="sldNum" sz="quarter" idx="10"/>
+          </p:nvPr>
+        </p:nvSpPr>
+        <p:spPr/>
+        <p:txBody>
+          <a:bodyPr/>
+          <a:lstStyle/>
+          <a:p>
+            <a:fld id="{F7021451-1387-4CA6-816F-3879F97B5CBC}" type="slidenum">
+              <a:rPr lang="en-US"/>
+              <a:t>13</a:t>
             </a:fld>
             <a:endParaRPr lang="en-US"/>
           </a:p>
@@ -1127,7 +1394,7 @@
           <a:p>
             <a:r>
               <a:rPr lang="en-US" dirty="0"/>
-              <a:t>연결이 끊기면 대기 내용만 Android 보안 저장소 또는 iOS Keychain에 보관합니다. 서버가 응답하면 대기 항목을 제거하고 mutation ID로 재전송 중복을 막습니다. 다중 기기 충돌은 무조건 덮어쓰지 않습니다. 백업은 검증 후 복원하며, 계정 삭제 이력을 다시 적용합니다. 실제 오프라인 UI에서 전송 대기 1건이 재연결 후 자동 저장 완료로 바뀌는 것을 확인했습니다.</a:t>
+              <a:t>모델을 새로 학습한 것이 아니라 공개 가중치를 Mac에서 실행합니다. STT는 Nemotron 3.5 ASR Streaming 0.6B Q8 GGUF, 번역은 TranslateGemma 12B Q4_K_M, 정리는 Gemma 4 12B IT QAT, TTS는 Qwen3-TTS-12Hz-0.6B-CustomVoice의 MLX bf16 변환본입니다. B는 이름의 규모 표기이며 파일 크기나 메모리 용량과 다릅니다. 구현·버전·선정 근거: docs/MODEL_SELECTION.md, docs/LOCAL_AI_RESULTS.md, docs/LOCAL_VOICE_RESULTS.md.</a:t>
             </a:r>
             <a:endParaRPr lang="en-US" dirty="0"/>
           </a:p>
@@ -1215,7 +1482,7 @@
           <a:p>
             <a:r>
               <a:rPr lang="en-US" dirty="0"/>
-              <a:t>핵심 시연 흐름을 직접 앱에서 조작하고, 최종 저장 결과를 PostgreSQL과 대조했습니다. 서버 테스트와 Android Host 및 iOS 시뮬레이터 회귀를 실행했습니다. 테스트 수가 제품 전체 커버리지나 실사용 정확도를 뜻하지는 않습니다. 음성은 합성 샘플로 파이프라인을 검사했고 실제 마이크, 휴대전화, 청취는 보류 상태입니다. 최신 수치는 저장소의 PRE_RELEASE 문서에서 확인합니다.</a:t>
+              <a:t>번역에는 번역 전용 모델인 TranslateGemma 12B Q4_K_M을 사용합니다. 업무 대화의 수량·시간·부정 표현과 이름을 보존하는 것이 선정 기준이며, 현재 Mac에서 필요한 세 언어의 예제 실행을 확인했습니다. 제목·분류·요약·할 일 후보에는 Gemma 4 12B IT QAT를 사용합니다. JSON mode로 구조화된 결과를 받고 서버가 원문 ID와 인용 근거를 검증할 수 있어 기록 기능에 적합합니다. 최초 정리는 AI가 담당하고 이후 편집은 사용자에게 맡깁니다. 이는 현재 프로젝트 조건에 맞춘 선정이며 일반 정확도나 모든 후보 대비 우위를 보장하지 않습니다. 선정 근거 문서: docs/MODEL_SELECTION.md.</a:t>
             </a:r>
             <a:endParaRPr lang="en-US" dirty="0"/>
           </a:p>
@@ -1303,7 +1570,7 @@
           <a:p>
             <a:r>
               <a:rPr lang="en-US" dirty="0"/>
-              <a:t>시연 시작은 프로젝트의 Demo.command입니다. Mac 서버가 실행되고 iOS 시뮬레이터는 시연 계정에 로그인되어 있습니다. 음성 시연이 보류된 자리에서는 키보드 보조 입력으로 표시한 문장을 입력합니다. 원문과 번역을 보여 준 뒤 종료하고 요약을 기다립니다. 할 일 추출 후 근거를 검토하고 완료합니다. 네트워크 장애 시 준비된 기록으로 설명하되 AI가 새로 처리한 것처럼 말하지 않습니다.</a:t>
+              <a:t>STT는 필요한 한국어·영어·일본어와 Metal 런타임을 확인해 선택했습니다. 합성 샘플에서 세 언어의 전사를 확인했지만 일본어 고유명사 오류가 남아 있습니다. TTS는 Qwen 공식 카드에 한·영·일 지원이 명시되어 있고 현재 Mac의 MLX 변환본에서 PCM 생성이 성공했습니다. 고정 음색을 사용하며 사용자 음성 복제를 요구하지 않습니다. 음성 모델의 실사용 품질과 고유명사 인식은 추가 검증이 필요하며, TTS 생성에는 준비 시간이 있습니다. 실제 마이크·사람 청취는 미검증입니다. 공식 근거: https://huggingface.co/nvidia/nemotron-3.5-asr-streaming-0.6b , https://github.com/NVIDIA/NeMo-Speech.cpp/blob/v0.2.0/docs/install.md , https://huggingface.co/Qwen/Qwen3-TTS-12Hz-0.6B-CustomVoice . 로컬 결과: docs/LOCAL_VOICE_RESULTS.md 및 .ecc/benchmarks/tts-member-https.json.</a:t>
             </a:r>
             <a:endParaRPr lang="en-US" dirty="0"/>
           </a:p>
@@ -1982,6 +2249,1743 @@
     <p:bg>
       <p:bgPr>
         <a:solidFill>
+          <a:srgbClr val="F2F3F9"/>
+        </a:solidFill>
+      </p:bgPr>
+    </p:bg>
+    <p:spTree>
+      <p:nvGrpSpPr>
+        <p:cNvPr id="1" name=""/>
+        <p:cNvGrpSpPr/>
+        <p:nvPr/>
+      </p:nvGrpSpPr>
+      <p:grpSpPr>
+        <a:xfrm>
+          <a:off x="0" y="0"/>
+          <a:ext cx="0" cy="0"/>
+          <a:chOff x="0" y="0"/>
+          <a:chExt cx="0" cy="0"/>
+        </a:xfrm>
+      </p:grpSpPr>
+      <p:sp>
+        <p:nvSpPr>
+          <p:cNvPr id="2" name="Text 0"/>
+          <p:cNvSpPr/>
+          <p:nvPr/>
+        </p:nvSpPr>
+        <p:spPr>
+          <a:xfrm>
+            <a:off x="502920" y="274320"/>
+            <a:ext cx="10058400" cy="274320"/>
+          </a:xfrm>
+          <a:prstGeom prst="rect">
+            <a:avLst/>
+          </a:prstGeom>
+          <a:noFill/>
+          <a:ln/>
+        </p:spPr>
+        <p:txBody>
+          <a:bodyPr wrap="square" lIns="0" tIns="0" rIns="0" bIns="0" rtlCol="0" anchor="ctr"/>
+          <a:lstStyle/>
+          <a:p>
+            <a:pPr indent="0" marL="0">
+              <a:buNone/>
+            </a:pPr>
+            <a:r>
+              <a:rPr lang="en-US" sz="1200" b="1" dirty="0">
+                <a:solidFill>
+                  <a:srgbClr val="405394"/>
+                </a:solidFill>
+                <a:latin typeface="Apple SD Gothic Neo" pitchFamily="34" charset="0"/>
+                <a:ea typeface="Apple SD Gothic Neo" pitchFamily="34" charset="-122"/>
+                <a:cs typeface="Apple SD Gothic Neo" pitchFamily="34" charset="-120"/>
+              </a:rPr>
+              <a:t>SPEECHBRIDGE  /  DATA &amp; RECOVERY</a:t>
+            </a:r>
+            <a:endParaRPr lang="en-US" sz="1200" dirty="0"/>
+          </a:p>
+        </p:txBody>
+      </p:sp>
+      <p:sp>
+        <p:nvSpPr>
+          <p:cNvPr id="3" name="Text 1"/>
+          <p:cNvSpPr/>
+          <p:nvPr/>
+        </p:nvSpPr>
+        <p:spPr>
+          <a:xfrm>
+            <a:off x="502920" y="768096"/>
+            <a:ext cx="11155680" cy="731520"/>
+          </a:xfrm>
+          <a:prstGeom prst="rect">
+            <a:avLst/>
+          </a:prstGeom>
+          <a:noFill/>
+          <a:ln/>
+        </p:spPr>
+        <p:txBody>
+          <a:bodyPr wrap="square" lIns="0" tIns="0" rIns="0" bIns="0" rtlCol="0" anchor="ctr"/>
+          <a:lstStyle/>
+          <a:p>
+            <a:pPr indent="0" marL="0">
+              <a:buNone/>
+            </a:pPr>
+            <a:r>
+              <a:rPr lang="en-US" sz="3400" b="1" dirty="0">
+                <a:solidFill>
+                  <a:srgbClr val="242938"/>
+                </a:solidFill>
+                <a:latin typeface="Apple SD Gothic Neo" pitchFamily="34" charset="0"/>
+                <a:ea typeface="Apple SD Gothic Neo" pitchFamily="34" charset="-122"/>
+                <a:cs typeface="Apple SD Gothic Neo" pitchFamily="34" charset="-120"/>
+              </a:rPr>
+              <a:t>연결이 끊겨도, 변경 내용을 잃지 않도록.</a:t>
+            </a:r>
+            <a:endParaRPr lang="en-US" sz="3400" dirty="0"/>
+          </a:p>
+        </p:txBody>
+      </p:sp>
+      <p:sp>
+        <p:nvSpPr>
+          <p:cNvPr id="4" name="Text 2"/>
+          <p:cNvSpPr/>
+          <p:nvPr/>
+        </p:nvSpPr>
+        <p:spPr>
+          <a:xfrm>
+            <a:off x="11201400" y="6419088"/>
+            <a:ext cx="457200" cy="182880"/>
+          </a:xfrm>
+          <a:prstGeom prst="rect">
+            <a:avLst/>
+          </a:prstGeom>
+          <a:noFill/>
+          <a:ln/>
+        </p:spPr>
+        <p:txBody>
+          <a:bodyPr wrap="square" lIns="0" tIns="0" rIns="0" bIns="0" rtlCol="0" anchor="ctr"/>
+          <a:lstStyle/>
+          <a:p>
+            <a:pPr indent="0" marL="0">
+              <a:buNone/>
+            </a:pPr>
+            <a:r>
+              <a:rPr lang="en-US" sz="1000" dirty="0">
+                <a:solidFill>
+                  <a:srgbClr val="626B80"/>
+                </a:solidFill>
+                <a:latin typeface="Apple SD Gothic Neo" pitchFamily="34" charset="0"/>
+                <a:ea typeface="Apple SD Gothic Neo" pitchFamily="34" charset="-122"/>
+                <a:cs typeface="Apple SD Gothic Neo" pitchFamily="34" charset="-120"/>
+              </a:rPr>
+              <a:t>10</a:t>
+            </a:r>
+            <a:endParaRPr lang="en-US" sz="1000" dirty="0"/>
+          </a:p>
+        </p:txBody>
+      </p:sp>
+      <p:sp>
+        <p:nvSpPr>
+          <p:cNvPr id="5" name="Text 3"/>
+          <p:cNvSpPr/>
+          <p:nvPr/>
+        </p:nvSpPr>
+        <p:spPr>
+          <a:xfrm>
+            <a:off x="502920" y="6419088"/>
+            <a:ext cx="9144000" cy="182880"/>
+          </a:xfrm>
+          <a:prstGeom prst="rect">
+            <a:avLst/>
+          </a:prstGeom>
+          <a:noFill/>
+          <a:ln/>
+        </p:spPr>
+        <p:txBody>
+          <a:bodyPr wrap="square" lIns="0" tIns="0" rIns="0" bIns="0" rtlCol="0" anchor="ctr"/>
+          <a:lstStyle/>
+          <a:p>
+            <a:pPr indent="0" marL="0">
+              <a:buNone/>
+            </a:pPr>
+            <a:r>
+              <a:rPr lang="en-US" sz="1000" dirty="0">
+                <a:solidFill>
+                  <a:srgbClr val="626B80"/>
+                </a:solidFill>
+                <a:latin typeface="Apple SD Gothic Neo" pitchFamily="34" charset="0"/>
+                <a:ea typeface="Apple SD Gothic Neo" pitchFamily="34" charset="-122"/>
+                <a:cs typeface="Apple SD Gothic Neo" pitchFamily="34" charset="-120"/>
+              </a:rPr>
+              <a:t>학교 과제 · 실제 앱 캡처 / 합성 시연 데이터</a:t>
+            </a:r>
+            <a:endParaRPr lang="en-US" sz="1000" dirty="0"/>
+          </a:p>
+        </p:txBody>
+      </p:sp>
+      <p:sp>
+        <p:nvSpPr>
+          <p:cNvPr id="7" name="Text 4"/>
+          <p:cNvSpPr/>
+          <p:nvPr/>
+        </p:nvSpPr>
+        <p:spPr>
+          <a:xfrm>
+            <a:off x="731520" y="2011680"/>
+            <a:ext cx="502920" cy="365760"/>
+          </a:xfrm>
+          <a:prstGeom prst="rect">
+            <a:avLst/>
+          </a:prstGeom>
+          <a:noFill/>
+          <a:ln/>
+        </p:spPr>
+        <p:txBody>
+          <a:bodyPr wrap="square" lIns="0" tIns="0" rIns="0" bIns="0" rtlCol="0" anchor="ctr"/>
+          <a:lstStyle/>
+          <a:p>
+            <a:pPr indent="0" marL="0">
+              <a:buNone/>
+            </a:pPr>
+            <a:r>
+              <a:rPr lang="en-US" sz="1600" b="1" dirty="0">
+                <a:solidFill>
+                  <a:srgbClr val="405394"/>
+                </a:solidFill>
+                <a:latin typeface="Apple SD Gothic Neo" pitchFamily="34" charset="0"/>
+                <a:ea typeface="Apple SD Gothic Neo" pitchFamily="34" charset="-122"/>
+                <a:cs typeface="Apple SD Gothic Neo" pitchFamily="34" charset="-120"/>
+              </a:rPr>
+              <a:t>01</a:t>
+            </a:r>
+            <a:endParaRPr lang="en-US" sz="1600" dirty="0"/>
+          </a:p>
+        </p:txBody>
+      </p:sp>
+      <p:sp>
+        <p:nvSpPr>
+          <p:cNvPr id="8" name="Text 5"/>
+          <p:cNvSpPr/>
+          <p:nvPr/>
+        </p:nvSpPr>
+        <p:spPr>
+          <a:xfrm>
+            <a:off x="1280160" y="2011680"/>
+            <a:ext cx="9784080" cy="411480"/>
+          </a:xfrm>
+          <a:prstGeom prst="rect">
+            <a:avLst/>
+          </a:prstGeom>
+          <a:noFill/>
+          <a:ln/>
+        </p:spPr>
+        <p:txBody>
+          <a:bodyPr wrap="square" lIns="0" tIns="0" rIns="0" bIns="0" rtlCol="0" anchor="ctr"/>
+          <a:lstStyle/>
+          <a:p>
+            <a:pPr indent="0" marL="0">
+              <a:buNone/>
+            </a:pPr>
+            <a:r>
+              <a:rPr lang="en-US" sz="2300" b="1" dirty="0">
+                <a:solidFill>
+                  <a:srgbClr val="242938"/>
+                </a:solidFill>
+                <a:latin typeface="Apple SD Gothic Neo" pitchFamily="34" charset="0"/>
+                <a:ea typeface="Apple SD Gothic Neo" pitchFamily="34" charset="-122"/>
+                <a:cs typeface="Apple SD Gothic Neo" pitchFamily="34" charset="-120"/>
+              </a:rPr>
+              <a:t>서버가 원본</a:t>
+            </a:r>
+            <a:endParaRPr lang="en-US" sz="2300" dirty="0"/>
+          </a:p>
+        </p:txBody>
+      </p:sp>
+      <p:sp>
+        <p:nvSpPr>
+          <p:cNvPr id="9" name="Text 6"/>
+          <p:cNvSpPr/>
+          <p:nvPr/>
+        </p:nvSpPr>
+        <p:spPr>
+          <a:xfrm>
+            <a:off x="1280160" y="2542032"/>
+            <a:ext cx="9784080" cy="731520"/>
+          </a:xfrm>
+          <a:prstGeom prst="rect">
+            <a:avLst/>
+          </a:prstGeom>
+          <a:noFill/>
+          <a:ln/>
+        </p:spPr>
+        <p:txBody>
+          <a:bodyPr wrap="square" lIns="0" tIns="0" rIns="0" bIns="0" rtlCol="0" anchor="ctr"/>
+          <a:lstStyle/>
+          <a:p>
+            <a:pPr indent="0" marL="0">
+              <a:buNone/>
+            </a:pPr>
+            <a:r>
+              <a:rPr lang="en-US" sz="1700" dirty="0">
+                <a:solidFill>
+                  <a:srgbClr val="626B80"/>
+                </a:solidFill>
+                <a:latin typeface="Apple SD Gothic Neo" pitchFamily="34" charset="0"/>
+                <a:ea typeface="Apple SD Gothic Neo" pitchFamily="34" charset="-122"/>
+                <a:cs typeface="Apple SD Gothic Neo" pitchFamily="34" charset="-120"/>
+              </a:rPr>
+              <a:t>기기에는 암호화된 전송 대기만</a:t>
+            </a:r>
+            <a:endParaRPr lang="en-US" sz="1700" dirty="0"/>
+          </a:p>
+        </p:txBody>
+      </p:sp>
+      <p:sp>
+        <p:nvSpPr>
+          <p:cNvPr id="10" name="Text 7"/>
+          <p:cNvSpPr/>
+          <p:nvPr/>
+        </p:nvSpPr>
+        <p:spPr>
+          <a:xfrm>
+            <a:off x="731520" y="3429000"/>
+            <a:ext cx="502920" cy="365760"/>
+          </a:xfrm>
+          <a:prstGeom prst="rect">
+            <a:avLst/>
+          </a:prstGeom>
+          <a:noFill/>
+          <a:ln/>
+        </p:spPr>
+        <p:txBody>
+          <a:bodyPr wrap="square" lIns="0" tIns="0" rIns="0" bIns="0" rtlCol="0" anchor="ctr"/>
+          <a:lstStyle/>
+          <a:p>
+            <a:pPr indent="0" marL="0">
+              <a:buNone/>
+            </a:pPr>
+            <a:r>
+              <a:rPr lang="en-US" sz="1600" b="1" dirty="0">
+                <a:solidFill>
+                  <a:srgbClr val="405394"/>
+                </a:solidFill>
+                <a:latin typeface="Apple SD Gothic Neo" pitchFamily="34" charset="0"/>
+                <a:ea typeface="Apple SD Gothic Neo" pitchFamily="34" charset="-122"/>
+                <a:cs typeface="Apple SD Gothic Neo" pitchFamily="34" charset="-120"/>
+              </a:rPr>
+              <a:t>02</a:t>
+            </a:r>
+            <a:endParaRPr lang="en-US" sz="1600" dirty="0"/>
+          </a:p>
+        </p:txBody>
+      </p:sp>
+      <p:sp>
+        <p:nvSpPr>
+          <p:cNvPr id="11" name="Text 8"/>
+          <p:cNvSpPr/>
+          <p:nvPr/>
+        </p:nvSpPr>
+        <p:spPr>
+          <a:xfrm>
+            <a:off x="1280160" y="3429000"/>
+            <a:ext cx="9784080" cy="411480"/>
+          </a:xfrm>
+          <a:prstGeom prst="rect">
+            <a:avLst/>
+          </a:prstGeom>
+          <a:noFill/>
+          <a:ln/>
+        </p:spPr>
+        <p:txBody>
+          <a:bodyPr wrap="square" lIns="0" tIns="0" rIns="0" bIns="0" rtlCol="0" anchor="ctr"/>
+          <a:lstStyle/>
+          <a:p>
+            <a:pPr indent="0" marL="0">
+              <a:buNone/>
+            </a:pPr>
+            <a:r>
+              <a:rPr lang="en-US" sz="2300" b="1" dirty="0">
+                <a:solidFill>
+                  <a:srgbClr val="242938"/>
+                </a:solidFill>
+                <a:latin typeface="Apple SD Gothic Neo" pitchFamily="34" charset="0"/>
+                <a:ea typeface="Apple SD Gothic Neo" pitchFamily="34" charset="-122"/>
+                <a:cs typeface="Apple SD Gothic Neo" pitchFamily="34" charset="-120"/>
+              </a:rPr>
+              <a:t>재전송·충돌·재시작에 대비</a:t>
+            </a:r>
+            <a:endParaRPr lang="en-US" sz="2300" dirty="0"/>
+          </a:p>
+        </p:txBody>
+      </p:sp>
+      <p:sp>
+        <p:nvSpPr>
+          <p:cNvPr id="12" name="Text 9"/>
+          <p:cNvSpPr/>
+          <p:nvPr/>
+        </p:nvSpPr>
+        <p:spPr>
+          <a:xfrm>
+            <a:off x="1280160" y="3959352"/>
+            <a:ext cx="9784080" cy="731520"/>
+          </a:xfrm>
+          <a:prstGeom prst="rect">
+            <a:avLst/>
+          </a:prstGeom>
+          <a:noFill/>
+          <a:ln/>
+        </p:spPr>
+        <p:txBody>
+          <a:bodyPr wrap="square" lIns="0" tIns="0" rIns="0" bIns="0" rtlCol="0" anchor="ctr"/>
+          <a:lstStyle/>
+          <a:p>
+            <a:pPr indent="0" marL="0">
+              <a:buNone/>
+            </a:pPr>
+            <a:r>
+              <a:rPr lang="en-US" sz="1700" dirty="0">
+                <a:solidFill>
+                  <a:srgbClr val="626B80"/>
+                </a:solidFill>
+                <a:latin typeface="Apple SD Gothic Neo" pitchFamily="34" charset="0"/>
+                <a:ea typeface="Apple SD Gothic Neo" pitchFamily="34" charset="-122"/>
+                <a:cs typeface="Apple SD Gothic Neo" pitchFamily="34" charset="-120"/>
+              </a:rPr>
+              <a:t>중복 반영 방지 / 충돌 시 내용 보존 / AI 작업 복구</a:t>
+            </a:r>
+            <a:endParaRPr lang="en-US" sz="1700" dirty="0"/>
+          </a:p>
+        </p:txBody>
+      </p:sp>
+      <p:sp>
+        <p:nvSpPr>
+          <p:cNvPr id="13" name="Text 10"/>
+          <p:cNvSpPr/>
+          <p:nvPr/>
+        </p:nvSpPr>
+        <p:spPr>
+          <a:xfrm>
+            <a:off x="731520" y="4846320"/>
+            <a:ext cx="502920" cy="365760"/>
+          </a:xfrm>
+          <a:prstGeom prst="rect">
+            <a:avLst/>
+          </a:prstGeom>
+          <a:noFill/>
+          <a:ln/>
+        </p:spPr>
+        <p:txBody>
+          <a:bodyPr wrap="square" lIns="0" tIns="0" rIns="0" bIns="0" rtlCol="0" anchor="ctr"/>
+          <a:lstStyle/>
+          <a:p>
+            <a:pPr indent="0" marL="0">
+              <a:buNone/>
+            </a:pPr>
+            <a:r>
+              <a:rPr lang="en-US" sz="1600" b="1" dirty="0">
+                <a:solidFill>
+                  <a:srgbClr val="405394"/>
+                </a:solidFill>
+                <a:latin typeface="Apple SD Gothic Neo" pitchFamily="34" charset="0"/>
+                <a:ea typeface="Apple SD Gothic Neo" pitchFamily="34" charset="-122"/>
+                <a:cs typeface="Apple SD Gothic Neo" pitchFamily="34" charset="-120"/>
+              </a:rPr>
+              <a:t>03</a:t>
+            </a:r>
+            <a:endParaRPr lang="en-US" sz="1600" dirty="0"/>
+          </a:p>
+        </p:txBody>
+      </p:sp>
+      <p:sp>
+        <p:nvSpPr>
+          <p:cNvPr id="14" name="Text 11"/>
+          <p:cNvSpPr/>
+          <p:nvPr/>
+        </p:nvSpPr>
+        <p:spPr>
+          <a:xfrm>
+            <a:off x="1280160" y="4846320"/>
+            <a:ext cx="9784080" cy="411480"/>
+          </a:xfrm>
+          <a:prstGeom prst="rect">
+            <a:avLst/>
+          </a:prstGeom>
+          <a:noFill/>
+          <a:ln/>
+        </p:spPr>
+        <p:txBody>
+          <a:bodyPr wrap="square" lIns="0" tIns="0" rIns="0" bIns="0" rtlCol="0" anchor="ctr"/>
+          <a:lstStyle/>
+          <a:p>
+            <a:pPr indent="0" marL="0">
+              <a:buNone/>
+            </a:pPr>
+            <a:r>
+              <a:rPr lang="en-US" sz="2300" b="1" dirty="0">
+                <a:solidFill>
+                  <a:srgbClr val="242938"/>
+                </a:solidFill>
+                <a:latin typeface="Apple SD Gothic Neo" pitchFamily="34" charset="0"/>
+                <a:ea typeface="Apple SD Gothic Neo" pitchFamily="34" charset="-122"/>
+                <a:cs typeface="Apple SD Gothic Neo" pitchFamily="34" charset="-120"/>
+              </a:rPr>
+              <a:t>삭제한 계정이 되살아나지 않도록</a:t>
+            </a:r>
+            <a:endParaRPr lang="en-US" sz="2300" dirty="0"/>
+          </a:p>
+        </p:txBody>
+      </p:sp>
+      <p:sp>
+        <p:nvSpPr>
+          <p:cNvPr id="15" name="Text 12"/>
+          <p:cNvSpPr/>
+          <p:nvPr/>
+        </p:nvSpPr>
+        <p:spPr>
+          <a:xfrm>
+            <a:off x="1280160" y="5376672"/>
+            <a:ext cx="9784080" cy="731520"/>
+          </a:xfrm>
+          <a:prstGeom prst="rect">
+            <a:avLst/>
+          </a:prstGeom>
+          <a:noFill/>
+          <a:ln/>
+        </p:spPr>
+        <p:txBody>
+          <a:bodyPr wrap="square" lIns="0" tIns="0" rIns="0" bIns="0" rtlCol="0" anchor="ctr"/>
+          <a:lstStyle/>
+          <a:p>
+            <a:pPr indent="0" marL="0">
+              <a:buNone/>
+            </a:pPr>
+            <a:r>
+              <a:rPr lang="en-US" sz="1700" dirty="0">
+                <a:solidFill>
+                  <a:srgbClr val="626B80"/>
+                </a:solidFill>
+                <a:latin typeface="Apple SD Gothic Neo" pitchFamily="34" charset="0"/>
+                <a:ea typeface="Apple SD Gothic Neo" pitchFamily="34" charset="-122"/>
+                <a:cs typeface="Apple SD Gothic Neo" pitchFamily="34" charset="-120"/>
+              </a:rPr>
+              <a:t>앱·웹 삭제 경로 / 백업 30일 정책 / 복원 시 삭제 이력 반영</a:t>
+            </a:r>
+            <a:endParaRPr lang="en-US" sz="1700" dirty="0"/>
+          </a:p>
+        </p:txBody>
+      </p:sp>
+    </p:spTree>
+  </p:cSld>
+  <p:clrMapOvr>
+    <a:masterClrMapping/>
+  </p:clrMapOvr>
+</p:sld>
+</file>
+
+<file path=ppt/slides/slide11.xml><?xml version="1.0" encoding="utf-8"?>
+<p:sld xmlns:a="http://schemas.openxmlformats.org/drawingml/2006/main" xmlns:r="http://schemas.openxmlformats.org/officeDocument/2006/relationships" xmlns:p="http://schemas.openxmlformats.org/presentationml/2006/main">
+  <p:cSld name="Slide 11">
+    <p:bg>
+      <p:bgPr>
+        <a:solidFill>
+          <a:srgbClr val="F2F3F9"/>
+        </a:solidFill>
+      </p:bgPr>
+    </p:bg>
+    <p:spTree>
+      <p:nvGrpSpPr>
+        <p:cNvPr id="1" name=""/>
+        <p:cNvGrpSpPr/>
+        <p:nvPr/>
+      </p:nvGrpSpPr>
+      <p:grpSpPr>
+        <a:xfrm>
+          <a:off x="0" y="0"/>
+          <a:ext cx="0" cy="0"/>
+          <a:chOff x="0" y="0"/>
+          <a:chExt cx="0" cy="0"/>
+        </a:xfrm>
+      </p:grpSpPr>
+      <p:sp>
+        <p:nvSpPr>
+          <p:cNvPr id="2" name="Text 0"/>
+          <p:cNvSpPr/>
+          <p:nvPr/>
+        </p:nvSpPr>
+        <p:spPr>
+          <a:xfrm>
+            <a:off x="502920" y="274320"/>
+            <a:ext cx="10058400" cy="274320"/>
+          </a:xfrm>
+          <a:prstGeom prst="rect">
+            <a:avLst/>
+          </a:prstGeom>
+          <a:noFill/>
+          <a:ln/>
+        </p:spPr>
+        <p:txBody>
+          <a:bodyPr wrap="square" lIns="0" tIns="0" rIns="0" bIns="0" rtlCol="0" anchor="ctr"/>
+          <a:lstStyle/>
+          <a:p>
+            <a:pPr indent="0" marL="0">
+              <a:buNone/>
+            </a:pPr>
+            <a:r>
+              <a:rPr lang="en-US" sz="1200" b="1" dirty="0">
+                <a:solidFill>
+                  <a:srgbClr val="405394"/>
+                </a:solidFill>
+                <a:latin typeface="Apple SD Gothic Neo" pitchFamily="34" charset="0"/>
+                <a:ea typeface="Apple SD Gothic Neo" pitchFamily="34" charset="-122"/>
+                <a:cs typeface="Apple SD Gothic Neo" pitchFamily="34" charset="-120"/>
+              </a:rPr>
+              <a:t>SPEECHBRIDGE  /  VALIDATION</a:t>
+            </a:r>
+            <a:endParaRPr lang="en-US" sz="1200" dirty="0"/>
+          </a:p>
+        </p:txBody>
+      </p:sp>
+      <p:sp>
+        <p:nvSpPr>
+          <p:cNvPr id="3" name="Text 1"/>
+          <p:cNvSpPr/>
+          <p:nvPr/>
+        </p:nvSpPr>
+        <p:spPr>
+          <a:xfrm>
+            <a:off x="502920" y="768096"/>
+            <a:ext cx="11155680" cy="731520"/>
+          </a:xfrm>
+          <a:prstGeom prst="rect">
+            <a:avLst/>
+          </a:prstGeom>
+          <a:noFill/>
+          <a:ln/>
+        </p:spPr>
+        <p:txBody>
+          <a:bodyPr wrap="square" lIns="0" tIns="0" rIns="0" bIns="0" rtlCol="0" anchor="ctr"/>
+          <a:lstStyle/>
+          <a:p>
+            <a:pPr indent="0" marL="0">
+              <a:buNone/>
+            </a:pPr>
+            <a:r>
+              <a:rPr lang="en-US" sz="3400" b="1" dirty="0">
+                <a:solidFill>
+                  <a:srgbClr val="242938"/>
+                </a:solidFill>
+                <a:latin typeface="Apple SD Gothic Neo" pitchFamily="34" charset="0"/>
+                <a:ea typeface="Apple SD Gothic Neo" pitchFamily="34" charset="-122"/>
+                <a:cs typeface="Apple SD Gothic Neo" pitchFamily="34" charset="-120"/>
+              </a:rPr>
+              <a:t>동작한 것과, 아직 확인하지 않은 것을 구분합니다.</a:t>
+            </a:r>
+            <a:endParaRPr lang="en-US" sz="3400" dirty="0"/>
+          </a:p>
+        </p:txBody>
+      </p:sp>
+      <p:sp>
+        <p:nvSpPr>
+          <p:cNvPr id="4" name="Text 2"/>
+          <p:cNvSpPr/>
+          <p:nvPr/>
+        </p:nvSpPr>
+        <p:spPr>
+          <a:xfrm>
+            <a:off x="11201400" y="6419088"/>
+            <a:ext cx="457200" cy="182880"/>
+          </a:xfrm>
+          <a:prstGeom prst="rect">
+            <a:avLst/>
+          </a:prstGeom>
+          <a:noFill/>
+          <a:ln/>
+        </p:spPr>
+        <p:txBody>
+          <a:bodyPr wrap="square" lIns="0" tIns="0" rIns="0" bIns="0" rtlCol="0" anchor="ctr"/>
+          <a:lstStyle/>
+          <a:p>
+            <a:pPr indent="0" marL="0">
+              <a:buNone/>
+            </a:pPr>
+            <a:r>
+              <a:rPr lang="en-US" sz="1000" dirty="0">
+                <a:solidFill>
+                  <a:srgbClr val="626B80"/>
+                </a:solidFill>
+                <a:latin typeface="Apple SD Gothic Neo" pitchFamily="34" charset="0"/>
+                <a:ea typeface="Apple SD Gothic Neo" pitchFamily="34" charset="-122"/>
+                <a:cs typeface="Apple SD Gothic Neo" pitchFamily="34" charset="-120"/>
+              </a:rPr>
+              <a:t>11</a:t>
+            </a:r>
+            <a:endParaRPr lang="en-US" sz="1000" dirty="0"/>
+          </a:p>
+        </p:txBody>
+      </p:sp>
+      <p:sp>
+        <p:nvSpPr>
+          <p:cNvPr id="5" name="Text 3"/>
+          <p:cNvSpPr/>
+          <p:nvPr/>
+        </p:nvSpPr>
+        <p:spPr>
+          <a:xfrm>
+            <a:off x="502920" y="6419088"/>
+            <a:ext cx="9144000" cy="182880"/>
+          </a:xfrm>
+          <a:prstGeom prst="rect">
+            <a:avLst/>
+          </a:prstGeom>
+          <a:noFill/>
+          <a:ln/>
+        </p:spPr>
+        <p:txBody>
+          <a:bodyPr wrap="square" lIns="0" tIns="0" rIns="0" bIns="0" rtlCol="0" anchor="ctr"/>
+          <a:lstStyle/>
+          <a:p>
+            <a:pPr indent="0" marL="0">
+              <a:buNone/>
+            </a:pPr>
+            <a:r>
+              <a:rPr lang="en-US" sz="1000" dirty="0">
+                <a:solidFill>
+                  <a:srgbClr val="626B80"/>
+                </a:solidFill>
+                <a:latin typeface="Apple SD Gothic Neo" pitchFamily="34" charset="0"/>
+                <a:ea typeface="Apple SD Gothic Neo" pitchFamily="34" charset="-122"/>
+                <a:cs typeface="Apple SD Gothic Neo" pitchFamily="34" charset="-120"/>
+              </a:rPr>
+              <a:t>학교 과제 · 실제 앱 캡처 / 합성 시연 데이터</a:t>
+            </a:r>
+            <a:endParaRPr lang="en-US" sz="1000" dirty="0"/>
+          </a:p>
+        </p:txBody>
+      </p:sp>
+      <p:sp>
+        <p:nvSpPr>
+          <p:cNvPr id="7" name="Shape 4"/>
+          <p:cNvSpPr/>
+          <p:nvPr/>
+        </p:nvSpPr>
+        <p:spPr>
+          <a:xfrm>
+            <a:off x="640080" y="1920240"/>
+            <a:ext cx="5349240" cy="3611880"/>
+          </a:xfrm>
+          <a:prstGeom prst="roundRect">
+            <a:avLst>
+              <a:gd name="adj" fmla="val 5570"/>
+            </a:avLst>
+          </a:prstGeom>
+          <a:solidFill>
+            <a:srgbClr val="FFFFFF"/>
+          </a:solidFill>
+          <a:ln w="12700">
+            <a:solidFill>
+              <a:srgbClr val="FFFFFF">
+                <a:alpha val="0"/>
+              </a:srgbClr>
+            </a:solidFill>
+            <a:prstDash val="solid"/>
+          </a:ln>
+        </p:spPr>
+      </p:sp>
+      <p:sp>
+        <p:nvSpPr>
+          <p:cNvPr id="8" name="Shape 5"/>
+          <p:cNvSpPr/>
+          <p:nvPr/>
+        </p:nvSpPr>
+        <p:spPr>
+          <a:xfrm>
+            <a:off x="6217920" y="1920240"/>
+            <a:ext cx="5349240" cy="3611880"/>
+          </a:xfrm>
+          <a:prstGeom prst="roundRect">
+            <a:avLst>
+              <a:gd name="adj" fmla="val 5570"/>
+            </a:avLst>
+          </a:prstGeom>
+          <a:solidFill>
+            <a:srgbClr val="DFE5FF"/>
+          </a:solidFill>
+          <a:ln w="12700">
+            <a:solidFill>
+              <a:srgbClr val="DFE5FF">
+                <a:alpha val="0"/>
+              </a:srgbClr>
+            </a:solidFill>
+            <a:prstDash val="solid"/>
+          </a:ln>
+        </p:spPr>
+      </p:sp>
+      <p:sp>
+        <p:nvSpPr>
+          <p:cNvPr id="9" name="Text 6"/>
+          <p:cNvSpPr/>
+          <p:nvPr/>
+        </p:nvSpPr>
+        <p:spPr>
+          <a:xfrm>
+            <a:off x="914400" y="2286000"/>
+            <a:ext cx="4572000" cy="457200"/>
+          </a:xfrm>
+          <a:prstGeom prst="rect">
+            <a:avLst/>
+          </a:prstGeom>
+          <a:noFill/>
+          <a:ln/>
+        </p:spPr>
+        <p:txBody>
+          <a:bodyPr wrap="square" lIns="0" tIns="0" rIns="0" bIns="0" rtlCol="0" anchor="ctr"/>
+          <a:lstStyle/>
+          <a:p>
+            <a:pPr indent="0" marL="0">
+              <a:buNone/>
+            </a:pPr>
+            <a:r>
+              <a:rPr lang="en-US" sz="2800" b="1" dirty="0">
+                <a:solidFill>
+                  <a:srgbClr val="405394"/>
+                </a:solidFill>
+                <a:latin typeface="Apple SD Gothic Neo" pitchFamily="34" charset="0"/>
+                <a:ea typeface="Apple SD Gothic Neo" pitchFamily="34" charset="-122"/>
+                <a:cs typeface="Apple SD Gothic Neo" pitchFamily="34" charset="-120"/>
+              </a:rPr>
+              <a:t>직접 확인</a:t>
+            </a:r>
+            <a:endParaRPr lang="en-US" sz="2800" dirty="0"/>
+          </a:p>
+        </p:txBody>
+      </p:sp>
+      <p:sp>
+        <p:nvSpPr>
+          <p:cNvPr id="10" name="Text 7"/>
+          <p:cNvSpPr/>
+          <p:nvPr/>
+        </p:nvSpPr>
+        <p:spPr>
+          <a:xfrm>
+            <a:off x="914400" y="3063240"/>
+            <a:ext cx="4663440" cy="1920240"/>
+          </a:xfrm>
+          <a:prstGeom prst="rect">
+            <a:avLst/>
+          </a:prstGeom>
+          <a:noFill/>
+          <a:ln/>
+        </p:spPr>
+        <p:txBody>
+          <a:bodyPr wrap="square" lIns="0" tIns="0" rIns="0" bIns="0" rtlCol="0" anchor="ctr"/>
+          <a:lstStyle/>
+          <a:p>
+            <a:pPr indent="0" marL="0">
+              <a:buNone/>
+            </a:pPr>
+            <a:r>
+              <a:rPr lang="en-US" sz="2200" dirty="0">
+                <a:solidFill>
+                  <a:srgbClr val="242938"/>
+                </a:solidFill>
+                <a:latin typeface="Apple SD Gothic Neo" pitchFamily="34" charset="0"/>
+                <a:ea typeface="Apple SD Gothic Neo" pitchFamily="34" charset="-122"/>
+                <a:cs typeface="Apple SD Gothic Neo" pitchFamily="34" charset="-120"/>
+              </a:rPr>
+              <a:t>번역 → 저장 → 요약 → 할 일</a:t>
+            </a:r>
+            <a:endParaRPr lang="en-US" sz="2200" dirty="0"/>
+          </a:p>
+          <a:p>
+            <a:pPr indent="0" marL="0">
+              <a:buNone/>
+            </a:pPr>
+            <a:r>
+              <a:rPr lang="en-US" sz="2200" dirty="0">
+                <a:solidFill>
+                  <a:srgbClr val="242938"/>
+                </a:solidFill>
+                <a:latin typeface="Apple SD Gothic Neo" pitchFamily="34" charset="0"/>
+                <a:ea typeface="Apple SD Gothic Neo" pitchFamily="34" charset="-122"/>
+                <a:cs typeface="Apple SD Gothic Neo" pitchFamily="34" charset="-120"/>
+              </a:rPr>
+              <a:t>언어 반전 · 필터 · 화면 모드</a:t>
+            </a:r>
+            <a:endParaRPr lang="en-US" sz="2200" dirty="0"/>
+          </a:p>
+          <a:p>
+            <a:pPr indent="0" marL="0">
+              <a:buNone/>
+            </a:pPr>
+            <a:r>
+              <a:rPr lang="en-US" sz="2200" dirty="0">
+                <a:solidFill>
+                  <a:srgbClr val="242938"/>
+                </a:solidFill>
+                <a:latin typeface="Apple SD Gothic Neo" pitchFamily="34" charset="0"/>
+                <a:ea typeface="Apple SD Gothic Neo" pitchFamily="34" charset="-122"/>
+                <a:cs typeface="Apple SD Gothic Neo" pitchFamily="34" charset="-120"/>
+              </a:rPr>
+              <a:t>재실행 · 연결 중단 후 복구</a:t>
+            </a:r>
+            <a:endParaRPr lang="en-US" sz="2200" dirty="0"/>
+          </a:p>
+          <a:p>
+            <a:pPr indent="0" marL="0">
+              <a:buNone/>
+            </a:pPr>
+            <a:r>
+              <a:rPr lang="en-US" sz="2200" dirty="0">
+                <a:solidFill>
+                  <a:srgbClr val="242938"/>
+                </a:solidFill>
+                <a:latin typeface="Apple SD Gothic Neo" pitchFamily="34" charset="0"/>
+                <a:ea typeface="Apple SD Gothic Neo" pitchFamily="34" charset="-122"/>
+                <a:cs typeface="Apple SD Gothic Neo" pitchFamily="34" charset="-120"/>
+              </a:rPr>
+              <a:t>권한 거절 안내 · 알림 자동 닫힘</a:t>
+            </a:r>
+            <a:endParaRPr lang="en-US" sz="2200" dirty="0"/>
+          </a:p>
+        </p:txBody>
+      </p:sp>
+      <p:sp>
+        <p:nvSpPr>
+          <p:cNvPr id="11" name="Text 8"/>
+          <p:cNvSpPr/>
+          <p:nvPr/>
+        </p:nvSpPr>
+        <p:spPr>
+          <a:xfrm>
+            <a:off x="6492240" y="2286000"/>
+            <a:ext cx="4572000" cy="457200"/>
+          </a:xfrm>
+          <a:prstGeom prst="rect">
+            <a:avLst/>
+          </a:prstGeom>
+          <a:noFill/>
+          <a:ln/>
+        </p:spPr>
+        <p:txBody>
+          <a:bodyPr wrap="square" lIns="0" tIns="0" rIns="0" bIns="0" rtlCol="0" anchor="ctr"/>
+          <a:lstStyle/>
+          <a:p>
+            <a:pPr indent="0" marL="0">
+              <a:buNone/>
+            </a:pPr>
+            <a:r>
+              <a:rPr lang="en-US" sz="2800" b="1" dirty="0">
+                <a:solidFill>
+                  <a:srgbClr val="405394"/>
+                </a:solidFill>
+                <a:latin typeface="Apple SD Gothic Neo" pitchFamily="34" charset="0"/>
+                <a:ea typeface="Apple SD Gothic Neo" pitchFamily="34" charset="-122"/>
+                <a:cs typeface="Apple SD Gothic Neo" pitchFamily="34" charset="-120"/>
+              </a:rPr>
+              <a:t>별도 확인 필요</a:t>
+            </a:r>
+            <a:endParaRPr lang="en-US" sz="2800" dirty="0"/>
+          </a:p>
+        </p:txBody>
+      </p:sp>
+      <p:sp>
+        <p:nvSpPr>
+          <p:cNvPr id="12" name="Text 9"/>
+          <p:cNvSpPr/>
+          <p:nvPr/>
+        </p:nvSpPr>
+        <p:spPr>
+          <a:xfrm>
+            <a:off x="6492240" y="3063240"/>
+            <a:ext cx="4663440" cy="1920240"/>
+          </a:xfrm>
+          <a:prstGeom prst="rect">
+            <a:avLst/>
+          </a:prstGeom>
+          <a:noFill/>
+          <a:ln/>
+        </p:spPr>
+        <p:txBody>
+          <a:bodyPr wrap="square" lIns="0" tIns="0" rIns="0" bIns="0" rtlCol="0" anchor="ctr"/>
+          <a:lstStyle/>
+          <a:p>
+            <a:pPr indent="0" marL="0">
+              <a:buNone/>
+            </a:pPr>
+            <a:r>
+              <a:rPr lang="en-US" sz="2200" dirty="0">
+                <a:solidFill>
+                  <a:srgbClr val="242938"/>
+                </a:solidFill>
+                <a:latin typeface="Apple SD Gothic Neo" pitchFamily="34" charset="0"/>
+                <a:ea typeface="Apple SD Gothic Neo" pitchFamily="34" charset="-122"/>
+                <a:cs typeface="Apple SD Gothic Neo" pitchFamily="34" charset="-120"/>
+              </a:rPr>
+              <a:t>실제 휴대전화와 마이크 · 청취</a:t>
+            </a:r>
+            <a:endParaRPr lang="en-US" sz="2200" dirty="0"/>
+          </a:p>
+          <a:p>
+            <a:pPr indent="0" marL="0">
+              <a:buNone/>
+            </a:pPr>
+            <a:r>
+              <a:rPr lang="en-US" sz="2200" dirty="0">
+                <a:solidFill>
+                  <a:srgbClr val="242938"/>
+                </a:solidFill>
+                <a:latin typeface="Apple SD Gothic Neo" pitchFamily="34" charset="0"/>
+                <a:ea typeface="Apple SD Gothic Neo" pitchFamily="34" charset="-122"/>
+                <a:cs typeface="Apple SD Gothic Neo" pitchFamily="34" charset="-120"/>
+              </a:rPr>
+              <a:t>운영 도메인 · 스토어 서명</a:t>
+            </a:r>
+            <a:endParaRPr lang="en-US" sz="2200" dirty="0"/>
+          </a:p>
+          <a:p>
+            <a:pPr indent="0" marL="0">
+              <a:buNone/>
+            </a:pPr>
+            <a:r>
+              <a:rPr lang="en-US" sz="2200" dirty="0">
+                <a:solidFill>
+                  <a:srgbClr val="242938"/>
+                </a:solidFill>
+                <a:latin typeface="Apple SD Gothic Neo" pitchFamily="34" charset="0"/>
+                <a:ea typeface="Apple SD Gothic Neo" pitchFamily="34" charset="-122"/>
+                <a:cs typeface="Apple SD Gothic Neo" pitchFamily="34" charset="-120"/>
+              </a:rPr>
+              <a:t>고유명사 등 음성 인식 품질</a:t>
+            </a:r>
+            <a:endParaRPr lang="en-US" sz="2200" dirty="0"/>
+          </a:p>
+          <a:p>
+            <a:pPr indent="0" marL="0">
+              <a:buNone/>
+            </a:pPr>
+            <a:r>
+              <a:rPr lang="en-US" sz="2200" dirty="0">
+                <a:solidFill>
+                  <a:srgbClr val="242938"/>
+                </a:solidFill>
+                <a:latin typeface="Apple SD Gothic Neo" pitchFamily="34" charset="0"/>
+                <a:ea typeface="Apple SD Gothic Neo" pitchFamily="34" charset="-122"/>
+                <a:cs typeface="Apple SD Gothic Neo" pitchFamily="34" charset="-120"/>
+              </a:rPr>
+              <a:t>정확도는 입력 환경에 따라 달라짐</a:t>
+            </a:r>
+            <a:endParaRPr lang="en-US" sz="2200" dirty="0"/>
+          </a:p>
+        </p:txBody>
+      </p:sp>
+    </p:spTree>
+  </p:cSld>
+  <p:clrMapOvr>
+    <a:masterClrMapping/>
+  </p:clrMapOvr>
+</p:sld>
+</file>
+
+<file path=ppt/slides/slide12.xml><?xml version="1.0" encoding="utf-8"?>
+<p:sld xmlns:a="http://schemas.openxmlformats.org/drawingml/2006/main" xmlns:r="http://schemas.openxmlformats.org/officeDocument/2006/relationships" xmlns:p="http://schemas.openxmlformats.org/presentationml/2006/main">
+  <p:cSld name="Slide 12">
+    <p:bg>
+      <p:bgPr>
+        <a:solidFill>
+          <a:srgbClr val="F2F3F9"/>
+        </a:solidFill>
+      </p:bgPr>
+    </p:bg>
+    <p:spTree>
+      <p:nvGrpSpPr>
+        <p:cNvPr id="1" name=""/>
+        <p:cNvGrpSpPr/>
+        <p:nvPr/>
+      </p:nvGrpSpPr>
+      <p:grpSpPr>
+        <a:xfrm>
+          <a:off x="0" y="0"/>
+          <a:ext cx="0" cy="0"/>
+          <a:chOff x="0" y="0"/>
+          <a:chExt cx="0" cy="0"/>
+        </a:xfrm>
+      </p:grpSpPr>
+      <p:sp>
+        <p:nvSpPr>
+          <p:cNvPr id="2" name="Text 0"/>
+          <p:cNvSpPr/>
+          <p:nvPr/>
+        </p:nvSpPr>
+        <p:spPr>
+          <a:xfrm>
+            <a:off x="502920" y="274320"/>
+            <a:ext cx="10058400" cy="274320"/>
+          </a:xfrm>
+          <a:prstGeom prst="rect">
+            <a:avLst/>
+          </a:prstGeom>
+          <a:noFill/>
+          <a:ln/>
+        </p:spPr>
+        <p:txBody>
+          <a:bodyPr wrap="square" lIns="0" tIns="0" rIns="0" bIns="0" rtlCol="0" anchor="ctr"/>
+          <a:lstStyle/>
+          <a:p>
+            <a:pPr indent="0" marL="0">
+              <a:buNone/>
+            </a:pPr>
+            <a:r>
+              <a:rPr lang="en-US" sz="1200" b="1" dirty="0">
+                <a:solidFill>
+                  <a:srgbClr val="405394"/>
+                </a:solidFill>
+                <a:latin typeface="Apple SD Gothic Neo" pitchFamily="34" charset="0"/>
+                <a:ea typeface="Apple SD Gothic Neo" pitchFamily="34" charset="-122"/>
+                <a:cs typeface="Apple SD Gothic Neo" pitchFamily="34" charset="-120"/>
+              </a:rPr>
+              <a:t>SPEECHBRIDGE  /  LIVE DEMO</a:t>
+            </a:r>
+            <a:endParaRPr lang="en-US" sz="1200" dirty="0"/>
+          </a:p>
+        </p:txBody>
+      </p:sp>
+      <p:sp>
+        <p:nvSpPr>
+          <p:cNvPr id="3" name="Text 1"/>
+          <p:cNvSpPr/>
+          <p:nvPr/>
+        </p:nvSpPr>
+        <p:spPr>
+          <a:xfrm>
+            <a:off x="502920" y="768096"/>
+            <a:ext cx="11155680" cy="731520"/>
+          </a:xfrm>
+          <a:prstGeom prst="rect">
+            <a:avLst/>
+          </a:prstGeom>
+          <a:noFill/>
+          <a:ln/>
+        </p:spPr>
+        <p:txBody>
+          <a:bodyPr wrap="square" lIns="0" tIns="0" rIns="0" bIns="0" rtlCol="0" anchor="ctr"/>
+          <a:lstStyle/>
+          <a:p>
+            <a:pPr indent="0" marL="0">
+              <a:buNone/>
+            </a:pPr>
+            <a:r>
+              <a:rPr lang="en-US" sz="3400" b="1" dirty="0">
+                <a:solidFill>
+                  <a:srgbClr val="242938"/>
+                </a:solidFill>
+                <a:latin typeface="Apple SD Gothic Neo" pitchFamily="34" charset="0"/>
+                <a:ea typeface="Apple SD Gothic Neo" pitchFamily="34" charset="-122"/>
+                <a:cs typeface="Apple SD Gothic Neo" pitchFamily="34" charset="-120"/>
+              </a:rPr>
+              <a:t>한 문장이 기록과 할 일이 되는 과정.</a:t>
+            </a:r>
+            <a:endParaRPr lang="en-US" sz="3400" dirty="0"/>
+          </a:p>
+        </p:txBody>
+      </p:sp>
+      <p:sp>
+        <p:nvSpPr>
+          <p:cNvPr id="4" name="Text 2"/>
+          <p:cNvSpPr/>
+          <p:nvPr/>
+        </p:nvSpPr>
+        <p:spPr>
+          <a:xfrm>
+            <a:off x="11201400" y="6419088"/>
+            <a:ext cx="457200" cy="182880"/>
+          </a:xfrm>
+          <a:prstGeom prst="rect">
+            <a:avLst/>
+          </a:prstGeom>
+          <a:noFill/>
+          <a:ln/>
+        </p:spPr>
+        <p:txBody>
+          <a:bodyPr wrap="square" lIns="0" tIns="0" rIns="0" bIns="0" rtlCol="0" anchor="ctr"/>
+          <a:lstStyle/>
+          <a:p>
+            <a:pPr indent="0" marL="0">
+              <a:buNone/>
+            </a:pPr>
+            <a:r>
+              <a:rPr lang="en-US" sz="1000" dirty="0">
+                <a:solidFill>
+                  <a:srgbClr val="626B80"/>
+                </a:solidFill>
+                <a:latin typeface="Apple SD Gothic Neo" pitchFamily="34" charset="0"/>
+                <a:ea typeface="Apple SD Gothic Neo" pitchFamily="34" charset="-122"/>
+                <a:cs typeface="Apple SD Gothic Neo" pitchFamily="34" charset="-120"/>
+              </a:rPr>
+              <a:t>12</a:t>
+            </a:r>
+            <a:endParaRPr lang="en-US" sz="1000" dirty="0"/>
+          </a:p>
+        </p:txBody>
+      </p:sp>
+      <p:sp>
+        <p:nvSpPr>
+          <p:cNvPr id="5" name="Text 3"/>
+          <p:cNvSpPr/>
+          <p:nvPr/>
+        </p:nvSpPr>
+        <p:spPr>
+          <a:xfrm>
+            <a:off x="502920" y="6419088"/>
+            <a:ext cx="9144000" cy="182880"/>
+          </a:xfrm>
+          <a:prstGeom prst="rect">
+            <a:avLst/>
+          </a:prstGeom>
+          <a:noFill/>
+          <a:ln/>
+        </p:spPr>
+        <p:txBody>
+          <a:bodyPr wrap="square" lIns="0" tIns="0" rIns="0" bIns="0" rtlCol="0" anchor="ctr"/>
+          <a:lstStyle/>
+          <a:p>
+            <a:pPr indent="0" marL="0">
+              <a:buNone/>
+            </a:pPr>
+            <a:r>
+              <a:rPr lang="en-US" sz="1000" dirty="0">
+                <a:solidFill>
+                  <a:srgbClr val="626B80"/>
+                </a:solidFill>
+                <a:latin typeface="Apple SD Gothic Neo" pitchFamily="34" charset="0"/>
+                <a:ea typeface="Apple SD Gothic Neo" pitchFamily="34" charset="-122"/>
+                <a:cs typeface="Apple SD Gothic Neo" pitchFamily="34" charset="-120"/>
+              </a:rPr>
+              <a:t>학교 과제 · 실제 앱 캡처 / 합성 시연 데이터</a:t>
+            </a:r>
+            <a:endParaRPr lang="en-US" sz="1000" dirty="0"/>
+          </a:p>
+        </p:txBody>
+      </p:sp>
+      <p:sp>
+        <p:nvSpPr>
+          <p:cNvPr id="7" name="Text 4"/>
+          <p:cNvSpPr/>
+          <p:nvPr/>
+        </p:nvSpPr>
+        <p:spPr>
+          <a:xfrm>
+            <a:off x="731520" y="1828800"/>
+            <a:ext cx="10698480" cy="731520"/>
+          </a:xfrm>
+          <a:prstGeom prst="rect">
+            <a:avLst/>
+          </a:prstGeom>
+          <a:noFill/>
+          <a:ln/>
+        </p:spPr>
+        <p:txBody>
+          <a:bodyPr wrap="square" lIns="0" tIns="0" rIns="0" bIns="0" rtlCol="0" anchor="ctr"/>
+          <a:lstStyle/>
+          <a:p>
+            <a:pPr indent="0" marL="0">
+              <a:buNone/>
+            </a:pPr>
+            <a:r>
+              <a:rPr lang="en-US" sz="3000" b="1" dirty="0">
+                <a:solidFill>
+                  <a:srgbClr val="405394"/>
+                </a:solidFill>
+                <a:latin typeface="Apple SD Gothic Neo" pitchFamily="34" charset="0"/>
+                <a:ea typeface="Apple SD Gothic Neo" pitchFamily="34" charset="-122"/>
+                <a:cs typeface="Apple SD Gothic Neo" pitchFamily="34" charset="-120"/>
+              </a:rPr>
+              <a:t>“please prepare demo slides by friday”</a:t>
+            </a:r>
+            <a:endParaRPr lang="en-US" sz="3000" dirty="0"/>
+          </a:p>
+        </p:txBody>
+      </p:sp>
+      <p:sp>
+        <p:nvSpPr>
+          <p:cNvPr id="8" name="Shape 5"/>
+          <p:cNvSpPr/>
+          <p:nvPr/>
+        </p:nvSpPr>
+        <p:spPr>
+          <a:xfrm>
+            <a:off x="731520" y="3200400"/>
+            <a:ext cx="2606040" cy="1463040"/>
+          </a:xfrm>
+          <a:prstGeom prst="roundRect">
+            <a:avLst>
+              <a:gd name="adj" fmla="val 13750"/>
+            </a:avLst>
+          </a:prstGeom>
+          <a:solidFill>
+            <a:srgbClr val="FFFFFF"/>
+          </a:solidFill>
+          <a:ln w="12700">
+            <a:solidFill>
+              <a:srgbClr val="FFFFFF">
+                <a:alpha val="0"/>
+              </a:srgbClr>
+            </a:solidFill>
+            <a:prstDash val="solid"/>
+          </a:ln>
+        </p:spPr>
+      </p:sp>
+      <p:sp>
+        <p:nvSpPr>
+          <p:cNvPr id="9" name="Text 6"/>
+          <p:cNvSpPr/>
+          <p:nvPr/>
+        </p:nvSpPr>
+        <p:spPr>
+          <a:xfrm>
+            <a:off x="960120" y="3401568"/>
+            <a:ext cx="2103120" cy="320040"/>
+          </a:xfrm>
+          <a:prstGeom prst="rect">
+            <a:avLst/>
+          </a:prstGeom>
+          <a:noFill/>
+          <a:ln/>
+        </p:spPr>
+        <p:txBody>
+          <a:bodyPr wrap="square" lIns="0" tIns="0" rIns="0" bIns="0" rtlCol="0" anchor="ctr"/>
+          <a:lstStyle/>
+          <a:p>
+            <a:pPr indent="0" marL="0">
+              <a:buNone/>
+            </a:pPr>
+            <a:r>
+              <a:rPr lang="en-US" sz="1400" b="1" dirty="0">
+                <a:solidFill>
+                  <a:srgbClr val="626B80"/>
+                </a:solidFill>
+                <a:latin typeface="Apple SD Gothic Neo" pitchFamily="34" charset="0"/>
+                <a:ea typeface="Apple SD Gothic Neo" pitchFamily="34" charset="-122"/>
+                <a:cs typeface="Apple SD Gothic Neo" pitchFamily="34" charset="-120"/>
+              </a:rPr>
+              <a:t>1</a:t>
+            </a:r>
+            <a:endParaRPr lang="en-US" sz="1400" dirty="0"/>
+          </a:p>
+        </p:txBody>
+      </p:sp>
+      <p:sp>
+        <p:nvSpPr>
+          <p:cNvPr id="10" name="Text 7"/>
+          <p:cNvSpPr/>
+          <p:nvPr/>
+        </p:nvSpPr>
+        <p:spPr>
+          <a:xfrm>
+            <a:off x="960120" y="3913632"/>
+            <a:ext cx="2103120" cy="411480"/>
+          </a:xfrm>
+          <a:prstGeom prst="rect">
+            <a:avLst/>
+          </a:prstGeom>
+          <a:noFill/>
+          <a:ln/>
+        </p:spPr>
+        <p:txBody>
+          <a:bodyPr wrap="square" lIns="0" tIns="0" rIns="0" bIns="0" rtlCol="0" anchor="ctr"/>
+          <a:lstStyle/>
+          <a:p>
+            <a:pPr indent="0" marL="0">
+              <a:buNone/>
+            </a:pPr>
+            <a:r>
+              <a:rPr lang="en-US" sz="2300" b="1" dirty="0">
+                <a:solidFill>
+                  <a:srgbClr val="242938"/>
+                </a:solidFill>
+                <a:latin typeface="Apple SD Gothic Neo" pitchFamily="34" charset="0"/>
+                <a:ea typeface="Apple SD Gothic Neo" pitchFamily="34" charset="-122"/>
+                <a:cs typeface="Apple SD Gothic Neo" pitchFamily="34" charset="-120"/>
+              </a:rPr>
+              <a:t>입력·번역</a:t>
+            </a:r>
+            <a:endParaRPr lang="en-US" sz="2300" dirty="0"/>
+          </a:p>
+        </p:txBody>
+      </p:sp>
+      <p:sp>
+        <p:nvSpPr>
+          <p:cNvPr id="11" name="Shape 8"/>
+          <p:cNvSpPr/>
+          <p:nvPr/>
+        </p:nvSpPr>
+        <p:spPr>
+          <a:xfrm>
+            <a:off x="3593592" y="3200400"/>
+            <a:ext cx="2606040" cy="1463040"/>
+          </a:xfrm>
+          <a:prstGeom prst="roundRect">
+            <a:avLst>
+              <a:gd name="adj" fmla="val 13750"/>
+            </a:avLst>
+          </a:prstGeom>
+          <a:solidFill>
+            <a:srgbClr val="FFFFFF"/>
+          </a:solidFill>
+          <a:ln w="12700">
+            <a:solidFill>
+              <a:srgbClr val="FFFFFF">
+                <a:alpha val="0"/>
+              </a:srgbClr>
+            </a:solidFill>
+            <a:prstDash val="solid"/>
+          </a:ln>
+        </p:spPr>
+      </p:sp>
+      <p:sp>
+        <p:nvSpPr>
+          <p:cNvPr id="12" name="Text 9"/>
+          <p:cNvSpPr/>
+          <p:nvPr/>
+        </p:nvSpPr>
+        <p:spPr>
+          <a:xfrm>
+            <a:off x="3822192" y="3401568"/>
+            <a:ext cx="2103120" cy="320040"/>
+          </a:xfrm>
+          <a:prstGeom prst="rect">
+            <a:avLst/>
+          </a:prstGeom>
+          <a:noFill/>
+          <a:ln/>
+        </p:spPr>
+        <p:txBody>
+          <a:bodyPr wrap="square" lIns="0" tIns="0" rIns="0" bIns="0" rtlCol="0" anchor="ctr"/>
+          <a:lstStyle/>
+          <a:p>
+            <a:pPr indent="0" marL="0">
+              <a:buNone/>
+            </a:pPr>
+            <a:r>
+              <a:rPr lang="en-US" sz="1400" b="1" dirty="0">
+                <a:solidFill>
+                  <a:srgbClr val="626B80"/>
+                </a:solidFill>
+                <a:latin typeface="Apple SD Gothic Neo" pitchFamily="34" charset="0"/>
+                <a:ea typeface="Apple SD Gothic Neo" pitchFamily="34" charset="-122"/>
+                <a:cs typeface="Apple SD Gothic Neo" pitchFamily="34" charset="-120"/>
+              </a:rPr>
+              <a:t>2</a:t>
+            </a:r>
+            <a:endParaRPr lang="en-US" sz="1400" dirty="0"/>
+          </a:p>
+        </p:txBody>
+      </p:sp>
+      <p:sp>
+        <p:nvSpPr>
+          <p:cNvPr id="13" name="Text 10"/>
+          <p:cNvSpPr/>
+          <p:nvPr/>
+        </p:nvSpPr>
+        <p:spPr>
+          <a:xfrm>
+            <a:off x="3822192" y="3913632"/>
+            <a:ext cx="2103120" cy="411480"/>
+          </a:xfrm>
+          <a:prstGeom prst="rect">
+            <a:avLst/>
+          </a:prstGeom>
+          <a:noFill/>
+          <a:ln/>
+        </p:spPr>
+        <p:txBody>
+          <a:bodyPr wrap="square" lIns="0" tIns="0" rIns="0" bIns="0" rtlCol="0" anchor="ctr"/>
+          <a:lstStyle/>
+          <a:p>
+            <a:pPr indent="0" marL="0">
+              <a:buNone/>
+            </a:pPr>
+            <a:r>
+              <a:rPr lang="en-US" sz="2300" b="1" dirty="0">
+                <a:solidFill>
+                  <a:srgbClr val="242938"/>
+                </a:solidFill>
+                <a:latin typeface="Apple SD Gothic Neo" pitchFamily="34" charset="0"/>
+                <a:ea typeface="Apple SD Gothic Neo" pitchFamily="34" charset="-122"/>
+                <a:cs typeface="Apple SD Gothic Neo" pitchFamily="34" charset="-120"/>
+              </a:rPr>
+              <a:t>종료·요약</a:t>
+            </a:r>
+            <a:endParaRPr lang="en-US" sz="2300" dirty="0"/>
+          </a:p>
+        </p:txBody>
+      </p:sp>
+      <p:sp>
+        <p:nvSpPr>
+          <p:cNvPr id="14" name="Shape 11"/>
+          <p:cNvSpPr/>
+          <p:nvPr/>
+        </p:nvSpPr>
+        <p:spPr>
+          <a:xfrm>
+            <a:off x="6455664" y="3200400"/>
+            <a:ext cx="2606040" cy="1463040"/>
+          </a:xfrm>
+          <a:prstGeom prst="roundRect">
+            <a:avLst>
+              <a:gd name="adj" fmla="val 13750"/>
+            </a:avLst>
+          </a:prstGeom>
+          <a:solidFill>
+            <a:srgbClr val="FFFFFF"/>
+          </a:solidFill>
+          <a:ln w="12700">
+            <a:solidFill>
+              <a:srgbClr val="FFFFFF">
+                <a:alpha val="0"/>
+              </a:srgbClr>
+            </a:solidFill>
+            <a:prstDash val="solid"/>
+          </a:ln>
+        </p:spPr>
+      </p:sp>
+      <p:sp>
+        <p:nvSpPr>
+          <p:cNvPr id="15" name="Text 12"/>
+          <p:cNvSpPr/>
+          <p:nvPr/>
+        </p:nvSpPr>
+        <p:spPr>
+          <a:xfrm>
+            <a:off x="6684264" y="3401568"/>
+            <a:ext cx="2103120" cy="320040"/>
+          </a:xfrm>
+          <a:prstGeom prst="rect">
+            <a:avLst/>
+          </a:prstGeom>
+          <a:noFill/>
+          <a:ln/>
+        </p:spPr>
+        <p:txBody>
+          <a:bodyPr wrap="square" lIns="0" tIns="0" rIns="0" bIns="0" rtlCol="0" anchor="ctr"/>
+          <a:lstStyle/>
+          <a:p>
+            <a:pPr indent="0" marL="0">
+              <a:buNone/>
+            </a:pPr>
+            <a:r>
+              <a:rPr lang="en-US" sz="1400" b="1" dirty="0">
+                <a:solidFill>
+                  <a:srgbClr val="626B80"/>
+                </a:solidFill>
+                <a:latin typeface="Apple SD Gothic Neo" pitchFamily="34" charset="0"/>
+                <a:ea typeface="Apple SD Gothic Neo" pitchFamily="34" charset="-122"/>
+                <a:cs typeface="Apple SD Gothic Neo" pitchFamily="34" charset="-120"/>
+              </a:rPr>
+              <a:t>3</a:t>
+            </a:r>
+            <a:endParaRPr lang="en-US" sz="1400" dirty="0"/>
+          </a:p>
+        </p:txBody>
+      </p:sp>
+      <p:sp>
+        <p:nvSpPr>
+          <p:cNvPr id="16" name="Text 13"/>
+          <p:cNvSpPr/>
+          <p:nvPr/>
+        </p:nvSpPr>
+        <p:spPr>
+          <a:xfrm>
+            <a:off x="6684264" y="3913632"/>
+            <a:ext cx="2103120" cy="411480"/>
+          </a:xfrm>
+          <a:prstGeom prst="rect">
+            <a:avLst/>
+          </a:prstGeom>
+          <a:noFill/>
+          <a:ln/>
+        </p:spPr>
+        <p:txBody>
+          <a:bodyPr wrap="square" lIns="0" tIns="0" rIns="0" bIns="0" rtlCol="0" anchor="ctr"/>
+          <a:lstStyle/>
+          <a:p>
+            <a:pPr indent="0" marL="0">
+              <a:buNone/>
+            </a:pPr>
+            <a:r>
+              <a:rPr lang="en-US" sz="2300" b="1" dirty="0">
+                <a:solidFill>
+                  <a:srgbClr val="242938"/>
+                </a:solidFill>
+                <a:latin typeface="Apple SD Gothic Neo" pitchFamily="34" charset="0"/>
+                <a:ea typeface="Apple SD Gothic Neo" pitchFamily="34" charset="-122"/>
+                <a:cs typeface="Apple SD Gothic Neo" pitchFamily="34" charset="-120"/>
+              </a:rPr>
+              <a:t>근거 확인</a:t>
+            </a:r>
+            <a:endParaRPr lang="en-US" sz="2300" dirty="0"/>
+          </a:p>
+        </p:txBody>
+      </p:sp>
+      <p:sp>
+        <p:nvSpPr>
+          <p:cNvPr id="17" name="Shape 14"/>
+          <p:cNvSpPr/>
+          <p:nvPr/>
+        </p:nvSpPr>
+        <p:spPr>
+          <a:xfrm>
+            <a:off x="9317736" y="3200400"/>
+            <a:ext cx="2606040" cy="1463040"/>
+          </a:xfrm>
+          <a:prstGeom prst="roundRect">
+            <a:avLst>
+              <a:gd name="adj" fmla="val 13750"/>
+            </a:avLst>
+          </a:prstGeom>
+          <a:solidFill>
+            <a:srgbClr val="FFFFFF"/>
+          </a:solidFill>
+          <a:ln w="12700">
+            <a:solidFill>
+              <a:srgbClr val="FFFFFF">
+                <a:alpha val="0"/>
+              </a:srgbClr>
+            </a:solidFill>
+            <a:prstDash val="solid"/>
+          </a:ln>
+        </p:spPr>
+      </p:sp>
+      <p:sp>
+        <p:nvSpPr>
+          <p:cNvPr id="18" name="Text 15"/>
+          <p:cNvSpPr/>
+          <p:nvPr/>
+        </p:nvSpPr>
+        <p:spPr>
+          <a:xfrm>
+            <a:off x="9546336" y="3401568"/>
+            <a:ext cx="2103120" cy="320040"/>
+          </a:xfrm>
+          <a:prstGeom prst="rect">
+            <a:avLst/>
+          </a:prstGeom>
+          <a:noFill/>
+          <a:ln/>
+        </p:spPr>
+        <p:txBody>
+          <a:bodyPr wrap="square" lIns="0" tIns="0" rIns="0" bIns="0" rtlCol="0" anchor="ctr"/>
+          <a:lstStyle/>
+          <a:p>
+            <a:pPr indent="0" marL="0">
+              <a:buNone/>
+            </a:pPr>
+            <a:r>
+              <a:rPr lang="en-US" sz="1400" b="1" dirty="0">
+                <a:solidFill>
+                  <a:srgbClr val="626B80"/>
+                </a:solidFill>
+                <a:latin typeface="Apple SD Gothic Neo" pitchFamily="34" charset="0"/>
+                <a:ea typeface="Apple SD Gothic Neo" pitchFamily="34" charset="-122"/>
+                <a:cs typeface="Apple SD Gothic Neo" pitchFamily="34" charset="-120"/>
+              </a:rPr>
+              <a:t>4</a:t>
+            </a:r>
+            <a:endParaRPr lang="en-US" sz="1400" dirty="0"/>
+          </a:p>
+        </p:txBody>
+      </p:sp>
+      <p:sp>
+        <p:nvSpPr>
+          <p:cNvPr id="19" name="Text 16"/>
+          <p:cNvSpPr/>
+          <p:nvPr/>
+        </p:nvSpPr>
+        <p:spPr>
+          <a:xfrm>
+            <a:off x="9546336" y="3913632"/>
+            <a:ext cx="2103120" cy="411480"/>
+          </a:xfrm>
+          <a:prstGeom prst="rect">
+            <a:avLst/>
+          </a:prstGeom>
+          <a:noFill/>
+          <a:ln/>
+        </p:spPr>
+        <p:txBody>
+          <a:bodyPr wrap="square" lIns="0" tIns="0" rIns="0" bIns="0" rtlCol="0" anchor="ctr"/>
+          <a:lstStyle/>
+          <a:p>
+            <a:pPr indent="0" marL="0">
+              <a:buNone/>
+            </a:pPr>
+            <a:r>
+              <a:rPr lang="en-US" sz="2300" b="1" dirty="0">
+                <a:solidFill>
+                  <a:srgbClr val="242938"/>
+                </a:solidFill>
+                <a:latin typeface="Apple SD Gothic Neo" pitchFamily="34" charset="0"/>
+                <a:ea typeface="Apple SD Gothic Neo" pitchFamily="34" charset="-122"/>
+                <a:cs typeface="Apple SD Gothic Neo" pitchFamily="34" charset="-120"/>
+              </a:rPr>
+              <a:t>할 일 완료</a:t>
+            </a:r>
+            <a:endParaRPr lang="en-US" sz="2300" dirty="0"/>
+          </a:p>
+        </p:txBody>
+      </p:sp>
+      <p:sp>
+        <p:nvSpPr>
+          <p:cNvPr id="20" name="Text 17"/>
+          <p:cNvSpPr/>
+          <p:nvPr/>
+        </p:nvSpPr>
+        <p:spPr>
+          <a:xfrm>
+            <a:off x="822960" y="5394960"/>
+            <a:ext cx="10607040" cy="457200"/>
+          </a:xfrm>
+          <a:prstGeom prst="rect">
+            <a:avLst/>
+          </a:prstGeom>
+          <a:noFill/>
+          <a:ln/>
+        </p:spPr>
+        <p:txBody>
+          <a:bodyPr wrap="square" lIns="0" tIns="0" rIns="0" bIns="0" rtlCol="0" anchor="ctr"/>
+          <a:lstStyle/>
+          <a:p>
+            <a:pPr indent="0" marL="0">
+              <a:buNone/>
+            </a:pPr>
+            <a:r>
+              <a:rPr lang="en-US" sz="2000" dirty="0">
+                <a:solidFill>
+                  <a:srgbClr val="626B80"/>
+                </a:solidFill>
+                <a:latin typeface="Apple SD Gothic Neo" pitchFamily="34" charset="0"/>
+                <a:ea typeface="Apple SD Gothic Neo" pitchFamily="34" charset="-122"/>
+                <a:cs typeface="Apple SD Gothic Neo" pitchFamily="34" charset="-120"/>
+              </a:rPr>
+              <a:t>시연 예시 데이터 사용 · AI 응답은 실행마다 달라질 수 있습니다.</a:t>
+            </a:r>
+            <a:endParaRPr lang="en-US" sz="2000" dirty="0"/>
+          </a:p>
+        </p:txBody>
+      </p:sp>
+    </p:spTree>
+  </p:cSld>
+  <p:clrMapOvr>
+    <a:masterClrMapping/>
+  </p:clrMapOvr>
+</p:sld>
+</file>
+
+<file path=ppt/slides/slide13.xml><?xml version="1.0" encoding="utf-8"?>
+<p:sld xmlns:a="http://schemas.openxmlformats.org/drawingml/2006/main" xmlns:r="http://schemas.openxmlformats.org/officeDocument/2006/relationships" xmlns:p="http://schemas.openxmlformats.org/presentationml/2006/main">
+  <p:cSld name="Slide 13">
+    <p:bg>
+      <p:bgPr>
+        <a:solidFill>
           <a:srgbClr val="141A29"/>
         </a:solidFill>
       </p:bgPr>
@@ -2072,7 +4076,7 @@
                 <a:ea typeface="Apple SD Gothic Neo" pitchFamily="34" charset="-122"/>
                 <a:cs typeface="Apple SD Gothic Neo" pitchFamily="34" charset="-120"/>
               </a:rPr>
-              <a:t>10</a:t>
+              <a:t>13</a:t>
             </a:r>
             <a:endParaRPr lang="en-US" sz="1000" dirty="0"/>
           </a:p>
@@ -5434,7 +7438,7 @@
                 <a:ea typeface="Apple SD Gothic Neo" pitchFamily="34" charset="-122"/>
                 <a:cs typeface="Apple SD Gothic Neo" pitchFamily="34" charset="-120"/>
               </a:rPr>
-              <a:t>SPEECHBRIDGE  /  DATA &amp; RECOVERY</a:t>
+              <a:t>SPEECHBRIDGE  /  MODELS / PIPELINE</a:t>
             </a:r>
             <a:endParaRPr lang="en-US" sz="1200" dirty="0"/>
           </a:p>
@@ -5473,7 +7477,7 @@
                 <a:ea typeface="Apple SD Gothic Neo" pitchFamily="34" charset="-122"/>
                 <a:cs typeface="Apple SD Gothic Neo" pitchFamily="34" charset="-120"/>
               </a:rPr>
-              <a:t>연결이 끊겨도, 변경 내용을 잃지 않도록.</a:t>
+              <a:t>한 모델에 모두 맡기지 않고, 역할을 나눴습니다.</a:t>
             </a:r>
             <a:endParaRPr lang="en-US" sz="3400" dirty="0"/>
           </a:p>
@@ -5559,30 +7563,59 @@
       </p:sp>
       <p:sp>
         <p:nvSpPr>
-          <p:cNvPr id="7" name="Text 4"/>
-          <p:cNvSpPr/>
-          <p:nvPr/>
-        </p:nvSpPr>
-        <p:spPr>
-          <a:xfrm>
-            <a:off x="731520" y="2011680"/>
-            <a:ext cx="502920" cy="365760"/>
-          </a:xfrm>
-          <a:prstGeom prst="rect">
-            <a:avLst/>
-          </a:prstGeom>
-          <a:noFill/>
-          <a:ln/>
-        </p:spPr>
-        <p:txBody>
-          <a:bodyPr wrap="square" lIns="0" tIns="0" rIns="0" bIns="0" rtlCol="0" anchor="ctr"/>
-          <a:lstStyle/>
-          <a:p>
-            <a:pPr indent="0" marL="0">
-              <a:buNone/>
-            </a:pPr>
-            <a:r>
-              <a:rPr lang="en-US" sz="1600" b="1" dirty="0">
+          <p:cNvPr id="7" name="Shape 4"/>
+          <p:cNvSpPr/>
+          <p:nvPr/>
+        </p:nvSpPr>
+        <p:spPr>
+          <a:xfrm>
+            <a:off x="640080" y="1783080"/>
+            <a:ext cx="5349240" cy="1856232"/>
+          </a:xfrm>
+          <a:prstGeom prst="roundRect">
+            <a:avLst>
+              <a:gd name="adj" fmla="val 10837"/>
+            </a:avLst>
+          </a:prstGeom>
+          <a:solidFill>
+            <a:srgbClr val="FFFFFF"/>
+          </a:solidFill>
+          <a:ln w="12700">
+            <a:solidFill>
+              <a:srgbClr val="FFFFFF">
+                <a:alpha val="0"/>
+              </a:srgbClr>
+            </a:solidFill>
+            <a:prstDash val="solid"/>
+          </a:ln>
+        </p:spPr>
+      </p:sp>
+      <p:sp>
+        <p:nvSpPr>
+          <p:cNvPr id="8" name="Text 5"/>
+          <p:cNvSpPr/>
+          <p:nvPr/>
+        </p:nvSpPr>
+        <p:spPr>
+          <a:xfrm>
+            <a:off x="868680" y="1947672"/>
+            <a:ext cx="4892040" cy="274320"/>
+          </a:xfrm>
+          <a:prstGeom prst="rect">
+            <a:avLst/>
+          </a:prstGeom>
+          <a:noFill/>
+          <a:ln/>
+        </p:spPr>
+        <p:txBody>
+          <a:bodyPr wrap="square" lIns="0" tIns="0" rIns="0" bIns="0" rtlCol="0" anchor="ctr"/>
+          <a:lstStyle/>
+          <a:p>
+            <a:pPr indent="0" marL="0">
+              <a:buNone/>
+            </a:pPr>
+            <a:r>
+              <a:rPr lang="en-US" sz="1400" b="1" dirty="0">
                 <a:solidFill>
                   <a:srgbClr val="405394"/>
                 </a:solidFill>
@@ -5590,38 +7623,38 @@
                 <a:ea typeface="Apple SD Gothic Neo" pitchFamily="34" charset="-122"/>
                 <a:cs typeface="Apple SD Gothic Neo" pitchFamily="34" charset="-120"/>
               </a:rPr>
-              <a:t>01</a:t>
-            </a:r>
-            <a:endParaRPr lang="en-US" sz="1600" dirty="0"/>
-          </a:p>
-        </p:txBody>
-      </p:sp>
-      <p:sp>
-        <p:nvSpPr>
-          <p:cNvPr id="8" name="Text 5"/>
-          <p:cNvSpPr/>
-          <p:nvPr/>
-        </p:nvSpPr>
-        <p:spPr>
-          <a:xfrm>
-            <a:off x="1280160" y="2011680"/>
-            <a:ext cx="9784080" cy="411480"/>
-          </a:xfrm>
-          <a:prstGeom prst="rect">
-            <a:avLst/>
-          </a:prstGeom>
-          <a:noFill/>
-          <a:ln/>
-        </p:spPr>
-        <p:txBody>
-          <a:bodyPr wrap="square" lIns="0" tIns="0" rIns="0" bIns="0" rtlCol="0" anchor="ctr"/>
-          <a:lstStyle/>
-          <a:p>
-            <a:pPr indent="0" marL="0">
-              <a:buNone/>
-            </a:pPr>
-            <a:r>
-              <a:rPr lang="en-US" sz="2300" b="1" dirty="0">
+              <a:t>01  음성 → 원문</a:t>
+            </a:r>
+            <a:endParaRPr lang="en-US" sz="1400" dirty="0"/>
+          </a:p>
+        </p:txBody>
+      </p:sp>
+      <p:sp>
+        <p:nvSpPr>
+          <p:cNvPr id="9" name="Text 6"/>
+          <p:cNvSpPr/>
+          <p:nvPr/>
+        </p:nvSpPr>
+        <p:spPr>
+          <a:xfrm>
+            <a:off x="868680" y="2377440"/>
+            <a:ext cx="4892040" cy="438912"/>
+          </a:xfrm>
+          <a:prstGeom prst="rect">
+            <a:avLst/>
+          </a:prstGeom>
+          <a:noFill/>
+          <a:ln/>
+        </p:spPr>
+        <p:txBody>
+          <a:bodyPr wrap="square" lIns="0" tIns="0" rIns="0" bIns="0" rtlCol="0" anchor="ctr"/>
+          <a:lstStyle/>
+          <a:p>
+            <a:pPr indent="0" marL="0">
+              <a:buNone/>
+            </a:pPr>
+            <a:r>
+              <a:rPr lang="en-US" sz="2600" b="1" dirty="0">
                 <a:solidFill>
                   <a:srgbClr val="242938"/>
                 </a:solidFill>
@@ -5629,22 +7662,22 @@
                 <a:ea typeface="Apple SD Gothic Neo" pitchFamily="34" charset="-122"/>
                 <a:cs typeface="Apple SD Gothic Neo" pitchFamily="34" charset="-120"/>
               </a:rPr>
-              <a:t>서버가 원본</a:t>
-            </a:r>
-            <a:endParaRPr lang="en-US" sz="2300" dirty="0"/>
-          </a:p>
-        </p:txBody>
-      </p:sp>
-      <p:sp>
-        <p:nvSpPr>
-          <p:cNvPr id="9" name="Text 6"/>
-          <p:cNvSpPr/>
-          <p:nvPr/>
-        </p:nvSpPr>
-        <p:spPr>
-          <a:xfrm>
-            <a:off x="1280160" y="2542032"/>
-            <a:ext cx="9784080" cy="731520"/>
+              <a:t>Nemotron 3.5 ASR</a:t>
+            </a:r>
+            <a:endParaRPr lang="en-US" sz="2600" dirty="0"/>
+          </a:p>
+        </p:txBody>
+      </p:sp>
+      <p:sp>
+        <p:nvSpPr>
+          <p:cNvPr id="10" name="Text 7"/>
+          <p:cNvSpPr/>
+          <p:nvPr/>
+        </p:nvSpPr>
+        <p:spPr>
+          <a:xfrm>
+            <a:off x="868680" y="2880360"/>
+            <a:ext cx="4892040" cy="274320"/>
           </a:xfrm>
           <a:prstGeom prst="rect">
             <a:avLst/>
@@ -5668,7 +7701,7 @@
                 <a:ea typeface="Apple SD Gothic Neo" pitchFamily="34" charset="-122"/>
                 <a:cs typeface="Apple SD Gothic Neo" pitchFamily="34" charset="-120"/>
               </a:rPr>
-              <a:t>기기에는 암호화된 전송 대기만</a:t>
+              <a:t>Streaming 0.6B · Q8 GGUF</a:t>
             </a:r>
             <a:endParaRPr lang="en-US" sz="1700" dirty="0"/>
           </a:p>
@@ -5676,30 +7709,98 @@
       </p:sp>
       <p:sp>
         <p:nvSpPr>
-          <p:cNvPr id="10" name="Text 7"/>
-          <p:cNvSpPr/>
-          <p:nvPr/>
-        </p:nvSpPr>
-        <p:spPr>
-          <a:xfrm>
-            <a:off x="731520" y="3429000"/>
-            <a:ext cx="502920" cy="365760"/>
-          </a:xfrm>
-          <a:prstGeom prst="rect">
-            <a:avLst/>
-          </a:prstGeom>
-          <a:noFill/>
-          <a:ln/>
-        </p:spPr>
-        <p:txBody>
-          <a:bodyPr wrap="square" lIns="0" tIns="0" rIns="0" bIns="0" rtlCol="0" anchor="ctr"/>
-          <a:lstStyle/>
-          <a:p>
-            <a:pPr indent="0" marL="0">
-              <a:buNone/>
-            </a:pPr>
-            <a:r>
-              <a:rPr lang="en-US" sz="1600" b="1" dirty="0">
+          <p:cNvPr id="11" name="Text 8"/>
+          <p:cNvSpPr/>
+          <p:nvPr/>
+        </p:nvSpPr>
+        <p:spPr>
+          <a:xfrm>
+            <a:off x="868680" y="3264408"/>
+            <a:ext cx="4892040" cy="228600"/>
+          </a:xfrm>
+          <a:prstGeom prst="rect">
+            <a:avLst/>
+          </a:prstGeom>
+          <a:noFill/>
+          <a:ln/>
+        </p:spPr>
+        <p:txBody>
+          <a:bodyPr wrap="square" lIns="0" tIns="0" rIns="0" bIns="0" rtlCol="0" anchor="ctr"/>
+          <a:lstStyle/>
+          <a:p>
+            <a:pPr indent="0" marL="0">
+              <a:buNone/>
+            </a:pPr>
+            <a:r>
+              <a:rPr lang="en-US" sz="1500" dirty="0">
+                <a:solidFill>
+                  <a:srgbClr val="626B80"/>
+                </a:solidFill>
+                <a:latin typeface="Apple SD Gothic Neo" pitchFamily="34" charset="0"/>
+                <a:ea typeface="Apple SD Gothic Neo" pitchFamily="34" charset="-122"/>
+                <a:cs typeface="Apple SD Gothic Neo" pitchFamily="34" charset="-120"/>
+              </a:rPr>
+              <a:t>NeMo-Speech.cpp / Metal</a:t>
+            </a:r>
+            <a:endParaRPr lang="en-US" sz="1500" dirty="0"/>
+          </a:p>
+        </p:txBody>
+      </p:sp>
+      <p:sp>
+        <p:nvSpPr>
+          <p:cNvPr id="12" name="Shape 9"/>
+          <p:cNvSpPr/>
+          <p:nvPr/>
+        </p:nvSpPr>
+        <p:spPr>
+          <a:xfrm>
+            <a:off x="6263640" y="1783080"/>
+            <a:ext cx="5349240" cy="1856232"/>
+          </a:xfrm>
+          <a:prstGeom prst="roundRect">
+            <a:avLst>
+              <a:gd name="adj" fmla="val 10837"/>
+            </a:avLst>
+          </a:prstGeom>
+          <a:solidFill>
+            <a:srgbClr val="FFFFFF"/>
+          </a:solidFill>
+          <a:ln w="12700">
+            <a:solidFill>
+              <a:srgbClr val="FFFFFF">
+                <a:alpha val="0"/>
+              </a:srgbClr>
+            </a:solidFill>
+            <a:prstDash val="solid"/>
+          </a:ln>
+        </p:spPr>
+      </p:sp>
+      <p:sp>
+        <p:nvSpPr>
+          <p:cNvPr id="13" name="Text 10"/>
+          <p:cNvSpPr/>
+          <p:nvPr/>
+        </p:nvSpPr>
+        <p:spPr>
+          <a:xfrm>
+            <a:off x="6492240" y="1947672"/>
+            <a:ext cx="4892040" cy="274320"/>
+          </a:xfrm>
+          <a:prstGeom prst="rect">
+            <a:avLst/>
+          </a:prstGeom>
+          <a:noFill/>
+          <a:ln/>
+        </p:spPr>
+        <p:txBody>
+          <a:bodyPr wrap="square" lIns="0" tIns="0" rIns="0" bIns="0" rtlCol="0" anchor="ctr"/>
+          <a:lstStyle/>
+          <a:p>
+            <a:pPr indent="0" marL="0">
+              <a:buNone/>
+            </a:pPr>
+            <a:r>
+              <a:rPr lang="en-US" sz="1400" b="1" dirty="0">
                 <a:solidFill>
                   <a:srgbClr val="405394"/>
                 </a:solidFill>
@@ -5707,38 +7808,38 @@
                 <a:ea typeface="Apple SD Gothic Neo" pitchFamily="34" charset="-122"/>
                 <a:cs typeface="Apple SD Gothic Neo" pitchFamily="34" charset="-120"/>
               </a:rPr>
-              <a:t>02</a:t>
-            </a:r>
-            <a:endParaRPr lang="en-US" sz="1600" dirty="0"/>
-          </a:p>
-        </p:txBody>
-      </p:sp>
-      <p:sp>
-        <p:nvSpPr>
-          <p:cNvPr id="11" name="Text 8"/>
-          <p:cNvSpPr/>
-          <p:nvPr/>
-        </p:nvSpPr>
-        <p:spPr>
-          <a:xfrm>
-            <a:off x="1280160" y="3429000"/>
-            <a:ext cx="9784080" cy="411480"/>
-          </a:xfrm>
-          <a:prstGeom prst="rect">
-            <a:avLst/>
-          </a:prstGeom>
-          <a:noFill/>
-          <a:ln/>
-        </p:spPr>
-        <p:txBody>
-          <a:bodyPr wrap="square" lIns="0" tIns="0" rIns="0" bIns="0" rtlCol="0" anchor="ctr"/>
-          <a:lstStyle/>
-          <a:p>
-            <a:pPr indent="0" marL="0">
-              <a:buNone/>
-            </a:pPr>
-            <a:r>
-              <a:rPr lang="en-US" sz="2300" b="1" dirty="0">
+              <a:t>02  원문 → 번역</a:t>
+            </a:r>
+            <a:endParaRPr lang="en-US" sz="1400" dirty="0"/>
+          </a:p>
+        </p:txBody>
+      </p:sp>
+      <p:sp>
+        <p:nvSpPr>
+          <p:cNvPr id="14" name="Text 11"/>
+          <p:cNvSpPr/>
+          <p:nvPr/>
+        </p:nvSpPr>
+        <p:spPr>
+          <a:xfrm>
+            <a:off x="6492240" y="2377440"/>
+            <a:ext cx="4892040" cy="438912"/>
+          </a:xfrm>
+          <a:prstGeom prst="rect">
+            <a:avLst/>
+          </a:prstGeom>
+          <a:noFill/>
+          <a:ln/>
+        </p:spPr>
+        <p:txBody>
+          <a:bodyPr wrap="square" lIns="0" tIns="0" rIns="0" bIns="0" rtlCol="0" anchor="ctr"/>
+          <a:lstStyle/>
+          <a:p>
+            <a:pPr indent="0" marL="0">
+              <a:buNone/>
+            </a:pPr>
+            <a:r>
+              <a:rPr lang="en-US" sz="2600" b="1" dirty="0">
                 <a:solidFill>
                   <a:srgbClr val="242938"/>
                 </a:solidFill>
@@ -5746,22 +7847,22 @@
                 <a:ea typeface="Apple SD Gothic Neo" pitchFamily="34" charset="-122"/>
                 <a:cs typeface="Apple SD Gothic Neo" pitchFamily="34" charset="-120"/>
               </a:rPr>
-              <a:t>재전송·충돌·재시작에 대비</a:t>
-            </a:r>
-            <a:endParaRPr lang="en-US" sz="2300" dirty="0"/>
-          </a:p>
-        </p:txBody>
-      </p:sp>
-      <p:sp>
-        <p:nvSpPr>
-          <p:cNvPr id="12" name="Text 9"/>
-          <p:cNvSpPr/>
-          <p:nvPr/>
-        </p:nvSpPr>
-        <p:spPr>
-          <a:xfrm>
-            <a:off x="1280160" y="3959352"/>
-            <a:ext cx="9784080" cy="731520"/>
+              <a:t>TranslateGemma 12B</a:t>
+            </a:r>
+            <a:endParaRPr lang="en-US" sz="2600" dirty="0"/>
+          </a:p>
+        </p:txBody>
+      </p:sp>
+      <p:sp>
+        <p:nvSpPr>
+          <p:cNvPr id="15" name="Text 12"/>
+          <p:cNvSpPr/>
+          <p:nvPr/>
+        </p:nvSpPr>
+        <p:spPr>
+          <a:xfrm>
+            <a:off x="6492240" y="2880360"/>
+            <a:ext cx="4892040" cy="274320"/>
           </a:xfrm>
           <a:prstGeom prst="rect">
             <a:avLst/>
@@ -5785,7 +7886,7 @@
                 <a:ea typeface="Apple SD Gothic Neo" pitchFamily="34" charset="-122"/>
                 <a:cs typeface="Apple SD Gothic Neo" pitchFamily="34" charset="-120"/>
               </a:rPr>
-              <a:t>중복 반영 방지 / 충돌 시 내용 보존 / AI 작업 복구</a:t>
+              <a:t>Q4_K_M</a:t>
             </a:r>
             <a:endParaRPr lang="en-US" sz="1700" dirty="0"/>
           </a:p>
@@ -5793,30 +7894,98 @@
       </p:sp>
       <p:sp>
         <p:nvSpPr>
-          <p:cNvPr id="13" name="Text 10"/>
-          <p:cNvSpPr/>
-          <p:nvPr/>
-        </p:nvSpPr>
-        <p:spPr>
-          <a:xfrm>
-            <a:off x="731520" y="4846320"/>
-            <a:ext cx="502920" cy="365760"/>
-          </a:xfrm>
-          <a:prstGeom prst="rect">
-            <a:avLst/>
-          </a:prstGeom>
-          <a:noFill/>
-          <a:ln/>
-        </p:spPr>
-        <p:txBody>
-          <a:bodyPr wrap="square" lIns="0" tIns="0" rIns="0" bIns="0" rtlCol="0" anchor="ctr"/>
-          <a:lstStyle/>
-          <a:p>
-            <a:pPr indent="0" marL="0">
-              <a:buNone/>
-            </a:pPr>
-            <a:r>
-              <a:rPr lang="en-US" sz="1600" b="1" dirty="0">
+          <p:cNvPr id="16" name="Text 13"/>
+          <p:cNvSpPr/>
+          <p:nvPr/>
+        </p:nvSpPr>
+        <p:spPr>
+          <a:xfrm>
+            <a:off x="6492240" y="3264408"/>
+            <a:ext cx="4892040" cy="228600"/>
+          </a:xfrm>
+          <a:prstGeom prst="rect">
+            <a:avLst/>
+          </a:prstGeom>
+          <a:noFill/>
+          <a:ln/>
+        </p:spPr>
+        <p:txBody>
+          <a:bodyPr wrap="square" lIns="0" tIns="0" rIns="0" bIns="0" rtlCol="0" anchor="ctr"/>
+          <a:lstStyle/>
+          <a:p>
+            <a:pPr indent="0" marL="0">
+              <a:buNone/>
+            </a:pPr>
+            <a:r>
+              <a:rPr lang="en-US" sz="1500" dirty="0">
+                <a:solidFill>
+                  <a:srgbClr val="626B80"/>
+                </a:solidFill>
+                <a:latin typeface="Apple SD Gothic Neo" pitchFamily="34" charset="0"/>
+                <a:ea typeface="Apple SD Gothic Neo" pitchFamily="34" charset="-122"/>
+                <a:cs typeface="Apple SD Gothic Neo" pitchFamily="34" charset="-120"/>
+              </a:rPr>
+              <a:t>Ollama / 번역 전용</a:t>
+            </a:r>
+            <a:endParaRPr lang="en-US" sz="1500" dirty="0"/>
+          </a:p>
+        </p:txBody>
+      </p:sp>
+      <p:sp>
+        <p:nvSpPr>
+          <p:cNvPr id="17" name="Shape 14"/>
+          <p:cNvSpPr/>
+          <p:nvPr/>
+        </p:nvSpPr>
+        <p:spPr>
+          <a:xfrm>
+            <a:off x="640080" y="3822192"/>
+            <a:ext cx="5349240" cy="1856232"/>
+          </a:xfrm>
+          <a:prstGeom prst="roundRect">
+            <a:avLst>
+              <a:gd name="adj" fmla="val 10837"/>
+            </a:avLst>
+          </a:prstGeom>
+          <a:solidFill>
+            <a:srgbClr val="FFFFFF"/>
+          </a:solidFill>
+          <a:ln w="12700">
+            <a:solidFill>
+              <a:srgbClr val="FFFFFF">
+                <a:alpha val="0"/>
+              </a:srgbClr>
+            </a:solidFill>
+            <a:prstDash val="solid"/>
+          </a:ln>
+        </p:spPr>
+      </p:sp>
+      <p:sp>
+        <p:nvSpPr>
+          <p:cNvPr id="18" name="Text 15"/>
+          <p:cNvSpPr/>
+          <p:nvPr/>
+        </p:nvSpPr>
+        <p:spPr>
+          <a:xfrm>
+            <a:off x="868680" y="3986784"/>
+            <a:ext cx="4892040" cy="274320"/>
+          </a:xfrm>
+          <a:prstGeom prst="rect">
+            <a:avLst/>
+          </a:prstGeom>
+          <a:noFill/>
+          <a:ln/>
+        </p:spPr>
+        <p:txBody>
+          <a:bodyPr wrap="square" lIns="0" tIns="0" rIns="0" bIns="0" rtlCol="0" anchor="ctr"/>
+          <a:lstStyle/>
+          <a:p>
+            <a:pPr indent="0" marL="0">
+              <a:buNone/>
+            </a:pPr>
+            <a:r>
+              <a:rPr lang="en-US" sz="1400" b="1" dirty="0">
                 <a:solidFill>
                   <a:srgbClr val="405394"/>
                 </a:solidFill>
@@ -5824,38 +7993,38 @@
                 <a:ea typeface="Apple SD Gothic Neo" pitchFamily="34" charset="-122"/>
                 <a:cs typeface="Apple SD Gothic Neo" pitchFamily="34" charset="-120"/>
               </a:rPr>
-              <a:t>03</a:t>
-            </a:r>
-            <a:endParaRPr lang="en-US" sz="1600" dirty="0"/>
-          </a:p>
-        </p:txBody>
-      </p:sp>
-      <p:sp>
-        <p:nvSpPr>
-          <p:cNvPr id="14" name="Text 11"/>
-          <p:cNvSpPr/>
-          <p:nvPr/>
-        </p:nvSpPr>
-        <p:spPr>
-          <a:xfrm>
-            <a:off x="1280160" y="4846320"/>
-            <a:ext cx="9784080" cy="411480"/>
-          </a:xfrm>
-          <a:prstGeom prst="rect">
-            <a:avLst/>
-          </a:prstGeom>
-          <a:noFill/>
-          <a:ln/>
-        </p:spPr>
-        <p:txBody>
-          <a:bodyPr wrap="square" lIns="0" tIns="0" rIns="0" bIns="0" rtlCol="0" anchor="ctr"/>
-          <a:lstStyle/>
-          <a:p>
-            <a:pPr indent="0" marL="0">
-              <a:buNone/>
-            </a:pPr>
-            <a:r>
-              <a:rPr lang="en-US" sz="2300" b="1" dirty="0">
+              <a:t>03  기록 → 정리</a:t>
+            </a:r>
+            <a:endParaRPr lang="en-US" sz="1400" dirty="0"/>
+          </a:p>
+        </p:txBody>
+      </p:sp>
+      <p:sp>
+        <p:nvSpPr>
+          <p:cNvPr id="19" name="Text 16"/>
+          <p:cNvSpPr/>
+          <p:nvPr/>
+        </p:nvSpPr>
+        <p:spPr>
+          <a:xfrm>
+            <a:off x="868680" y="4416552"/>
+            <a:ext cx="4892040" cy="438912"/>
+          </a:xfrm>
+          <a:prstGeom prst="rect">
+            <a:avLst/>
+          </a:prstGeom>
+          <a:noFill/>
+          <a:ln/>
+        </p:spPr>
+        <p:txBody>
+          <a:bodyPr wrap="square" lIns="0" tIns="0" rIns="0" bIns="0" rtlCol="0" anchor="ctr"/>
+          <a:lstStyle/>
+          <a:p>
+            <a:pPr indent="0" marL="0">
+              <a:buNone/>
+            </a:pPr>
+            <a:r>
+              <a:rPr lang="en-US" sz="2600" b="1" dirty="0">
                 <a:solidFill>
                   <a:srgbClr val="242938"/>
                 </a:solidFill>
@@ -5863,22 +8032,22 @@
                 <a:ea typeface="Apple SD Gothic Neo" pitchFamily="34" charset="-122"/>
                 <a:cs typeface="Apple SD Gothic Neo" pitchFamily="34" charset="-120"/>
               </a:rPr>
-              <a:t>삭제한 계정이 되살아나지 않도록</a:t>
-            </a:r>
-            <a:endParaRPr lang="en-US" sz="2300" dirty="0"/>
-          </a:p>
-        </p:txBody>
-      </p:sp>
-      <p:sp>
-        <p:nvSpPr>
-          <p:cNvPr id="15" name="Text 12"/>
-          <p:cNvSpPr/>
-          <p:nvPr/>
-        </p:nvSpPr>
-        <p:spPr>
-          <a:xfrm>
-            <a:off x="1280160" y="5376672"/>
-            <a:ext cx="9784080" cy="731520"/>
+              <a:t>Gemma 4 12B</a:t>
+            </a:r>
+            <a:endParaRPr lang="en-US" sz="2600" dirty="0"/>
+          </a:p>
+        </p:txBody>
+      </p:sp>
+      <p:sp>
+        <p:nvSpPr>
+          <p:cNvPr id="20" name="Text 17"/>
+          <p:cNvSpPr/>
+          <p:nvPr/>
+        </p:nvSpPr>
+        <p:spPr>
+          <a:xfrm>
+            <a:off x="868680" y="4919472"/>
+            <a:ext cx="4892040" cy="274320"/>
           </a:xfrm>
           <a:prstGeom prst="rect">
             <a:avLst/>
@@ -5902,7 +8071,270 @@
                 <a:ea typeface="Apple SD Gothic Neo" pitchFamily="34" charset="-122"/>
                 <a:cs typeface="Apple SD Gothic Neo" pitchFamily="34" charset="-120"/>
               </a:rPr>
-              <a:t>앱·웹 삭제 경로 / 백업 30일 정책 / 복원 시 삭제 이력 반영</a:t>
+              <a:t>IT QAT</a:t>
+            </a:r>
+            <a:endParaRPr lang="en-US" sz="1700" dirty="0"/>
+          </a:p>
+        </p:txBody>
+      </p:sp>
+      <p:sp>
+        <p:nvSpPr>
+          <p:cNvPr id="21" name="Text 18"/>
+          <p:cNvSpPr/>
+          <p:nvPr/>
+        </p:nvSpPr>
+        <p:spPr>
+          <a:xfrm>
+            <a:off x="868680" y="5303520"/>
+            <a:ext cx="4892040" cy="228600"/>
+          </a:xfrm>
+          <a:prstGeom prst="rect">
+            <a:avLst/>
+          </a:prstGeom>
+          <a:noFill/>
+          <a:ln/>
+        </p:spPr>
+        <p:txBody>
+          <a:bodyPr wrap="square" lIns="0" tIns="0" rIns="0" bIns="0" rtlCol="0" anchor="ctr"/>
+          <a:lstStyle/>
+          <a:p>
+            <a:pPr indent="0" marL="0">
+              <a:buNone/>
+            </a:pPr>
+            <a:r>
+              <a:rPr lang="en-US" sz="1500" dirty="0">
+                <a:solidFill>
+                  <a:srgbClr val="626B80"/>
+                </a:solidFill>
+                <a:latin typeface="Apple SD Gothic Neo" pitchFamily="34" charset="0"/>
+                <a:ea typeface="Apple SD Gothic Neo" pitchFamily="34" charset="-122"/>
+                <a:cs typeface="Apple SD Gothic Neo" pitchFamily="34" charset="-120"/>
+              </a:rPr>
+              <a:t>Ollama / JSON + 서버 검증</a:t>
+            </a:r>
+            <a:endParaRPr lang="en-US" sz="1500" dirty="0"/>
+          </a:p>
+        </p:txBody>
+      </p:sp>
+      <p:sp>
+        <p:nvSpPr>
+          <p:cNvPr id="22" name="Shape 19"/>
+          <p:cNvSpPr/>
+          <p:nvPr/>
+        </p:nvSpPr>
+        <p:spPr>
+          <a:xfrm>
+            <a:off x="6263640" y="3822192"/>
+            <a:ext cx="5349240" cy="1856232"/>
+          </a:xfrm>
+          <a:prstGeom prst="roundRect">
+            <a:avLst>
+              <a:gd name="adj" fmla="val 10837"/>
+            </a:avLst>
+          </a:prstGeom>
+          <a:solidFill>
+            <a:srgbClr val="FFFFFF"/>
+          </a:solidFill>
+          <a:ln w="12700">
+            <a:solidFill>
+              <a:srgbClr val="FFFFFF">
+                <a:alpha val="0"/>
+              </a:srgbClr>
+            </a:solidFill>
+            <a:prstDash val="solid"/>
+          </a:ln>
+        </p:spPr>
+      </p:sp>
+      <p:sp>
+        <p:nvSpPr>
+          <p:cNvPr id="23" name="Text 20"/>
+          <p:cNvSpPr/>
+          <p:nvPr/>
+        </p:nvSpPr>
+        <p:spPr>
+          <a:xfrm>
+            <a:off x="6492240" y="3986784"/>
+            <a:ext cx="4892040" cy="274320"/>
+          </a:xfrm>
+          <a:prstGeom prst="rect">
+            <a:avLst/>
+          </a:prstGeom>
+          <a:noFill/>
+          <a:ln/>
+        </p:spPr>
+        <p:txBody>
+          <a:bodyPr wrap="square" lIns="0" tIns="0" rIns="0" bIns="0" rtlCol="0" anchor="ctr"/>
+          <a:lstStyle/>
+          <a:p>
+            <a:pPr indent="0" marL="0">
+              <a:buNone/>
+            </a:pPr>
+            <a:r>
+              <a:rPr lang="en-US" sz="1400" b="1" dirty="0">
+                <a:solidFill>
+                  <a:srgbClr val="405394"/>
+                </a:solidFill>
+                <a:latin typeface="Apple SD Gothic Neo" pitchFamily="34" charset="0"/>
+                <a:ea typeface="Apple SD Gothic Neo" pitchFamily="34" charset="-122"/>
+                <a:cs typeface="Apple SD Gothic Neo" pitchFamily="34" charset="-120"/>
+              </a:rPr>
+              <a:t>04  번역 → 음성</a:t>
+            </a:r>
+            <a:endParaRPr lang="en-US" sz="1400" dirty="0"/>
+          </a:p>
+        </p:txBody>
+      </p:sp>
+      <p:sp>
+        <p:nvSpPr>
+          <p:cNvPr id="24" name="Text 21"/>
+          <p:cNvSpPr/>
+          <p:nvPr/>
+        </p:nvSpPr>
+        <p:spPr>
+          <a:xfrm>
+            <a:off x="6492240" y="4416552"/>
+            <a:ext cx="4892040" cy="438912"/>
+          </a:xfrm>
+          <a:prstGeom prst="rect">
+            <a:avLst/>
+          </a:prstGeom>
+          <a:noFill/>
+          <a:ln/>
+        </p:spPr>
+        <p:txBody>
+          <a:bodyPr wrap="square" lIns="0" tIns="0" rIns="0" bIns="0" rtlCol="0" anchor="ctr"/>
+          <a:lstStyle/>
+          <a:p>
+            <a:pPr indent="0" marL="0">
+              <a:buNone/>
+            </a:pPr>
+            <a:r>
+              <a:rPr lang="en-US" sz="2600" b="1" dirty="0">
+                <a:solidFill>
+                  <a:srgbClr val="242938"/>
+                </a:solidFill>
+                <a:latin typeface="Apple SD Gothic Neo" pitchFamily="34" charset="0"/>
+                <a:ea typeface="Apple SD Gothic Neo" pitchFamily="34" charset="-122"/>
+                <a:cs typeface="Apple SD Gothic Neo" pitchFamily="34" charset="-120"/>
+              </a:rPr>
+              <a:t>Qwen3-TTS 0.6B</a:t>
+            </a:r>
+            <a:endParaRPr lang="en-US" sz="2600" dirty="0"/>
+          </a:p>
+        </p:txBody>
+      </p:sp>
+      <p:sp>
+        <p:nvSpPr>
+          <p:cNvPr id="25" name="Text 22"/>
+          <p:cNvSpPr/>
+          <p:nvPr/>
+        </p:nvSpPr>
+        <p:spPr>
+          <a:xfrm>
+            <a:off x="6492240" y="4919472"/>
+            <a:ext cx="4892040" cy="274320"/>
+          </a:xfrm>
+          <a:prstGeom prst="rect">
+            <a:avLst/>
+          </a:prstGeom>
+          <a:noFill/>
+          <a:ln/>
+        </p:spPr>
+        <p:txBody>
+          <a:bodyPr wrap="square" lIns="0" tIns="0" rIns="0" bIns="0" rtlCol="0" anchor="ctr"/>
+          <a:lstStyle/>
+          <a:p>
+            <a:pPr indent="0" marL="0">
+              <a:buNone/>
+            </a:pPr>
+            <a:r>
+              <a:rPr lang="en-US" sz="1700" dirty="0">
+                <a:solidFill>
+                  <a:srgbClr val="626B80"/>
+                </a:solidFill>
+                <a:latin typeface="Apple SD Gothic Neo" pitchFamily="34" charset="0"/>
+                <a:ea typeface="Apple SD Gothic Neo" pitchFamily="34" charset="-122"/>
+                <a:cs typeface="Apple SD Gothic Neo" pitchFamily="34" charset="-120"/>
+              </a:rPr>
+              <a:t>12Hz CustomVoice · bf16</a:t>
+            </a:r>
+            <a:endParaRPr lang="en-US" sz="1700" dirty="0"/>
+          </a:p>
+        </p:txBody>
+      </p:sp>
+      <p:sp>
+        <p:nvSpPr>
+          <p:cNvPr id="26" name="Text 23"/>
+          <p:cNvSpPr/>
+          <p:nvPr/>
+        </p:nvSpPr>
+        <p:spPr>
+          <a:xfrm>
+            <a:off x="6492240" y="5303520"/>
+            <a:ext cx="4892040" cy="228600"/>
+          </a:xfrm>
+          <a:prstGeom prst="rect">
+            <a:avLst/>
+          </a:prstGeom>
+          <a:noFill/>
+          <a:ln/>
+        </p:spPr>
+        <p:txBody>
+          <a:bodyPr wrap="square" lIns="0" tIns="0" rIns="0" bIns="0" rtlCol="0" anchor="ctr"/>
+          <a:lstStyle/>
+          <a:p>
+            <a:pPr indent="0" marL="0">
+              <a:buNone/>
+            </a:pPr>
+            <a:r>
+              <a:rPr lang="en-US" sz="1500" dirty="0">
+                <a:solidFill>
+                  <a:srgbClr val="626B80"/>
+                </a:solidFill>
+                <a:latin typeface="Apple SD Gothic Neo" pitchFamily="34" charset="0"/>
+                <a:ea typeface="Apple SD Gothic Neo" pitchFamily="34" charset="-122"/>
+                <a:cs typeface="Apple SD Gothic Neo" pitchFamily="34" charset="-120"/>
+              </a:rPr>
+              <a:t>MLX / 고정 음색</a:t>
+            </a:r>
+            <a:endParaRPr lang="en-US" sz="1500" dirty="0"/>
+          </a:p>
+        </p:txBody>
+      </p:sp>
+      <p:sp>
+        <p:nvSpPr>
+          <p:cNvPr id="27" name="Text 24"/>
+          <p:cNvSpPr/>
+          <p:nvPr/>
+        </p:nvSpPr>
+        <p:spPr>
+          <a:xfrm>
+            <a:off x="777240" y="6016752"/>
+            <a:ext cx="10789920" cy="274320"/>
+          </a:xfrm>
+          <a:prstGeom prst="rect">
+            <a:avLst/>
+          </a:prstGeom>
+          <a:noFill/>
+          <a:ln/>
+        </p:spPr>
+        <p:txBody>
+          <a:bodyPr wrap="square" lIns="0" tIns="0" rIns="0" bIns="0" rtlCol="0" anchor="ctr"/>
+          <a:lstStyle/>
+          <a:p>
+            <a:pPr indent="0" marL="0">
+              <a:buNone/>
+            </a:pPr>
+            <a:r>
+              <a:rPr lang="en-US" sz="1700" b="1" dirty="0">
+                <a:solidFill>
+                  <a:srgbClr val="405394"/>
+                </a:solidFill>
+                <a:latin typeface="Apple SD Gothic Neo" pitchFamily="34" charset="0"/>
+                <a:ea typeface="Apple SD Gothic Neo" pitchFamily="34" charset="-122"/>
+                <a:cs typeface="Apple SD Gothic Neo" pitchFamily="34" charset="-120"/>
+              </a:rPr>
+              <a:t>Mac 로컬 추론 · 유료 API 없음 · 앱 지원 언어: 한국어 / 영어 / 일본어</a:t>
             </a:r>
             <a:endParaRPr lang="en-US" sz="1700" dirty="0"/>
           </a:p>
@@ -5973,7 +8405,7 @@
                 <a:ea typeface="Apple SD Gothic Neo" pitchFamily="34" charset="-122"/>
                 <a:cs typeface="Apple SD Gothic Neo" pitchFamily="34" charset="-120"/>
               </a:rPr>
-              <a:t>SPEECHBRIDGE  /  VALIDATION</a:t>
+              <a:t>SPEECHBRIDGE  /  MODELS / TEXT</a:t>
             </a:r>
             <a:endParaRPr lang="en-US" sz="1200" dirty="0"/>
           </a:p>
@@ -6012,7 +8444,7 @@
                 <a:ea typeface="Apple SD Gothic Neo" pitchFamily="34" charset="-122"/>
                 <a:cs typeface="Apple SD Gothic Neo" pitchFamily="34" charset="-120"/>
               </a:rPr>
-              <a:t>동작한 것과, 아직 확인하지 않은 것을 구분합니다.</a:t>
+              <a:t>의미를 보존하고, 근거를 확인할 수 있도록.</a:t>
             </a:r>
             <a:endParaRPr lang="en-US" sz="3400" dirty="0"/>
           </a:p>
@@ -6104,12 +8536,12 @@
         </p:nvSpPr>
         <p:spPr>
           <a:xfrm>
-            <a:off x="640080" y="1920240"/>
-            <a:ext cx="5349240" cy="3611880"/>
+            <a:off x="640080" y="1828800"/>
+            <a:ext cx="5349240" cy="3858768"/>
           </a:xfrm>
           <a:prstGeom prst="roundRect">
             <a:avLst>
-              <a:gd name="adj" fmla="val 5570"/>
+              <a:gd name="adj" fmla="val 5213"/>
             </a:avLst>
           </a:prstGeom>
           <a:solidFill>
@@ -6133,12 +8565,12 @@
         </p:nvSpPr>
         <p:spPr>
           <a:xfrm>
-            <a:off x="6217920" y="1920240"/>
-            <a:ext cx="5349240" cy="3611880"/>
+            <a:off x="6217920" y="1828800"/>
+            <a:ext cx="5349240" cy="3858768"/>
           </a:xfrm>
           <a:prstGeom prst="roundRect">
             <a:avLst>
-              <a:gd name="adj" fmla="val 5570"/>
+              <a:gd name="adj" fmla="val 5213"/>
             </a:avLst>
           </a:prstGeom>
           <a:solidFill>
@@ -6162,24 +8594,24 @@
         </p:nvSpPr>
         <p:spPr>
           <a:xfrm>
-            <a:off x="914400" y="2286000"/>
-            <a:ext cx="4572000" cy="457200"/>
-          </a:xfrm>
-          <a:prstGeom prst="rect">
-            <a:avLst/>
-          </a:prstGeom>
-          <a:noFill/>
-          <a:ln/>
-        </p:spPr>
-        <p:txBody>
-          <a:bodyPr wrap="square" lIns="0" tIns="0" rIns="0" bIns="0" rtlCol="0" anchor="ctr"/>
-          <a:lstStyle/>
-          <a:p>
-            <a:pPr indent="0" marL="0">
-              <a:buNone/>
-            </a:pPr>
-            <a:r>
-              <a:rPr lang="en-US" sz="2800" b="1" dirty="0">
+            <a:off x="914400" y="2148840"/>
+            <a:ext cx="4800600" cy="457200"/>
+          </a:xfrm>
+          <a:prstGeom prst="rect">
+            <a:avLst/>
+          </a:prstGeom>
+          <a:noFill/>
+          <a:ln/>
+        </p:spPr>
+        <p:txBody>
+          <a:bodyPr wrap="square" lIns="0" tIns="0" rIns="0" bIns="0" rtlCol="0" anchor="ctr"/>
+          <a:lstStyle/>
+          <a:p>
+            <a:pPr indent="0" marL="0">
+              <a:buNone/>
+            </a:pPr>
+            <a:r>
+              <a:rPr lang="en-US" sz="2400" b="1" dirty="0">
                 <a:solidFill>
                   <a:srgbClr val="405394"/>
                 </a:solidFill>
@@ -6187,9 +8619,9 @@
                 <a:ea typeface="Apple SD Gothic Neo" pitchFamily="34" charset="-122"/>
                 <a:cs typeface="Apple SD Gothic Neo" pitchFamily="34" charset="-120"/>
               </a:rPr>
-              <a:t>직접 확인</a:t>
-            </a:r>
-            <a:endParaRPr lang="en-US" sz="2800" dirty="0"/>
+              <a:t>번역  /  TranslateGemma 12B</a:t>
+            </a:r>
+            <a:endParaRPr lang="en-US" sz="2400" dirty="0"/>
           </a:p>
         </p:txBody>
       </p:sp>
@@ -6201,8 +8633,47 @@
         </p:nvSpPr>
         <p:spPr>
           <a:xfrm>
-            <a:off x="914400" y="3063240"/>
-            <a:ext cx="4663440" cy="1920240"/>
+            <a:off x="914400" y="2926080"/>
+            <a:ext cx="4663440" cy="594360"/>
+          </a:xfrm>
+          <a:prstGeom prst="rect">
+            <a:avLst/>
+          </a:prstGeom>
+          <a:noFill/>
+          <a:ln/>
+        </p:spPr>
+        <p:txBody>
+          <a:bodyPr wrap="square" lIns="0" tIns="0" rIns="0" bIns="0" rtlCol="0" anchor="ctr"/>
+          <a:lstStyle/>
+          <a:p>
+            <a:pPr indent="0" marL="0">
+              <a:buNone/>
+            </a:pPr>
+            <a:r>
+              <a:rPr lang="en-US" sz="3000" b="1" dirty="0">
+                <a:solidFill>
+                  <a:srgbClr val="242938"/>
+                </a:solidFill>
+                <a:latin typeface="Apple SD Gothic Neo" pitchFamily="34" charset="0"/>
+                <a:ea typeface="Apple SD Gothic Neo" pitchFamily="34" charset="-122"/>
+                <a:cs typeface="Apple SD Gothic Neo" pitchFamily="34" charset="-120"/>
+              </a:rPr>
+              <a:t>대화의 의미 보존</a:t>
+            </a:r>
+            <a:endParaRPr lang="en-US" sz="3000" dirty="0"/>
+          </a:p>
+        </p:txBody>
+      </p:sp>
+      <p:sp>
+        <p:nvSpPr>
+          <p:cNvPr id="11" name="Text 8"/>
+          <p:cNvSpPr/>
+          <p:nvPr/>
+        </p:nvSpPr>
+        <p:spPr>
+          <a:xfrm>
+            <a:off x="914400" y="3813048"/>
+            <a:ext cx="4663440" cy="1188720"/>
           </a:xfrm>
           <a:prstGeom prst="rect">
             <a:avLst/>
@@ -6226,7 +8697,7 @@
                 <a:ea typeface="Apple SD Gothic Neo" pitchFamily="34" charset="-122"/>
                 <a:cs typeface="Apple SD Gothic Neo" pitchFamily="34" charset="-120"/>
               </a:rPr>
-              <a:t>번역 → 저장 → 요약 → 할 일</a:t>
+              <a:t>한국어 · 영어 · 일본어</a:t>
             </a:r>
             <a:endParaRPr lang="en-US" sz="2200" dirty="0"/>
           </a:p>
@@ -6243,7 +8714,7 @@
                 <a:ea typeface="Apple SD Gothic Neo" pitchFamily="34" charset="-122"/>
                 <a:cs typeface="Apple SD Gothic Neo" pitchFamily="34" charset="-120"/>
               </a:rPr>
-              <a:t>언어 반전 · 필터 · 화면 모드</a:t>
+              <a:t>수량 · 시간 · 부정 표현 · 이름</a:t>
             </a:r>
             <a:endParaRPr lang="en-US" sz="2200" dirty="0"/>
           </a:p>
@@ -6260,10 +8731,149 @@
                 <a:ea typeface="Apple SD Gothic Neo" pitchFamily="34" charset="-122"/>
                 <a:cs typeface="Apple SD Gothic Neo" pitchFamily="34" charset="-120"/>
               </a:rPr>
-              <a:t>재실행 · 연결 중단 후 복구</a:t>
+              <a:t>Mac에서 로컬 실행</a:t>
             </a:r>
             <a:endParaRPr lang="en-US" sz="2200" dirty="0"/>
           </a:p>
+        </p:txBody>
+      </p:sp>
+      <p:sp>
+        <p:nvSpPr>
+          <p:cNvPr id="12" name="Text 9"/>
+          <p:cNvSpPr/>
+          <p:nvPr/>
+        </p:nvSpPr>
+        <p:spPr>
+          <a:xfrm>
+            <a:off x="914400" y="5166360"/>
+            <a:ext cx="4663440" cy="274320"/>
+          </a:xfrm>
+          <a:prstGeom prst="rect">
+            <a:avLst/>
+          </a:prstGeom>
+          <a:noFill/>
+          <a:ln/>
+        </p:spPr>
+        <p:txBody>
+          <a:bodyPr wrap="square" lIns="0" tIns="0" rIns="0" bIns="0" rtlCol="0" anchor="ctr"/>
+          <a:lstStyle/>
+          <a:p>
+            <a:pPr indent="0" marL="0">
+              <a:buNone/>
+            </a:pPr>
+            <a:r>
+              <a:rPr lang="en-US" sz="1800" b="1" dirty="0">
+                <a:solidFill>
+                  <a:srgbClr val="405394"/>
+                </a:solidFill>
+                <a:latin typeface="Apple SD Gothic Neo" pitchFamily="34" charset="0"/>
+                <a:ea typeface="Apple SD Gothic Neo" pitchFamily="34" charset="-122"/>
+                <a:cs typeface="Apple SD Gothic Neo" pitchFamily="34" charset="-120"/>
+              </a:rPr>
+              <a:t>오역은 원문 확인 후 수정</a:t>
+            </a:r>
+            <a:endParaRPr lang="en-US" sz="1800" dirty="0"/>
+          </a:p>
+        </p:txBody>
+      </p:sp>
+      <p:sp>
+        <p:nvSpPr>
+          <p:cNvPr id="13" name="Text 10"/>
+          <p:cNvSpPr/>
+          <p:nvPr/>
+        </p:nvSpPr>
+        <p:spPr>
+          <a:xfrm>
+            <a:off x="6492240" y="2148840"/>
+            <a:ext cx="4800600" cy="457200"/>
+          </a:xfrm>
+          <a:prstGeom prst="rect">
+            <a:avLst/>
+          </a:prstGeom>
+          <a:noFill/>
+          <a:ln/>
+        </p:spPr>
+        <p:txBody>
+          <a:bodyPr wrap="square" lIns="0" tIns="0" rIns="0" bIns="0" rtlCol="0" anchor="ctr"/>
+          <a:lstStyle/>
+          <a:p>
+            <a:pPr indent="0" marL="0">
+              <a:buNone/>
+            </a:pPr>
+            <a:r>
+              <a:rPr lang="en-US" sz="2400" b="1" dirty="0">
+                <a:solidFill>
+                  <a:srgbClr val="405394"/>
+                </a:solidFill>
+                <a:latin typeface="Apple SD Gothic Neo" pitchFamily="34" charset="0"/>
+                <a:ea typeface="Apple SD Gothic Neo" pitchFamily="34" charset="-122"/>
+                <a:cs typeface="Apple SD Gothic Neo" pitchFamily="34" charset="-120"/>
+              </a:rPr>
+              <a:t>정리  /  Gemma 4 12B IT QAT</a:t>
+            </a:r>
+            <a:endParaRPr lang="en-US" sz="2400" dirty="0"/>
+          </a:p>
+        </p:txBody>
+      </p:sp>
+      <p:sp>
+        <p:nvSpPr>
+          <p:cNvPr id="14" name="Text 11"/>
+          <p:cNvSpPr/>
+          <p:nvPr/>
+        </p:nvSpPr>
+        <p:spPr>
+          <a:xfrm>
+            <a:off x="6492240" y="2926080"/>
+            <a:ext cx="4663440" cy="594360"/>
+          </a:xfrm>
+          <a:prstGeom prst="rect">
+            <a:avLst/>
+          </a:prstGeom>
+          <a:noFill/>
+          <a:ln/>
+        </p:spPr>
+        <p:txBody>
+          <a:bodyPr wrap="square" lIns="0" tIns="0" rIns="0" bIns="0" rtlCol="0" anchor="ctr"/>
+          <a:lstStyle/>
+          <a:p>
+            <a:pPr indent="0" marL="0">
+              <a:buNone/>
+            </a:pPr>
+            <a:r>
+              <a:rPr lang="en-US" sz="3000" b="1" dirty="0">
+                <a:solidFill>
+                  <a:srgbClr val="242938"/>
+                </a:solidFill>
+                <a:latin typeface="Apple SD Gothic Neo" pitchFamily="34" charset="0"/>
+                <a:ea typeface="Apple SD Gothic Neo" pitchFamily="34" charset="-122"/>
+                <a:cs typeface="Apple SD Gothic Neo" pitchFamily="34" charset="-120"/>
+              </a:rPr>
+              <a:t>검토 가능한 기록 정리</a:t>
+            </a:r>
+            <a:endParaRPr lang="en-US" sz="3000" dirty="0"/>
+          </a:p>
+        </p:txBody>
+      </p:sp>
+      <p:sp>
+        <p:nvSpPr>
+          <p:cNvPr id="15" name="Text 12"/>
+          <p:cNvSpPr/>
+          <p:nvPr/>
+        </p:nvSpPr>
+        <p:spPr>
+          <a:xfrm>
+            <a:off x="6492240" y="3813048"/>
+            <a:ext cx="4663440" cy="1188720"/>
+          </a:xfrm>
+          <a:prstGeom prst="rect">
+            <a:avLst/>
+          </a:prstGeom>
+          <a:noFill/>
+          <a:ln/>
+        </p:spPr>
+        <p:txBody>
+          <a:bodyPr wrap="square" lIns="0" tIns="0" rIns="0" bIns="0" rtlCol="0" anchor="ctr"/>
+          <a:lstStyle/>
           <a:p>
             <a:pPr indent="0" marL="0">
               <a:buNone/>
@@ -6277,38 +8887,72 @@
                 <a:ea typeface="Apple SD Gothic Neo" pitchFamily="34" charset="-122"/>
                 <a:cs typeface="Apple SD Gothic Neo" pitchFamily="34" charset="-120"/>
               </a:rPr>
-              <a:t>권한 거절 안내 · 알림 자동 닫힘</a:t>
+              <a:t>제목 · 분류 · 요약 · 할 일 후보</a:t>
             </a:r>
             <a:endParaRPr lang="en-US" sz="2200" dirty="0"/>
           </a:p>
-        </p:txBody>
-      </p:sp>
-      <p:sp>
-        <p:nvSpPr>
-          <p:cNvPr id="11" name="Text 8"/>
-          <p:cNvSpPr/>
-          <p:nvPr/>
-        </p:nvSpPr>
-        <p:spPr>
-          <a:xfrm>
-            <a:off x="6492240" y="2286000"/>
-            <a:ext cx="4572000" cy="457200"/>
-          </a:xfrm>
-          <a:prstGeom prst="rect">
-            <a:avLst/>
-          </a:prstGeom>
-          <a:noFill/>
-          <a:ln/>
-        </p:spPr>
-        <p:txBody>
-          <a:bodyPr wrap="square" lIns="0" tIns="0" rIns="0" bIns="0" rtlCol="0" anchor="ctr"/>
-          <a:lstStyle/>
-          <a:p>
-            <a:pPr indent="0" marL="0">
-              <a:buNone/>
-            </a:pPr>
-            <a:r>
-              <a:rPr lang="en-US" sz="2800" b="1" dirty="0">
+          <a:p>
+            <a:pPr indent="0" marL="0">
+              <a:buNone/>
+            </a:pPr>
+            <a:r>
+              <a:rPr lang="en-US" sz="2200" dirty="0">
+                <a:solidFill>
+                  <a:srgbClr val="242938"/>
+                </a:solidFill>
+                <a:latin typeface="Apple SD Gothic Neo" pitchFamily="34" charset="0"/>
+                <a:ea typeface="Apple SD Gothic Neo" pitchFamily="34" charset="-122"/>
+                <a:cs typeface="Apple SD Gothic Neo" pitchFamily="34" charset="-120"/>
+              </a:rPr>
+              <a:t>JSON 형식으로 결과 구성</a:t>
+            </a:r>
+            <a:endParaRPr lang="en-US" sz="2200" dirty="0"/>
+          </a:p>
+          <a:p>
+            <a:pPr indent="0" marL="0">
+              <a:buNone/>
+            </a:pPr>
+            <a:r>
+              <a:rPr lang="en-US" sz="2200" dirty="0">
+                <a:solidFill>
+                  <a:srgbClr val="242938"/>
+                </a:solidFill>
+                <a:latin typeface="Apple SD Gothic Neo" pitchFamily="34" charset="0"/>
+                <a:ea typeface="Apple SD Gothic Neo" pitchFamily="34" charset="-122"/>
+                <a:cs typeface="Apple SD Gothic Neo" pitchFamily="34" charset="-120"/>
+              </a:rPr>
+              <a:t>서버에서 원문 근거 검증</a:t>
+            </a:r>
+            <a:endParaRPr lang="en-US" sz="2200" dirty="0"/>
+          </a:p>
+        </p:txBody>
+      </p:sp>
+      <p:sp>
+        <p:nvSpPr>
+          <p:cNvPr id="16" name="Text 13"/>
+          <p:cNvSpPr/>
+          <p:nvPr/>
+        </p:nvSpPr>
+        <p:spPr>
+          <a:xfrm>
+            <a:off x="6492240" y="5166360"/>
+            <a:ext cx="4663440" cy="274320"/>
+          </a:xfrm>
+          <a:prstGeom prst="rect">
+            <a:avLst/>
+          </a:prstGeom>
+          <a:noFill/>
+          <a:ln/>
+        </p:spPr>
+        <p:txBody>
+          <a:bodyPr wrap="square" lIns="0" tIns="0" rIns="0" bIns="0" rtlCol="0" anchor="ctr"/>
+          <a:lstStyle/>
+          <a:p>
+            <a:pPr indent="0" marL="0">
+              <a:buNone/>
+            </a:pPr>
+            <a:r>
+              <a:rPr lang="en-US" sz="1800" b="1" dirty="0">
                 <a:solidFill>
                   <a:srgbClr val="405394"/>
                 </a:solidFill>
@@ -6316,99 +8960,48 @@
                 <a:ea typeface="Apple SD Gothic Neo" pitchFamily="34" charset="-122"/>
                 <a:cs typeface="Apple SD Gothic Neo" pitchFamily="34" charset="-120"/>
               </a:rPr>
-              <a:t>별도 확인 필요</a:t>
-            </a:r>
-            <a:endParaRPr lang="en-US" sz="2800" dirty="0"/>
-          </a:p>
-        </p:txBody>
-      </p:sp>
-      <p:sp>
-        <p:nvSpPr>
-          <p:cNvPr id="12" name="Text 9"/>
-          <p:cNvSpPr/>
-          <p:nvPr/>
-        </p:nvSpPr>
-        <p:spPr>
-          <a:xfrm>
-            <a:off x="6492240" y="3063240"/>
-            <a:ext cx="4663440" cy="1920240"/>
-          </a:xfrm>
-          <a:prstGeom prst="rect">
-            <a:avLst/>
-          </a:prstGeom>
-          <a:noFill/>
-          <a:ln/>
-        </p:spPr>
-        <p:txBody>
-          <a:bodyPr wrap="square" lIns="0" tIns="0" rIns="0" bIns="0" rtlCol="0" anchor="ctr"/>
-          <a:lstStyle/>
-          <a:p>
-            <a:pPr indent="0" marL="0">
-              <a:buNone/>
-            </a:pPr>
-            <a:r>
-              <a:rPr lang="en-US" sz="2200" dirty="0">
-                <a:solidFill>
-                  <a:srgbClr val="242938"/>
-                </a:solidFill>
-                <a:latin typeface="Apple SD Gothic Neo" pitchFamily="34" charset="0"/>
-                <a:ea typeface="Apple SD Gothic Neo" pitchFamily="34" charset="-122"/>
-                <a:cs typeface="Apple SD Gothic Neo" pitchFamily="34" charset="-120"/>
-              </a:rPr>
-              <a:t>실제 휴대전화와 마이크 · 청취</a:t>
-            </a:r>
-            <a:endParaRPr lang="en-US" sz="2200" dirty="0"/>
-          </a:p>
-          <a:p>
-            <a:pPr indent="0" marL="0">
-              <a:buNone/>
-            </a:pPr>
-            <a:r>
-              <a:rPr lang="en-US" sz="2200" dirty="0">
-                <a:solidFill>
-                  <a:srgbClr val="242938"/>
-                </a:solidFill>
-                <a:latin typeface="Apple SD Gothic Neo" pitchFamily="34" charset="0"/>
-                <a:ea typeface="Apple SD Gothic Neo" pitchFamily="34" charset="-122"/>
-                <a:cs typeface="Apple SD Gothic Neo" pitchFamily="34" charset="-120"/>
-              </a:rPr>
-              <a:t>운영 도메인 · 스토어 서명</a:t>
-            </a:r>
-            <a:endParaRPr lang="en-US" sz="2200" dirty="0"/>
-          </a:p>
-          <a:p>
-            <a:pPr indent="0" marL="0">
-              <a:buNone/>
-            </a:pPr>
-            <a:r>
-              <a:rPr lang="en-US" sz="2200" dirty="0">
-                <a:solidFill>
-                  <a:srgbClr val="242938"/>
-                </a:solidFill>
-                <a:latin typeface="Apple SD Gothic Neo" pitchFamily="34" charset="0"/>
-                <a:ea typeface="Apple SD Gothic Neo" pitchFamily="34" charset="-122"/>
-                <a:cs typeface="Apple SD Gothic Neo" pitchFamily="34" charset="-120"/>
-              </a:rPr>
-              <a:t>고유명사 등 음성 인식 품질</a:t>
-            </a:r>
-            <a:endParaRPr lang="en-US" sz="2200" dirty="0"/>
-          </a:p>
-          <a:p>
-            <a:pPr indent="0" marL="0">
-              <a:buNone/>
-            </a:pPr>
-            <a:r>
-              <a:rPr lang="en-US" sz="2200" dirty="0">
-                <a:solidFill>
-                  <a:srgbClr val="242938"/>
-                </a:solidFill>
-                <a:latin typeface="Apple SD Gothic Neo" pitchFamily="34" charset="0"/>
-                <a:ea typeface="Apple SD Gothic Neo" pitchFamily="34" charset="-122"/>
-                <a:cs typeface="Apple SD Gothic Neo" pitchFamily="34" charset="-120"/>
-              </a:rPr>
-              <a:t>정확도는 입력 환경에 따라 달라짐</a:t>
-            </a:r>
-            <a:endParaRPr lang="en-US" sz="2200" dirty="0"/>
+              <a:t>최초 정리 후 편집은 사용자에게</a:t>
+            </a:r>
+            <a:endParaRPr lang="en-US" sz="1800" dirty="0"/>
+          </a:p>
+        </p:txBody>
+      </p:sp>
+      <p:sp>
+        <p:nvSpPr>
+          <p:cNvPr id="17" name="Text 14"/>
+          <p:cNvSpPr/>
+          <p:nvPr/>
+        </p:nvSpPr>
+        <p:spPr>
+          <a:xfrm>
+            <a:off x="777240" y="5989320"/>
+            <a:ext cx="10789920" cy="274320"/>
+          </a:xfrm>
+          <a:prstGeom prst="rect">
+            <a:avLst/>
+          </a:prstGeom>
+          <a:noFill/>
+          <a:ln/>
+        </p:spPr>
+        <p:txBody>
+          <a:bodyPr wrap="square" lIns="0" tIns="0" rIns="0" bIns="0" rtlCol="0" anchor="ctr"/>
+          <a:lstStyle/>
+          <a:p>
+            <a:pPr indent="0" marL="0">
+              <a:buNone/>
+            </a:pPr>
+            <a:r>
+              <a:rPr lang="en-US" sz="1700" dirty="0">
+                <a:solidFill>
+                  <a:srgbClr val="626B80"/>
+                </a:solidFill>
+                <a:latin typeface="Apple SD Gothic Neo" pitchFamily="34" charset="0"/>
+                <a:ea typeface="Apple SD Gothic Neo" pitchFamily="34" charset="-122"/>
+                <a:cs typeface="Apple SD Gothic Neo" pitchFamily="34" charset="-120"/>
+              </a:rPr>
+              <a:t>선정 기준: 필요한 언어 · 의미 보존 · 결과 검증 가능성 · 현재 Mac에서의 실행</a:t>
+            </a:r>
+            <a:endParaRPr lang="en-US" sz="1700" dirty="0"/>
           </a:p>
         </p:txBody>
       </p:sp>
@@ -6477,7 +9070,7 @@
                 <a:ea typeface="Apple SD Gothic Neo" pitchFamily="34" charset="-122"/>
                 <a:cs typeface="Apple SD Gothic Neo" pitchFamily="34" charset="-120"/>
               </a:rPr>
-              <a:t>SPEECHBRIDGE  /  LIVE DEMO</a:t>
+              <a:t>SPEECHBRIDGE  /  MODELS / VOICE</a:t>
             </a:r>
             <a:endParaRPr lang="en-US" sz="1200" dirty="0"/>
           </a:p>
@@ -6516,7 +9109,7 @@
                 <a:ea typeface="Apple SD Gothic Neo" pitchFamily="34" charset="-122"/>
                 <a:cs typeface="Apple SD Gothic Neo" pitchFamily="34" charset="-120"/>
               </a:rPr>
-              <a:t>한 문장이 기록과 할 일이 되는 과정.</a:t>
+              <a:t>세 언어와 Mac 실행 조건을 충족하는 음성 모델.</a:t>
             </a:r>
             <a:endParaRPr lang="en-US" sz="3400" dirty="0"/>
           </a:p>
@@ -6609,23 +9202,23 @@
         <p:spPr>
           <a:xfrm>
             <a:off x="731520" y="1828800"/>
-            <a:ext cx="10698480" cy="731520"/>
-          </a:xfrm>
-          <a:prstGeom prst="rect">
-            <a:avLst/>
-          </a:prstGeom>
-          <a:noFill/>
-          <a:ln/>
-        </p:spPr>
-        <p:txBody>
-          <a:bodyPr wrap="square" lIns="0" tIns="0" rIns="0" bIns="0" rtlCol="0" anchor="ctr"/>
-          <a:lstStyle/>
-          <a:p>
-            <a:pPr indent="0" marL="0">
-              <a:buNone/>
-            </a:pPr>
-            <a:r>
-              <a:rPr lang="en-US" sz="3000" b="1" dirty="0">
+            <a:ext cx="502920" cy="365760"/>
+          </a:xfrm>
+          <a:prstGeom prst="rect">
+            <a:avLst/>
+          </a:prstGeom>
+          <a:noFill/>
+          <a:ln/>
+        </p:spPr>
+        <p:txBody>
+          <a:bodyPr wrap="square" lIns="0" tIns="0" rIns="0" bIns="0" rtlCol="0" anchor="ctr"/>
+          <a:lstStyle/>
+          <a:p>
+            <a:pPr indent="0" marL="0">
+              <a:buNone/>
+            </a:pPr>
+            <a:r>
+              <a:rPr lang="en-US" sz="1600" b="1" dirty="0">
                 <a:solidFill>
                   <a:srgbClr val="405394"/>
                 </a:solidFill>
@@ -6633,67 +9226,194 @@
                 <a:ea typeface="Apple SD Gothic Neo" pitchFamily="34" charset="-122"/>
                 <a:cs typeface="Apple SD Gothic Neo" pitchFamily="34" charset="-120"/>
               </a:rPr>
-              <a:t>“please prepare demo slides by friday”</a:t>
-            </a:r>
-            <a:endParaRPr lang="en-US" sz="3000" dirty="0"/>
-          </a:p>
-        </p:txBody>
-      </p:sp>
-      <p:sp>
-        <p:nvSpPr>
-          <p:cNvPr id="8" name="Shape 5"/>
+              <a:t>01</a:t>
+            </a:r>
+            <a:endParaRPr lang="en-US" sz="1600" dirty="0"/>
+          </a:p>
+        </p:txBody>
+      </p:sp>
+      <p:sp>
+        <p:nvSpPr>
+          <p:cNvPr id="8" name="Text 5"/>
+          <p:cNvSpPr/>
+          <p:nvPr/>
+        </p:nvSpPr>
+        <p:spPr>
+          <a:xfrm>
+            <a:off x="1280160" y="1828800"/>
+            <a:ext cx="9875520" cy="411480"/>
+          </a:xfrm>
+          <a:prstGeom prst="rect">
+            <a:avLst/>
+          </a:prstGeom>
+          <a:noFill/>
+          <a:ln/>
+        </p:spPr>
+        <p:txBody>
+          <a:bodyPr wrap="square" lIns="0" tIns="0" rIns="0" bIns="0" rtlCol="0" anchor="ctr"/>
+          <a:lstStyle/>
+          <a:p>
+            <a:pPr indent="0" marL="0">
+              <a:buNone/>
+            </a:pPr>
+            <a:r>
+              <a:rPr lang="en-US" sz="2300" b="1" dirty="0">
+                <a:solidFill>
+                  <a:srgbClr val="242938"/>
+                </a:solidFill>
+                <a:latin typeface="Apple SD Gothic Neo" pitchFamily="34" charset="0"/>
+                <a:ea typeface="Apple SD Gothic Neo" pitchFamily="34" charset="-122"/>
+                <a:cs typeface="Apple SD Gothic Neo" pitchFamily="34" charset="-120"/>
+              </a:rPr>
+              <a:t>Nemotron: 음성 인식과 언어 감지</a:t>
+            </a:r>
+            <a:endParaRPr lang="en-US" sz="2300" dirty="0"/>
+          </a:p>
+        </p:txBody>
+      </p:sp>
+      <p:sp>
+        <p:nvSpPr>
+          <p:cNvPr id="9" name="Text 6"/>
+          <p:cNvSpPr/>
+          <p:nvPr/>
+        </p:nvSpPr>
+        <p:spPr>
+          <a:xfrm>
+            <a:off x="1280160" y="2359152"/>
+            <a:ext cx="9875520" cy="731520"/>
+          </a:xfrm>
+          <a:prstGeom prst="rect">
+            <a:avLst/>
+          </a:prstGeom>
+          <a:noFill/>
+          <a:ln/>
+        </p:spPr>
+        <p:txBody>
+          <a:bodyPr wrap="square" lIns="0" tIns="0" rIns="0" bIns="0" rtlCol="0" anchor="ctr"/>
+          <a:lstStyle/>
+          <a:p>
+            <a:pPr indent="0" marL="0">
+              <a:buNone/>
+            </a:pPr>
+            <a:r>
+              <a:rPr lang="en-US" sz="1700" dirty="0">
+                <a:solidFill>
+                  <a:srgbClr val="626B80"/>
+                </a:solidFill>
+                <a:latin typeface="Apple SD Gothic Neo" pitchFamily="34" charset="0"/>
+                <a:ea typeface="Apple SD Gothic Neo" pitchFamily="34" charset="-122"/>
+                <a:cs typeface="Apple SD Gothic Neo" pitchFamily="34" charset="-120"/>
+              </a:rPr>
+              <a:t>한·영·일 합성 샘플 확인 / Mac Metal 실행</a:t>
+            </a:r>
+            <a:endParaRPr lang="en-US" sz="1700" dirty="0"/>
+          </a:p>
+        </p:txBody>
+      </p:sp>
+      <p:sp>
+        <p:nvSpPr>
+          <p:cNvPr id="10" name="Text 7"/>
           <p:cNvSpPr/>
           <p:nvPr/>
         </p:nvSpPr>
         <p:spPr>
           <a:xfrm>
             <a:off x="731520" y="3200400"/>
-            <a:ext cx="2606040" cy="1463040"/>
-          </a:xfrm>
-          <a:prstGeom prst="roundRect">
-            <a:avLst>
-              <a:gd name="adj" fmla="val 13750"/>
-            </a:avLst>
-          </a:prstGeom>
-          <a:solidFill>
-            <a:srgbClr val="FFFFFF"/>
-          </a:solidFill>
-          <a:ln w="12700">
-            <a:solidFill>
-              <a:srgbClr val="FFFFFF">
-                <a:alpha val="0"/>
-              </a:srgbClr>
-            </a:solidFill>
-            <a:prstDash val="solid"/>
-          </a:ln>
-        </p:spPr>
-      </p:sp>
-      <p:sp>
-        <p:nvSpPr>
-          <p:cNvPr id="9" name="Text 6"/>
-          <p:cNvSpPr/>
-          <p:nvPr/>
-        </p:nvSpPr>
-        <p:spPr>
-          <a:xfrm>
-            <a:off x="960120" y="3401568"/>
-            <a:ext cx="2103120" cy="320040"/>
-          </a:xfrm>
-          <a:prstGeom prst="rect">
-            <a:avLst/>
-          </a:prstGeom>
-          <a:noFill/>
-          <a:ln/>
-        </p:spPr>
-        <p:txBody>
-          <a:bodyPr wrap="square" lIns="0" tIns="0" rIns="0" bIns="0" rtlCol="0" anchor="ctr"/>
-          <a:lstStyle/>
-          <a:p>
-            <a:pPr indent="0" marL="0">
-              <a:buNone/>
-            </a:pPr>
-            <a:r>
-              <a:rPr lang="en-US" sz="1400" b="1" dirty="0">
+            <a:ext cx="502920" cy="365760"/>
+          </a:xfrm>
+          <a:prstGeom prst="rect">
+            <a:avLst/>
+          </a:prstGeom>
+          <a:noFill/>
+          <a:ln/>
+        </p:spPr>
+        <p:txBody>
+          <a:bodyPr wrap="square" lIns="0" tIns="0" rIns="0" bIns="0" rtlCol="0" anchor="ctr"/>
+          <a:lstStyle/>
+          <a:p>
+            <a:pPr indent="0" marL="0">
+              <a:buNone/>
+            </a:pPr>
+            <a:r>
+              <a:rPr lang="en-US" sz="1600" b="1" dirty="0">
+                <a:solidFill>
+                  <a:srgbClr val="405394"/>
+                </a:solidFill>
+                <a:latin typeface="Apple SD Gothic Neo" pitchFamily="34" charset="0"/>
+                <a:ea typeface="Apple SD Gothic Neo" pitchFamily="34" charset="-122"/>
+                <a:cs typeface="Apple SD Gothic Neo" pitchFamily="34" charset="-120"/>
+              </a:rPr>
+              <a:t>02</a:t>
+            </a:r>
+            <a:endParaRPr lang="en-US" sz="1600" dirty="0"/>
+          </a:p>
+        </p:txBody>
+      </p:sp>
+      <p:sp>
+        <p:nvSpPr>
+          <p:cNvPr id="11" name="Text 8"/>
+          <p:cNvSpPr/>
+          <p:nvPr/>
+        </p:nvSpPr>
+        <p:spPr>
+          <a:xfrm>
+            <a:off x="1280160" y="3200400"/>
+            <a:ext cx="9875520" cy="411480"/>
+          </a:xfrm>
+          <a:prstGeom prst="rect">
+            <a:avLst/>
+          </a:prstGeom>
+          <a:noFill/>
+          <a:ln/>
+        </p:spPr>
+        <p:txBody>
+          <a:bodyPr wrap="square" lIns="0" tIns="0" rIns="0" bIns="0" rtlCol="0" anchor="ctr"/>
+          <a:lstStyle/>
+          <a:p>
+            <a:pPr indent="0" marL="0">
+              <a:buNone/>
+            </a:pPr>
+            <a:r>
+              <a:rPr lang="en-US" sz="2300" b="1" dirty="0">
+                <a:solidFill>
+                  <a:srgbClr val="242938"/>
+                </a:solidFill>
+                <a:latin typeface="Apple SD Gothic Neo" pitchFamily="34" charset="0"/>
+                <a:ea typeface="Apple SD Gothic Neo" pitchFamily="34" charset="-122"/>
+                <a:cs typeface="Apple SD Gothic Neo" pitchFamily="34" charset="-120"/>
+              </a:rPr>
+              <a:t>Qwen3-TTS: 번역문을 소리로</a:t>
+            </a:r>
+            <a:endParaRPr lang="en-US" sz="2300" dirty="0"/>
+          </a:p>
+        </p:txBody>
+      </p:sp>
+      <p:sp>
+        <p:nvSpPr>
+          <p:cNvPr id="12" name="Text 9"/>
+          <p:cNvSpPr/>
+          <p:nvPr/>
+        </p:nvSpPr>
+        <p:spPr>
+          <a:xfrm>
+            <a:off x="1280160" y="3730752"/>
+            <a:ext cx="9875520" cy="731520"/>
+          </a:xfrm>
+          <a:prstGeom prst="rect">
+            <a:avLst/>
+          </a:prstGeom>
+          <a:noFill/>
+          <a:ln/>
+        </p:spPr>
+        <p:txBody>
+          <a:bodyPr wrap="square" lIns="0" tIns="0" rIns="0" bIns="0" rtlCol="0" anchor="ctr"/>
+          <a:lstStyle/>
+          <a:p>
+            <a:pPr indent="0" marL="0">
+              <a:buNone/>
+            </a:pPr>
+            <a:r>
+              <a:rPr lang="en-US" sz="1700" dirty="0">
                 <a:solidFill>
                   <a:srgbClr val="626B80"/>
                 </a:solidFill>
@@ -6701,22 +9421,61 @@
                 <a:ea typeface="Apple SD Gothic Neo" pitchFamily="34" charset="-122"/>
                 <a:cs typeface="Apple SD Gothic Neo" pitchFamily="34" charset="-120"/>
               </a:rPr>
-              <a:t>1</a:t>
-            </a:r>
-            <a:endParaRPr lang="en-US" sz="1400" dirty="0"/>
-          </a:p>
-        </p:txBody>
-      </p:sp>
-      <p:sp>
-        <p:nvSpPr>
-          <p:cNvPr id="10" name="Text 7"/>
-          <p:cNvSpPr/>
-          <p:nvPr/>
-        </p:nvSpPr>
-        <p:spPr>
-          <a:xfrm>
-            <a:off x="960120" y="3913632"/>
-            <a:ext cx="2103120" cy="411480"/>
+              <a:t>한·영·일 지원 / MLX 실행 / 고정 음색</a:t>
+            </a:r>
+            <a:endParaRPr lang="en-US" sz="1700" dirty="0"/>
+          </a:p>
+        </p:txBody>
+      </p:sp>
+      <p:sp>
+        <p:nvSpPr>
+          <p:cNvPr id="13" name="Text 10"/>
+          <p:cNvSpPr/>
+          <p:nvPr/>
+        </p:nvSpPr>
+        <p:spPr>
+          <a:xfrm>
+            <a:off x="731520" y="4572000"/>
+            <a:ext cx="502920" cy="365760"/>
+          </a:xfrm>
+          <a:prstGeom prst="rect">
+            <a:avLst/>
+          </a:prstGeom>
+          <a:noFill/>
+          <a:ln/>
+        </p:spPr>
+        <p:txBody>
+          <a:bodyPr wrap="square" lIns="0" tIns="0" rIns="0" bIns="0" rtlCol="0" anchor="ctr"/>
+          <a:lstStyle/>
+          <a:p>
+            <a:pPr indent="0" marL="0">
+              <a:buNone/>
+            </a:pPr>
+            <a:r>
+              <a:rPr lang="en-US" sz="1600" b="1" dirty="0">
+                <a:solidFill>
+                  <a:srgbClr val="405394"/>
+                </a:solidFill>
+                <a:latin typeface="Apple SD Gothic Neo" pitchFamily="34" charset="0"/>
+                <a:ea typeface="Apple SD Gothic Neo" pitchFamily="34" charset="-122"/>
+                <a:cs typeface="Apple SD Gothic Neo" pitchFamily="34" charset="-120"/>
+              </a:rPr>
+              <a:t>03</a:t>
+            </a:r>
+            <a:endParaRPr lang="en-US" sz="1600" dirty="0"/>
+          </a:p>
+        </p:txBody>
+      </p:sp>
+      <p:sp>
+        <p:nvSpPr>
+          <p:cNvPr id="14" name="Text 11"/>
+          <p:cNvSpPr/>
+          <p:nvPr/>
+        </p:nvSpPr>
+        <p:spPr>
+          <a:xfrm>
+            <a:off x="1280160" y="4572000"/>
+            <a:ext cx="9875520" cy="411480"/>
           </a:xfrm>
           <a:prstGeom prst="rect">
             <a:avLst/>
@@ -6740,7 +9499,7 @@
                 <a:ea typeface="Apple SD Gothic Neo" pitchFamily="34" charset="-122"/>
                 <a:cs typeface="Apple SD Gothic Neo" pitchFamily="34" charset="-120"/>
               </a:rPr>
-              <a:t>입력·번역</a:t>
+              <a:t>자동 읽기, 필요하면 설정에서 끄기</a:t>
             </a:r>
             <a:endParaRPr lang="en-US" sz="2300" dirty="0"/>
           </a:p>
@@ -6748,59 +9507,30 @@
       </p:sp>
       <p:sp>
         <p:nvSpPr>
-          <p:cNvPr id="11" name="Shape 8"/>
-          <p:cNvSpPr/>
-          <p:nvPr/>
-        </p:nvSpPr>
-        <p:spPr>
-          <a:xfrm>
-            <a:off x="3593592" y="3200400"/>
-            <a:ext cx="2606040" cy="1463040"/>
-          </a:xfrm>
-          <a:prstGeom prst="roundRect">
-            <a:avLst>
-              <a:gd name="adj" fmla="val 13750"/>
-            </a:avLst>
-          </a:prstGeom>
-          <a:solidFill>
-            <a:srgbClr val="FFFFFF"/>
-          </a:solidFill>
-          <a:ln w="12700">
-            <a:solidFill>
-              <a:srgbClr val="FFFFFF">
-                <a:alpha val="0"/>
-              </a:srgbClr>
-            </a:solidFill>
-            <a:prstDash val="solid"/>
-          </a:ln>
-        </p:spPr>
-      </p:sp>
-      <p:sp>
-        <p:nvSpPr>
-          <p:cNvPr id="12" name="Text 9"/>
-          <p:cNvSpPr/>
-          <p:nvPr/>
-        </p:nvSpPr>
-        <p:spPr>
-          <a:xfrm>
-            <a:off x="3822192" y="3401568"/>
-            <a:ext cx="2103120" cy="320040"/>
-          </a:xfrm>
-          <a:prstGeom prst="rect">
-            <a:avLst/>
-          </a:prstGeom>
-          <a:noFill/>
-          <a:ln/>
-        </p:spPr>
-        <p:txBody>
-          <a:bodyPr wrap="square" lIns="0" tIns="0" rIns="0" bIns="0" rtlCol="0" anchor="ctr"/>
-          <a:lstStyle/>
-          <a:p>
-            <a:pPr indent="0" marL="0">
-              <a:buNone/>
-            </a:pPr>
-            <a:r>
-              <a:rPr lang="en-US" sz="1400" b="1" dirty="0">
+          <p:cNvPr id="15" name="Text 12"/>
+          <p:cNvSpPr/>
+          <p:nvPr/>
+        </p:nvSpPr>
+        <p:spPr>
+          <a:xfrm>
+            <a:off x="1280160" y="5102352"/>
+            <a:ext cx="9875520" cy="731520"/>
+          </a:xfrm>
+          <a:prstGeom prst="rect">
+            <a:avLst/>
+          </a:prstGeom>
+          <a:noFill/>
+          <a:ln/>
+        </p:spPr>
+        <p:txBody>
+          <a:bodyPr wrap="square" lIns="0" tIns="0" rIns="0" bIns="0" rtlCol="0" anchor="ctr"/>
+          <a:lstStyle/>
+          <a:p>
+            <a:pPr indent="0" marL="0">
+              <a:buNone/>
+            </a:pPr>
+            <a:r>
+              <a:rPr lang="en-US" sz="1700" dirty="0">
                 <a:solidFill>
                   <a:srgbClr val="626B80"/>
                 </a:solidFill>
@@ -6808,106 +9538,38 @@
                 <a:ea typeface="Apple SD Gothic Neo" pitchFamily="34" charset="-122"/>
                 <a:cs typeface="Apple SD Gothic Neo" pitchFamily="34" charset="-120"/>
               </a:rPr>
-              <a:t>2</a:t>
-            </a:r>
-            <a:endParaRPr lang="en-US" sz="1400" dirty="0"/>
-          </a:p>
-        </p:txBody>
-      </p:sp>
-      <p:sp>
-        <p:nvSpPr>
-          <p:cNvPr id="13" name="Text 10"/>
-          <p:cNvSpPr/>
-          <p:nvPr/>
-        </p:nvSpPr>
-        <p:spPr>
-          <a:xfrm>
-            <a:off x="3822192" y="3913632"/>
-            <a:ext cx="2103120" cy="411480"/>
-          </a:xfrm>
-          <a:prstGeom prst="rect">
-            <a:avLst/>
-          </a:prstGeom>
-          <a:noFill/>
-          <a:ln/>
-        </p:spPr>
-        <p:txBody>
-          <a:bodyPr wrap="square" lIns="0" tIns="0" rIns="0" bIns="0" rtlCol="0" anchor="ctr"/>
-          <a:lstStyle/>
-          <a:p>
-            <a:pPr indent="0" marL="0">
-              <a:buNone/>
-            </a:pPr>
-            <a:r>
-              <a:rPr lang="en-US" sz="2300" b="1" dirty="0">
-                <a:solidFill>
-                  <a:srgbClr val="242938"/>
-                </a:solidFill>
-                <a:latin typeface="Apple SD Gothic Neo" pitchFamily="34" charset="0"/>
-                <a:ea typeface="Apple SD Gothic Neo" pitchFamily="34" charset="-122"/>
-                <a:cs typeface="Apple SD Gothic Neo" pitchFamily="34" charset="-120"/>
-              </a:rPr>
-              <a:t>종료·요약</a:t>
-            </a:r>
-            <a:endParaRPr lang="en-US" sz="2300" dirty="0"/>
-          </a:p>
-        </p:txBody>
-      </p:sp>
-      <p:sp>
-        <p:nvSpPr>
-          <p:cNvPr id="14" name="Shape 11"/>
-          <p:cNvSpPr/>
-          <p:nvPr/>
-        </p:nvSpPr>
-        <p:spPr>
-          <a:xfrm>
-            <a:off x="6455664" y="3200400"/>
-            <a:ext cx="2606040" cy="1463040"/>
-          </a:xfrm>
-          <a:prstGeom prst="roundRect">
-            <a:avLst>
-              <a:gd name="adj" fmla="val 13750"/>
-            </a:avLst>
-          </a:prstGeom>
-          <a:solidFill>
-            <a:srgbClr val="FFFFFF"/>
-          </a:solidFill>
-          <a:ln w="12700">
-            <a:solidFill>
-              <a:srgbClr val="FFFFFF">
-                <a:alpha val="0"/>
-              </a:srgbClr>
-            </a:solidFill>
-            <a:prstDash val="solid"/>
-          </a:ln>
-        </p:spPr>
-      </p:sp>
-      <p:sp>
-        <p:nvSpPr>
-          <p:cNvPr id="15" name="Text 12"/>
-          <p:cNvSpPr/>
-          <p:nvPr/>
-        </p:nvSpPr>
-        <p:spPr>
-          <a:xfrm>
-            <a:off x="6684264" y="3401568"/>
-            <a:ext cx="2103120" cy="320040"/>
-          </a:xfrm>
-          <a:prstGeom prst="rect">
-            <a:avLst/>
-          </a:prstGeom>
-          <a:noFill/>
-          <a:ln/>
-        </p:spPr>
-        <p:txBody>
-          <a:bodyPr wrap="square" lIns="0" tIns="0" rIns="0" bIns="0" rtlCol="0" anchor="ctr"/>
-          <a:lstStyle/>
-          <a:p>
-            <a:pPr indent="0" marL="0">
-              <a:buNone/>
-            </a:pPr>
-            <a:r>
-              <a:rPr lang="en-US" sz="1400" b="1" dirty="0">
+              <a:t>새 번역만 읽기 / 준비 중·중지 상태 표시</a:t>
+            </a:r>
+            <a:endParaRPr lang="en-US" sz="1700" dirty="0"/>
+          </a:p>
+        </p:txBody>
+      </p:sp>
+      <p:sp>
+        <p:nvSpPr>
+          <p:cNvPr id="16" name="Text 13"/>
+          <p:cNvSpPr/>
+          <p:nvPr/>
+        </p:nvSpPr>
+        <p:spPr>
+          <a:xfrm>
+            <a:off x="777240" y="5989320"/>
+            <a:ext cx="10789920" cy="274320"/>
+          </a:xfrm>
+          <a:prstGeom prst="rect">
+            <a:avLst/>
+          </a:prstGeom>
+          <a:noFill/>
+          <a:ln/>
+        </p:spPr>
+        <p:txBody>
+          <a:bodyPr wrap="square" lIns="0" tIns="0" rIns="0" bIns="0" rtlCol="0" anchor="ctr"/>
+          <a:lstStyle/>
+          <a:p>
+            <a:pPr indent="0" marL="0">
+              <a:buNone/>
+            </a:pPr>
+            <a:r>
+              <a:rPr lang="en-US" sz="1700" dirty="0">
                 <a:solidFill>
                   <a:srgbClr val="626B80"/>
                 </a:solidFill>
@@ -6915,194 +9577,9 @@
                 <a:ea typeface="Apple SD Gothic Neo" pitchFamily="34" charset="-122"/>
                 <a:cs typeface="Apple SD Gothic Neo" pitchFamily="34" charset="-120"/>
               </a:rPr>
-              <a:t>3</a:t>
-            </a:r>
-            <a:endParaRPr lang="en-US" sz="1400" dirty="0"/>
-          </a:p>
-        </p:txBody>
-      </p:sp>
-      <p:sp>
-        <p:nvSpPr>
-          <p:cNvPr id="16" name="Text 13"/>
-          <p:cNvSpPr/>
-          <p:nvPr/>
-        </p:nvSpPr>
-        <p:spPr>
-          <a:xfrm>
-            <a:off x="6684264" y="3913632"/>
-            <a:ext cx="2103120" cy="411480"/>
-          </a:xfrm>
-          <a:prstGeom prst="rect">
-            <a:avLst/>
-          </a:prstGeom>
-          <a:noFill/>
-          <a:ln/>
-        </p:spPr>
-        <p:txBody>
-          <a:bodyPr wrap="square" lIns="0" tIns="0" rIns="0" bIns="0" rtlCol="0" anchor="ctr"/>
-          <a:lstStyle/>
-          <a:p>
-            <a:pPr indent="0" marL="0">
-              <a:buNone/>
-            </a:pPr>
-            <a:r>
-              <a:rPr lang="en-US" sz="2300" b="1" dirty="0">
-                <a:solidFill>
-                  <a:srgbClr val="242938"/>
-                </a:solidFill>
-                <a:latin typeface="Apple SD Gothic Neo" pitchFamily="34" charset="0"/>
-                <a:ea typeface="Apple SD Gothic Neo" pitchFamily="34" charset="-122"/>
-                <a:cs typeface="Apple SD Gothic Neo" pitchFamily="34" charset="-120"/>
-              </a:rPr>
-              <a:t>근거 확인</a:t>
-            </a:r>
-            <a:endParaRPr lang="en-US" sz="2300" dirty="0"/>
-          </a:p>
-        </p:txBody>
-      </p:sp>
-      <p:sp>
-        <p:nvSpPr>
-          <p:cNvPr id="17" name="Shape 14"/>
-          <p:cNvSpPr/>
-          <p:nvPr/>
-        </p:nvSpPr>
-        <p:spPr>
-          <a:xfrm>
-            <a:off x="9317736" y="3200400"/>
-            <a:ext cx="2606040" cy="1463040"/>
-          </a:xfrm>
-          <a:prstGeom prst="roundRect">
-            <a:avLst>
-              <a:gd name="adj" fmla="val 13750"/>
-            </a:avLst>
-          </a:prstGeom>
-          <a:solidFill>
-            <a:srgbClr val="FFFFFF"/>
-          </a:solidFill>
-          <a:ln w="12700">
-            <a:solidFill>
-              <a:srgbClr val="FFFFFF">
-                <a:alpha val="0"/>
-              </a:srgbClr>
-            </a:solidFill>
-            <a:prstDash val="solid"/>
-          </a:ln>
-        </p:spPr>
-      </p:sp>
-      <p:sp>
-        <p:nvSpPr>
-          <p:cNvPr id="18" name="Text 15"/>
-          <p:cNvSpPr/>
-          <p:nvPr/>
-        </p:nvSpPr>
-        <p:spPr>
-          <a:xfrm>
-            <a:off x="9546336" y="3401568"/>
-            <a:ext cx="2103120" cy="320040"/>
-          </a:xfrm>
-          <a:prstGeom prst="rect">
-            <a:avLst/>
-          </a:prstGeom>
-          <a:noFill/>
-          <a:ln/>
-        </p:spPr>
-        <p:txBody>
-          <a:bodyPr wrap="square" lIns="0" tIns="0" rIns="0" bIns="0" rtlCol="0" anchor="ctr"/>
-          <a:lstStyle/>
-          <a:p>
-            <a:pPr indent="0" marL="0">
-              <a:buNone/>
-            </a:pPr>
-            <a:r>
-              <a:rPr lang="en-US" sz="1400" b="1" dirty="0">
-                <a:solidFill>
-                  <a:srgbClr val="626B80"/>
-                </a:solidFill>
-                <a:latin typeface="Apple SD Gothic Neo" pitchFamily="34" charset="0"/>
-                <a:ea typeface="Apple SD Gothic Neo" pitchFamily="34" charset="-122"/>
-                <a:cs typeface="Apple SD Gothic Neo" pitchFamily="34" charset="-120"/>
-              </a:rPr>
-              <a:t>4</a:t>
-            </a:r>
-            <a:endParaRPr lang="en-US" sz="1400" dirty="0"/>
-          </a:p>
-        </p:txBody>
-      </p:sp>
-      <p:sp>
-        <p:nvSpPr>
-          <p:cNvPr id="19" name="Text 16"/>
-          <p:cNvSpPr/>
-          <p:nvPr/>
-        </p:nvSpPr>
-        <p:spPr>
-          <a:xfrm>
-            <a:off x="9546336" y="3913632"/>
-            <a:ext cx="2103120" cy="411480"/>
-          </a:xfrm>
-          <a:prstGeom prst="rect">
-            <a:avLst/>
-          </a:prstGeom>
-          <a:noFill/>
-          <a:ln/>
-        </p:spPr>
-        <p:txBody>
-          <a:bodyPr wrap="square" lIns="0" tIns="0" rIns="0" bIns="0" rtlCol="0" anchor="ctr"/>
-          <a:lstStyle/>
-          <a:p>
-            <a:pPr indent="0" marL="0">
-              <a:buNone/>
-            </a:pPr>
-            <a:r>
-              <a:rPr lang="en-US" sz="2300" b="1" dirty="0">
-                <a:solidFill>
-                  <a:srgbClr val="242938"/>
-                </a:solidFill>
-                <a:latin typeface="Apple SD Gothic Neo" pitchFamily="34" charset="0"/>
-                <a:ea typeface="Apple SD Gothic Neo" pitchFamily="34" charset="-122"/>
-                <a:cs typeface="Apple SD Gothic Neo" pitchFamily="34" charset="-120"/>
-              </a:rPr>
-              <a:t>할 일 완료</a:t>
-            </a:r>
-            <a:endParaRPr lang="en-US" sz="2300" dirty="0"/>
-          </a:p>
-        </p:txBody>
-      </p:sp>
-      <p:sp>
-        <p:nvSpPr>
-          <p:cNvPr id="20" name="Text 17"/>
-          <p:cNvSpPr/>
-          <p:nvPr/>
-        </p:nvSpPr>
-        <p:spPr>
-          <a:xfrm>
-            <a:off x="822960" y="5394960"/>
-            <a:ext cx="10607040" cy="457200"/>
-          </a:xfrm>
-          <a:prstGeom prst="rect">
-            <a:avLst/>
-          </a:prstGeom>
-          <a:noFill/>
-          <a:ln/>
-        </p:spPr>
-        <p:txBody>
-          <a:bodyPr wrap="square" lIns="0" tIns="0" rIns="0" bIns="0" rtlCol="0" anchor="ctr"/>
-          <a:lstStyle/>
-          <a:p>
-            <a:pPr indent="0" marL="0">
-              <a:buNone/>
-            </a:pPr>
-            <a:r>
-              <a:rPr lang="en-US" sz="2000" dirty="0">
-                <a:solidFill>
-                  <a:srgbClr val="626B80"/>
-                </a:solidFill>
-                <a:latin typeface="Apple SD Gothic Neo" pitchFamily="34" charset="0"/>
-                <a:ea typeface="Apple SD Gothic Neo" pitchFamily="34" charset="-122"/>
-                <a:cs typeface="Apple SD Gothic Neo" pitchFamily="34" charset="-120"/>
-              </a:rPr>
-              <a:t>시연 예시 데이터 사용 · AI 응답은 실행마다 달라질 수 있습니다.</a:t>
-            </a:r>
-            <a:endParaRPr lang="en-US" sz="2000" dirty="0"/>
+              <a:t>현재는 녹음 완료 후 처리 · 실시간 스트리밍 및 실사용 음성 품질은 별도 검증</a:t>
+            </a:r>
+            <a:endParaRPr lang="en-US" sz="1700" dirty="0"/>
           </a:p>
         </p:txBody>
       </p:sp>

</xml_diff>

<commit_message>
docs: hide simulator toolbar in presentation and README captures
</commit_message>
<xml_diff>
--- a/presentation/SpeechBridge.pptx
+++ b/presentation/SpeechBridge.pptx
@@ -2221,14 +2221,13 @@
         </p:nvPicPr>
         <p:blipFill>
           <a:blip r:embed="rId1"/>
-          <a:stretch>
-            <a:fillRect/>
-          </a:stretch>
+          <a:srcRect l="0" r="0" t="6173" b="0"/>
+          <a:stretch/>
         </p:blipFill>
         <p:spPr>
           <a:xfrm>
             <a:off x="8458200" y="411480"/>
-            <a:ext cx="2766907" cy="5897880"/>
+            <a:ext cx="2948940" cy="5897880"/>
           </a:xfrm>
           <a:prstGeom prst="rect">
             <a:avLst/>
@@ -5508,14 +5507,13 @@
         </p:nvPicPr>
         <p:blipFill>
           <a:blip r:embed="rId1"/>
-          <a:stretch>
-            <a:fillRect/>
-          </a:stretch>
+          <a:srcRect l="0" r="0" t="6173" b="0"/>
+          <a:stretch/>
         </p:blipFill>
         <p:spPr>
           <a:xfrm>
             <a:off x="8321040" y="914400"/>
-            <a:ext cx="2530969" cy="5394960"/>
+            <a:ext cx="2697480" cy="5394960"/>
           </a:xfrm>
           <a:prstGeom prst="rect">
             <a:avLst/>
@@ -5720,14 +5718,13 @@
         </p:nvPicPr>
         <p:blipFill>
           <a:blip r:embed="rId1"/>
-          <a:stretch>
-            <a:fillRect/>
-          </a:stretch>
+          <a:srcRect l="0" r="0" t="6173" b="0"/>
+          <a:stretch/>
         </p:blipFill>
         <p:spPr>
           <a:xfrm>
             <a:off x="640080" y="1737360"/>
-            <a:ext cx="2123440" cy="4526280"/>
+            <a:ext cx="2263140" cy="4526280"/>
           </a:xfrm>
           <a:prstGeom prst="rect">
             <a:avLst/>
@@ -5744,14 +5741,13 @@
         </p:nvPicPr>
         <p:blipFill>
           <a:blip r:embed="rId2"/>
-          <a:stretch>
-            <a:fillRect/>
-          </a:stretch>
+          <a:srcRect l="0" r="0" t="6173" b="0"/>
+          <a:stretch/>
         </p:blipFill>
         <p:spPr>
           <a:xfrm>
             <a:off x="3154680" y="1737360"/>
-            <a:ext cx="2123440" cy="4526280"/>
+            <a:ext cx="2263140" cy="4526280"/>
           </a:xfrm>
           <a:prstGeom prst="rect">
             <a:avLst/>
@@ -6307,14 +6303,13 @@
         </p:nvPicPr>
         <p:blipFill>
           <a:blip r:embed="rId1"/>
-          <a:stretch>
-            <a:fillRect/>
-          </a:stretch>
+          <a:srcRect l="0" r="0" t="6173" b="0"/>
+          <a:stretch/>
         </p:blipFill>
         <p:spPr>
           <a:xfrm>
             <a:off x="640080" y="1691640"/>
-            <a:ext cx="2144889" cy="4572000"/>
+            <a:ext cx="2286000" cy="4572000"/>
           </a:xfrm>
           <a:prstGeom prst="rect">
             <a:avLst/>
@@ -6331,14 +6326,13 @@
         </p:nvPicPr>
         <p:blipFill>
           <a:blip r:embed="rId2"/>
-          <a:stretch>
-            <a:fillRect/>
-          </a:stretch>
+          <a:srcRect l="0" r="0" t="6173" b="0"/>
+          <a:stretch/>
         </p:blipFill>
         <p:spPr>
           <a:xfrm>
             <a:off x="3200400" y="1691640"/>
-            <a:ext cx="2144889" cy="4572000"/>
+            <a:ext cx="2286000" cy="4572000"/>
           </a:xfrm>
           <a:prstGeom prst="rect">
             <a:avLst/>

</xml_diff>

<commit_message>
docs: refresh app captures and polish Korean presentation
</commit_message>
<xml_diff>
--- a/presentation/SpeechBridge.pptx
+++ b/presentation/SpeechBridge.pptx
@@ -596,7 +596,7 @@
           <a:p>
             <a:r>
               <a:rPr lang="en-US" dirty="0"/>
-              <a:t>마이크 중심 화면에서 언어를 선택하고 녹음 완료 후 번역합니다. 한국어·영어·일본어를 지원합니다. 새 번역은 자동으로 읽으며 설정에서 끌 수 있습니다. 오른쪽은 실제 텍스트 입력으로 얻은 번역 결과입니다.</a:t>
+              <a:t>언어를 선택하고 마이크로 녹음한 뒤 번역합니다. 한국어·영어·일본어를 지원합니다. 새 번역은 자동으로 읽어줍니다. 자동 읽기는 설정에서 끌 수 있습니다. 오른쪽 화면은 직접 입력한 문장의 번역 결과입니다.</a:t>
             </a:r>
             <a:endParaRPr lang="en-US" dirty="0"/>
           </a:p>
@@ -684,7 +684,7 @@
           <a:p>
             <a:r>
               <a:rPr lang="en-US" dirty="0"/>
-              <a:t>대화는 자동 저장되고 종료 시 AI가 제목·분류·요약을 정리합니다. 이후에는 사용자가 직접 수정합니다. 일상·업무·업무 폴더로 기록을 찾을 수 있습니다.</a:t>
+              <a:t>대화는 자동으로 저장됩니다. 대화가 끝나면 AI가 제목을 붙이고 분류와 요약을 정리합니다. 이후에는 사용자가 직접 수정합니다. 일상·업무·업무 폴더로 기록을 찾을 수 있습니다.</a:t>
             </a:r>
             <a:endParaRPr lang="en-US" dirty="0"/>
           </a:p>
@@ -772,7 +772,7 @@
           <a:p>
             <a:r>
               <a:rPr lang="en-US" dirty="0"/>
-              <a:t>대화에서 찾은 할 일 후보의 원문 근거를 확인하고 등록·완료합니다. 할 일에서 원래 기록으로 돌아갈 수 있습니다.</a:t>
+              <a:t>대화에서 찾은 할 일 후보는 원문을 확인한 뒤 등록하고 완료합니다. 할 일에서 원래 기록으로 돌아갈 수 있습니다.</a:t>
             </a:r>
             <a:endParaRPr lang="en-US" dirty="0"/>
           </a:p>
@@ -948,7 +948,7 @@
           <a:p>
             <a:r>
               <a:rPr lang="en-US" dirty="0"/>
-              <a:t>앱의 회원 요청을 Mac 서버가 처리합니다. 사용자 데이터는 PostgreSQL에 저장하며 연결이 끊기면 변경 내용을 기기에 암호화해 임시 보관하고 다시 연결되면 전송합니다.</a:t>
+              <a:t>앱에서 보낸 회원 요청은 Mac 서버가 처리합니다. 사용자 데이터는 PostgreSQL에 저장합니다. 연결이 끊기면 변경 내용을 기기에 암호화해 잠시 보관했다가 다시 연결될 때 전송합니다.</a:t>
             </a:r>
             <a:endParaRPr lang="en-US" dirty="0"/>
           </a:p>
@@ -1036,7 +1036,7 @@
           <a:p>
             <a:r>
               <a:rPr lang="en-US" dirty="0"/>
-              <a:t>Demo.command로 준비합니다. 보조 키보드로 “please prepare demo slides by friday”를 입력해 번역을 보여주고, 대화를 종료해 요약을 확인한 뒤 할 일 근거를 검토합니다. 화면은 가상 시연 데이터입니다. 실제 휴대전화·마이크·청취 검증은 보류 중이므로 이번 시연은 텍스트 입력으로 진행합니다.</a:t>
+              <a:t>Demo.command를 실행해 시연을 준비합니다. 보조 키보드로 “please prepare demo slides by friday”를 입력해 번역을 보여주고 대화를 종료해 요약을 확인한 뒤 할 일 근거를 검토합니다. 화면에 나온 내용은 시연용 가상 데이터입니다. 실제 휴대전화·마이크·청취 검증은 보류 중이라 이번에는 텍스트를 입력해 시연합니다.</a:t>
             </a:r>
             <a:endParaRPr lang="en-US" dirty="0"/>
           </a:p>
@@ -1787,7 +1787,7 @@
                 <a:ea typeface="Apple SD Gothic Neo" pitchFamily="34" charset="-122"/>
                 <a:cs typeface="Apple SD Gothic Neo" pitchFamily="34" charset="-120"/>
               </a:rPr>
-              <a:t>말하고, 번역하고, 듣기</a:t>
+              <a:t>음성 입력·번역·읽어주기</a:t>
             </a:r>
             <a:endParaRPr lang="en-US" sz="3400" dirty="0"/>
           </a:p>
@@ -2115,7 +2115,7 @@
                 <a:ea typeface="Apple SD Gothic Neo" pitchFamily="34" charset="-122"/>
                 <a:cs typeface="Apple SD Gothic Neo" pitchFamily="34" charset="-120"/>
               </a:rPr>
-              <a:t>대화는 기록으로, 내용은 요약으로</a:t>
+              <a:t>대화 기록과 요약</a:t>
             </a:r>
             <a:endParaRPr lang="en-US" sz="3400" dirty="0"/>
           </a:p>
@@ -2427,7 +2427,7 @@
                 <a:ea typeface="Apple SD Gothic Neo" pitchFamily="34" charset="-122"/>
                 <a:cs typeface="Apple SD Gothic Neo" pitchFamily="34" charset="-120"/>
               </a:rPr>
-              <a:t>할 일은 원문을 확인하고 관리</a:t>
+              <a:t>할 일 관리와 원문 확인</a:t>
             </a:r>
             <a:endParaRPr lang="en-US" sz="3400" dirty="0"/>
           </a:p>
@@ -3903,7 +3903,7 @@
                 <a:ea typeface="Apple SD Gothic Neo" pitchFamily="34" charset="-122"/>
                 <a:cs typeface="Apple SD Gothic Neo" pitchFamily="34" charset="-120"/>
               </a:rPr>
-              <a:t>번역에서 할 일까지, 직접 시연</a:t>
+              <a:t>직접 사용해 보기</a:t>
             </a:r>
             <a:endParaRPr lang="en-US" sz="3400" dirty="0"/>
           </a:p>

</xml_diff>

<commit_message>
docs: add architecture and API diagram with official logos
</commit_message>
<xml_diff>
--- a/presentation/SpeechBridge.pptx
+++ b/presentation/SpeechBridge.pptx
@@ -948,7 +948,7 @@
           <a:p>
             <a:r>
               <a:rPr lang="en-US" dirty="0"/>
-              <a:t>앱에서 보낸 회원 요청은 Mac 서버가 처리합니다. 사용자 데이터는 PostgreSQL에 저장합니다. 연결이 끊기면 변경 내용을 기기에 암호화해 잠시 보관했다가 다시 연결될 때 전송합니다.</a:t>
+              <a:t>Kotlin Multiplatform · Compose Multiplatform · Ktor / HTTPS · Node.js / Ollama · NeMo-Speech.cpp · Python · MLX / PostgreSQL</a:t>
             </a:r>
             <a:endParaRPr lang="en-US" dirty="0"/>
           </a:p>
@@ -3316,7 +3316,7 @@
                 <a:ea typeface="Apple SD Gothic Neo" pitchFamily="34" charset="-122"/>
                 <a:cs typeface="Apple SD Gothic Neo" pitchFamily="34" charset="-120"/>
               </a:rPr>
-              <a:t>앱은 휴대전화에서, AI는 Mac에서</a:t>
+              <a:t>시스템 아키텍처 · API 흐름</a:t>
             </a:r>
             <a:endParaRPr lang="en-US" sz="3400" dirty="0"/>
           </a:p>
@@ -3369,12 +3369,80 @@
         </p:nvSpPr>
         <p:spPr>
           <a:xfrm>
-            <a:off x="640080" y="2194560"/>
-            <a:ext cx="3346704" cy="2103120"/>
+            <a:off x="3337560" y="1508760"/>
+            <a:ext cx="8275320" cy="4800600"/>
           </a:xfrm>
           <a:prstGeom prst="roundRect">
             <a:avLst>
-              <a:gd name="adj" fmla="val 8696"/>
+              <a:gd name="adj" fmla="val 3810"/>
+            </a:avLst>
+          </a:prstGeom>
+          <a:solidFill>
+            <a:srgbClr val="DFE5FF"/>
+          </a:solidFill>
+          <a:ln w="12700">
+            <a:solidFill>
+              <a:srgbClr val="DFE5FF">
+                <a:alpha val="0"/>
+              </a:srgbClr>
+            </a:solidFill>
+            <a:prstDash val="solid"/>
+          </a:ln>
+        </p:spPr>
+      </p:sp>
+      <p:sp>
+        <p:nvSpPr>
+          <p:cNvPr id="7" name="Text 4"/>
+          <p:cNvSpPr/>
+          <p:nvPr/>
+        </p:nvSpPr>
+        <p:spPr>
+          <a:xfrm>
+            <a:off x="3611880" y="1691640"/>
+            <a:ext cx="7498080" cy="329184"/>
+          </a:xfrm>
+          <a:prstGeom prst="rect">
+            <a:avLst/>
+          </a:prstGeom>
+          <a:noFill/>
+          <a:ln/>
+        </p:spPr>
+        <p:txBody>
+          <a:bodyPr wrap="square" lIns="0" tIns="0" rIns="0" bIns="0" rtlCol="0" anchor="ctr"/>
+          <a:lstStyle/>
+          <a:p>
+            <a:pPr indent="0" marL="0">
+              <a:buNone/>
+            </a:pPr>
+            <a:r>
+              <a:rPr lang="en-US" sz="2100" b="1" dirty="0">
+                <a:solidFill>
+                  <a:srgbClr val="405394"/>
+                </a:solidFill>
+                <a:latin typeface="Apple SD Gothic Neo" pitchFamily="34" charset="0"/>
+                <a:ea typeface="Apple SD Gothic Neo" pitchFamily="34" charset="-122"/>
+                <a:cs typeface="Apple SD Gothic Neo" pitchFamily="34" charset="-120"/>
+              </a:rPr>
+              <a:t>MacBook</a:t>
+            </a:r>
+            <a:endParaRPr lang="en-US" sz="2100" dirty="0"/>
+          </a:p>
+        </p:txBody>
+      </p:sp>
+      <p:sp>
+        <p:nvSpPr>
+          <p:cNvPr id="8" name="Shape 5"/>
+          <p:cNvSpPr/>
+          <p:nvPr/>
+        </p:nvSpPr>
+        <p:spPr>
+          <a:xfrm>
+            <a:off x="548640" y="2286000"/>
+            <a:ext cx="2331720" cy="3300984"/>
+          </a:xfrm>
+          <a:prstGeom prst="roundRect">
+            <a:avLst>
+              <a:gd name="adj" fmla="val 7843"/>
             </a:avLst>
           </a:prstGeom>
           <a:solidFill>
@@ -3390,32 +3458,56 @@
           </a:ln>
         </p:spPr>
       </p:sp>
-      <p:sp>
-        <p:nvSpPr>
-          <p:cNvPr id="7" name="Text 4"/>
-          <p:cNvSpPr/>
-          <p:nvPr/>
-        </p:nvSpPr>
-        <p:spPr>
-          <a:xfrm>
-            <a:off x="877824" y="2624328"/>
-            <a:ext cx="2871216" cy="502920"/>
-          </a:xfrm>
-          <a:prstGeom prst="rect">
-            <a:avLst/>
-          </a:prstGeom>
-          <a:noFill/>
-          <a:ln/>
-        </p:spPr>
-        <p:txBody>
-          <a:bodyPr wrap="square" lIns="0" tIns="0" rIns="0" bIns="0" rtlCol="0" anchor="ctr"/>
-          <a:lstStyle/>
-          <a:p>
-            <a:pPr indent="0" marL="0">
-              <a:buNone/>
-            </a:pPr>
-            <a:r>
-              <a:rPr lang="en-US" sz="2900" b="1" dirty="0">
+      <p:pic>
+        <p:nvPicPr>
+          <p:cNvPr id="9" name="Image 0" descr="kotlin-multiplatform">    </p:cNvPr>
+          <p:cNvPicPr>
+            <a:picLocks noChangeAspect="1"/>
+          </p:cNvPicPr>
+          <p:nvPr/>
+        </p:nvPicPr>
+        <p:blipFill>
+          <a:blip r:embed="rId1"/>
+          <a:stretch>
+            <a:fillRect/>
+          </a:stretch>
+        </p:blipFill>
+        <p:spPr>
+          <a:xfrm>
+            <a:off x="731520" y="2704636"/>
+            <a:ext cx="1965960" cy="205144"/>
+          </a:xfrm>
+          <a:prstGeom prst="rect">
+            <a:avLst/>
+          </a:prstGeom>
+        </p:spPr>
+      </p:pic>
+      <p:sp>
+        <p:nvSpPr>
+          <p:cNvPr id="10" name="Text 6"/>
+          <p:cNvSpPr/>
+          <p:nvPr/>
+        </p:nvSpPr>
+        <p:spPr>
+          <a:xfrm>
+            <a:off x="786384" y="3410712"/>
+            <a:ext cx="1920240" cy="347472"/>
+          </a:xfrm>
+          <a:prstGeom prst="rect">
+            <a:avLst/>
+          </a:prstGeom>
+          <a:noFill/>
+          <a:ln/>
+        </p:spPr>
+        <p:txBody>
+          <a:bodyPr wrap="square" lIns="0" tIns="0" rIns="0" bIns="0" rtlCol="0" anchor="ctr"/>
+          <a:lstStyle/>
+          <a:p>
+            <a:pPr indent="0" marL="0">
+              <a:buNone/>
+            </a:pPr>
+            <a:r>
+              <a:rPr lang="en-US" sz="2300" b="1" dirty="0">
                 <a:solidFill>
                   <a:srgbClr val="405394"/>
                 </a:solidFill>
@@ -3423,38 +3515,38 @@
                 <a:ea typeface="Apple SD Gothic Neo" pitchFamily="34" charset="-122"/>
                 <a:cs typeface="Apple SD Gothic Neo" pitchFamily="34" charset="-120"/>
               </a:rPr>
-              <a:t>모바일 앱</a:t>
-            </a:r>
-            <a:endParaRPr lang="en-US" sz="2900" dirty="0"/>
-          </a:p>
-        </p:txBody>
-      </p:sp>
-      <p:sp>
-        <p:nvSpPr>
-          <p:cNvPr id="8" name="Text 5"/>
-          <p:cNvSpPr/>
-          <p:nvPr/>
-        </p:nvSpPr>
-        <p:spPr>
-          <a:xfrm>
-            <a:off x="877824" y="3474720"/>
-            <a:ext cx="2871216" cy="411480"/>
-          </a:xfrm>
-          <a:prstGeom prst="rect">
-            <a:avLst/>
-          </a:prstGeom>
-          <a:noFill/>
-          <a:ln/>
-        </p:spPr>
-        <p:txBody>
-          <a:bodyPr wrap="square" lIns="0" tIns="0" rIns="0" bIns="0" rtlCol="0" anchor="ctr"/>
-          <a:lstStyle/>
-          <a:p>
-            <a:pPr indent="0" marL="0">
-              <a:buNone/>
-            </a:pPr>
-            <a:r>
-              <a:rPr lang="en-US" sz="2200" dirty="0">
+              <a:t>Android · iOS</a:t>
+            </a:r>
+            <a:endParaRPr lang="en-US" sz="2300" dirty="0"/>
+          </a:p>
+        </p:txBody>
+      </p:sp>
+      <p:sp>
+        <p:nvSpPr>
+          <p:cNvPr id="11" name="Text 7"/>
+          <p:cNvSpPr/>
+          <p:nvPr/>
+        </p:nvSpPr>
+        <p:spPr>
+          <a:xfrm>
+            <a:off x="786384" y="3968496"/>
+            <a:ext cx="1920240" cy="365760"/>
+          </a:xfrm>
+          <a:prstGeom prst="rect">
+            <a:avLst/>
+          </a:prstGeom>
+          <a:noFill/>
+          <a:ln/>
+        </p:spPr>
+        <p:txBody>
+          <a:bodyPr wrap="square" lIns="0" tIns="0" rIns="0" bIns="0" rtlCol="0" anchor="ctr"/>
+          <a:lstStyle/>
+          <a:p>
+            <a:pPr indent="0" marL="0">
+              <a:buNone/>
+            </a:pPr>
+            <a:r>
+              <a:rPr lang="en-US" sz="1500" dirty="0">
                 <a:solidFill>
                   <a:srgbClr val="242938"/>
                 </a:solidFill>
@@ -3462,211 +3554,104 @@
                 <a:ea typeface="Apple SD Gothic Neo" pitchFamily="34" charset="-122"/>
                 <a:cs typeface="Apple SD Gothic Neo" pitchFamily="34" charset="-120"/>
               </a:rPr>
-              <a:t>Android · iOS</a:t>
-            </a:r>
-            <a:endParaRPr lang="en-US" sz="2200" dirty="0"/>
-          </a:p>
-        </p:txBody>
-      </p:sp>
-      <p:sp>
-        <p:nvSpPr>
-          <p:cNvPr id="9" name="Text 6"/>
-          <p:cNvSpPr/>
-          <p:nvPr/>
-        </p:nvSpPr>
-        <p:spPr>
-          <a:xfrm>
-            <a:off x="4023360" y="2990088"/>
-            <a:ext cx="365760" cy="365760"/>
-          </a:xfrm>
-          <a:prstGeom prst="rect">
-            <a:avLst/>
-          </a:prstGeom>
-          <a:noFill/>
-          <a:ln/>
-        </p:spPr>
-        <p:txBody>
-          <a:bodyPr wrap="square" lIns="0" tIns="0" rIns="0" bIns="0" rtlCol="0" anchor="ctr"/>
-          <a:lstStyle/>
-          <a:p>
-            <a:pPr indent="0" marL="0">
-              <a:buNone/>
-            </a:pPr>
-            <a:r>
-              <a:rPr lang="en-US" sz="2700" b="1" dirty="0">
-                <a:solidFill>
-                  <a:srgbClr val="405394"/>
-                </a:solidFill>
-                <a:latin typeface="Apple SD Gothic Neo" pitchFamily="34" charset="0"/>
-                <a:ea typeface="Apple SD Gothic Neo" pitchFamily="34" charset="-122"/>
-                <a:cs typeface="Apple SD Gothic Neo" pitchFamily="34" charset="-120"/>
-              </a:rPr>
-              <a:t>→</a:t>
-            </a:r>
-            <a:endParaRPr lang="en-US" sz="2700" dirty="0"/>
-          </a:p>
-        </p:txBody>
-      </p:sp>
-      <p:sp>
-        <p:nvSpPr>
-          <p:cNvPr id="10" name="Shape 7"/>
-          <p:cNvSpPr/>
-          <p:nvPr/>
-        </p:nvSpPr>
-        <p:spPr>
-          <a:xfrm>
-            <a:off x="4416552" y="2194560"/>
-            <a:ext cx="3346704" cy="2103120"/>
+              <a:t>Compose Multiplatform</a:t>
+            </a:r>
+            <a:endParaRPr lang="en-US" sz="1500" dirty="0"/>
+          </a:p>
+        </p:txBody>
+      </p:sp>
+      <p:sp>
+        <p:nvSpPr>
+          <p:cNvPr id="12" name="Text 8"/>
+          <p:cNvSpPr/>
+          <p:nvPr/>
+        </p:nvSpPr>
+        <p:spPr>
+          <a:xfrm>
+            <a:off x="786384" y="4498848"/>
+            <a:ext cx="1920240" cy="320040"/>
+          </a:xfrm>
+          <a:prstGeom prst="rect">
+            <a:avLst/>
+          </a:prstGeom>
+          <a:noFill/>
+          <a:ln/>
+        </p:spPr>
+        <p:txBody>
+          <a:bodyPr wrap="square" lIns="0" tIns="0" rIns="0" bIns="0" rtlCol="0" anchor="ctr"/>
+          <a:lstStyle/>
+          <a:p>
+            <a:pPr indent="0" marL="0">
+              <a:buNone/>
+            </a:pPr>
+            <a:r>
+              <a:rPr lang="en-US" sz="2000" dirty="0">
+                <a:solidFill>
+                  <a:srgbClr val="242938"/>
+                </a:solidFill>
+                <a:latin typeface="Apple SD Gothic Neo" pitchFamily="34" charset="0"/>
+                <a:ea typeface="Apple SD Gothic Neo" pitchFamily="34" charset="-122"/>
+                <a:cs typeface="Apple SD Gothic Neo" pitchFamily="34" charset="-120"/>
+              </a:rPr>
+              <a:t>Ktor Client</a:t>
+            </a:r>
+            <a:endParaRPr lang="en-US" sz="2000" dirty="0"/>
+          </a:p>
+        </p:txBody>
+      </p:sp>
+      <p:sp>
+        <p:nvSpPr>
+          <p:cNvPr id="13" name="Text 9"/>
+          <p:cNvSpPr/>
+          <p:nvPr/>
+        </p:nvSpPr>
+        <p:spPr>
+          <a:xfrm>
+            <a:off x="786384" y="5093208"/>
+            <a:ext cx="1920240" cy="256032"/>
+          </a:xfrm>
+          <a:prstGeom prst="rect">
+            <a:avLst/>
+          </a:prstGeom>
+          <a:noFill/>
+          <a:ln/>
+        </p:spPr>
+        <p:txBody>
+          <a:bodyPr wrap="square" lIns="0" tIns="0" rIns="0" bIns="0" rtlCol="0" anchor="ctr"/>
+          <a:lstStyle/>
+          <a:p>
+            <a:pPr indent="0" marL="0">
+              <a:buNone/>
+            </a:pPr>
+            <a:r>
+              <a:rPr lang="en-US" sz="1500" dirty="0">
+                <a:solidFill>
+                  <a:srgbClr val="626B80"/>
+                </a:solidFill>
+                <a:latin typeface="Apple SD Gothic Neo" pitchFamily="34" charset="0"/>
+                <a:ea typeface="Apple SD Gothic Neo" pitchFamily="34" charset="-122"/>
+                <a:cs typeface="Apple SD Gothic Neo" pitchFamily="34" charset="-120"/>
+              </a:rPr>
+              <a:t>Keychain · Keystore</a:t>
+            </a:r>
+            <a:endParaRPr lang="en-US" sz="1500" dirty="0"/>
+          </a:p>
+        </p:txBody>
+      </p:sp>
+      <p:sp>
+        <p:nvSpPr>
+          <p:cNvPr id="14" name="Shape 10"/>
+          <p:cNvSpPr/>
+          <p:nvPr/>
+        </p:nvSpPr>
+        <p:spPr>
+          <a:xfrm>
+            <a:off x="3712464" y="2167128"/>
+            <a:ext cx="3986784" cy="3867912"/>
           </a:xfrm>
           <a:prstGeom prst="roundRect">
             <a:avLst>
-              <a:gd name="adj" fmla="val 8696"/>
-            </a:avLst>
-          </a:prstGeom>
-          <a:solidFill>
-            <a:srgbClr val="DFE5FF"/>
-          </a:solidFill>
-          <a:ln w="12700">
-            <a:solidFill>
-              <a:srgbClr val="DFE5FF">
-                <a:alpha val="0"/>
-              </a:srgbClr>
-            </a:solidFill>
-            <a:prstDash val="solid"/>
-          </a:ln>
-        </p:spPr>
-      </p:sp>
-      <p:sp>
-        <p:nvSpPr>
-          <p:cNvPr id="11" name="Text 8"/>
-          <p:cNvSpPr/>
-          <p:nvPr/>
-        </p:nvSpPr>
-        <p:spPr>
-          <a:xfrm>
-            <a:off x="4654296" y="2624328"/>
-            <a:ext cx="2871216" cy="502920"/>
-          </a:xfrm>
-          <a:prstGeom prst="rect">
-            <a:avLst/>
-          </a:prstGeom>
-          <a:noFill/>
-          <a:ln/>
-        </p:spPr>
-        <p:txBody>
-          <a:bodyPr wrap="square" lIns="0" tIns="0" rIns="0" bIns="0" rtlCol="0" anchor="ctr"/>
-          <a:lstStyle/>
-          <a:p>
-            <a:pPr indent="0" marL="0">
-              <a:buNone/>
-            </a:pPr>
-            <a:r>
-              <a:rPr lang="en-US" sz="2900" b="1" dirty="0">
-                <a:solidFill>
-                  <a:srgbClr val="405394"/>
-                </a:solidFill>
-                <a:latin typeface="Apple SD Gothic Neo" pitchFamily="34" charset="0"/>
-                <a:ea typeface="Apple SD Gothic Neo" pitchFamily="34" charset="-122"/>
-                <a:cs typeface="Apple SD Gothic Neo" pitchFamily="34" charset="-120"/>
-              </a:rPr>
-              <a:t>Mac 서버</a:t>
-            </a:r>
-            <a:endParaRPr lang="en-US" sz="2900" dirty="0"/>
-          </a:p>
-        </p:txBody>
-      </p:sp>
-      <p:sp>
-        <p:nvSpPr>
-          <p:cNvPr id="12" name="Text 9"/>
-          <p:cNvSpPr/>
-          <p:nvPr/>
-        </p:nvSpPr>
-        <p:spPr>
-          <a:xfrm>
-            <a:off x="4654296" y="3474720"/>
-            <a:ext cx="2871216" cy="411480"/>
-          </a:xfrm>
-          <a:prstGeom prst="rect">
-            <a:avLst/>
-          </a:prstGeom>
-          <a:noFill/>
-          <a:ln/>
-        </p:spPr>
-        <p:txBody>
-          <a:bodyPr wrap="square" lIns="0" tIns="0" rIns="0" bIns="0" rtlCol="0" anchor="ctr"/>
-          <a:lstStyle/>
-          <a:p>
-            <a:pPr indent="0" marL="0">
-              <a:buNone/>
-            </a:pPr>
-            <a:r>
-              <a:rPr lang="en-US" sz="2200" dirty="0">
-                <a:solidFill>
-                  <a:srgbClr val="242938"/>
-                </a:solidFill>
-                <a:latin typeface="Apple SD Gothic Neo" pitchFamily="34" charset="0"/>
-                <a:ea typeface="Apple SD Gothic Neo" pitchFamily="34" charset="-122"/>
-                <a:cs typeface="Apple SD Gothic Neo" pitchFamily="34" charset="-120"/>
-              </a:rPr>
-              <a:t>회원 인증 · AI 처리</a:t>
-            </a:r>
-            <a:endParaRPr lang="en-US" sz="2200" dirty="0"/>
-          </a:p>
-        </p:txBody>
-      </p:sp>
-      <p:sp>
-        <p:nvSpPr>
-          <p:cNvPr id="13" name="Text 10"/>
-          <p:cNvSpPr/>
-          <p:nvPr/>
-        </p:nvSpPr>
-        <p:spPr>
-          <a:xfrm>
-            <a:off x="7799832" y="2990088"/>
-            <a:ext cx="365760" cy="365760"/>
-          </a:xfrm>
-          <a:prstGeom prst="rect">
-            <a:avLst/>
-          </a:prstGeom>
-          <a:noFill/>
-          <a:ln/>
-        </p:spPr>
-        <p:txBody>
-          <a:bodyPr wrap="square" lIns="0" tIns="0" rIns="0" bIns="0" rtlCol="0" anchor="ctr"/>
-          <a:lstStyle/>
-          <a:p>
-            <a:pPr indent="0" marL="0">
-              <a:buNone/>
-            </a:pPr>
-            <a:r>
-              <a:rPr lang="en-US" sz="2700" b="1" dirty="0">
-                <a:solidFill>
-                  <a:srgbClr val="405394"/>
-                </a:solidFill>
-                <a:latin typeface="Apple SD Gothic Neo" pitchFamily="34" charset="0"/>
-                <a:ea typeface="Apple SD Gothic Neo" pitchFamily="34" charset="-122"/>
-                <a:cs typeface="Apple SD Gothic Neo" pitchFamily="34" charset="-120"/>
-              </a:rPr>
-              <a:t>→</a:t>
-            </a:r>
-            <a:endParaRPr lang="en-US" sz="2700" dirty="0"/>
-          </a:p>
-        </p:txBody>
-      </p:sp>
-      <p:sp>
-        <p:nvSpPr>
-          <p:cNvPr id="14" name="Shape 11"/>
-          <p:cNvSpPr/>
-          <p:nvPr/>
-        </p:nvSpPr>
-        <p:spPr>
-          <a:xfrm>
-            <a:off x="8193024" y="2194560"/>
-            <a:ext cx="3346704" cy="2103120"/>
-          </a:xfrm>
-          <a:prstGeom prst="roundRect">
-            <a:avLst>
-              <a:gd name="adj" fmla="val 8696"/>
+              <a:gd name="adj" fmla="val 4728"/>
             </a:avLst>
           </a:prstGeom>
           <a:solidFill>
@@ -3682,32 +3667,56 @@
           </a:ln>
         </p:spPr>
       </p:sp>
-      <p:sp>
-        <p:nvSpPr>
-          <p:cNvPr id="15" name="Text 12"/>
-          <p:cNvSpPr/>
-          <p:nvPr/>
-        </p:nvSpPr>
-        <p:spPr>
-          <a:xfrm>
-            <a:off x="8430768" y="2624328"/>
-            <a:ext cx="2871216" cy="502920"/>
-          </a:xfrm>
-          <a:prstGeom prst="rect">
-            <a:avLst/>
-          </a:prstGeom>
-          <a:noFill/>
-          <a:ln/>
-        </p:spPr>
-        <p:txBody>
-          <a:bodyPr wrap="square" lIns="0" tIns="0" rIns="0" bIns="0" rtlCol="0" anchor="ctr"/>
-          <a:lstStyle/>
-          <a:p>
-            <a:pPr indent="0" marL="0">
-              <a:buNone/>
-            </a:pPr>
-            <a:r>
-              <a:rPr lang="en-US" sz="2900" b="1" dirty="0">
+      <p:pic>
+        <p:nvPicPr>
+          <p:cNvPr id="15" name="Image 1" descr="nodejs">    </p:cNvPr>
+          <p:cNvPicPr>
+            <a:picLocks noChangeAspect="1"/>
+          </p:cNvPicPr>
+          <p:nvPr/>
+        </p:nvPicPr>
+        <p:blipFill>
+          <a:blip r:embed="rId2"/>
+          <a:stretch>
+            <a:fillRect/>
+          </a:stretch>
+        </p:blipFill>
+        <p:spPr>
+          <a:xfrm>
+            <a:off x="3977640" y="2425477"/>
+            <a:ext cx="1207008" cy="361126"/>
+          </a:xfrm>
+          <a:prstGeom prst="rect">
+            <a:avLst/>
+          </a:prstGeom>
+        </p:spPr>
+      </p:pic>
+      <p:sp>
+        <p:nvSpPr>
+          <p:cNvPr id="16" name="Text 11"/>
+          <p:cNvSpPr/>
+          <p:nvPr/>
+        </p:nvSpPr>
+        <p:spPr>
+          <a:xfrm>
+            <a:off x="5404104" y="2441448"/>
+            <a:ext cx="2039112" cy="365760"/>
+          </a:xfrm>
+          <a:prstGeom prst="rect">
+            <a:avLst/>
+          </a:prstGeom>
+          <a:noFill/>
+          <a:ln/>
+        </p:spPr>
+        <p:txBody>
+          <a:bodyPr wrap="square" lIns="0" tIns="0" rIns="0" bIns="0" rtlCol="0" anchor="ctr"/>
+          <a:lstStyle/>
+          <a:p>
+            <a:pPr indent="0" marL="0">
+              <a:buNone/>
+            </a:pPr>
+            <a:r>
+              <a:rPr lang="en-US" sz="2300" b="1" dirty="0">
                 <a:solidFill>
                   <a:srgbClr val="405394"/>
                 </a:solidFill>
@@ -3715,77 +3724,1071 @@
                 <a:ea typeface="Apple SD Gothic Neo" pitchFamily="34" charset="-122"/>
                 <a:cs typeface="Apple SD Gothic Neo" pitchFamily="34" charset="-120"/>
               </a:rPr>
+              <a:t>HTTP API</a:t>
+            </a:r>
+            <a:endParaRPr lang="en-US" sz="2300" dirty="0"/>
+          </a:p>
+        </p:txBody>
+      </p:sp>
+      <p:sp>
+        <p:nvSpPr>
+          <p:cNvPr id="17" name="Text 12"/>
+          <p:cNvSpPr/>
+          <p:nvPr/>
+        </p:nvSpPr>
+        <p:spPr>
+          <a:xfrm>
+            <a:off x="3977640" y="3008376"/>
+            <a:ext cx="3474720" cy="256032"/>
+          </a:xfrm>
+          <a:prstGeom prst="rect">
+            <a:avLst/>
+          </a:prstGeom>
+          <a:noFill/>
+          <a:ln/>
+        </p:spPr>
+        <p:txBody>
+          <a:bodyPr wrap="square" lIns="0" tIns="0" rIns="0" bIns="0" rtlCol="0" anchor="ctr"/>
+          <a:lstStyle/>
+          <a:p>
+            <a:pPr indent="0" marL="0">
+              <a:buNone/>
+            </a:pPr>
+            <a:r>
+              <a:rPr lang="en-US" sz="1700" dirty="0">
+                <a:solidFill>
+                  <a:srgbClr val="626B80"/>
+                </a:solidFill>
+                <a:latin typeface="Apple SD Gothic Neo" pitchFamily="34" charset="0"/>
+                <a:ea typeface="Apple SD Gothic Neo" pitchFamily="34" charset="-122"/>
+                <a:cs typeface="Apple SD Gothic Neo" pitchFamily="34" charset="-120"/>
+              </a:rPr>
+              <a:t>node:http · node:https</a:t>
+            </a:r>
+            <a:endParaRPr lang="en-US" sz="1700" dirty="0"/>
+          </a:p>
+        </p:txBody>
+      </p:sp>
+      <p:sp>
+        <p:nvSpPr>
+          <p:cNvPr id="18" name="Text 13"/>
+          <p:cNvSpPr/>
+          <p:nvPr/>
+        </p:nvSpPr>
+        <p:spPr>
+          <a:xfrm>
+            <a:off x="3977640" y="3575304"/>
+            <a:ext cx="484632" cy="201168"/>
+          </a:xfrm>
+          <a:prstGeom prst="rect">
+            <a:avLst/>
+          </a:prstGeom>
+          <a:noFill/>
+          <a:ln/>
+        </p:spPr>
+        <p:txBody>
+          <a:bodyPr wrap="square" lIns="0" tIns="0" rIns="0" bIns="0" rtlCol="0" anchor="ctr"/>
+          <a:lstStyle/>
+          <a:p>
+            <a:pPr indent="0" marL="0">
+              <a:buNone/>
+            </a:pPr>
+            <a:r>
+              <a:rPr lang="en-US" sz="1200" b="1" dirty="0">
+                <a:solidFill>
+                  <a:srgbClr val="405394"/>
+                </a:solidFill>
+                <a:latin typeface="Apple SD Gothic Neo" pitchFamily="34" charset="0"/>
+                <a:ea typeface="Apple SD Gothic Neo" pitchFamily="34" charset="-122"/>
+                <a:cs typeface="Apple SD Gothic Neo" pitchFamily="34" charset="-120"/>
+              </a:rPr>
+              <a:t>POST</a:t>
+            </a:r>
+            <a:endParaRPr lang="en-US" sz="1200" dirty="0"/>
+          </a:p>
+        </p:txBody>
+      </p:sp>
+      <p:sp>
+        <p:nvSpPr>
+          <p:cNvPr id="19" name="Text 14"/>
+          <p:cNvSpPr/>
+          <p:nvPr/>
+        </p:nvSpPr>
+        <p:spPr>
+          <a:xfrm>
+            <a:off x="4553712" y="3575304"/>
+            <a:ext cx="2926080" cy="201168"/>
+          </a:xfrm>
+          <a:prstGeom prst="rect">
+            <a:avLst/>
+          </a:prstGeom>
+          <a:noFill/>
+          <a:ln/>
+        </p:spPr>
+        <p:txBody>
+          <a:bodyPr wrap="square" lIns="0" tIns="0" rIns="0" bIns="0" rtlCol="0" anchor="ctr"/>
+          <a:lstStyle/>
+          <a:p>
+            <a:pPr indent="0" marL="0">
+              <a:buNone/>
+            </a:pPr>
+            <a:r>
+              <a:rPr lang="en-US" sz="1400" dirty="0">
+                <a:solidFill>
+                  <a:srgbClr val="242938"/>
+                </a:solidFill>
+                <a:latin typeface="Apple SD Gothic Neo" pitchFamily="34" charset="0"/>
+                <a:ea typeface="Apple SD Gothic Neo" pitchFamily="34" charset="-122"/>
+                <a:cs typeface="Apple SD Gothic Neo" pitchFamily="34" charset="-120"/>
+              </a:rPr>
+              <a:t>/auth/register · /auth/login</a:t>
+            </a:r>
+            <a:endParaRPr lang="en-US" sz="1400" dirty="0"/>
+          </a:p>
+        </p:txBody>
+      </p:sp>
+      <p:sp>
+        <p:nvSpPr>
+          <p:cNvPr id="20" name="Text 15"/>
+          <p:cNvSpPr/>
+          <p:nvPr/>
+        </p:nvSpPr>
+        <p:spPr>
+          <a:xfrm>
+            <a:off x="3977640" y="3849624"/>
+            <a:ext cx="484632" cy="201168"/>
+          </a:xfrm>
+          <a:prstGeom prst="rect">
+            <a:avLst/>
+          </a:prstGeom>
+          <a:noFill/>
+          <a:ln/>
+        </p:spPr>
+        <p:txBody>
+          <a:bodyPr wrap="square" lIns="0" tIns="0" rIns="0" bIns="0" rtlCol="0" anchor="ctr"/>
+          <a:lstStyle/>
+          <a:p>
+            <a:pPr indent="0" marL="0">
+              <a:buNone/>
+            </a:pPr>
+            <a:r>
+              <a:rPr lang="en-US" sz="1200" b="1" dirty="0">
+                <a:solidFill>
+                  <a:srgbClr val="405394"/>
+                </a:solidFill>
+                <a:latin typeface="Apple SD Gothic Neo" pitchFamily="34" charset="0"/>
+                <a:ea typeface="Apple SD Gothic Neo" pitchFamily="34" charset="-122"/>
+                <a:cs typeface="Apple SD Gothic Neo" pitchFamily="34" charset="-120"/>
+              </a:rPr>
+              <a:t>POST</a:t>
+            </a:r>
+            <a:endParaRPr lang="en-US" sz="1200" dirty="0"/>
+          </a:p>
+        </p:txBody>
+      </p:sp>
+      <p:sp>
+        <p:nvSpPr>
+          <p:cNvPr id="21" name="Text 16"/>
+          <p:cNvSpPr/>
+          <p:nvPr/>
+        </p:nvSpPr>
+        <p:spPr>
+          <a:xfrm>
+            <a:off x="4553712" y="3849624"/>
+            <a:ext cx="2926080" cy="201168"/>
+          </a:xfrm>
+          <a:prstGeom prst="rect">
+            <a:avLst/>
+          </a:prstGeom>
+          <a:noFill/>
+          <a:ln/>
+        </p:spPr>
+        <p:txBody>
+          <a:bodyPr wrap="square" lIns="0" tIns="0" rIns="0" bIns="0" rtlCol="0" anchor="ctr"/>
+          <a:lstStyle/>
+          <a:p>
+            <a:pPr indent="0" marL="0">
+              <a:buNone/>
+            </a:pPr>
+            <a:r>
+              <a:rPr lang="en-US" sz="1400" dirty="0">
+                <a:solidFill>
+                  <a:srgbClr val="242938"/>
+                </a:solidFill>
+                <a:latin typeface="Apple SD Gothic Neo" pitchFamily="34" charset="0"/>
+                <a:ea typeface="Apple SD Gothic Neo" pitchFamily="34" charset="-122"/>
+                <a:cs typeface="Apple SD Gothic Neo" pitchFamily="34" charset="-120"/>
+              </a:rPr>
+              <a:t>/auth/logout · /auth/delete</a:t>
+            </a:r>
+            <a:endParaRPr lang="en-US" sz="1400" dirty="0"/>
+          </a:p>
+        </p:txBody>
+      </p:sp>
+      <p:sp>
+        <p:nvSpPr>
+          <p:cNvPr id="22" name="Text 17"/>
+          <p:cNvSpPr/>
+          <p:nvPr/>
+        </p:nvSpPr>
+        <p:spPr>
+          <a:xfrm>
+            <a:off x="3977640" y="4123944"/>
+            <a:ext cx="484632" cy="201168"/>
+          </a:xfrm>
+          <a:prstGeom prst="rect">
+            <a:avLst/>
+          </a:prstGeom>
+          <a:noFill/>
+          <a:ln/>
+        </p:spPr>
+        <p:txBody>
+          <a:bodyPr wrap="square" lIns="0" tIns="0" rIns="0" bIns="0" rtlCol="0" anchor="ctr"/>
+          <a:lstStyle/>
+          <a:p>
+            <a:pPr indent="0" marL="0">
+              <a:buNone/>
+            </a:pPr>
+            <a:r>
+              <a:rPr lang="en-US" sz="1200" b="1" dirty="0">
+                <a:solidFill>
+                  <a:srgbClr val="405394"/>
+                </a:solidFill>
+                <a:latin typeface="Apple SD Gothic Neo" pitchFamily="34" charset="0"/>
+                <a:ea typeface="Apple SD Gothic Neo" pitchFamily="34" charset="-122"/>
+                <a:cs typeface="Apple SD Gothic Neo" pitchFamily="34" charset="-120"/>
+              </a:rPr>
+              <a:t>GET</a:t>
+            </a:r>
+            <a:endParaRPr lang="en-US" sz="1200" dirty="0"/>
+          </a:p>
+        </p:txBody>
+      </p:sp>
+      <p:sp>
+        <p:nvSpPr>
+          <p:cNvPr id="23" name="Text 18"/>
+          <p:cNvSpPr/>
+          <p:nvPr/>
+        </p:nvSpPr>
+        <p:spPr>
+          <a:xfrm>
+            <a:off x="4553712" y="4123944"/>
+            <a:ext cx="2926080" cy="201168"/>
+          </a:xfrm>
+          <a:prstGeom prst="rect">
+            <a:avLst/>
+          </a:prstGeom>
+          <a:noFill/>
+          <a:ln/>
+        </p:spPr>
+        <p:txBody>
+          <a:bodyPr wrap="square" lIns="0" tIns="0" rIns="0" bIns="0" rtlCol="0" anchor="ctr"/>
+          <a:lstStyle/>
+          <a:p>
+            <a:pPr indent="0" marL="0">
+              <a:buNone/>
+            </a:pPr>
+            <a:r>
+              <a:rPr lang="en-US" sz="1400" dirty="0">
+                <a:solidFill>
+                  <a:srgbClr val="242938"/>
+                </a:solidFill>
+                <a:latin typeface="Apple SD Gothic Neo" pitchFamily="34" charset="0"/>
+                <a:ea typeface="Apple SD Gothic Neo" pitchFamily="34" charset="-122"/>
+                <a:cs typeface="Apple SD Gothic Neo" pitchFamily="34" charset="-120"/>
+              </a:rPr>
+              <a:t>/auth/me</a:t>
+            </a:r>
+            <a:endParaRPr lang="en-US" sz="1400" dirty="0"/>
+          </a:p>
+        </p:txBody>
+      </p:sp>
+      <p:sp>
+        <p:nvSpPr>
+          <p:cNvPr id="24" name="Text 19"/>
+          <p:cNvSpPr/>
+          <p:nvPr/>
+        </p:nvSpPr>
+        <p:spPr>
+          <a:xfrm>
+            <a:off x="3977640" y="4507992"/>
+            <a:ext cx="484632" cy="201168"/>
+          </a:xfrm>
+          <a:prstGeom prst="rect">
+            <a:avLst/>
+          </a:prstGeom>
+          <a:noFill/>
+          <a:ln/>
+        </p:spPr>
+        <p:txBody>
+          <a:bodyPr wrap="square" lIns="0" tIns="0" rIns="0" bIns="0" rtlCol="0" anchor="ctr"/>
+          <a:lstStyle/>
+          <a:p>
+            <a:pPr indent="0" marL="0">
+              <a:buNone/>
+            </a:pPr>
+            <a:r>
+              <a:rPr lang="en-US" sz="1200" b="1" dirty="0">
+                <a:solidFill>
+                  <a:srgbClr val="405394"/>
+                </a:solidFill>
+                <a:latin typeface="Apple SD Gothic Neo" pitchFamily="34" charset="0"/>
+                <a:ea typeface="Apple SD Gothic Neo" pitchFamily="34" charset="-122"/>
+                <a:cs typeface="Apple SD Gothic Neo" pitchFamily="34" charset="-120"/>
+              </a:rPr>
+              <a:t>POST</a:t>
+            </a:r>
+            <a:endParaRPr lang="en-US" sz="1200" dirty="0"/>
+          </a:p>
+        </p:txBody>
+      </p:sp>
+      <p:sp>
+        <p:nvSpPr>
+          <p:cNvPr id="25" name="Text 20"/>
+          <p:cNvSpPr/>
+          <p:nvPr/>
+        </p:nvSpPr>
+        <p:spPr>
+          <a:xfrm>
+            <a:off x="4553712" y="4507992"/>
+            <a:ext cx="2926080" cy="201168"/>
+          </a:xfrm>
+          <a:prstGeom prst="rect">
+            <a:avLst/>
+          </a:prstGeom>
+          <a:noFill/>
+          <a:ln/>
+        </p:spPr>
+        <p:txBody>
+          <a:bodyPr wrap="square" lIns="0" tIns="0" rIns="0" bIns="0" rtlCol="0" anchor="ctr"/>
+          <a:lstStyle/>
+          <a:p>
+            <a:pPr indent="0" marL="0">
+              <a:buNone/>
+            </a:pPr>
+            <a:r>
+              <a:rPr lang="en-US" sz="1400" dirty="0">
+                <a:solidFill>
+                  <a:srgbClr val="242938"/>
+                </a:solidFill>
+                <a:latin typeface="Apple SD Gothic Neo" pitchFamily="34" charset="0"/>
+                <a:ea typeface="Apple SD Gothic Neo" pitchFamily="34" charset="-122"/>
+                <a:cs typeface="Apple SD Gothic Neo" pitchFamily="34" charset="-120"/>
+              </a:rPr>
+              <a:t>/speech/transcribe</a:t>
+            </a:r>
+            <a:endParaRPr lang="en-US" sz="1400" dirty="0"/>
+          </a:p>
+        </p:txBody>
+      </p:sp>
+      <p:sp>
+        <p:nvSpPr>
+          <p:cNvPr id="26" name="Text 21"/>
+          <p:cNvSpPr/>
+          <p:nvPr/>
+        </p:nvSpPr>
+        <p:spPr>
+          <a:xfrm>
+            <a:off x="3977640" y="4782312"/>
+            <a:ext cx="484632" cy="201168"/>
+          </a:xfrm>
+          <a:prstGeom prst="rect">
+            <a:avLst/>
+          </a:prstGeom>
+          <a:noFill/>
+          <a:ln/>
+        </p:spPr>
+        <p:txBody>
+          <a:bodyPr wrap="square" lIns="0" tIns="0" rIns="0" bIns="0" rtlCol="0" anchor="ctr"/>
+          <a:lstStyle/>
+          <a:p>
+            <a:pPr indent="0" marL="0">
+              <a:buNone/>
+            </a:pPr>
+            <a:r>
+              <a:rPr lang="en-US" sz="1200" b="1" dirty="0">
+                <a:solidFill>
+                  <a:srgbClr val="405394"/>
+                </a:solidFill>
+                <a:latin typeface="Apple SD Gothic Neo" pitchFamily="34" charset="0"/>
+                <a:ea typeface="Apple SD Gothic Neo" pitchFamily="34" charset="-122"/>
+                <a:cs typeface="Apple SD Gothic Neo" pitchFamily="34" charset="-120"/>
+              </a:rPr>
+              <a:t>POST</a:t>
+            </a:r>
+            <a:endParaRPr lang="en-US" sz="1200" dirty="0"/>
+          </a:p>
+        </p:txBody>
+      </p:sp>
+      <p:sp>
+        <p:nvSpPr>
+          <p:cNvPr id="27" name="Text 22"/>
+          <p:cNvSpPr/>
+          <p:nvPr/>
+        </p:nvSpPr>
+        <p:spPr>
+          <a:xfrm>
+            <a:off x="4553712" y="4782312"/>
+            <a:ext cx="2926080" cy="201168"/>
+          </a:xfrm>
+          <a:prstGeom prst="rect">
+            <a:avLst/>
+          </a:prstGeom>
+          <a:noFill/>
+          <a:ln/>
+        </p:spPr>
+        <p:txBody>
+          <a:bodyPr wrap="square" lIns="0" tIns="0" rIns="0" bIns="0" rtlCol="0" anchor="ctr"/>
+          <a:lstStyle/>
+          <a:p>
+            <a:pPr indent="0" marL="0">
+              <a:buNone/>
+            </a:pPr>
+            <a:r>
+              <a:rPr lang="en-US" sz="1400" dirty="0">
+                <a:solidFill>
+                  <a:srgbClr val="242938"/>
+                </a:solidFill>
+                <a:latin typeface="Apple SD Gothic Neo" pitchFamily="34" charset="0"/>
+                <a:ea typeface="Apple SD Gothic Neo" pitchFamily="34" charset="-122"/>
+                <a:cs typeface="Apple SD Gothic Neo" pitchFamily="34" charset="-120"/>
+              </a:rPr>
+              <a:t>/speech/synthesize</a:t>
+            </a:r>
+            <a:endParaRPr lang="en-US" sz="1400" dirty="0"/>
+          </a:p>
+        </p:txBody>
+      </p:sp>
+      <p:sp>
+        <p:nvSpPr>
+          <p:cNvPr id="28" name="Text 23"/>
+          <p:cNvSpPr/>
+          <p:nvPr/>
+        </p:nvSpPr>
+        <p:spPr>
+          <a:xfrm>
+            <a:off x="3977640" y="5166360"/>
+            <a:ext cx="484632" cy="201168"/>
+          </a:xfrm>
+          <a:prstGeom prst="rect">
+            <a:avLst/>
+          </a:prstGeom>
+          <a:noFill/>
+          <a:ln/>
+        </p:spPr>
+        <p:txBody>
+          <a:bodyPr wrap="square" lIns="0" tIns="0" rIns="0" bIns="0" rtlCol="0" anchor="ctr"/>
+          <a:lstStyle/>
+          <a:p>
+            <a:pPr indent="0" marL="0">
+              <a:buNone/>
+            </a:pPr>
+            <a:r>
+              <a:rPr lang="en-US" sz="1200" b="1" dirty="0">
+                <a:solidFill>
+                  <a:srgbClr val="405394"/>
+                </a:solidFill>
+                <a:latin typeface="Apple SD Gothic Neo" pitchFamily="34" charset="0"/>
+                <a:ea typeface="Apple SD Gothic Neo" pitchFamily="34" charset="-122"/>
+                <a:cs typeface="Apple SD Gothic Neo" pitchFamily="34" charset="-120"/>
+              </a:rPr>
+              <a:t>POST</a:t>
+            </a:r>
+            <a:endParaRPr lang="en-US" sz="1200" dirty="0"/>
+          </a:p>
+        </p:txBody>
+      </p:sp>
+      <p:sp>
+        <p:nvSpPr>
+          <p:cNvPr id="29" name="Text 24"/>
+          <p:cNvSpPr/>
+          <p:nvPr/>
+        </p:nvSpPr>
+        <p:spPr>
+          <a:xfrm>
+            <a:off x="4553712" y="5166360"/>
+            <a:ext cx="2926080" cy="201168"/>
+          </a:xfrm>
+          <a:prstGeom prst="rect">
+            <a:avLst/>
+          </a:prstGeom>
+          <a:noFill/>
+          <a:ln/>
+        </p:spPr>
+        <p:txBody>
+          <a:bodyPr wrap="square" lIns="0" tIns="0" rIns="0" bIns="0" rtlCol="0" anchor="ctr"/>
+          <a:lstStyle/>
+          <a:p>
+            <a:pPr indent="0" marL="0">
+              <a:buNone/>
+            </a:pPr>
+            <a:r>
+              <a:rPr lang="en-US" sz="1400" dirty="0">
+                <a:solidFill>
+                  <a:srgbClr val="242938"/>
+                </a:solidFill>
+                <a:latin typeface="Apple SD Gothic Neo" pitchFamily="34" charset="0"/>
+                <a:ea typeface="Apple SD Gothic Neo" pitchFamily="34" charset="-122"/>
+                <a:cs typeface="Apple SD Gothic Neo" pitchFamily="34" charset="-120"/>
+              </a:rPr>
+              <a:t>/translate · /extract</a:t>
+            </a:r>
+            <a:endParaRPr lang="en-US" sz="1400" dirty="0"/>
+          </a:p>
+        </p:txBody>
+      </p:sp>
+      <p:sp>
+        <p:nvSpPr>
+          <p:cNvPr id="30" name="Text 25"/>
+          <p:cNvSpPr/>
+          <p:nvPr/>
+        </p:nvSpPr>
+        <p:spPr>
+          <a:xfrm>
+            <a:off x="3977640" y="5440680"/>
+            <a:ext cx="484632" cy="201168"/>
+          </a:xfrm>
+          <a:prstGeom prst="rect">
+            <a:avLst/>
+          </a:prstGeom>
+          <a:noFill/>
+          <a:ln/>
+        </p:spPr>
+        <p:txBody>
+          <a:bodyPr wrap="square" lIns="0" tIns="0" rIns="0" bIns="0" rtlCol="0" anchor="ctr"/>
+          <a:lstStyle/>
+          <a:p>
+            <a:pPr indent="0" marL="0">
+              <a:buNone/>
+            </a:pPr>
+            <a:r>
+              <a:rPr lang="en-US" sz="1200" b="1" dirty="0">
+                <a:solidFill>
+                  <a:srgbClr val="405394"/>
+                </a:solidFill>
+                <a:latin typeface="Apple SD Gothic Neo" pitchFamily="34" charset="0"/>
+                <a:ea typeface="Apple SD Gothic Neo" pitchFamily="34" charset="-122"/>
+                <a:cs typeface="Apple SD Gothic Neo" pitchFamily="34" charset="-120"/>
+              </a:rPr>
+              <a:t>POST</a:t>
+            </a:r>
+            <a:endParaRPr lang="en-US" sz="1200" dirty="0"/>
+          </a:p>
+        </p:txBody>
+      </p:sp>
+      <p:sp>
+        <p:nvSpPr>
+          <p:cNvPr id="31" name="Text 26"/>
+          <p:cNvSpPr/>
+          <p:nvPr/>
+        </p:nvSpPr>
+        <p:spPr>
+          <a:xfrm>
+            <a:off x="4553712" y="5440680"/>
+            <a:ext cx="2926080" cy="201168"/>
+          </a:xfrm>
+          <a:prstGeom prst="rect">
+            <a:avLst/>
+          </a:prstGeom>
+          <a:noFill/>
+          <a:ln/>
+        </p:spPr>
+        <p:txBody>
+          <a:bodyPr wrap="square" lIns="0" tIns="0" rIns="0" bIns="0" rtlCol="0" anchor="ctr"/>
+          <a:lstStyle/>
+          <a:p>
+            <a:pPr indent="0" marL="0">
+              <a:buNone/>
+            </a:pPr>
+            <a:r>
+              <a:rPr lang="en-US" sz="1400" dirty="0">
+                <a:solidFill>
+                  <a:srgbClr val="242938"/>
+                </a:solidFill>
+                <a:latin typeface="Apple SD Gothic Neo" pitchFamily="34" charset="0"/>
+                <a:ea typeface="Apple SD Gothic Neo" pitchFamily="34" charset="-122"/>
+                <a:cs typeface="Apple SD Gothic Neo" pitchFamily="34" charset="-120"/>
+              </a:rPr>
+              <a:t>/data/snapshot · /data/mutate</a:t>
+            </a:r>
+            <a:endParaRPr lang="en-US" sz="1400" dirty="0"/>
+          </a:p>
+        </p:txBody>
+      </p:sp>
+      <p:sp>
+        <p:nvSpPr>
+          <p:cNvPr id="32" name="Text 27"/>
+          <p:cNvSpPr/>
+          <p:nvPr/>
+        </p:nvSpPr>
+        <p:spPr>
+          <a:xfrm>
+            <a:off x="3977640" y="5715000"/>
+            <a:ext cx="484632" cy="201168"/>
+          </a:xfrm>
+          <a:prstGeom prst="rect">
+            <a:avLst/>
+          </a:prstGeom>
+          <a:noFill/>
+          <a:ln/>
+        </p:spPr>
+        <p:txBody>
+          <a:bodyPr wrap="square" lIns="0" tIns="0" rIns="0" bIns="0" rtlCol="0" anchor="ctr"/>
+          <a:lstStyle/>
+          <a:p>
+            <a:pPr indent="0" marL="0">
+              <a:buNone/>
+            </a:pPr>
+            <a:r>
+              <a:rPr lang="en-US" sz="1200" b="1" dirty="0">
+                <a:solidFill>
+                  <a:srgbClr val="405394"/>
+                </a:solidFill>
+                <a:latin typeface="Apple SD Gothic Neo" pitchFamily="34" charset="0"/>
+                <a:ea typeface="Apple SD Gothic Neo" pitchFamily="34" charset="-122"/>
+                <a:cs typeface="Apple SD Gothic Neo" pitchFamily="34" charset="-120"/>
+              </a:rPr>
+              <a:t>POST</a:t>
+            </a:r>
+            <a:endParaRPr lang="en-US" sz="1200" dirty="0"/>
+          </a:p>
+        </p:txBody>
+      </p:sp>
+      <p:sp>
+        <p:nvSpPr>
+          <p:cNvPr id="33" name="Text 28"/>
+          <p:cNvSpPr/>
+          <p:nvPr/>
+        </p:nvSpPr>
+        <p:spPr>
+          <a:xfrm>
+            <a:off x="4553712" y="5715000"/>
+            <a:ext cx="2926080" cy="201168"/>
+          </a:xfrm>
+          <a:prstGeom prst="rect">
+            <a:avLst/>
+          </a:prstGeom>
+          <a:noFill/>
+          <a:ln/>
+        </p:spPr>
+        <p:txBody>
+          <a:bodyPr wrap="square" lIns="0" tIns="0" rIns="0" bIns="0" rtlCol="0" anchor="ctr"/>
+          <a:lstStyle/>
+          <a:p>
+            <a:pPr indent="0" marL="0">
+              <a:buNone/>
+            </a:pPr>
+            <a:r>
+              <a:rPr lang="en-US" sz="1400" dirty="0">
+                <a:solidFill>
+                  <a:srgbClr val="242938"/>
+                </a:solidFill>
+                <a:latin typeface="Apple SD Gothic Neo" pitchFamily="34" charset="0"/>
+                <a:ea typeface="Apple SD Gothic Neo" pitchFamily="34" charset="-122"/>
+                <a:cs typeface="Apple SD Gothic Neo" pitchFamily="34" charset="-120"/>
+              </a:rPr>
+              <a:t>/data/changes</a:t>
+            </a:r>
+            <a:endParaRPr lang="en-US" sz="1400" dirty="0"/>
+          </a:p>
+        </p:txBody>
+      </p:sp>
+      <p:sp>
+        <p:nvSpPr>
+          <p:cNvPr id="34" name="Shape 29"/>
+          <p:cNvSpPr/>
+          <p:nvPr/>
+        </p:nvSpPr>
+        <p:spPr>
+          <a:xfrm>
+            <a:off x="8458200" y="2167128"/>
+            <a:ext cx="2816352" cy="1179576"/>
+          </a:xfrm>
+          <a:prstGeom prst="roundRect">
+            <a:avLst>
+              <a:gd name="adj" fmla="val 15504"/>
+            </a:avLst>
+          </a:prstGeom>
+          <a:solidFill>
+            <a:srgbClr val="FFFFFF"/>
+          </a:solidFill>
+          <a:ln w="12700">
+            <a:solidFill>
+              <a:srgbClr val="FFFFFF">
+                <a:alpha val="0"/>
+              </a:srgbClr>
+            </a:solidFill>
+            <a:prstDash val="solid"/>
+          </a:ln>
+        </p:spPr>
+      </p:sp>
+      <p:sp>
+        <p:nvSpPr>
+          <p:cNvPr id="35" name="Text 30"/>
+          <p:cNvSpPr/>
+          <p:nvPr/>
+        </p:nvSpPr>
+        <p:spPr>
+          <a:xfrm>
+            <a:off x="8695944" y="2331720"/>
+            <a:ext cx="2340864" cy="320040"/>
+          </a:xfrm>
+          <a:prstGeom prst="rect">
+            <a:avLst/>
+          </a:prstGeom>
+          <a:noFill/>
+          <a:ln/>
+        </p:spPr>
+        <p:txBody>
+          <a:bodyPr wrap="square" lIns="0" tIns="0" rIns="0" bIns="0" rtlCol="0" anchor="ctr"/>
+          <a:lstStyle/>
+          <a:p>
+            <a:pPr indent="0" marL="0">
+              <a:buNone/>
+            </a:pPr>
+            <a:r>
+              <a:rPr lang="en-US" sz="2400" b="1" dirty="0">
+                <a:solidFill>
+                  <a:srgbClr val="405394"/>
+                </a:solidFill>
+                <a:latin typeface="Apple SD Gothic Neo" pitchFamily="34" charset="0"/>
+                <a:ea typeface="Apple SD Gothic Neo" pitchFamily="34" charset="-122"/>
+                <a:cs typeface="Apple SD Gothic Neo" pitchFamily="34" charset="-120"/>
+              </a:rPr>
+              <a:t>Ollama</a:t>
+            </a:r>
+            <a:endParaRPr lang="en-US" sz="2400" dirty="0"/>
+          </a:p>
+        </p:txBody>
+      </p:sp>
+      <p:sp>
+        <p:nvSpPr>
+          <p:cNvPr id="36" name="Text 31"/>
+          <p:cNvSpPr/>
+          <p:nvPr/>
+        </p:nvSpPr>
+        <p:spPr>
+          <a:xfrm>
+            <a:off x="8695944" y="2761488"/>
+            <a:ext cx="2340864" cy="274320"/>
+          </a:xfrm>
+          <a:prstGeom prst="rect">
+            <a:avLst/>
+          </a:prstGeom>
+          <a:noFill/>
+          <a:ln/>
+        </p:spPr>
+        <p:txBody>
+          <a:bodyPr wrap="square" lIns="0" tIns="0" rIns="0" bIns="0" rtlCol="0" anchor="ctr"/>
+          <a:lstStyle/>
+          <a:p>
+            <a:pPr indent="0" marL="0">
+              <a:buNone/>
+            </a:pPr>
+            <a:r>
+              <a:rPr lang="en-US" sz="2000" dirty="0">
+                <a:solidFill>
+                  <a:srgbClr val="242938"/>
+                </a:solidFill>
+                <a:latin typeface="Apple SD Gothic Neo" pitchFamily="34" charset="0"/>
+                <a:ea typeface="Apple SD Gothic Neo" pitchFamily="34" charset="-122"/>
+                <a:cs typeface="Apple SD Gothic Neo" pitchFamily="34" charset="-120"/>
+              </a:rPr>
+              <a:t>POST /api/chat</a:t>
+            </a:r>
+            <a:endParaRPr lang="en-US" sz="2000" dirty="0"/>
+          </a:p>
+        </p:txBody>
+      </p:sp>
+      <p:sp>
+        <p:nvSpPr>
+          <p:cNvPr id="37" name="Shape 32"/>
+          <p:cNvSpPr/>
+          <p:nvPr/>
+        </p:nvSpPr>
+        <p:spPr>
+          <a:xfrm>
+            <a:off x="8458200" y="3621024"/>
+            <a:ext cx="2816352" cy="1078992"/>
+          </a:xfrm>
+          <a:prstGeom prst="roundRect">
+            <a:avLst>
+              <a:gd name="adj" fmla="val 16949"/>
+            </a:avLst>
+          </a:prstGeom>
+          <a:solidFill>
+            <a:srgbClr val="FFFFFF"/>
+          </a:solidFill>
+          <a:ln w="12700">
+            <a:solidFill>
+              <a:srgbClr val="FFFFFF">
+                <a:alpha val="0"/>
+              </a:srgbClr>
+            </a:solidFill>
+            <a:prstDash val="solid"/>
+          </a:ln>
+        </p:spPr>
+      </p:sp>
+      <p:sp>
+        <p:nvSpPr>
+          <p:cNvPr id="38" name="Text 33"/>
+          <p:cNvSpPr/>
+          <p:nvPr/>
+        </p:nvSpPr>
+        <p:spPr>
+          <a:xfrm>
+            <a:off x="8695944" y="3813048"/>
+            <a:ext cx="2340864" cy="283464"/>
+          </a:xfrm>
+          <a:prstGeom prst="rect">
+            <a:avLst/>
+          </a:prstGeom>
+          <a:noFill/>
+          <a:ln/>
+        </p:spPr>
+        <p:txBody>
+          <a:bodyPr wrap="square" lIns="0" tIns="0" rIns="0" bIns="0" rtlCol="0" anchor="ctr"/>
+          <a:lstStyle/>
+          <a:p>
+            <a:pPr indent="0" marL="0">
+              <a:buNone/>
+            </a:pPr>
+            <a:r>
+              <a:rPr lang="en-US" sz="1900" b="1" dirty="0">
+                <a:solidFill>
+                  <a:srgbClr val="405394"/>
+                </a:solidFill>
+                <a:latin typeface="Apple SD Gothic Neo" pitchFamily="34" charset="0"/>
+                <a:ea typeface="Apple SD Gothic Neo" pitchFamily="34" charset="-122"/>
+                <a:cs typeface="Apple SD Gothic Neo" pitchFamily="34" charset="-120"/>
+              </a:rPr>
+              <a:t>NeMo-Speech.cpp</a:t>
+            </a:r>
+            <a:endParaRPr lang="en-US" sz="1900" dirty="0"/>
+          </a:p>
+        </p:txBody>
+      </p:sp>
+      <p:sp>
+        <p:nvSpPr>
+          <p:cNvPr id="39" name="Text 34"/>
+          <p:cNvSpPr/>
+          <p:nvPr/>
+        </p:nvSpPr>
+        <p:spPr>
+          <a:xfrm>
+            <a:off x="8695944" y="4224528"/>
+            <a:ext cx="2340864" cy="265176"/>
+          </a:xfrm>
+          <a:prstGeom prst="rect">
+            <a:avLst/>
+          </a:prstGeom>
+          <a:noFill/>
+          <a:ln/>
+        </p:spPr>
+        <p:txBody>
+          <a:bodyPr wrap="square" lIns="0" tIns="0" rIns="0" bIns="0" rtlCol="0" anchor="ctr"/>
+          <a:lstStyle/>
+          <a:p>
+            <a:pPr indent="0" marL="0">
+              <a:buNone/>
+            </a:pPr>
+            <a:r>
+              <a:rPr lang="en-US" sz="2000" dirty="0">
+                <a:solidFill>
+                  <a:srgbClr val="242938"/>
+                </a:solidFill>
+                <a:latin typeface="Apple SD Gothic Neo" pitchFamily="34" charset="0"/>
+                <a:ea typeface="Apple SD Gothic Neo" pitchFamily="34" charset="-122"/>
+                <a:cs typeface="Apple SD Gothic Neo" pitchFamily="34" charset="-120"/>
+              </a:rPr>
+              <a:t>Python · MLX</a:t>
+            </a:r>
+            <a:endParaRPr lang="en-US" sz="2000" dirty="0"/>
+          </a:p>
+        </p:txBody>
+      </p:sp>
+      <p:sp>
+        <p:nvSpPr>
+          <p:cNvPr id="40" name="Shape 35"/>
+          <p:cNvSpPr/>
+          <p:nvPr/>
+        </p:nvSpPr>
+        <p:spPr>
+          <a:xfrm>
+            <a:off x="8458200" y="4974336"/>
+            <a:ext cx="2816352" cy="1060704"/>
+          </a:xfrm>
+          <a:prstGeom prst="roundRect">
+            <a:avLst>
+              <a:gd name="adj" fmla="val 17241"/>
+            </a:avLst>
+          </a:prstGeom>
+          <a:solidFill>
+            <a:srgbClr val="FFFFFF"/>
+          </a:solidFill>
+          <a:ln w="12700">
+            <a:solidFill>
+              <a:srgbClr val="FFFFFF">
+                <a:alpha val="0"/>
+              </a:srgbClr>
+            </a:solidFill>
+            <a:prstDash val="solid"/>
+          </a:ln>
+        </p:spPr>
+      </p:sp>
+      <p:pic>
+        <p:nvPicPr>
+          <p:cNvPr id="41" name="Image 2" descr="postgresql">    </p:cNvPr>
+          <p:cNvPicPr>
+            <a:picLocks noChangeAspect="1"/>
+          </p:cNvPicPr>
+          <p:nvPr/>
+        </p:nvPicPr>
+        <p:blipFill>
+          <a:blip r:embed="rId3"/>
+          <a:stretch>
+            <a:fillRect/>
+          </a:stretch>
+        </p:blipFill>
+        <p:spPr>
+          <a:xfrm>
+            <a:off x="8678698" y="5138928"/>
+            <a:ext cx="647139" cy="667512"/>
+          </a:xfrm>
+          <a:prstGeom prst="rect">
+            <a:avLst/>
+          </a:prstGeom>
+        </p:spPr>
+      </p:pic>
+      <p:sp>
+        <p:nvSpPr>
+          <p:cNvPr id="42" name="Text 36"/>
+          <p:cNvSpPr/>
+          <p:nvPr/>
+        </p:nvSpPr>
+        <p:spPr>
+          <a:xfrm>
+            <a:off x="9518904" y="5230368"/>
+            <a:ext cx="1600200" cy="320040"/>
+          </a:xfrm>
+          <a:prstGeom prst="rect">
+            <a:avLst/>
+          </a:prstGeom>
+          <a:noFill/>
+          <a:ln/>
+        </p:spPr>
+        <p:txBody>
+          <a:bodyPr wrap="square" lIns="0" tIns="0" rIns="0" bIns="0" rtlCol="0" anchor="ctr"/>
+          <a:lstStyle/>
+          <a:p>
+            <a:pPr indent="0" marL="0">
+              <a:buNone/>
+            </a:pPr>
+            <a:r>
+              <a:rPr lang="en-US" sz="2100" b="1" dirty="0">
+                <a:solidFill>
+                  <a:srgbClr val="242938"/>
+                </a:solidFill>
+                <a:latin typeface="Apple SD Gothic Neo" pitchFamily="34" charset="0"/>
+                <a:ea typeface="Apple SD Gothic Neo" pitchFamily="34" charset="-122"/>
+                <a:cs typeface="Apple SD Gothic Neo" pitchFamily="34" charset="-120"/>
+              </a:rPr>
               <a:t>PostgreSQL</a:t>
             </a:r>
-            <a:endParaRPr lang="en-US" sz="2900" dirty="0"/>
-          </a:p>
-        </p:txBody>
-      </p:sp>
-      <p:sp>
-        <p:nvSpPr>
-          <p:cNvPr id="16" name="Text 13"/>
-          <p:cNvSpPr/>
-          <p:nvPr/>
-        </p:nvSpPr>
-        <p:spPr>
-          <a:xfrm>
-            <a:off x="8430768" y="3474720"/>
-            <a:ext cx="2871216" cy="411480"/>
-          </a:xfrm>
-          <a:prstGeom prst="rect">
-            <a:avLst/>
-          </a:prstGeom>
-          <a:noFill/>
-          <a:ln/>
-        </p:spPr>
-        <p:txBody>
-          <a:bodyPr wrap="square" lIns="0" tIns="0" rIns="0" bIns="0" rtlCol="0" anchor="ctr"/>
-          <a:lstStyle/>
-          <a:p>
-            <a:pPr indent="0" marL="0">
-              <a:buNone/>
-            </a:pPr>
-            <a:r>
-              <a:rPr lang="en-US" sz="2200" dirty="0">
-                <a:solidFill>
-                  <a:srgbClr val="242938"/>
-                </a:solidFill>
-                <a:latin typeface="Apple SD Gothic Neo" pitchFamily="34" charset="0"/>
-                <a:ea typeface="Apple SD Gothic Neo" pitchFamily="34" charset="-122"/>
-                <a:cs typeface="Apple SD Gothic Neo" pitchFamily="34" charset="-120"/>
-              </a:rPr>
-              <a:t>계정별 기록 저장</a:t>
-            </a:r>
-            <a:endParaRPr lang="en-US" sz="2200" dirty="0"/>
-          </a:p>
-        </p:txBody>
-      </p:sp>
-      <p:sp>
-        <p:nvSpPr>
-          <p:cNvPr id="17" name="Text 14"/>
-          <p:cNvSpPr/>
-          <p:nvPr/>
-        </p:nvSpPr>
-        <p:spPr>
-          <a:xfrm>
-            <a:off x="777240" y="5166360"/>
-            <a:ext cx="10698480" cy="548640"/>
-          </a:xfrm>
-          <a:prstGeom prst="rect">
-            <a:avLst/>
-          </a:prstGeom>
-          <a:noFill/>
-          <a:ln/>
-        </p:spPr>
-        <p:txBody>
-          <a:bodyPr wrap="square" lIns="0" tIns="0" rIns="0" bIns="0" rtlCol="0" anchor="ctr"/>
-          <a:lstStyle/>
-          <a:p>
-            <a:pPr indent="0" marL="0">
-              <a:buNone/>
-            </a:pPr>
-            <a:r>
-              <a:rPr lang="en-US" sz="2800" b="1" dirty="0">
+            <a:endParaRPr lang="en-US" sz="2100" dirty="0"/>
+          </a:p>
+        </p:txBody>
+      </p:sp>
+      <p:sp>
+        <p:nvSpPr>
+          <p:cNvPr id="43" name="Text 37"/>
+          <p:cNvSpPr/>
+          <p:nvPr/>
+        </p:nvSpPr>
+        <p:spPr>
+          <a:xfrm>
+            <a:off x="9518904" y="5641848"/>
+            <a:ext cx="1600200" cy="201168"/>
+          </a:xfrm>
+          <a:prstGeom prst="rect">
+            <a:avLst/>
+          </a:prstGeom>
+          <a:noFill/>
+          <a:ln/>
+        </p:spPr>
+        <p:txBody>
+          <a:bodyPr wrap="square" lIns="0" tIns="0" rIns="0" bIns="0" rtlCol="0" anchor="ctr"/>
+          <a:lstStyle/>
+          <a:p>
+            <a:pPr indent="0" marL="0">
+              <a:buNone/>
+            </a:pPr>
+            <a:r>
+              <a:rPr lang="en-US" sz="1300" dirty="0">
+                <a:solidFill>
+                  <a:srgbClr val="626B80"/>
+                </a:solidFill>
+                <a:latin typeface="Apple SD Gothic Neo" pitchFamily="34" charset="0"/>
+                <a:ea typeface="Apple SD Gothic Neo" pitchFamily="34" charset="-122"/>
+                <a:cs typeface="Apple SD Gothic Neo" pitchFamily="34" charset="-120"/>
+              </a:rPr>
+              <a:t>pg · SQL · RLS</a:t>
+            </a:r>
+            <a:endParaRPr lang="en-US" sz="1300" dirty="0"/>
+          </a:p>
+        </p:txBody>
+      </p:sp>
+      <p:sp>
+        <p:nvSpPr>
+          <p:cNvPr id="44" name="Shape 38"/>
+          <p:cNvSpPr/>
+          <p:nvPr/>
+        </p:nvSpPr>
+        <p:spPr>
+          <a:xfrm>
+            <a:off x="2889504" y="4142232"/>
+            <a:ext cx="786384" cy="0"/>
+          </a:xfrm>
+          <a:prstGeom prst="line">
+            <a:avLst/>
+          </a:prstGeom>
+          <a:noFill/>
+          <a:ln w="20320">
+            <a:solidFill>
+              <a:srgbClr val="405394"/>
+            </a:solidFill>
+            <a:prstDash val="solid"/>
+            <a:headEnd type="triangle"/>
+            <a:tailEnd type="triangle"/>
+          </a:ln>
+        </p:spPr>
+      </p:sp>
+      <p:sp>
+        <p:nvSpPr>
+          <p:cNvPr id="45" name="Text 39"/>
+          <p:cNvSpPr/>
+          <p:nvPr/>
+        </p:nvSpPr>
+        <p:spPr>
+          <a:xfrm>
+            <a:off x="2907792" y="3538728"/>
+            <a:ext cx="758952" cy="201168"/>
+          </a:xfrm>
+          <a:prstGeom prst="rect">
+            <a:avLst/>
+          </a:prstGeom>
+          <a:noFill/>
+          <a:ln/>
+        </p:spPr>
+        <p:txBody>
+          <a:bodyPr wrap="square" lIns="0" tIns="0" rIns="0" bIns="0" rtlCol="0" anchor="ctr"/>
+          <a:lstStyle/>
+          <a:p>
+            <a:pPr indent="0" marL="0">
+              <a:buNone/>
+            </a:pPr>
+            <a:r>
+              <a:rPr lang="en-US" sz="1200" dirty="0">
                 <a:solidFill>
                   <a:srgbClr val="405394"/>
                 </a:solidFill>
@@ -3793,9 +4796,240 @@
                 <a:ea typeface="Apple SD Gothic Neo" pitchFamily="34" charset="-122"/>
                 <a:cs typeface="Apple SD Gothic Neo" pitchFamily="34" charset="-120"/>
               </a:rPr>
-              <a:t>연결이 복구되면 자동 동기화</a:t>
-            </a:r>
-            <a:endParaRPr lang="en-US" sz="2800" dirty="0"/>
+              <a:t>HTTPS</a:t>
+            </a:r>
+            <a:endParaRPr lang="en-US" sz="1200" dirty="0"/>
+          </a:p>
+        </p:txBody>
+      </p:sp>
+      <p:sp>
+        <p:nvSpPr>
+          <p:cNvPr id="46" name="Text 40"/>
+          <p:cNvSpPr/>
+          <p:nvPr/>
+        </p:nvSpPr>
+        <p:spPr>
+          <a:xfrm>
+            <a:off x="2907792" y="3813048"/>
+            <a:ext cx="758952" cy="201168"/>
+          </a:xfrm>
+          <a:prstGeom prst="rect">
+            <a:avLst/>
+          </a:prstGeom>
+          <a:noFill/>
+          <a:ln/>
+        </p:spPr>
+        <p:txBody>
+          <a:bodyPr wrap="square" lIns="0" tIns="0" rIns="0" bIns="0" rtlCol="0" anchor="ctr"/>
+          <a:lstStyle/>
+          <a:p>
+            <a:pPr indent="0" marL="0">
+              <a:buNone/>
+            </a:pPr>
+            <a:r>
+              <a:rPr lang="en-US" sz="1200" dirty="0">
+                <a:solidFill>
+                  <a:srgbClr val="626B80"/>
+                </a:solidFill>
+                <a:latin typeface="Apple SD Gothic Neo" pitchFamily="34" charset="0"/>
+                <a:ea typeface="Apple SD Gothic Neo" pitchFamily="34" charset="-122"/>
+                <a:cs typeface="Apple SD Gothic Neo" pitchFamily="34" charset="-120"/>
+              </a:rPr>
+              <a:t>Bearer</a:t>
+            </a:r>
+            <a:endParaRPr lang="en-US" sz="1200" dirty="0"/>
+          </a:p>
+        </p:txBody>
+      </p:sp>
+      <p:sp>
+        <p:nvSpPr>
+          <p:cNvPr id="47" name="Shape 41"/>
+          <p:cNvSpPr/>
+          <p:nvPr/>
+        </p:nvSpPr>
+        <p:spPr>
+          <a:xfrm>
+            <a:off x="7735824" y="2770632"/>
+            <a:ext cx="685800" cy="0"/>
+          </a:xfrm>
+          <a:prstGeom prst="line">
+            <a:avLst/>
+          </a:prstGeom>
+          <a:noFill/>
+          <a:ln w="20320">
+            <a:solidFill>
+              <a:srgbClr val="405394"/>
+            </a:solidFill>
+            <a:prstDash val="solid"/>
+            <a:headEnd type="triangle"/>
+            <a:tailEnd type="triangle"/>
+          </a:ln>
+        </p:spPr>
+      </p:sp>
+      <p:sp>
+        <p:nvSpPr>
+          <p:cNvPr id="48" name="Text 42"/>
+          <p:cNvSpPr/>
+          <p:nvPr/>
+        </p:nvSpPr>
+        <p:spPr>
+          <a:xfrm>
+            <a:off x="7744968" y="2450592"/>
+            <a:ext cx="676656" cy="201168"/>
+          </a:xfrm>
+          <a:prstGeom prst="rect">
+            <a:avLst/>
+          </a:prstGeom>
+          <a:noFill/>
+          <a:ln/>
+        </p:spPr>
+        <p:txBody>
+          <a:bodyPr wrap="square" lIns="0" tIns="0" rIns="0" bIns="0" rtlCol="0" anchor="ctr"/>
+          <a:lstStyle/>
+          <a:p>
+            <a:pPr indent="0" marL="0">
+              <a:buNone/>
+            </a:pPr>
+            <a:r>
+              <a:rPr lang="en-US" sz="1200" dirty="0">
+                <a:solidFill>
+                  <a:srgbClr val="405394"/>
+                </a:solidFill>
+                <a:latin typeface="Apple SD Gothic Neo" pitchFamily="34" charset="0"/>
+                <a:ea typeface="Apple SD Gothic Neo" pitchFamily="34" charset="-122"/>
+                <a:cs typeface="Apple SD Gothic Neo" pitchFamily="34" charset="-120"/>
+              </a:rPr>
+              <a:t>HTTP</a:t>
+            </a:r>
+            <a:endParaRPr lang="en-US" sz="1200" dirty="0"/>
+          </a:p>
+        </p:txBody>
+      </p:sp>
+      <p:sp>
+        <p:nvSpPr>
+          <p:cNvPr id="49" name="Shape 43"/>
+          <p:cNvSpPr/>
+          <p:nvPr/>
+        </p:nvSpPr>
+        <p:spPr>
+          <a:xfrm>
+            <a:off x="7735824" y="4160520"/>
+            <a:ext cx="685800" cy="0"/>
+          </a:xfrm>
+          <a:prstGeom prst="line">
+            <a:avLst/>
+          </a:prstGeom>
+          <a:noFill/>
+          <a:ln w="20320">
+            <a:solidFill>
+              <a:srgbClr val="405394"/>
+            </a:solidFill>
+            <a:prstDash val="solid"/>
+            <a:headEnd type="triangle"/>
+            <a:tailEnd type="triangle"/>
+          </a:ln>
+        </p:spPr>
+      </p:sp>
+      <p:sp>
+        <p:nvSpPr>
+          <p:cNvPr id="50" name="Text 44"/>
+          <p:cNvSpPr/>
+          <p:nvPr/>
+        </p:nvSpPr>
+        <p:spPr>
+          <a:xfrm>
+            <a:off x="7744968" y="3822192"/>
+            <a:ext cx="676656" cy="201168"/>
+          </a:xfrm>
+          <a:prstGeom prst="rect">
+            <a:avLst/>
+          </a:prstGeom>
+          <a:noFill/>
+          <a:ln/>
+        </p:spPr>
+        <p:txBody>
+          <a:bodyPr wrap="square" lIns="0" tIns="0" rIns="0" bIns="0" rtlCol="0" anchor="ctr"/>
+          <a:lstStyle/>
+          <a:p>
+            <a:pPr indent="0" marL="0">
+              <a:buNone/>
+            </a:pPr>
+            <a:r>
+              <a:rPr lang="en-US" sz="1100" dirty="0">
+                <a:solidFill>
+                  <a:srgbClr val="405394"/>
+                </a:solidFill>
+                <a:latin typeface="Apple SD Gothic Neo" pitchFamily="34" charset="0"/>
+                <a:ea typeface="Apple SD Gothic Neo" pitchFamily="34" charset="-122"/>
+                <a:cs typeface="Apple SD Gothic Neo" pitchFamily="34" charset="-120"/>
+              </a:rPr>
+              <a:t>프로세스</a:t>
+            </a:r>
+            <a:endParaRPr lang="en-US" sz="1100" dirty="0"/>
+          </a:p>
+        </p:txBody>
+      </p:sp>
+      <p:sp>
+        <p:nvSpPr>
+          <p:cNvPr id="51" name="Shape 45"/>
+          <p:cNvSpPr/>
+          <p:nvPr/>
+        </p:nvSpPr>
+        <p:spPr>
+          <a:xfrm>
+            <a:off x="7735824" y="5513832"/>
+            <a:ext cx="685800" cy="0"/>
+          </a:xfrm>
+          <a:prstGeom prst="line">
+            <a:avLst/>
+          </a:prstGeom>
+          <a:noFill/>
+          <a:ln w="20320">
+            <a:solidFill>
+              <a:srgbClr val="405394"/>
+            </a:solidFill>
+            <a:prstDash val="solid"/>
+            <a:headEnd type="triangle"/>
+            <a:tailEnd type="triangle"/>
+          </a:ln>
+        </p:spPr>
+      </p:sp>
+      <p:sp>
+        <p:nvSpPr>
+          <p:cNvPr id="52" name="Text 46"/>
+          <p:cNvSpPr/>
+          <p:nvPr/>
+        </p:nvSpPr>
+        <p:spPr>
+          <a:xfrm>
+            <a:off x="7744968" y="5193792"/>
+            <a:ext cx="676656" cy="201168"/>
+          </a:xfrm>
+          <a:prstGeom prst="rect">
+            <a:avLst/>
+          </a:prstGeom>
+          <a:noFill/>
+          <a:ln/>
+        </p:spPr>
+        <p:txBody>
+          <a:bodyPr wrap="square" lIns="0" tIns="0" rIns="0" bIns="0" rtlCol="0" anchor="ctr"/>
+          <a:lstStyle/>
+          <a:p>
+            <a:pPr indent="0" marL="0">
+              <a:buNone/>
+            </a:pPr>
+            <a:r>
+              <a:rPr lang="en-US" sz="1200" dirty="0">
+                <a:solidFill>
+                  <a:srgbClr val="405394"/>
+                </a:solidFill>
+                <a:latin typeface="Apple SD Gothic Neo" pitchFamily="34" charset="0"/>
+                <a:ea typeface="Apple SD Gothic Neo" pitchFamily="34" charset="-122"/>
+                <a:cs typeface="Apple SD Gothic Neo" pitchFamily="34" charset="-120"/>
+              </a:rPr>
+              <a:t>SQL</a:t>
+            </a:r>
+            <a:endParaRPr lang="en-US" sz="1200" dirty="0"/>
           </a:p>
         </p:txBody>
       </p:sp>

</xml_diff>

<commit_message>
docs: simplify architecture to server APIs and data flows
</commit_message>
<xml_diff>
--- a/presentation/SpeechBridge.pptx
+++ b/presentation/SpeechBridge.pptx
@@ -948,7 +948,7 @@
           <a:p>
             <a:r>
               <a:rPr lang="en-US" dirty="0"/>
-              <a:t>Kotlin Multiplatform · Compose Multiplatform · Ktor / HTTPS · Node.js / Ollama · NeMo-Speech.cpp · Python · MLX / PostgreSQL</a:t>
+              <a:t>모바일 앱 ↔ MacBook 서버: Node.js HTTP API ↔ Ollama API / NeMo-Speech.cpp / Python·MLX / PostgreSQL. 회원 인증·음성 인식·번역·음성 합성·할 일 추출·기록 동기화 API.</a:t>
             </a:r>
             <a:endParaRPr lang="en-US" dirty="0"/>
           </a:p>
@@ -3316,7 +3316,7 @@
                 <a:ea typeface="Apple SD Gothic Neo" pitchFamily="34" charset="-122"/>
                 <a:cs typeface="Apple SD Gothic Neo" pitchFamily="34" charset="-120"/>
               </a:rPr>
-              <a:t>시스템 아키텍처 · API 흐름</a:t>
+              <a:t>시스템 아키텍처</a:t>
             </a:r>
             <a:endParaRPr lang="en-US" sz="3400" dirty="0"/>
           </a:p>
@@ -3369,8 +3369,8 @@
         </p:nvSpPr>
         <p:spPr>
           <a:xfrm>
-            <a:off x="3337560" y="1508760"/>
-            <a:ext cx="8275320" cy="4800600"/>
+            <a:off x="2971800" y="1508760"/>
+            <a:ext cx="8641080" cy="4800600"/>
           </a:xfrm>
           <a:prstGeom prst="roundRect">
             <a:avLst>
@@ -3398,24 +3398,24 @@
         </p:nvSpPr>
         <p:spPr>
           <a:xfrm>
-            <a:off x="3611880" y="1691640"/>
-            <a:ext cx="7498080" cy="329184"/>
-          </a:xfrm>
-          <a:prstGeom prst="rect">
-            <a:avLst/>
-          </a:prstGeom>
-          <a:noFill/>
-          <a:ln/>
-        </p:spPr>
-        <p:txBody>
-          <a:bodyPr wrap="square" lIns="0" tIns="0" rIns="0" bIns="0" rtlCol="0" anchor="ctr"/>
-          <a:lstStyle/>
-          <a:p>
-            <a:pPr indent="0" marL="0">
-              <a:buNone/>
-            </a:pPr>
-            <a:r>
-              <a:rPr lang="en-US" sz="2100" b="1" dirty="0">
+            <a:off x="3264408" y="1700784"/>
+            <a:ext cx="7955280" cy="365760"/>
+          </a:xfrm>
+          <a:prstGeom prst="rect">
+            <a:avLst/>
+          </a:prstGeom>
+          <a:noFill/>
+          <a:ln/>
+        </p:spPr>
+        <p:txBody>
+          <a:bodyPr wrap="square" lIns="0" tIns="0" rIns="0" bIns="0" rtlCol="0" anchor="ctr"/>
+          <a:lstStyle/>
+          <a:p>
+            <a:pPr indent="0" marL="0">
+              <a:buNone/>
+            </a:pPr>
+            <a:r>
+              <a:rPr lang="en-US" sz="2500" b="1" dirty="0">
                 <a:solidFill>
                   <a:srgbClr val="405394"/>
                 </a:solidFill>
@@ -3423,9 +3423,9 @@
                 <a:ea typeface="Apple SD Gothic Neo" pitchFamily="34" charset="-122"/>
                 <a:cs typeface="Apple SD Gothic Neo" pitchFamily="34" charset="-120"/>
               </a:rPr>
-              <a:t>MacBook</a:t>
-            </a:r>
-            <a:endParaRPr lang="en-US" sz="2100" dirty="0"/>
+              <a:t>MacBook 서버</a:t>
+            </a:r>
+            <a:endParaRPr lang="en-US" sz="2500" dirty="0"/>
           </a:p>
         </p:txBody>
       </p:sp>
@@ -3437,12 +3437,12 @@
         </p:nvSpPr>
         <p:spPr>
           <a:xfrm>
-            <a:off x="548640" y="2286000"/>
-            <a:ext cx="2331720" cy="3300984"/>
+            <a:off x="548640" y="2834640"/>
+            <a:ext cx="1874520" cy="1737360"/>
           </a:xfrm>
           <a:prstGeom prst="roundRect">
             <a:avLst>
-              <a:gd name="adj" fmla="val 7843"/>
+              <a:gd name="adj" fmla="val 10526"/>
             </a:avLst>
           </a:prstGeom>
           <a:solidFill>
@@ -3458,200 +3458,109 @@
           </a:ln>
         </p:spPr>
       </p:sp>
-      <p:pic>
-        <p:nvPicPr>
-          <p:cNvPr id="9" name="Image 0" descr="kotlin-multiplatform">    </p:cNvPr>
-          <p:cNvPicPr>
-            <a:picLocks noChangeAspect="1"/>
-          </p:cNvPicPr>
-          <p:nvPr/>
-        </p:nvPicPr>
-        <p:blipFill>
-          <a:blip r:embed="rId1"/>
-          <a:stretch>
-            <a:fillRect/>
-          </a:stretch>
-        </p:blipFill>
-        <p:spPr>
-          <a:xfrm>
-            <a:off x="731520" y="2704636"/>
-            <a:ext cx="1965960" cy="205144"/>
-          </a:xfrm>
-          <a:prstGeom prst="rect">
-            <a:avLst/>
-          </a:prstGeom>
-        </p:spPr>
-      </p:pic>
-      <p:sp>
-        <p:nvSpPr>
-          <p:cNvPr id="10" name="Text 6"/>
-          <p:cNvSpPr/>
-          <p:nvPr/>
-        </p:nvSpPr>
-        <p:spPr>
-          <a:xfrm>
-            <a:off x="786384" y="3410712"/>
-            <a:ext cx="1920240" cy="347472"/>
-          </a:xfrm>
-          <a:prstGeom prst="rect">
-            <a:avLst/>
-          </a:prstGeom>
-          <a:noFill/>
-          <a:ln/>
-        </p:spPr>
-        <p:txBody>
-          <a:bodyPr wrap="square" lIns="0" tIns="0" rIns="0" bIns="0" rtlCol="0" anchor="ctr"/>
-          <a:lstStyle/>
-          <a:p>
-            <a:pPr indent="0" marL="0">
-              <a:buNone/>
-            </a:pPr>
-            <a:r>
-              <a:rPr lang="en-US" sz="2300" b="1" dirty="0">
-                <a:solidFill>
-                  <a:srgbClr val="405394"/>
-                </a:solidFill>
-                <a:latin typeface="Apple SD Gothic Neo" pitchFamily="34" charset="0"/>
-                <a:ea typeface="Apple SD Gothic Neo" pitchFamily="34" charset="-122"/>
-                <a:cs typeface="Apple SD Gothic Neo" pitchFamily="34" charset="-120"/>
-              </a:rPr>
-              <a:t>Android · iOS</a:t>
-            </a:r>
-            <a:endParaRPr lang="en-US" sz="2300" dirty="0"/>
-          </a:p>
-        </p:txBody>
-      </p:sp>
-      <p:sp>
-        <p:nvSpPr>
-          <p:cNvPr id="11" name="Text 7"/>
-          <p:cNvSpPr/>
-          <p:nvPr/>
-        </p:nvSpPr>
-        <p:spPr>
-          <a:xfrm>
-            <a:off x="786384" y="3968496"/>
-            <a:ext cx="1920240" cy="365760"/>
-          </a:xfrm>
-          <a:prstGeom prst="rect">
-            <a:avLst/>
-          </a:prstGeom>
-          <a:noFill/>
-          <a:ln/>
-        </p:spPr>
-        <p:txBody>
-          <a:bodyPr wrap="square" lIns="0" tIns="0" rIns="0" bIns="0" rtlCol="0" anchor="ctr"/>
-          <a:lstStyle/>
-          <a:p>
-            <a:pPr indent="0" marL="0">
-              <a:buNone/>
-            </a:pPr>
-            <a:r>
-              <a:rPr lang="en-US" sz="1500" dirty="0">
-                <a:solidFill>
-                  <a:srgbClr val="242938"/>
-                </a:solidFill>
-                <a:latin typeface="Apple SD Gothic Neo" pitchFamily="34" charset="0"/>
-                <a:ea typeface="Apple SD Gothic Neo" pitchFamily="34" charset="-122"/>
-                <a:cs typeface="Apple SD Gothic Neo" pitchFamily="34" charset="-120"/>
-              </a:rPr>
-              <a:t>Compose Multiplatform</a:t>
-            </a:r>
-            <a:endParaRPr lang="en-US" sz="1500" dirty="0"/>
-          </a:p>
-        </p:txBody>
-      </p:sp>
-      <p:sp>
-        <p:nvSpPr>
-          <p:cNvPr id="12" name="Text 8"/>
-          <p:cNvSpPr/>
-          <p:nvPr/>
-        </p:nvSpPr>
-        <p:spPr>
-          <a:xfrm>
-            <a:off x="786384" y="4498848"/>
-            <a:ext cx="1920240" cy="320040"/>
-          </a:xfrm>
-          <a:prstGeom prst="rect">
-            <a:avLst/>
-          </a:prstGeom>
-          <a:noFill/>
-          <a:ln/>
-        </p:spPr>
-        <p:txBody>
-          <a:bodyPr wrap="square" lIns="0" tIns="0" rIns="0" bIns="0" rtlCol="0" anchor="ctr"/>
-          <a:lstStyle/>
-          <a:p>
-            <a:pPr indent="0" marL="0">
-              <a:buNone/>
-            </a:pPr>
-            <a:r>
-              <a:rPr lang="en-US" sz="2000" dirty="0">
-                <a:solidFill>
-                  <a:srgbClr val="242938"/>
-                </a:solidFill>
-                <a:latin typeface="Apple SD Gothic Neo" pitchFamily="34" charset="0"/>
-                <a:ea typeface="Apple SD Gothic Neo" pitchFamily="34" charset="-122"/>
-                <a:cs typeface="Apple SD Gothic Neo" pitchFamily="34" charset="-120"/>
-              </a:rPr>
-              <a:t>Ktor Client</a:t>
-            </a:r>
-            <a:endParaRPr lang="en-US" sz="2000" dirty="0"/>
-          </a:p>
-        </p:txBody>
-      </p:sp>
-      <p:sp>
-        <p:nvSpPr>
-          <p:cNvPr id="13" name="Text 9"/>
-          <p:cNvSpPr/>
-          <p:nvPr/>
-        </p:nvSpPr>
-        <p:spPr>
-          <a:xfrm>
-            <a:off x="786384" y="5093208"/>
-            <a:ext cx="1920240" cy="256032"/>
-          </a:xfrm>
-          <a:prstGeom prst="rect">
-            <a:avLst/>
-          </a:prstGeom>
-          <a:noFill/>
-          <a:ln/>
-        </p:spPr>
-        <p:txBody>
-          <a:bodyPr wrap="square" lIns="0" tIns="0" rIns="0" bIns="0" rtlCol="0" anchor="ctr"/>
-          <a:lstStyle/>
-          <a:p>
-            <a:pPr indent="0" marL="0">
-              <a:buNone/>
-            </a:pPr>
-            <a:r>
-              <a:rPr lang="en-US" sz="1500" dirty="0">
-                <a:solidFill>
-                  <a:srgbClr val="626B80"/>
-                </a:solidFill>
-                <a:latin typeface="Apple SD Gothic Neo" pitchFamily="34" charset="0"/>
-                <a:ea typeface="Apple SD Gothic Neo" pitchFamily="34" charset="-122"/>
-                <a:cs typeface="Apple SD Gothic Neo" pitchFamily="34" charset="-120"/>
-              </a:rPr>
-              <a:t>Keychain · Keystore</a:t>
-            </a:r>
-            <a:endParaRPr lang="en-US" sz="1500" dirty="0"/>
-          </a:p>
-        </p:txBody>
-      </p:sp>
-      <p:sp>
-        <p:nvSpPr>
-          <p:cNvPr id="14" name="Shape 10"/>
-          <p:cNvSpPr/>
-          <p:nvPr/>
-        </p:nvSpPr>
-        <p:spPr>
-          <a:xfrm>
-            <a:off x="3712464" y="2167128"/>
-            <a:ext cx="3986784" cy="3867912"/>
+      <p:sp>
+        <p:nvSpPr>
+          <p:cNvPr id="9" name="Shape 6"/>
+          <p:cNvSpPr/>
+          <p:nvPr/>
+        </p:nvSpPr>
+        <p:spPr>
+          <a:xfrm>
+            <a:off x="1207008" y="3072384"/>
+            <a:ext cx="530352" cy="731520"/>
           </a:xfrm>
           <a:prstGeom prst="roundRect">
             <a:avLst>
-              <a:gd name="adj" fmla="val 4728"/>
+              <a:gd name="adj" fmla="val 13793"/>
+            </a:avLst>
+          </a:prstGeom>
+          <a:solidFill>
+            <a:srgbClr val="FFFFFF"/>
+          </a:solidFill>
+          <a:ln w="25400">
+            <a:solidFill>
+              <a:srgbClr val="405394"/>
+            </a:solidFill>
+            <a:prstDash val="solid"/>
+          </a:ln>
+        </p:spPr>
+      </p:sp>
+      <p:sp>
+        <p:nvSpPr>
+          <p:cNvPr id="10" name="Shape 7"/>
+          <p:cNvSpPr/>
+          <p:nvPr/>
+        </p:nvSpPr>
+        <p:spPr>
+          <a:xfrm>
+            <a:off x="1362456" y="3694176"/>
+            <a:ext cx="219456" cy="0"/>
+          </a:xfrm>
+          <a:prstGeom prst="line">
+            <a:avLst/>
+          </a:prstGeom>
+          <a:noFill/>
+          <a:ln w="25400">
+            <a:solidFill>
+              <a:srgbClr val="405394"/>
+            </a:solidFill>
+            <a:prstDash val="solid"/>
+          </a:ln>
+        </p:spPr>
+      </p:sp>
+      <p:sp>
+        <p:nvSpPr>
+          <p:cNvPr id="11" name="Text 8"/>
+          <p:cNvSpPr/>
+          <p:nvPr/>
+        </p:nvSpPr>
+        <p:spPr>
+          <a:xfrm>
+            <a:off x="777240" y="4005072"/>
+            <a:ext cx="1417320" cy="365760"/>
+          </a:xfrm>
+          <a:prstGeom prst="rect">
+            <a:avLst/>
+          </a:prstGeom>
+          <a:noFill/>
+          <a:ln/>
+        </p:spPr>
+        <p:txBody>
+          <a:bodyPr wrap="square" lIns="0" tIns="0" rIns="0" bIns="0" rtlCol="0" anchor="ctr"/>
+          <a:lstStyle/>
+          <a:p>
+            <a:pPr indent="0" marL="0">
+              <a:buNone/>
+            </a:pPr>
+            <a:r>
+              <a:rPr lang="en-US" sz="2400" b="1" dirty="0">
+                <a:solidFill>
+                  <a:srgbClr val="405394"/>
+                </a:solidFill>
+                <a:latin typeface="Apple SD Gothic Neo" pitchFamily="34" charset="0"/>
+                <a:ea typeface="Apple SD Gothic Neo" pitchFamily="34" charset="-122"/>
+                <a:cs typeface="Apple SD Gothic Neo" pitchFamily="34" charset="-120"/>
+              </a:rPr>
+              <a:t>모바일 앱</a:t>
+            </a:r>
+            <a:endParaRPr lang="en-US" sz="2400" dirty="0"/>
+          </a:p>
+        </p:txBody>
+      </p:sp>
+      <p:sp>
+        <p:nvSpPr>
+          <p:cNvPr id="12" name="Shape 9"/>
+          <p:cNvSpPr/>
+          <p:nvPr/>
+        </p:nvSpPr>
+        <p:spPr>
+          <a:xfrm>
+            <a:off x="3328416" y="2304288"/>
+            <a:ext cx="3767328" cy="3648456"/>
+          </a:xfrm>
+          <a:prstGeom prst="roundRect">
+            <a:avLst>
+              <a:gd name="adj" fmla="val 5013"/>
             </a:avLst>
           </a:prstGeom>
           <a:solidFill>
@@ -3669,22 +3578,22 @@
       </p:sp>
       <p:pic>
         <p:nvPicPr>
-          <p:cNvPr id="15" name="Image 1" descr="nodejs">    </p:cNvPr>
+          <p:cNvPr id="13" name="Image 0" descr="nodejs">    </p:cNvPr>
           <p:cNvPicPr>
             <a:picLocks noChangeAspect="1"/>
           </p:cNvPicPr>
           <p:nvPr/>
         </p:nvPicPr>
         <p:blipFill>
-          <a:blip r:embed="rId2"/>
+          <a:blip r:embed="rId1"/>
           <a:stretch>
             <a:fillRect/>
           </a:stretch>
         </p:blipFill>
         <p:spPr>
           <a:xfrm>
-            <a:off x="3977640" y="2425477"/>
-            <a:ext cx="1207008" cy="361126"/>
+            <a:off x="3602736" y="2665057"/>
+            <a:ext cx="1225296" cy="366598"/>
           </a:xfrm>
           <a:prstGeom prst="rect">
             <a:avLst/>
@@ -3693,14 +3602,53 @@
       </p:pic>
       <p:sp>
         <p:nvSpPr>
-          <p:cNvPr id="16" name="Text 11"/>
-          <p:cNvSpPr/>
-          <p:nvPr/>
-        </p:nvSpPr>
-        <p:spPr>
-          <a:xfrm>
-            <a:off x="5404104" y="2441448"/>
-            <a:ext cx="2039112" cy="365760"/>
+          <p:cNvPr id="14" name="Text 10"/>
+          <p:cNvSpPr/>
+          <p:nvPr/>
+        </p:nvSpPr>
+        <p:spPr>
+          <a:xfrm>
+            <a:off x="5102352" y="2606040"/>
+            <a:ext cx="1673352" cy="365760"/>
+          </a:xfrm>
+          <a:prstGeom prst="rect">
+            <a:avLst/>
+          </a:prstGeom>
+          <a:noFill/>
+          <a:ln/>
+        </p:spPr>
+        <p:txBody>
+          <a:bodyPr wrap="square" lIns="0" tIns="0" rIns="0" bIns="0" rtlCol="0" anchor="ctr"/>
+          <a:lstStyle/>
+          <a:p>
+            <a:pPr indent="0" marL="0">
+              <a:buNone/>
+            </a:pPr>
+            <a:r>
+              <a:rPr lang="en-US" sz="2500" b="1" dirty="0">
+                <a:solidFill>
+                  <a:srgbClr val="405394"/>
+                </a:solidFill>
+                <a:latin typeface="Apple SD Gothic Neo" pitchFamily="34" charset="0"/>
+                <a:ea typeface="Apple SD Gothic Neo" pitchFamily="34" charset="-122"/>
+                <a:cs typeface="Apple SD Gothic Neo" pitchFamily="34" charset="-120"/>
+              </a:rPr>
+              <a:t>API 서버</a:t>
+            </a:r>
+            <a:endParaRPr lang="en-US" sz="2500" dirty="0"/>
+          </a:p>
+        </p:txBody>
+      </p:sp>
+      <p:sp>
+        <p:nvSpPr>
+          <p:cNvPr id="15" name="Text 11"/>
+          <p:cNvSpPr/>
+          <p:nvPr/>
+        </p:nvSpPr>
+        <p:spPr>
+          <a:xfrm>
+            <a:off x="3630168" y="3337560"/>
+            <a:ext cx="3200400" cy="329184"/>
           </a:xfrm>
           <a:prstGeom prst="rect">
             <a:avLst/>
@@ -3718,7 +3666,7 @@
             <a:r>
               <a:rPr lang="en-US" sz="2300" b="1" dirty="0">
                 <a:solidFill>
-                  <a:srgbClr val="405394"/>
+                  <a:srgbClr val="242938"/>
                 </a:solidFill>
                 <a:latin typeface="Apple SD Gothic Neo" pitchFamily="34" charset="0"/>
                 <a:ea typeface="Apple SD Gothic Neo" pitchFamily="34" charset="-122"/>
@@ -3732,108 +3680,30 @@
       </p:sp>
       <p:sp>
         <p:nvSpPr>
-          <p:cNvPr id="17" name="Text 12"/>
-          <p:cNvSpPr/>
-          <p:nvPr/>
-        </p:nvSpPr>
-        <p:spPr>
-          <a:xfrm>
-            <a:off x="3977640" y="3008376"/>
-            <a:ext cx="3474720" cy="256032"/>
-          </a:xfrm>
-          <a:prstGeom prst="rect">
-            <a:avLst/>
-          </a:prstGeom>
-          <a:noFill/>
-          <a:ln/>
-        </p:spPr>
-        <p:txBody>
-          <a:bodyPr wrap="square" lIns="0" tIns="0" rIns="0" bIns="0" rtlCol="0" anchor="ctr"/>
-          <a:lstStyle/>
-          <a:p>
-            <a:pPr indent="0" marL="0">
-              <a:buNone/>
-            </a:pPr>
-            <a:r>
-              <a:rPr lang="en-US" sz="1700" dirty="0">
-                <a:solidFill>
-                  <a:srgbClr val="626B80"/>
-                </a:solidFill>
-                <a:latin typeface="Apple SD Gothic Neo" pitchFamily="34" charset="0"/>
-                <a:ea typeface="Apple SD Gothic Neo" pitchFamily="34" charset="-122"/>
-                <a:cs typeface="Apple SD Gothic Neo" pitchFamily="34" charset="-120"/>
-              </a:rPr>
-              <a:t>node:http · node:https</a:t>
-            </a:r>
-            <a:endParaRPr lang="en-US" sz="1700" dirty="0"/>
-          </a:p>
-        </p:txBody>
-      </p:sp>
-      <p:sp>
-        <p:nvSpPr>
-          <p:cNvPr id="18" name="Text 13"/>
-          <p:cNvSpPr/>
-          <p:nvPr/>
-        </p:nvSpPr>
-        <p:spPr>
-          <a:xfrm>
-            <a:off x="3977640" y="3575304"/>
-            <a:ext cx="484632" cy="201168"/>
-          </a:xfrm>
-          <a:prstGeom prst="rect">
-            <a:avLst/>
-          </a:prstGeom>
-          <a:noFill/>
-          <a:ln/>
-        </p:spPr>
-        <p:txBody>
-          <a:bodyPr wrap="square" lIns="0" tIns="0" rIns="0" bIns="0" rtlCol="0" anchor="ctr"/>
-          <a:lstStyle/>
-          <a:p>
-            <a:pPr indent="0" marL="0">
-              <a:buNone/>
-            </a:pPr>
-            <a:r>
-              <a:rPr lang="en-US" sz="1200" b="1" dirty="0">
-                <a:solidFill>
-                  <a:srgbClr val="405394"/>
-                </a:solidFill>
-                <a:latin typeface="Apple SD Gothic Neo" pitchFamily="34" charset="0"/>
-                <a:ea typeface="Apple SD Gothic Neo" pitchFamily="34" charset="-122"/>
-                <a:cs typeface="Apple SD Gothic Neo" pitchFamily="34" charset="-120"/>
-              </a:rPr>
-              <a:t>POST</a:t>
-            </a:r>
-            <a:endParaRPr lang="en-US" sz="1200" dirty="0"/>
-          </a:p>
-        </p:txBody>
-      </p:sp>
-      <p:sp>
-        <p:nvSpPr>
-          <p:cNvPr id="19" name="Text 14"/>
-          <p:cNvSpPr/>
-          <p:nvPr/>
-        </p:nvSpPr>
-        <p:spPr>
-          <a:xfrm>
-            <a:off x="4553712" y="3575304"/>
-            <a:ext cx="2926080" cy="201168"/>
-          </a:xfrm>
-          <a:prstGeom prst="rect">
-            <a:avLst/>
-          </a:prstGeom>
-          <a:noFill/>
-          <a:ln/>
-        </p:spPr>
-        <p:txBody>
-          <a:bodyPr wrap="square" lIns="0" tIns="0" rIns="0" bIns="0" rtlCol="0" anchor="ctr"/>
-          <a:lstStyle/>
-          <a:p>
-            <a:pPr indent="0" marL="0">
-              <a:buNone/>
-            </a:pPr>
-            <a:r>
-              <a:rPr lang="en-US" sz="1400" dirty="0">
+          <p:cNvPr id="16" name="Text 12"/>
+          <p:cNvSpPr/>
+          <p:nvPr/>
+        </p:nvSpPr>
+        <p:spPr>
+          <a:xfrm>
+            <a:off x="3630168" y="3977640"/>
+            <a:ext cx="3200400" cy="237744"/>
+          </a:xfrm>
+          <a:prstGeom prst="rect">
+            <a:avLst/>
+          </a:prstGeom>
+          <a:noFill/>
+          <a:ln/>
+        </p:spPr>
+        <p:txBody>
+          <a:bodyPr wrap="square" lIns="0" tIns="0" rIns="0" bIns="0" rtlCol="0" anchor="ctr"/>
+          <a:lstStyle/>
+          <a:p>
+            <a:pPr indent="0" marL="0">
+              <a:buNone/>
+            </a:pPr>
+            <a:r>
+              <a:rPr lang="en-US" sz="1900" dirty="0">
                 <a:solidFill>
                   <a:srgbClr val="242938"/>
                 </a:solidFill>
@@ -3841,77 +3711,38 @@
                 <a:ea typeface="Apple SD Gothic Neo" pitchFamily="34" charset="-122"/>
                 <a:cs typeface="Apple SD Gothic Neo" pitchFamily="34" charset="-120"/>
               </a:rPr>
-              <a:t>/auth/register · /auth/login</a:t>
-            </a:r>
-            <a:endParaRPr lang="en-US" sz="1400" dirty="0"/>
-          </a:p>
-        </p:txBody>
-      </p:sp>
-      <p:sp>
-        <p:nvSpPr>
-          <p:cNvPr id="20" name="Text 15"/>
-          <p:cNvSpPr/>
-          <p:nvPr/>
-        </p:nvSpPr>
-        <p:spPr>
-          <a:xfrm>
-            <a:off x="3977640" y="3849624"/>
-            <a:ext cx="484632" cy="201168"/>
-          </a:xfrm>
-          <a:prstGeom prst="rect">
-            <a:avLst/>
-          </a:prstGeom>
-          <a:noFill/>
-          <a:ln/>
-        </p:spPr>
-        <p:txBody>
-          <a:bodyPr wrap="square" lIns="0" tIns="0" rIns="0" bIns="0" rtlCol="0" anchor="ctr"/>
-          <a:lstStyle/>
-          <a:p>
-            <a:pPr indent="0" marL="0">
-              <a:buNone/>
-            </a:pPr>
-            <a:r>
-              <a:rPr lang="en-US" sz="1200" b="1" dirty="0">
-                <a:solidFill>
-                  <a:srgbClr val="405394"/>
-                </a:solidFill>
-                <a:latin typeface="Apple SD Gothic Neo" pitchFamily="34" charset="0"/>
-                <a:ea typeface="Apple SD Gothic Neo" pitchFamily="34" charset="-122"/>
-                <a:cs typeface="Apple SD Gothic Neo" pitchFamily="34" charset="-120"/>
-              </a:rPr>
-              <a:t>POST</a:t>
-            </a:r>
-            <a:endParaRPr lang="en-US" sz="1200" dirty="0"/>
-          </a:p>
-        </p:txBody>
-      </p:sp>
-      <p:sp>
-        <p:nvSpPr>
-          <p:cNvPr id="21" name="Text 16"/>
-          <p:cNvSpPr/>
-          <p:nvPr/>
-        </p:nvSpPr>
-        <p:spPr>
-          <a:xfrm>
-            <a:off x="4553712" y="3849624"/>
-            <a:ext cx="2926080" cy="201168"/>
-          </a:xfrm>
-          <a:prstGeom prst="rect">
-            <a:avLst/>
-          </a:prstGeom>
-          <a:noFill/>
-          <a:ln/>
-        </p:spPr>
-        <p:txBody>
-          <a:bodyPr wrap="square" lIns="0" tIns="0" rIns="0" bIns="0" rtlCol="0" anchor="ctr"/>
-          <a:lstStyle/>
-          <a:p>
-            <a:pPr indent="0" marL="0">
-              <a:buNone/>
-            </a:pPr>
-            <a:r>
-              <a:rPr lang="en-US" sz="1400" dirty="0">
+              <a:t>회원 인증 API</a:t>
+            </a:r>
+            <a:endParaRPr lang="en-US" sz="1900" dirty="0"/>
+          </a:p>
+        </p:txBody>
+      </p:sp>
+      <p:sp>
+        <p:nvSpPr>
+          <p:cNvPr id="17" name="Text 13"/>
+          <p:cNvSpPr/>
+          <p:nvPr/>
+        </p:nvSpPr>
+        <p:spPr>
+          <a:xfrm>
+            <a:off x="3630168" y="4288536"/>
+            <a:ext cx="3200400" cy="237744"/>
+          </a:xfrm>
+          <a:prstGeom prst="rect">
+            <a:avLst/>
+          </a:prstGeom>
+          <a:noFill/>
+          <a:ln/>
+        </p:spPr>
+        <p:txBody>
+          <a:bodyPr wrap="square" lIns="0" tIns="0" rIns="0" bIns="0" rtlCol="0" anchor="ctr"/>
+          <a:lstStyle/>
+          <a:p>
+            <a:pPr indent="0" marL="0">
+              <a:buNone/>
+            </a:pPr>
+            <a:r>
+              <a:rPr lang="en-US" sz="1900" dirty="0">
                 <a:solidFill>
                   <a:srgbClr val="242938"/>
                 </a:solidFill>
@@ -3919,77 +3750,38 @@
                 <a:ea typeface="Apple SD Gothic Neo" pitchFamily="34" charset="-122"/>
                 <a:cs typeface="Apple SD Gothic Neo" pitchFamily="34" charset="-120"/>
               </a:rPr>
-              <a:t>/auth/logout · /auth/delete</a:t>
-            </a:r>
-            <a:endParaRPr lang="en-US" sz="1400" dirty="0"/>
-          </a:p>
-        </p:txBody>
-      </p:sp>
-      <p:sp>
-        <p:nvSpPr>
-          <p:cNvPr id="22" name="Text 17"/>
-          <p:cNvSpPr/>
-          <p:nvPr/>
-        </p:nvSpPr>
-        <p:spPr>
-          <a:xfrm>
-            <a:off x="3977640" y="4123944"/>
-            <a:ext cx="484632" cy="201168"/>
-          </a:xfrm>
-          <a:prstGeom prst="rect">
-            <a:avLst/>
-          </a:prstGeom>
-          <a:noFill/>
-          <a:ln/>
-        </p:spPr>
-        <p:txBody>
-          <a:bodyPr wrap="square" lIns="0" tIns="0" rIns="0" bIns="0" rtlCol="0" anchor="ctr"/>
-          <a:lstStyle/>
-          <a:p>
-            <a:pPr indent="0" marL="0">
-              <a:buNone/>
-            </a:pPr>
-            <a:r>
-              <a:rPr lang="en-US" sz="1200" b="1" dirty="0">
-                <a:solidFill>
-                  <a:srgbClr val="405394"/>
-                </a:solidFill>
-                <a:latin typeface="Apple SD Gothic Neo" pitchFamily="34" charset="0"/>
-                <a:ea typeface="Apple SD Gothic Neo" pitchFamily="34" charset="-122"/>
-                <a:cs typeface="Apple SD Gothic Neo" pitchFamily="34" charset="-120"/>
-              </a:rPr>
-              <a:t>GET</a:t>
-            </a:r>
-            <a:endParaRPr lang="en-US" sz="1200" dirty="0"/>
-          </a:p>
-        </p:txBody>
-      </p:sp>
-      <p:sp>
-        <p:nvSpPr>
-          <p:cNvPr id="23" name="Text 18"/>
-          <p:cNvSpPr/>
-          <p:nvPr/>
-        </p:nvSpPr>
-        <p:spPr>
-          <a:xfrm>
-            <a:off x="4553712" y="4123944"/>
-            <a:ext cx="2926080" cy="201168"/>
-          </a:xfrm>
-          <a:prstGeom prst="rect">
-            <a:avLst/>
-          </a:prstGeom>
-          <a:noFill/>
-          <a:ln/>
-        </p:spPr>
-        <p:txBody>
-          <a:bodyPr wrap="square" lIns="0" tIns="0" rIns="0" bIns="0" rtlCol="0" anchor="ctr"/>
-          <a:lstStyle/>
-          <a:p>
-            <a:pPr indent="0" marL="0">
-              <a:buNone/>
-            </a:pPr>
-            <a:r>
-              <a:rPr lang="en-US" sz="1400" dirty="0">
+              <a:t>음성 인식 API</a:t>
+            </a:r>
+            <a:endParaRPr lang="en-US" sz="1900" dirty="0"/>
+          </a:p>
+        </p:txBody>
+      </p:sp>
+      <p:sp>
+        <p:nvSpPr>
+          <p:cNvPr id="18" name="Text 14"/>
+          <p:cNvSpPr/>
+          <p:nvPr/>
+        </p:nvSpPr>
+        <p:spPr>
+          <a:xfrm>
+            <a:off x="3630168" y="4599432"/>
+            <a:ext cx="3200400" cy="237744"/>
+          </a:xfrm>
+          <a:prstGeom prst="rect">
+            <a:avLst/>
+          </a:prstGeom>
+          <a:noFill/>
+          <a:ln/>
+        </p:spPr>
+        <p:txBody>
+          <a:bodyPr wrap="square" lIns="0" tIns="0" rIns="0" bIns="0" rtlCol="0" anchor="ctr"/>
+          <a:lstStyle/>
+          <a:p>
+            <a:pPr indent="0" marL="0">
+              <a:buNone/>
+            </a:pPr>
+            <a:r>
+              <a:rPr lang="en-US" sz="1900" dirty="0">
                 <a:solidFill>
                   <a:srgbClr val="242938"/>
                 </a:solidFill>
@@ -3997,77 +3789,38 @@
                 <a:ea typeface="Apple SD Gothic Neo" pitchFamily="34" charset="-122"/>
                 <a:cs typeface="Apple SD Gothic Neo" pitchFamily="34" charset="-120"/>
               </a:rPr>
-              <a:t>/auth/me</a:t>
-            </a:r>
-            <a:endParaRPr lang="en-US" sz="1400" dirty="0"/>
-          </a:p>
-        </p:txBody>
-      </p:sp>
-      <p:sp>
-        <p:nvSpPr>
-          <p:cNvPr id="24" name="Text 19"/>
-          <p:cNvSpPr/>
-          <p:nvPr/>
-        </p:nvSpPr>
-        <p:spPr>
-          <a:xfrm>
-            <a:off x="3977640" y="4507992"/>
-            <a:ext cx="484632" cy="201168"/>
-          </a:xfrm>
-          <a:prstGeom prst="rect">
-            <a:avLst/>
-          </a:prstGeom>
-          <a:noFill/>
-          <a:ln/>
-        </p:spPr>
-        <p:txBody>
-          <a:bodyPr wrap="square" lIns="0" tIns="0" rIns="0" bIns="0" rtlCol="0" anchor="ctr"/>
-          <a:lstStyle/>
-          <a:p>
-            <a:pPr indent="0" marL="0">
-              <a:buNone/>
-            </a:pPr>
-            <a:r>
-              <a:rPr lang="en-US" sz="1200" b="1" dirty="0">
-                <a:solidFill>
-                  <a:srgbClr val="405394"/>
-                </a:solidFill>
-                <a:latin typeface="Apple SD Gothic Neo" pitchFamily="34" charset="0"/>
-                <a:ea typeface="Apple SD Gothic Neo" pitchFamily="34" charset="-122"/>
-                <a:cs typeface="Apple SD Gothic Neo" pitchFamily="34" charset="-120"/>
-              </a:rPr>
-              <a:t>POST</a:t>
-            </a:r>
-            <a:endParaRPr lang="en-US" sz="1200" dirty="0"/>
-          </a:p>
-        </p:txBody>
-      </p:sp>
-      <p:sp>
-        <p:nvSpPr>
-          <p:cNvPr id="25" name="Text 20"/>
-          <p:cNvSpPr/>
-          <p:nvPr/>
-        </p:nvSpPr>
-        <p:spPr>
-          <a:xfrm>
-            <a:off x="4553712" y="4507992"/>
-            <a:ext cx="2926080" cy="201168"/>
-          </a:xfrm>
-          <a:prstGeom prst="rect">
-            <a:avLst/>
-          </a:prstGeom>
-          <a:noFill/>
-          <a:ln/>
-        </p:spPr>
-        <p:txBody>
-          <a:bodyPr wrap="square" lIns="0" tIns="0" rIns="0" bIns="0" rtlCol="0" anchor="ctr"/>
-          <a:lstStyle/>
-          <a:p>
-            <a:pPr indent="0" marL="0">
-              <a:buNone/>
-            </a:pPr>
-            <a:r>
-              <a:rPr lang="en-US" sz="1400" dirty="0">
+              <a:t>번역 API</a:t>
+            </a:r>
+            <a:endParaRPr lang="en-US" sz="1900" dirty="0"/>
+          </a:p>
+        </p:txBody>
+      </p:sp>
+      <p:sp>
+        <p:nvSpPr>
+          <p:cNvPr id="19" name="Text 15"/>
+          <p:cNvSpPr/>
+          <p:nvPr/>
+        </p:nvSpPr>
+        <p:spPr>
+          <a:xfrm>
+            <a:off x="3630168" y="4910328"/>
+            <a:ext cx="3200400" cy="237744"/>
+          </a:xfrm>
+          <a:prstGeom prst="rect">
+            <a:avLst/>
+          </a:prstGeom>
+          <a:noFill/>
+          <a:ln/>
+        </p:spPr>
+        <p:txBody>
+          <a:bodyPr wrap="square" lIns="0" tIns="0" rIns="0" bIns="0" rtlCol="0" anchor="ctr"/>
+          <a:lstStyle/>
+          <a:p>
+            <a:pPr indent="0" marL="0">
+              <a:buNone/>
+            </a:pPr>
+            <a:r>
+              <a:rPr lang="en-US" sz="1900" dirty="0">
                 <a:solidFill>
                   <a:srgbClr val="242938"/>
                 </a:solidFill>
@@ -4075,77 +3828,38 @@
                 <a:ea typeface="Apple SD Gothic Neo" pitchFamily="34" charset="-122"/>
                 <a:cs typeface="Apple SD Gothic Neo" pitchFamily="34" charset="-120"/>
               </a:rPr>
-              <a:t>/speech/transcribe</a:t>
-            </a:r>
-            <a:endParaRPr lang="en-US" sz="1400" dirty="0"/>
-          </a:p>
-        </p:txBody>
-      </p:sp>
-      <p:sp>
-        <p:nvSpPr>
-          <p:cNvPr id="26" name="Text 21"/>
-          <p:cNvSpPr/>
-          <p:nvPr/>
-        </p:nvSpPr>
-        <p:spPr>
-          <a:xfrm>
-            <a:off x="3977640" y="4782312"/>
-            <a:ext cx="484632" cy="201168"/>
-          </a:xfrm>
-          <a:prstGeom prst="rect">
-            <a:avLst/>
-          </a:prstGeom>
-          <a:noFill/>
-          <a:ln/>
-        </p:spPr>
-        <p:txBody>
-          <a:bodyPr wrap="square" lIns="0" tIns="0" rIns="0" bIns="0" rtlCol="0" anchor="ctr"/>
-          <a:lstStyle/>
-          <a:p>
-            <a:pPr indent="0" marL="0">
-              <a:buNone/>
-            </a:pPr>
-            <a:r>
-              <a:rPr lang="en-US" sz="1200" b="1" dirty="0">
-                <a:solidFill>
-                  <a:srgbClr val="405394"/>
-                </a:solidFill>
-                <a:latin typeface="Apple SD Gothic Neo" pitchFamily="34" charset="0"/>
-                <a:ea typeface="Apple SD Gothic Neo" pitchFamily="34" charset="-122"/>
-                <a:cs typeface="Apple SD Gothic Neo" pitchFamily="34" charset="-120"/>
-              </a:rPr>
-              <a:t>POST</a:t>
-            </a:r>
-            <a:endParaRPr lang="en-US" sz="1200" dirty="0"/>
-          </a:p>
-        </p:txBody>
-      </p:sp>
-      <p:sp>
-        <p:nvSpPr>
-          <p:cNvPr id="27" name="Text 22"/>
-          <p:cNvSpPr/>
-          <p:nvPr/>
-        </p:nvSpPr>
-        <p:spPr>
-          <a:xfrm>
-            <a:off x="4553712" y="4782312"/>
-            <a:ext cx="2926080" cy="201168"/>
-          </a:xfrm>
-          <a:prstGeom prst="rect">
-            <a:avLst/>
-          </a:prstGeom>
-          <a:noFill/>
-          <a:ln/>
-        </p:spPr>
-        <p:txBody>
-          <a:bodyPr wrap="square" lIns="0" tIns="0" rIns="0" bIns="0" rtlCol="0" anchor="ctr"/>
-          <a:lstStyle/>
-          <a:p>
-            <a:pPr indent="0" marL="0">
-              <a:buNone/>
-            </a:pPr>
-            <a:r>
-              <a:rPr lang="en-US" sz="1400" dirty="0">
+              <a:t>음성 합성 API</a:t>
+            </a:r>
+            <a:endParaRPr lang="en-US" sz="1900" dirty="0"/>
+          </a:p>
+        </p:txBody>
+      </p:sp>
+      <p:sp>
+        <p:nvSpPr>
+          <p:cNvPr id="20" name="Text 16"/>
+          <p:cNvSpPr/>
+          <p:nvPr/>
+        </p:nvSpPr>
+        <p:spPr>
+          <a:xfrm>
+            <a:off x="3630168" y="5221224"/>
+            <a:ext cx="3200400" cy="237744"/>
+          </a:xfrm>
+          <a:prstGeom prst="rect">
+            <a:avLst/>
+          </a:prstGeom>
+          <a:noFill/>
+          <a:ln/>
+        </p:spPr>
+        <p:txBody>
+          <a:bodyPr wrap="square" lIns="0" tIns="0" rIns="0" bIns="0" rtlCol="0" anchor="ctr"/>
+          <a:lstStyle/>
+          <a:p>
+            <a:pPr indent="0" marL="0">
+              <a:buNone/>
+            </a:pPr>
+            <a:r>
+              <a:rPr lang="en-US" sz="1900" dirty="0">
                 <a:solidFill>
                   <a:srgbClr val="242938"/>
                 </a:solidFill>
@@ -4153,77 +3867,38 @@
                 <a:ea typeface="Apple SD Gothic Neo" pitchFamily="34" charset="-122"/>
                 <a:cs typeface="Apple SD Gothic Neo" pitchFamily="34" charset="-120"/>
               </a:rPr>
-              <a:t>/speech/synthesize</a:t>
-            </a:r>
-            <a:endParaRPr lang="en-US" sz="1400" dirty="0"/>
-          </a:p>
-        </p:txBody>
-      </p:sp>
-      <p:sp>
-        <p:nvSpPr>
-          <p:cNvPr id="28" name="Text 23"/>
-          <p:cNvSpPr/>
-          <p:nvPr/>
-        </p:nvSpPr>
-        <p:spPr>
-          <a:xfrm>
-            <a:off x="3977640" y="5166360"/>
-            <a:ext cx="484632" cy="201168"/>
-          </a:xfrm>
-          <a:prstGeom prst="rect">
-            <a:avLst/>
-          </a:prstGeom>
-          <a:noFill/>
-          <a:ln/>
-        </p:spPr>
-        <p:txBody>
-          <a:bodyPr wrap="square" lIns="0" tIns="0" rIns="0" bIns="0" rtlCol="0" anchor="ctr"/>
-          <a:lstStyle/>
-          <a:p>
-            <a:pPr indent="0" marL="0">
-              <a:buNone/>
-            </a:pPr>
-            <a:r>
-              <a:rPr lang="en-US" sz="1200" b="1" dirty="0">
-                <a:solidFill>
-                  <a:srgbClr val="405394"/>
-                </a:solidFill>
-                <a:latin typeface="Apple SD Gothic Neo" pitchFamily="34" charset="0"/>
-                <a:ea typeface="Apple SD Gothic Neo" pitchFamily="34" charset="-122"/>
-                <a:cs typeface="Apple SD Gothic Neo" pitchFamily="34" charset="-120"/>
-              </a:rPr>
-              <a:t>POST</a:t>
-            </a:r>
-            <a:endParaRPr lang="en-US" sz="1200" dirty="0"/>
-          </a:p>
-        </p:txBody>
-      </p:sp>
-      <p:sp>
-        <p:nvSpPr>
-          <p:cNvPr id="29" name="Text 24"/>
-          <p:cNvSpPr/>
-          <p:nvPr/>
-        </p:nvSpPr>
-        <p:spPr>
-          <a:xfrm>
-            <a:off x="4553712" y="5166360"/>
-            <a:ext cx="2926080" cy="201168"/>
-          </a:xfrm>
-          <a:prstGeom prst="rect">
-            <a:avLst/>
-          </a:prstGeom>
-          <a:noFill/>
-          <a:ln/>
-        </p:spPr>
-        <p:txBody>
-          <a:bodyPr wrap="square" lIns="0" tIns="0" rIns="0" bIns="0" rtlCol="0" anchor="ctr"/>
-          <a:lstStyle/>
-          <a:p>
-            <a:pPr indent="0" marL="0">
-              <a:buNone/>
-            </a:pPr>
-            <a:r>
-              <a:rPr lang="en-US" sz="1400" dirty="0">
+              <a:t>할 일 추출 API</a:t>
+            </a:r>
+            <a:endParaRPr lang="en-US" sz="1900" dirty="0"/>
+          </a:p>
+        </p:txBody>
+      </p:sp>
+      <p:sp>
+        <p:nvSpPr>
+          <p:cNvPr id="21" name="Text 17"/>
+          <p:cNvSpPr/>
+          <p:nvPr/>
+        </p:nvSpPr>
+        <p:spPr>
+          <a:xfrm>
+            <a:off x="3630168" y="5532120"/>
+            <a:ext cx="3200400" cy="237744"/>
+          </a:xfrm>
+          <a:prstGeom prst="rect">
+            <a:avLst/>
+          </a:prstGeom>
+          <a:noFill/>
+          <a:ln/>
+        </p:spPr>
+        <p:txBody>
+          <a:bodyPr wrap="square" lIns="0" tIns="0" rIns="0" bIns="0" rtlCol="0" anchor="ctr"/>
+          <a:lstStyle/>
+          <a:p>
+            <a:pPr indent="0" marL="0">
+              <a:buNone/>
+            </a:pPr>
+            <a:r>
+              <a:rPr lang="en-US" sz="1900" dirty="0">
                 <a:solidFill>
                   <a:srgbClr val="242938"/>
                 </a:solidFill>
@@ -4231,182 +3906,26 @@
                 <a:ea typeface="Apple SD Gothic Neo" pitchFamily="34" charset="-122"/>
                 <a:cs typeface="Apple SD Gothic Neo" pitchFamily="34" charset="-120"/>
               </a:rPr>
-              <a:t>/translate · /extract</a:t>
-            </a:r>
-            <a:endParaRPr lang="en-US" sz="1400" dirty="0"/>
-          </a:p>
-        </p:txBody>
-      </p:sp>
-      <p:sp>
-        <p:nvSpPr>
-          <p:cNvPr id="30" name="Text 25"/>
-          <p:cNvSpPr/>
-          <p:nvPr/>
-        </p:nvSpPr>
-        <p:spPr>
-          <a:xfrm>
-            <a:off x="3977640" y="5440680"/>
-            <a:ext cx="484632" cy="201168"/>
-          </a:xfrm>
-          <a:prstGeom prst="rect">
-            <a:avLst/>
-          </a:prstGeom>
-          <a:noFill/>
-          <a:ln/>
-        </p:spPr>
-        <p:txBody>
-          <a:bodyPr wrap="square" lIns="0" tIns="0" rIns="0" bIns="0" rtlCol="0" anchor="ctr"/>
-          <a:lstStyle/>
-          <a:p>
-            <a:pPr indent="0" marL="0">
-              <a:buNone/>
-            </a:pPr>
-            <a:r>
-              <a:rPr lang="en-US" sz="1200" b="1" dirty="0">
-                <a:solidFill>
-                  <a:srgbClr val="405394"/>
-                </a:solidFill>
-                <a:latin typeface="Apple SD Gothic Neo" pitchFamily="34" charset="0"/>
-                <a:ea typeface="Apple SD Gothic Neo" pitchFamily="34" charset="-122"/>
-                <a:cs typeface="Apple SD Gothic Neo" pitchFamily="34" charset="-120"/>
-              </a:rPr>
-              <a:t>POST</a:t>
-            </a:r>
-            <a:endParaRPr lang="en-US" sz="1200" dirty="0"/>
-          </a:p>
-        </p:txBody>
-      </p:sp>
-      <p:sp>
-        <p:nvSpPr>
-          <p:cNvPr id="31" name="Text 26"/>
-          <p:cNvSpPr/>
-          <p:nvPr/>
-        </p:nvSpPr>
-        <p:spPr>
-          <a:xfrm>
-            <a:off x="4553712" y="5440680"/>
-            <a:ext cx="2926080" cy="201168"/>
-          </a:xfrm>
-          <a:prstGeom prst="rect">
-            <a:avLst/>
-          </a:prstGeom>
-          <a:noFill/>
-          <a:ln/>
-        </p:spPr>
-        <p:txBody>
-          <a:bodyPr wrap="square" lIns="0" tIns="0" rIns="0" bIns="0" rtlCol="0" anchor="ctr"/>
-          <a:lstStyle/>
-          <a:p>
-            <a:pPr indent="0" marL="0">
-              <a:buNone/>
-            </a:pPr>
-            <a:r>
-              <a:rPr lang="en-US" sz="1400" dirty="0">
-                <a:solidFill>
-                  <a:srgbClr val="242938"/>
-                </a:solidFill>
-                <a:latin typeface="Apple SD Gothic Neo" pitchFamily="34" charset="0"/>
-                <a:ea typeface="Apple SD Gothic Neo" pitchFamily="34" charset="-122"/>
-                <a:cs typeface="Apple SD Gothic Neo" pitchFamily="34" charset="-120"/>
-              </a:rPr>
-              <a:t>/data/snapshot · /data/mutate</a:t>
-            </a:r>
-            <a:endParaRPr lang="en-US" sz="1400" dirty="0"/>
-          </a:p>
-        </p:txBody>
-      </p:sp>
-      <p:sp>
-        <p:nvSpPr>
-          <p:cNvPr id="32" name="Text 27"/>
-          <p:cNvSpPr/>
-          <p:nvPr/>
-        </p:nvSpPr>
-        <p:spPr>
-          <a:xfrm>
-            <a:off x="3977640" y="5715000"/>
-            <a:ext cx="484632" cy="201168"/>
-          </a:xfrm>
-          <a:prstGeom prst="rect">
-            <a:avLst/>
-          </a:prstGeom>
-          <a:noFill/>
-          <a:ln/>
-        </p:spPr>
-        <p:txBody>
-          <a:bodyPr wrap="square" lIns="0" tIns="0" rIns="0" bIns="0" rtlCol="0" anchor="ctr"/>
-          <a:lstStyle/>
-          <a:p>
-            <a:pPr indent="0" marL="0">
-              <a:buNone/>
-            </a:pPr>
-            <a:r>
-              <a:rPr lang="en-US" sz="1200" b="1" dirty="0">
-                <a:solidFill>
-                  <a:srgbClr val="405394"/>
-                </a:solidFill>
-                <a:latin typeface="Apple SD Gothic Neo" pitchFamily="34" charset="0"/>
-                <a:ea typeface="Apple SD Gothic Neo" pitchFamily="34" charset="-122"/>
-                <a:cs typeface="Apple SD Gothic Neo" pitchFamily="34" charset="-120"/>
-              </a:rPr>
-              <a:t>POST</a:t>
-            </a:r>
-            <a:endParaRPr lang="en-US" sz="1200" dirty="0"/>
-          </a:p>
-        </p:txBody>
-      </p:sp>
-      <p:sp>
-        <p:nvSpPr>
-          <p:cNvPr id="33" name="Text 28"/>
-          <p:cNvSpPr/>
-          <p:nvPr/>
-        </p:nvSpPr>
-        <p:spPr>
-          <a:xfrm>
-            <a:off x="4553712" y="5715000"/>
-            <a:ext cx="2926080" cy="201168"/>
-          </a:xfrm>
-          <a:prstGeom prst="rect">
-            <a:avLst/>
-          </a:prstGeom>
-          <a:noFill/>
-          <a:ln/>
-        </p:spPr>
-        <p:txBody>
-          <a:bodyPr wrap="square" lIns="0" tIns="0" rIns="0" bIns="0" rtlCol="0" anchor="ctr"/>
-          <a:lstStyle/>
-          <a:p>
-            <a:pPr indent="0" marL="0">
-              <a:buNone/>
-            </a:pPr>
-            <a:r>
-              <a:rPr lang="en-US" sz="1400" dirty="0">
-                <a:solidFill>
-                  <a:srgbClr val="242938"/>
-                </a:solidFill>
-                <a:latin typeface="Apple SD Gothic Neo" pitchFamily="34" charset="0"/>
-                <a:ea typeface="Apple SD Gothic Neo" pitchFamily="34" charset="-122"/>
-                <a:cs typeface="Apple SD Gothic Neo" pitchFamily="34" charset="-120"/>
-              </a:rPr>
-              <a:t>/data/changes</a:t>
-            </a:r>
-            <a:endParaRPr lang="en-US" sz="1400" dirty="0"/>
-          </a:p>
-        </p:txBody>
-      </p:sp>
-      <p:sp>
-        <p:nvSpPr>
-          <p:cNvPr id="34" name="Shape 29"/>
-          <p:cNvSpPr/>
-          <p:nvPr/>
-        </p:nvSpPr>
-        <p:spPr>
-          <a:xfrm>
-            <a:off x="8458200" y="2167128"/>
-            <a:ext cx="2816352" cy="1179576"/>
+              <a:t>기록 동기화 API</a:t>
+            </a:r>
+            <a:endParaRPr lang="en-US" sz="1900" dirty="0"/>
+          </a:p>
+        </p:txBody>
+      </p:sp>
+      <p:sp>
+        <p:nvSpPr>
+          <p:cNvPr id="22" name="Shape 18"/>
+          <p:cNvSpPr/>
+          <p:nvPr/>
+        </p:nvSpPr>
+        <p:spPr>
+          <a:xfrm>
+            <a:off x="8449056" y="2304288"/>
+            <a:ext cx="2807208" cy="987552"/>
           </a:xfrm>
           <a:prstGeom prst="roundRect">
             <a:avLst>
-              <a:gd name="adj" fmla="val 15504"/>
+              <a:gd name="adj" fmla="val 18519"/>
             </a:avLst>
           </a:prstGeom>
           <a:solidFill>
@@ -4424,30 +3943,30 @@
       </p:sp>
       <p:sp>
         <p:nvSpPr>
-          <p:cNvPr id="35" name="Text 30"/>
-          <p:cNvSpPr/>
-          <p:nvPr/>
-        </p:nvSpPr>
-        <p:spPr>
-          <a:xfrm>
-            <a:off x="8695944" y="2331720"/>
-            <a:ext cx="2340864" cy="320040"/>
-          </a:xfrm>
-          <a:prstGeom prst="rect">
-            <a:avLst/>
-          </a:prstGeom>
-          <a:noFill/>
-          <a:ln/>
-        </p:spPr>
-        <p:txBody>
-          <a:bodyPr wrap="square" lIns="0" tIns="0" rIns="0" bIns="0" rtlCol="0" anchor="ctr"/>
-          <a:lstStyle/>
-          <a:p>
-            <a:pPr indent="0" marL="0">
-              <a:buNone/>
-            </a:pPr>
-            <a:r>
-              <a:rPr lang="en-US" sz="2400" b="1" dirty="0">
+          <p:cNvPr id="23" name="Text 19"/>
+          <p:cNvSpPr/>
+          <p:nvPr/>
+        </p:nvSpPr>
+        <p:spPr>
+          <a:xfrm>
+            <a:off x="8677656" y="2624328"/>
+            <a:ext cx="2359152" cy="356616"/>
+          </a:xfrm>
+          <a:prstGeom prst="rect">
+            <a:avLst/>
+          </a:prstGeom>
+          <a:noFill/>
+          <a:ln/>
+        </p:spPr>
+        <p:txBody>
+          <a:bodyPr wrap="square" lIns="0" tIns="0" rIns="0" bIns="0" rtlCol="0" anchor="ctr"/>
+          <a:lstStyle/>
+          <a:p>
+            <a:pPr indent="0" marL="0">
+              <a:buNone/>
+            </a:pPr>
+            <a:r>
+              <a:rPr lang="en-US" sz="2500" b="1" dirty="0">
                 <a:solidFill>
                   <a:srgbClr val="405394"/>
                 </a:solidFill>
@@ -4455,65 +3974,26 @@
                 <a:ea typeface="Apple SD Gothic Neo" pitchFamily="34" charset="-122"/>
                 <a:cs typeface="Apple SD Gothic Neo" pitchFamily="34" charset="-120"/>
               </a:rPr>
-              <a:t>Ollama</a:t>
-            </a:r>
-            <a:endParaRPr lang="en-US" sz="2400" dirty="0"/>
-          </a:p>
-        </p:txBody>
-      </p:sp>
-      <p:sp>
-        <p:nvSpPr>
-          <p:cNvPr id="36" name="Text 31"/>
-          <p:cNvSpPr/>
-          <p:nvPr/>
-        </p:nvSpPr>
-        <p:spPr>
-          <a:xfrm>
-            <a:off x="8695944" y="2761488"/>
-            <a:ext cx="2340864" cy="274320"/>
-          </a:xfrm>
-          <a:prstGeom prst="rect">
-            <a:avLst/>
-          </a:prstGeom>
-          <a:noFill/>
-          <a:ln/>
-        </p:spPr>
-        <p:txBody>
-          <a:bodyPr wrap="square" lIns="0" tIns="0" rIns="0" bIns="0" rtlCol="0" anchor="ctr"/>
-          <a:lstStyle/>
-          <a:p>
-            <a:pPr indent="0" marL="0">
-              <a:buNone/>
-            </a:pPr>
-            <a:r>
-              <a:rPr lang="en-US" sz="2000" dirty="0">
-                <a:solidFill>
-                  <a:srgbClr val="242938"/>
-                </a:solidFill>
-                <a:latin typeface="Apple SD Gothic Neo" pitchFamily="34" charset="0"/>
-                <a:ea typeface="Apple SD Gothic Neo" pitchFamily="34" charset="-122"/>
-                <a:cs typeface="Apple SD Gothic Neo" pitchFamily="34" charset="-120"/>
-              </a:rPr>
-              <a:t>POST /api/chat</a:t>
-            </a:r>
-            <a:endParaRPr lang="en-US" sz="2000" dirty="0"/>
-          </a:p>
-        </p:txBody>
-      </p:sp>
-      <p:sp>
-        <p:nvSpPr>
-          <p:cNvPr id="37" name="Shape 32"/>
-          <p:cNvSpPr/>
-          <p:nvPr/>
-        </p:nvSpPr>
-        <p:spPr>
-          <a:xfrm>
-            <a:off x="8458200" y="3621024"/>
-            <a:ext cx="2816352" cy="1078992"/>
+              <a:t>Ollama API</a:t>
+            </a:r>
+            <a:endParaRPr lang="en-US" sz="2500" dirty="0"/>
+          </a:p>
+        </p:txBody>
+      </p:sp>
+      <p:sp>
+        <p:nvSpPr>
+          <p:cNvPr id="24" name="Shape 20"/>
+          <p:cNvSpPr/>
+          <p:nvPr/>
+        </p:nvSpPr>
+        <p:spPr>
+          <a:xfrm>
+            <a:off x="8449056" y="3630168"/>
+            <a:ext cx="2807208" cy="987552"/>
           </a:xfrm>
           <a:prstGeom prst="roundRect">
             <a:avLst>
-              <a:gd name="adj" fmla="val 16949"/>
+              <a:gd name="adj" fmla="val 18519"/>
             </a:avLst>
           </a:prstGeom>
           <a:solidFill>
@@ -4531,30 +4011,30 @@
       </p:sp>
       <p:sp>
         <p:nvSpPr>
-          <p:cNvPr id="38" name="Text 33"/>
-          <p:cNvSpPr/>
-          <p:nvPr/>
-        </p:nvSpPr>
-        <p:spPr>
-          <a:xfrm>
-            <a:off x="8695944" y="3813048"/>
-            <a:ext cx="2340864" cy="283464"/>
-          </a:xfrm>
-          <a:prstGeom prst="rect">
-            <a:avLst/>
-          </a:prstGeom>
-          <a:noFill/>
-          <a:ln/>
-        </p:spPr>
-        <p:txBody>
-          <a:bodyPr wrap="square" lIns="0" tIns="0" rIns="0" bIns="0" rtlCol="0" anchor="ctr"/>
-          <a:lstStyle/>
-          <a:p>
-            <a:pPr indent="0" marL="0">
-              <a:buNone/>
-            </a:pPr>
-            <a:r>
-              <a:rPr lang="en-US" sz="1900" b="1" dirty="0">
+          <p:cNvPr id="25" name="Text 21"/>
+          <p:cNvSpPr/>
+          <p:nvPr/>
+        </p:nvSpPr>
+        <p:spPr>
+          <a:xfrm>
+            <a:off x="8677656" y="3785616"/>
+            <a:ext cx="2359152" cy="274320"/>
+          </a:xfrm>
+          <a:prstGeom prst="rect">
+            <a:avLst/>
+          </a:prstGeom>
+          <a:noFill/>
+          <a:ln/>
+        </p:spPr>
+        <p:txBody>
+          <a:bodyPr wrap="square" lIns="0" tIns="0" rIns="0" bIns="0" rtlCol="0" anchor="ctr"/>
+          <a:lstStyle/>
+          <a:p>
+            <a:pPr indent="0" marL="0">
+              <a:buNone/>
+            </a:pPr>
+            <a:r>
+              <a:rPr lang="en-US" sz="2000" b="1" dirty="0">
                 <a:solidFill>
                   <a:srgbClr val="405394"/>
                 </a:solidFill>
@@ -4564,20 +4044,20 @@
               </a:rPr>
               <a:t>NeMo-Speech.cpp</a:t>
             </a:r>
-            <a:endParaRPr lang="en-US" sz="1900" dirty="0"/>
-          </a:p>
-        </p:txBody>
-      </p:sp>
-      <p:sp>
-        <p:nvSpPr>
-          <p:cNvPr id="39" name="Text 34"/>
-          <p:cNvSpPr/>
-          <p:nvPr/>
-        </p:nvSpPr>
-        <p:spPr>
-          <a:xfrm>
-            <a:off x="8695944" y="4224528"/>
-            <a:ext cx="2340864" cy="265176"/>
+            <a:endParaRPr lang="en-US" sz="2000" dirty="0"/>
+          </a:p>
+        </p:txBody>
+      </p:sp>
+      <p:sp>
+        <p:nvSpPr>
+          <p:cNvPr id="26" name="Text 22"/>
+          <p:cNvSpPr/>
+          <p:nvPr/>
+        </p:nvSpPr>
+        <p:spPr>
+          <a:xfrm>
+            <a:off x="8677656" y="4178808"/>
+            <a:ext cx="2359152" cy="265176"/>
           </a:xfrm>
           <a:prstGeom prst="rect">
             <a:avLst/>
@@ -4609,18 +4089,18 @@
       </p:sp>
       <p:sp>
         <p:nvSpPr>
-          <p:cNvPr id="40" name="Shape 35"/>
-          <p:cNvSpPr/>
-          <p:nvPr/>
-        </p:nvSpPr>
-        <p:spPr>
-          <a:xfrm>
-            <a:off x="8458200" y="4974336"/>
-            <a:ext cx="2816352" cy="1060704"/>
+          <p:cNvPr id="27" name="Shape 23"/>
+          <p:cNvSpPr/>
+          <p:nvPr/>
+        </p:nvSpPr>
+        <p:spPr>
+          <a:xfrm>
+            <a:off x="8449056" y="4956048"/>
+            <a:ext cx="2807208" cy="996696"/>
           </a:xfrm>
           <a:prstGeom prst="roundRect">
             <a:avLst>
-              <a:gd name="adj" fmla="val 17241"/>
+              <a:gd name="adj" fmla="val 18349"/>
             </a:avLst>
           </a:prstGeom>
           <a:solidFill>
@@ -4638,22 +4118,22 @@
       </p:sp>
       <p:pic>
         <p:nvPicPr>
-          <p:cNvPr id="41" name="Image 2" descr="postgresql">    </p:cNvPr>
+          <p:cNvPr id="28" name="Image 1" descr="postgresql">    </p:cNvPr>
           <p:cNvPicPr>
             <a:picLocks noChangeAspect="1"/>
           </p:cNvPicPr>
           <p:nvPr/>
         </p:nvPicPr>
         <p:blipFill>
-          <a:blip r:embed="rId3"/>
+          <a:blip r:embed="rId2"/>
           <a:stretch>
             <a:fillRect/>
           </a:stretch>
         </p:blipFill>
         <p:spPr>
           <a:xfrm>
-            <a:off x="8678698" y="5138928"/>
-            <a:ext cx="647139" cy="667512"/>
+            <a:off x="8642402" y="5111496"/>
+            <a:ext cx="664869" cy="685800"/>
           </a:xfrm>
           <a:prstGeom prst="rect">
             <a:avLst/>
@@ -4662,14 +4142,14 @@
       </p:pic>
       <p:sp>
         <p:nvSpPr>
-          <p:cNvPr id="42" name="Text 36"/>
-          <p:cNvSpPr/>
-          <p:nvPr/>
-        </p:nvSpPr>
-        <p:spPr>
-          <a:xfrm>
-            <a:off x="9518904" y="5230368"/>
-            <a:ext cx="1600200" cy="320040"/>
+          <p:cNvPr id="29" name="Text 24"/>
+          <p:cNvSpPr/>
+          <p:nvPr/>
+        </p:nvSpPr>
+        <p:spPr>
+          <a:xfrm>
+            <a:off x="9500616" y="5276088"/>
+            <a:ext cx="1572768" cy="338328"/>
           </a:xfrm>
           <a:prstGeom prst="rect">
             <a:avLst/>
@@ -4701,53 +4181,14 @@
       </p:sp>
       <p:sp>
         <p:nvSpPr>
-          <p:cNvPr id="43" name="Text 37"/>
-          <p:cNvSpPr/>
-          <p:nvPr/>
-        </p:nvSpPr>
-        <p:spPr>
-          <a:xfrm>
-            <a:off x="9518904" y="5641848"/>
-            <a:ext cx="1600200" cy="201168"/>
-          </a:xfrm>
-          <a:prstGeom prst="rect">
-            <a:avLst/>
-          </a:prstGeom>
-          <a:noFill/>
-          <a:ln/>
-        </p:spPr>
-        <p:txBody>
-          <a:bodyPr wrap="square" lIns="0" tIns="0" rIns="0" bIns="0" rtlCol="0" anchor="ctr"/>
-          <a:lstStyle/>
-          <a:p>
-            <a:pPr indent="0" marL="0">
-              <a:buNone/>
-            </a:pPr>
-            <a:r>
-              <a:rPr lang="en-US" sz="1300" dirty="0">
-                <a:solidFill>
-                  <a:srgbClr val="626B80"/>
-                </a:solidFill>
-                <a:latin typeface="Apple SD Gothic Neo" pitchFamily="34" charset="0"/>
-                <a:ea typeface="Apple SD Gothic Neo" pitchFamily="34" charset="-122"/>
-                <a:cs typeface="Apple SD Gothic Neo" pitchFamily="34" charset="-120"/>
-              </a:rPr>
-              <a:t>pg · SQL · RLS</a:t>
-            </a:r>
-            <a:endParaRPr lang="en-US" sz="1300" dirty="0"/>
-          </a:p>
-        </p:txBody>
-      </p:sp>
-      <p:sp>
-        <p:nvSpPr>
-          <p:cNvPr id="44" name="Shape 38"/>
-          <p:cNvSpPr/>
-          <p:nvPr/>
-        </p:nvSpPr>
-        <p:spPr>
-          <a:xfrm>
-            <a:off x="2889504" y="4142232"/>
-            <a:ext cx="786384" cy="0"/>
+          <p:cNvPr id="30" name="Shape 25"/>
+          <p:cNvSpPr/>
+          <p:nvPr/>
+        </p:nvSpPr>
+        <p:spPr>
+          <a:xfrm>
+            <a:off x="2459736" y="3694176"/>
+            <a:ext cx="832104" cy="0"/>
           </a:xfrm>
           <a:prstGeom prst="line">
             <a:avLst/>
@@ -4765,30 +4206,30 @@
       </p:sp>
       <p:sp>
         <p:nvSpPr>
-          <p:cNvPr id="45" name="Text 39"/>
-          <p:cNvSpPr/>
-          <p:nvPr/>
-        </p:nvSpPr>
-        <p:spPr>
-          <a:xfrm>
-            <a:off x="2907792" y="3538728"/>
-            <a:ext cx="758952" cy="201168"/>
-          </a:xfrm>
-          <a:prstGeom prst="rect">
-            <a:avLst/>
-          </a:prstGeom>
-          <a:noFill/>
-          <a:ln/>
-        </p:spPr>
-        <p:txBody>
-          <a:bodyPr wrap="square" lIns="0" tIns="0" rIns="0" bIns="0" rtlCol="0" anchor="ctr"/>
-          <a:lstStyle/>
-          <a:p>
-            <a:pPr indent="0" marL="0">
-              <a:buNone/>
-            </a:pPr>
-            <a:r>
-              <a:rPr lang="en-US" sz="1200" dirty="0">
+          <p:cNvPr id="31" name="Text 26"/>
+          <p:cNvSpPr/>
+          <p:nvPr/>
+        </p:nvSpPr>
+        <p:spPr>
+          <a:xfrm>
+            <a:off x="2468880" y="3310128"/>
+            <a:ext cx="813816" cy="228600"/>
+          </a:xfrm>
+          <a:prstGeom prst="rect">
+            <a:avLst/>
+          </a:prstGeom>
+          <a:noFill/>
+          <a:ln/>
+        </p:spPr>
+        <p:txBody>
+          <a:bodyPr wrap="square" lIns="0" tIns="0" rIns="0" bIns="0" rtlCol="0" anchor="ctr"/>
+          <a:lstStyle/>
+          <a:p>
+            <a:pPr indent="0" marL="0">
+              <a:buNone/>
+            </a:pPr>
+            <a:r>
+              <a:rPr lang="en-US" sz="1300" dirty="0">
                 <a:solidFill>
                   <a:srgbClr val="405394"/>
                 </a:solidFill>
@@ -4798,59 +4239,20 @@
               </a:rPr>
               <a:t>HTTPS</a:t>
             </a:r>
-            <a:endParaRPr lang="en-US" sz="1200" dirty="0"/>
-          </a:p>
-        </p:txBody>
-      </p:sp>
-      <p:sp>
-        <p:nvSpPr>
-          <p:cNvPr id="46" name="Text 40"/>
-          <p:cNvSpPr/>
-          <p:nvPr/>
-        </p:nvSpPr>
-        <p:spPr>
-          <a:xfrm>
-            <a:off x="2907792" y="3813048"/>
-            <a:ext cx="758952" cy="201168"/>
-          </a:xfrm>
-          <a:prstGeom prst="rect">
-            <a:avLst/>
-          </a:prstGeom>
-          <a:noFill/>
-          <a:ln/>
-        </p:spPr>
-        <p:txBody>
-          <a:bodyPr wrap="square" lIns="0" tIns="0" rIns="0" bIns="0" rtlCol="0" anchor="ctr"/>
-          <a:lstStyle/>
-          <a:p>
-            <a:pPr indent="0" marL="0">
-              <a:buNone/>
-            </a:pPr>
-            <a:r>
-              <a:rPr lang="en-US" sz="1200" dirty="0">
-                <a:solidFill>
-                  <a:srgbClr val="626B80"/>
-                </a:solidFill>
-                <a:latin typeface="Apple SD Gothic Neo" pitchFamily="34" charset="0"/>
-                <a:ea typeface="Apple SD Gothic Neo" pitchFamily="34" charset="-122"/>
-                <a:cs typeface="Apple SD Gothic Neo" pitchFamily="34" charset="-120"/>
-              </a:rPr>
-              <a:t>Bearer</a:t>
-            </a:r>
-            <a:endParaRPr lang="en-US" sz="1200" dirty="0"/>
-          </a:p>
-        </p:txBody>
-      </p:sp>
-      <p:sp>
-        <p:nvSpPr>
-          <p:cNvPr id="47" name="Shape 41"/>
-          <p:cNvSpPr/>
-          <p:nvPr/>
-        </p:nvSpPr>
-        <p:spPr>
-          <a:xfrm>
-            <a:off x="7735824" y="2770632"/>
-            <a:ext cx="685800" cy="0"/>
+            <a:endParaRPr lang="en-US" sz="1300" dirty="0"/>
+          </a:p>
+        </p:txBody>
+      </p:sp>
+      <p:sp>
+        <p:nvSpPr>
+          <p:cNvPr id="32" name="Shape 27"/>
+          <p:cNvSpPr/>
+          <p:nvPr/>
+        </p:nvSpPr>
+        <p:spPr>
+          <a:xfrm>
+            <a:off x="7141464" y="2798064"/>
+            <a:ext cx="1261872" cy="0"/>
           </a:xfrm>
           <a:prstGeom prst="line">
             <a:avLst/>
@@ -4868,14 +4270,14 @@
       </p:sp>
       <p:sp>
         <p:nvSpPr>
-          <p:cNvPr id="48" name="Text 42"/>
-          <p:cNvSpPr/>
-          <p:nvPr/>
-        </p:nvSpPr>
-        <p:spPr>
-          <a:xfrm>
-            <a:off x="7744968" y="2450592"/>
-            <a:ext cx="676656" cy="201168"/>
+          <p:cNvPr id="33" name="Text 28"/>
+          <p:cNvSpPr/>
+          <p:nvPr/>
+        </p:nvSpPr>
+        <p:spPr>
+          <a:xfrm>
+            <a:off x="7196328" y="2441448"/>
+            <a:ext cx="1143000" cy="228600"/>
           </a:xfrm>
           <a:prstGeom prst="rect">
             <a:avLst/>
@@ -4899,7 +4301,7 @@
                 <a:ea typeface="Apple SD Gothic Neo" pitchFamily="34" charset="-122"/>
                 <a:cs typeface="Apple SD Gothic Neo" pitchFamily="34" charset="-120"/>
               </a:rPr>
-              <a:t>HTTP</a:t>
+              <a:t>텍스트 · 결과</a:t>
             </a:r>
             <a:endParaRPr lang="en-US" sz="1200" dirty="0"/>
           </a:p>
@@ -4907,14 +4309,14 @@
       </p:sp>
       <p:sp>
         <p:nvSpPr>
-          <p:cNvPr id="49" name="Shape 43"/>
-          <p:cNvSpPr/>
-          <p:nvPr/>
-        </p:nvSpPr>
-        <p:spPr>
-          <a:xfrm>
-            <a:off x="7735824" y="4160520"/>
-            <a:ext cx="685800" cy="0"/>
+          <p:cNvPr id="34" name="Shape 29"/>
+          <p:cNvSpPr/>
+          <p:nvPr/>
+        </p:nvSpPr>
+        <p:spPr>
+          <a:xfrm>
+            <a:off x="7141464" y="4123944"/>
+            <a:ext cx="1261872" cy="0"/>
           </a:xfrm>
           <a:prstGeom prst="line">
             <a:avLst/>
@@ -4932,30 +4334,30 @@
       </p:sp>
       <p:sp>
         <p:nvSpPr>
-          <p:cNvPr id="50" name="Text 44"/>
-          <p:cNvSpPr/>
-          <p:nvPr/>
-        </p:nvSpPr>
-        <p:spPr>
-          <a:xfrm>
-            <a:off x="7744968" y="3822192"/>
-            <a:ext cx="676656" cy="201168"/>
-          </a:xfrm>
-          <a:prstGeom prst="rect">
-            <a:avLst/>
-          </a:prstGeom>
-          <a:noFill/>
-          <a:ln/>
-        </p:spPr>
-        <p:txBody>
-          <a:bodyPr wrap="square" lIns="0" tIns="0" rIns="0" bIns="0" rtlCol="0" anchor="ctr"/>
-          <a:lstStyle/>
-          <a:p>
-            <a:pPr indent="0" marL="0">
-              <a:buNone/>
-            </a:pPr>
-            <a:r>
-              <a:rPr lang="en-US" sz="1100" dirty="0">
+          <p:cNvPr id="35" name="Text 30"/>
+          <p:cNvSpPr/>
+          <p:nvPr/>
+        </p:nvSpPr>
+        <p:spPr>
+          <a:xfrm>
+            <a:off x="7196328" y="3767328"/>
+            <a:ext cx="1143000" cy="228600"/>
+          </a:xfrm>
+          <a:prstGeom prst="rect">
+            <a:avLst/>
+          </a:prstGeom>
+          <a:noFill/>
+          <a:ln/>
+        </p:spPr>
+        <p:txBody>
+          <a:bodyPr wrap="square" lIns="0" tIns="0" rIns="0" bIns="0" rtlCol="0" anchor="ctr"/>
+          <a:lstStyle/>
+          <a:p>
+            <a:pPr indent="0" marL="0">
+              <a:buNone/>
+            </a:pPr>
+            <a:r>
+              <a:rPr lang="en-US" sz="1200" dirty="0">
                 <a:solidFill>
                   <a:srgbClr val="405394"/>
                 </a:solidFill>
@@ -4963,22 +4365,22 @@
                 <a:ea typeface="Apple SD Gothic Neo" pitchFamily="34" charset="-122"/>
                 <a:cs typeface="Apple SD Gothic Neo" pitchFamily="34" charset="-120"/>
               </a:rPr>
-              <a:t>프로세스</a:t>
-            </a:r>
-            <a:endParaRPr lang="en-US" sz="1100" dirty="0"/>
-          </a:p>
-        </p:txBody>
-      </p:sp>
-      <p:sp>
-        <p:nvSpPr>
-          <p:cNvPr id="51" name="Shape 45"/>
-          <p:cNvSpPr/>
-          <p:nvPr/>
-        </p:nvSpPr>
-        <p:spPr>
-          <a:xfrm>
-            <a:off x="7735824" y="5513832"/>
-            <a:ext cx="685800" cy="0"/>
+              <a:t>음성 · 텍스트</a:t>
+            </a:r>
+            <a:endParaRPr lang="en-US" sz="1200" dirty="0"/>
+          </a:p>
+        </p:txBody>
+      </p:sp>
+      <p:sp>
+        <p:nvSpPr>
+          <p:cNvPr id="36" name="Shape 31"/>
+          <p:cNvSpPr/>
+          <p:nvPr/>
+        </p:nvSpPr>
+        <p:spPr>
+          <a:xfrm>
+            <a:off x="7141464" y="5449824"/>
+            <a:ext cx="1261872" cy="0"/>
           </a:xfrm>
           <a:prstGeom prst="line">
             <a:avLst/>
@@ -4996,14 +4398,14 @@
       </p:sp>
       <p:sp>
         <p:nvSpPr>
-          <p:cNvPr id="52" name="Text 46"/>
-          <p:cNvSpPr/>
-          <p:nvPr/>
-        </p:nvSpPr>
-        <p:spPr>
-          <a:xfrm>
-            <a:off x="7744968" y="5193792"/>
-            <a:ext cx="676656" cy="201168"/>
+          <p:cNvPr id="37" name="Text 32"/>
+          <p:cNvSpPr/>
+          <p:nvPr/>
+        </p:nvSpPr>
+        <p:spPr>
+          <a:xfrm>
+            <a:off x="7196328" y="5093208"/>
+            <a:ext cx="1143000" cy="228600"/>
           </a:xfrm>
           <a:prstGeom prst="rect">
             <a:avLst/>
@@ -5027,7 +4429,7 @@
                 <a:ea typeface="Apple SD Gothic Neo" pitchFamily="34" charset="-122"/>
                 <a:cs typeface="Apple SD Gothic Neo" pitchFamily="34" charset="-120"/>
               </a:rPr>
-              <a:t>SQL</a:t>
+              <a:t>계정 · 기록</a:t>
             </a:r>
             <a:endParaRPr lang="en-US" sz="1200" dirty="0"/>
           </a:p>

</xml_diff>

<commit_message>
docs: match supplied architecture slide layout
</commit_message>
<xml_diff>
--- a/presentation/SpeechBridge.pptx
+++ b/presentation/SpeechBridge.pptx
@@ -948,7 +948,7 @@
           <a:p>
             <a:r>
               <a:rPr lang="en-US" dirty="0"/>
-              <a:t>모바일 앱 ↔ MacBook 서버: Node.js HTTP API ↔ Ollama API / NeMo-Speech.cpp / Python·MLX / PostgreSQL. 회원 인증·음성 인식·번역·음성 합성·할 일 추출·기록 동기화 API.</a:t>
+              <a:t>모바일 앱 · HTTP API · SpeechBridge MacBook 서버(Node.js) · 로컬 AI · PostgreSQL.</a:t>
             </a:r>
             <a:endParaRPr lang="en-US" dirty="0"/>
           </a:p>
@@ -3369,12 +3369,226 @@
         </p:nvSpPr>
         <p:spPr>
           <a:xfrm>
-            <a:off x="2971800" y="1508760"/>
-            <a:ext cx="8641080" cy="4800600"/>
+            <a:off x="594360" y="1828800"/>
+            <a:ext cx="2240280" cy="1783080"/>
           </a:xfrm>
           <a:prstGeom prst="roundRect">
             <a:avLst>
-              <a:gd name="adj" fmla="val 3810"/>
+              <a:gd name="adj" fmla="val 10256"/>
+            </a:avLst>
+          </a:prstGeom>
+          <a:solidFill>
+            <a:srgbClr val="FFFFFF"/>
+          </a:solidFill>
+          <a:ln w="12700">
+            <a:solidFill>
+              <a:srgbClr val="FFFFFF">
+                <a:alpha val="0"/>
+              </a:srgbClr>
+            </a:solidFill>
+            <a:prstDash val="solid"/>
+          </a:ln>
+        </p:spPr>
+      </p:sp>
+      <p:sp>
+        <p:nvSpPr>
+          <p:cNvPr id="7" name="Shape 4"/>
+          <p:cNvSpPr/>
+          <p:nvPr/>
+        </p:nvSpPr>
+        <p:spPr>
+          <a:xfrm>
+            <a:off x="594360" y="4069080"/>
+            <a:ext cx="2240280" cy="1783080"/>
+          </a:xfrm>
+          <a:prstGeom prst="roundRect">
+            <a:avLst>
+              <a:gd name="adj" fmla="val 10256"/>
+            </a:avLst>
+          </a:prstGeom>
+          <a:solidFill>
+            <a:srgbClr val="FFFFFF"/>
+          </a:solidFill>
+          <a:ln w="12700">
+            <a:solidFill>
+              <a:srgbClr val="FFFFFF">
+                <a:alpha val="0"/>
+              </a:srgbClr>
+            </a:solidFill>
+            <a:prstDash val="solid"/>
+          </a:ln>
+        </p:spPr>
+      </p:sp>
+      <p:sp>
+        <p:nvSpPr>
+          <p:cNvPr id="8" name="Text 5"/>
+          <p:cNvSpPr/>
+          <p:nvPr/>
+        </p:nvSpPr>
+        <p:spPr>
+          <a:xfrm>
+            <a:off x="804672" y="2267712"/>
+            <a:ext cx="1828800" cy="457200"/>
+          </a:xfrm>
+          <a:prstGeom prst="rect">
+            <a:avLst/>
+          </a:prstGeom>
+          <a:noFill/>
+          <a:ln/>
+        </p:spPr>
+        <p:txBody>
+          <a:bodyPr wrap="square" lIns="0" tIns="0" rIns="0" bIns="0" rtlCol="0" anchor="ctr"/>
+          <a:lstStyle/>
+          <a:p>
+            <a:pPr algn="ctr" indent="0" marL="0">
+              <a:buNone/>
+            </a:pPr>
+            <a:r>
+              <a:rPr lang="en-US" sz="2800" b="1" dirty="0">
+                <a:solidFill>
+                  <a:srgbClr val="405394"/>
+                </a:solidFill>
+                <a:latin typeface="Apple SD Gothic Neo" pitchFamily="34" charset="0"/>
+                <a:ea typeface="Apple SD Gothic Neo" pitchFamily="34" charset="-122"/>
+                <a:cs typeface="Apple SD Gothic Neo" pitchFamily="34" charset="-120"/>
+              </a:rPr>
+              <a:t>모바일 앱</a:t>
+            </a:r>
+            <a:endParaRPr lang="en-US" sz="2800" dirty="0"/>
+          </a:p>
+        </p:txBody>
+      </p:sp>
+      <p:sp>
+        <p:nvSpPr>
+          <p:cNvPr id="9" name="Text 6"/>
+          <p:cNvSpPr/>
+          <p:nvPr/>
+        </p:nvSpPr>
+        <p:spPr>
+          <a:xfrm>
+            <a:off x="804672" y="2889504"/>
+            <a:ext cx="1828800" cy="365760"/>
+          </a:xfrm>
+          <a:prstGeom prst="rect">
+            <a:avLst/>
+          </a:prstGeom>
+          <a:noFill/>
+          <a:ln/>
+        </p:spPr>
+        <p:txBody>
+          <a:bodyPr wrap="square" lIns="0" tIns="0" rIns="0" bIns="0" rtlCol="0" anchor="ctr"/>
+          <a:lstStyle/>
+          <a:p>
+            <a:pPr algn="ctr" indent="0" marL="0">
+              <a:buNone/>
+            </a:pPr>
+            <a:r>
+              <a:rPr lang="en-US" sz="2300" dirty="0">
+                <a:solidFill>
+                  <a:srgbClr val="242938"/>
+                </a:solidFill>
+                <a:latin typeface="Apple SD Gothic Neo" pitchFamily="34" charset="0"/>
+                <a:ea typeface="Apple SD Gothic Neo" pitchFamily="34" charset="-122"/>
+                <a:cs typeface="Apple SD Gothic Neo" pitchFamily="34" charset="-120"/>
+              </a:rPr>
+              <a:t>음성 · 텍스트</a:t>
+            </a:r>
+            <a:endParaRPr lang="en-US" sz="2300" dirty="0"/>
+          </a:p>
+        </p:txBody>
+      </p:sp>
+      <p:sp>
+        <p:nvSpPr>
+          <p:cNvPr id="10" name="Text 7"/>
+          <p:cNvSpPr/>
+          <p:nvPr/>
+        </p:nvSpPr>
+        <p:spPr>
+          <a:xfrm>
+            <a:off x="804672" y="4517136"/>
+            <a:ext cx="1828800" cy="457200"/>
+          </a:xfrm>
+          <a:prstGeom prst="rect">
+            <a:avLst/>
+          </a:prstGeom>
+          <a:noFill/>
+          <a:ln/>
+        </p:spPr>
+        <p:txBody>
+          <a:bodyPr wrap="square" lIns="0" tIns="0" rIns="0" bIns="0" rtlCol="0" anchor="ctr"/>
+          <a:lstStyle/>
+          <a:p>
+            <a:pPr algn="ctr" indent="0" marL="0">
+              <a:buNone/>
+            </a:pPr>
+            <a:r>
+              <a:rPr lang="en-US" sz="2800" b="1" dirty="0">
+                <a:solidFill>
+                  <a:srgbClr val="405394"/>
+                </a:solidFill>
+                <a:latin typeface="Apple SD Gothic Neo" pitchFamily="34" charset="0"/>
+                <a:ea typeface="Apple SD Gothic Neo" pitchFamily="34" charset="-122"/>
+                <a:cs typeface="Apple SD Gothic Neo" pitchFamily="34" charset="-120"/>
+              </a:rPr>
+              <a:t>기록 · 할 일</a:t>
+            </a:r>
+            <a:endParaRPr lang="en-US" sz="2800" dirty="0"/>
+          </a:p>
+        </p:txBody>
+      </p:sp>
+      <p:sp>
+        <p:nvSpPr>
+          <p:cNvPr id="11" name="Text 8"/>
+          <p:cNvSpPr/>
+          <p:nvPr/>
+        </p:nvSpPr>
+        <p:spPr>
+          <a:xfrm>
+            <a:off x="804672" y="5138928"/>
+            <a:ext cx="1828800" cy="365760"/>
+          </a:xfrm>
+          <a:prstGeom prst="rect">
+            <a:avLst/>
+          </a:prstGeom>
+          <a:noFill/>
+          <a:ln/>
+        </p:spPr>
+        <p:txBody>
+          <a:bodyPr wrap="square" lIns="0" tIns="0" rIns="0" bIns="0" rtlCol="0" anchor="ctr"/>
+          <a:lstStyle/>
+          <a:p>
+            <a:pPr algn="ctr" indent="0" marL="0">
+              <a:buNone/>
+            </a:pPr>
+            <a:r>
+              <a:rPr lang="en-US" sz="2300" dirty="0">
+                <a:solidFill>
+                  <a:srgbClr val="242938"/>
+                </a:solidFill>
+                <a:latin typeface="Apple SD Gothic Neo" pitchFamily="34" charset="0"/>
+                <a:ea typeface="Apple SD Gothic Neo" pitchFamily="34" charset="-122"/>
+                <a:cs typeface="Apple SD Gothic Neo" pitchFamily="34" charset="-120"/>
+              </a:rPr>
+              <a:t>조회 · 수정</a:t>
+            </a:r>
+            <a:endParaRPr lang="en-US" sz="2300" dirty="0"/>
+          </a:p>
+        </p:txBody>
+      </p:sp>
+      <p:sp>
+        <p:nvSpPr>
+          <p:cNvPr id="12" name="Shape 9"/>
+          <p:cNvSpPr/>
+          <p:nvPr/>
+        </p:nvSpPr>
+        <p:spPr>
+          <a:xfrm>
+            <a:off x="3319272" y="1828800"/>
+            <a:ext cx="2377440" cy="1783080"/>
+          </a:xfrm>
+          <a:prstGeom prst="roundRect">
+            <a:avLst>
+              <a:gd name="adj" fmla="val 10256"/>
             </a:avLst>
           </a:prstGeom>
           <a:solidFill>
@@ -3392,57 +3606,383 @@
       </p:sp>
       <p:sp>
         <p:nvSpPr>
-          <p:cNvPr id="7" name="Text 4"/>
-          <p:cNvSpPr/>
-          <p:nvPr/>
-        </p:nvSpPr>
-        <p:spPr>
-          <a:xfrm>
-            <a:off x="3264408" y="1700784"/>
-            <a:ext cx="7955280" cy="365760"/>
-          </a:xfrm>
-          <a:prstGeom prst="rect">
-            <a:avLst/>
-          </a:prstGeom>
-          <a:noFill/>
-          <a:ln/>
-        </p:spPr>
-        <p:txBody>
-          <a:bodyPr wrap="square" lIns="0" tIns="0" rIns="0" bIns="0" rtlCol="0" anchor="ctr"/>
-          <a:lstStyle/>
-          <a:p>
-            <a:pPr indent="0" marL="0">
-              <a:buNone/>
-            </a:pPr>
-            <a:r>
-              <a:rPr lang="en-US" sz="2500" b="1" dirty="0">
-                <a:solidFill>
-                  <a:srgbClr val="405394"/>
-                </a:solidFill>
-                <a:latin typeface="Apple SD Gothic Neo" pitchFamily="34" charset="0"/>
-                <a:ea typeface="Apple SD Gothic Neo" pitchFamily="34" charset="-122"/>
-                <a:cs typeface="Apple SD Gothic Neo" pitchFamily="34" charset="-120"/>
-              </a:rPr>
-              <a:t>MacBook 서버</a:t>
-            </a:r>
-            <a:endParaRPr lang="en-US" sz="2500" dirty="0"/>
-          </a:p>
-        </p:txBody>
-      </p:sp>
-      <p:sp>
-        <p:nvSpPr>
-          <p:cNvPr id="8" name="Shape 5"/>
-          <p:cNvSpPr/>
-          <p:nvPr/>
-        </p:nvSpPr>
-        <p:spPr>
-          <a:xfrm>
-            <a:off x="548640" y="2834640"/>
-            <a:ext cx="1874520" cy="1737360"/>
+          <p:cNvPr id="13" name="Shape 10"/>
+          <p:cNvSpPr/>
+          <p:nvPr/>
+        </p:nvSpPr>
+        <p:spPr>
+          <a:xfrm>
+            <a:off x="3319272" y="4069080"/>
+            <a:ext cx="2377440" cy="1783080"/>
           </a:xfrm>
           <a:prstGeom prst="roundRect">
             <a:avLst>
-              <a:gd name="adj" fmla="val 10526"/>
+              <a:gd name="adj" fmla="val 10256"/>
+            </a:avLst>
+          </a:prstGeom>
+          <a:solidFill>
+            <a:srgbClr val="DFE5FF"/>
+          </a:solidFill>
+          <a:ln w="12700">
+            <a:solidFill>
+              <a:srgbClr val="DFE5FF">
+                <a:alpha val="0"/>
+              </a:srgbClr>
+            </a:solidFill>
+            <a:prstDash val="solid"/>
+          </a:ln>
+        </p:spPr>
+      </p:sp>
+      <p:sp>
+        <p:nvSpPr>
+          <p:cNvPr id="14" name="Text 11"/>
+          <p:cNvSpPr/>
+          <p:nvPr/>
+        </p:nvSpPr>
+        <p:spPr>
+          <a:xfrm>
+            <a:off x="3529584" y="2121408"/>
+            <a:ext cx="1956816" cy="438912"/>
+          </a:xfrm>
+          <a:prstGeom prst="rect">
+            <a:avLst/>
+          </a:prstGeom>
+          <a:noFill/>
+          <a:ln/>
+        </p:spPr>
+        <p:txBody>
+          <a:bodyPr wrap="square" lIns="0" tIns="0" rIns="0" bIns="0" rtlCol="0" anchor="ctr"/>
+          <a:lstStyle/>
+          <a:p>
+            <a:pPr algn="ctr" indent="0" marL="0">
+              <a:buNone/>
+            </a:pPr>
+            <a:r>
+              <a:rPr lang="en-US" sz="2800" b="1" dirty="0">
+                <a:solidFill>
+                  <a:srgbClr val="405394"/>
+                </a:solidFill>
+                <a:latin typeface="Apple SD Gothic Neo" pitchFamily="34" charset="0"/>
+                <a:ea typeface="Apple SD Gothic Neo" pitchFamily="34" charset="-122"/>
+                <a:cs typeface="Apple SD Gothic Neo" pitchFamily="34" charset="-120"/>
+              </a:rPr>
+              <a:t>HTTP API</a:t>
+            </a:r>
+            <a:endParaRPr lang="en-US" sz="2800" dirty="0"/>
+          </a:p>
+        </p:txBody>
+      </p:sp>
+      <p:sp>
+        <p:nvSpPr>
+          <p:cNvPr id="15" name="Text 12"/>
+          <p:cNvSpPr/>
+          <p:nvPr/>
+        </p:nvSpPr>
+        <p:spPr>
+          <a:xfrm>
+            <a:off x="3529584" y="2770632"/>
+            <a:ext cx="1956816" cy="603504"/>
+          </a:xfrm>
+          <a:prstGeom prst="rect">
+            <a:avLst/>
+          </a:prstGeom>
+          <a:noFill/>
+          <a:ln/>
+        </p:spPr>
+        <p:txBody>
+          <a:bodyPr wrap="square" lIns="0" tIns="0" rIns="0" bIns="0" rtlCol="0" anchor="ctr"/>
+          <a:lstStyle/>
+          <a:p>
+            <a:pPr algn="ctr" indent="0" marL="0">
+              <a:buNone/>
+            </a:pPr>
+            <a:r>
+              <a:rPr lang="en-US" sz="2100" dirty="0">
+                <a:solidFill>
+                  <a:srgbClr val="242938"/>
+                </a:solidFill>
+                <a:latin typeface="Apple SD Gothic Neo" pitchFamily="34" charset="0"/>
+                <a:ea typeface="Apple SD Gothic Neo" pitchFamily="34" charset="-122"/>
+                <a:cs typeface="Apple SD Gothic Neo" pitchFamily="34" charset="-120"/>
+              </a:rPr>
+              <a:t>음성 인식 · 번역</a:t>
+            </a:r>
+            <a:endParaRPr lang="en-US" sz="2100" dirty="0"/>
+          </a:p>
+          <a:p>
+            <a:pPr algn="ctr" indent="0" marL="0">
+              <a:buNone/>
+            </a:pPr>
+            <a:r>
+              <a:rPr lang="en-US" sz="2100" dirty="0">
+                <a:solidFill>
+                  <a:srgbClr val="242938"/>
+                </a:solidFill>
+                <a:latin typeface="Apple SD Gothic Neo" pitchFamily="34" charset="0"/>
+                <a:ea typeface="Apple SD Gothic Neo" pitchFamily="34" charset="-122"/>
+                <a:cs typeface="Apple SD Gothic Neo" pitchFamily="34" charset="-120"/>
+              </a:rPr>
+              <a:t>음성 합성</a:t>
+            </a:r>
+            <a:endParaRPr lang="en-US" sz="2100" dirty="0"/>
+          </a:p>
+        </p:txBody>
+      </p:sp>
+      <p:sp>
+        <p:nvSpPr>
+          <p:cNvPr id="16" name="Text 13"/>
+          <p:cNvSpPr/>
+          <p:nvPr/>
+        </p:nvSpPr>
+        <p:spPr>
+          <a:xfrm>
+            <a:off x="3529584" y="4361688"/>
+            <a:ext cx="1956816" cy="438912"/>
+          </a:xfrm>
+          <a:prstGeom prst="rect">
+            <a:avLst/>
+          </a:prstGeom>
+          <a:noFill/>
+          <a:ln/>
+        </p:spPr>
+        <p:txBody>
+          <a:bodyPr wrap="square" lIns="0" tIns="0" rIns="0" bIns="0" rtlCol="0" anchor="ctr"/>
+          <a:lstStyle/>
+          <a:p>
+            <a:pPr algn="ctr" indent="0" marL="0">
+              <a:buNone/>
+            </a:pPr>
+            <a:r>
+              <a:rPr lang="en-US" sz="2800" b="1" dirty="0">
+                <a:solidFill>
+                  <a:srgbClr val="405394"/>
+                </a:solidFill>
+                <a:latin typeface="Apple SD Gothic Neo" pitchFamily="34" charset="0"/>
+                <a:ea typeface="Apple SD Gothic Neo" pitchFamily="34" charset="-122"/>
+                <a:cs typeface="Apple SD Gothic Neo" pitchFamily="34" charset="-120"/>
+              </a:rPr>
+              <a:t>HTTP API</a:t>
+            </a:r>
+            <a:endParaRPr lang="en-US" sz="2800" dirty="0"/>
+          </a:p>
+        </p:txBody>
+      </p:sp>
+      <p:sp>
+        <p:nvSpPr>
+          <p:cNvPr id="17" name="Text 14"/>
+          <p:cNvSpPr/>
+          <p:nvPr/>
+        </p:nvSpPr>
+        <p:spPr>
+          <a:xfrm>
+            <a:off x="3529584" y="5010912"/>
+            <a:ext cx="1956816" cy="603504"/>
+          </a:xfrm>
+          <a:prstGeom prst="rect">
+            <a:avLst/>
+          </a:prstGeom>
+          <a:noFill/>
+          <a:ln/>
+        </p:spPr>
+        <p:txBody>
+          <a:bodyPr wrap="square" lIns="0" tIns="0" rIns="0" bIns="0" rtlCol="0" anchor="ctr"/>
+          <a:lstStyle/>
+          <a:p>
+            <a:pPr algn="ctr" indent="0" marL="0">
+              <a:buNone/>
+            </a:pPr>
+            <a:r>
+              <a:rPr lang="en-US" sz="2100" dirty="0">
+                <a:solidFill>
+                  <a:srgbClr val="242938"/>
+                </a:solidFill>
+                <a:latin typeface="Apple SD Gothic Neo" pitchFamily="34" charset="0"/>
+                <a:ea typeface="Apple SD Gothic Neo" pitchFamily="34" charset="-122"/>
+                <a:cs typeface="Apple SD Gothic Neo" pitchFamily="34" charset="-120"/>
+              </a:rPr>
+              <a:t>회원 인증 · 동기화</a:t>
+            </a:r>
+            <a:endParaRPr lang="en-US" sz="2100" dirty="0"/>
+          </a:p>
+          <a:p>
+            <a:pPr algn="ctr" indent="0" marL="0">
+              <a:buNone/>
+            </a:pPr>
+            <a:r>
+              <a:rPr lang="en-US" sz="2100" dirty="0">
+                <a:solidFill>
+                  <a:srgbClr val="242938"/>
+                </a:solidFill>
+                <a:latin typeface="Apple SD Gothic Neo" pitchFamily="34" charset="0"/>
+                <a:ea typeface="Apple SD Gothic Neo" pitchFamily="34" charset="-122"/>
+                <a:cs typeface="Apple SD Gothic Neo" pitchFamily="34" charset="-120"/>
+              </a:rPr>
+              <a:t>할 일 추출</a:t>
+            </a:r>
+            <a:endParaRPr lang="en-US" sz="2100" dirty="0"/>
+          </a:p>
+        </p:txBody>
+      </p:sp>
+      <p:sp>
+        <p:nvSpPr>
+          <p:cNvPr id="18" name="Shape 15"/>
+          <p:cNvSpPr/>
+          <p:nvPr/>
+        </p:nvSpPr>
+        <p:spPr>
+          <a:xfrm>
+            <a:off x="6318504" y="1828800"/>
+            <a:ext cx="2432304" cy="4023360"/>
+          </a:xfrm>
+          <a:prstGeom prst="roundRect">
+            <a:avLst>
+              <a:gd name="adj" fmla="val 7519"/>
+            </a:avLst>
+          </a:prstGeom>
+          <a:solidFill>
+            <a:srgbClr val="405394"/>
+          </a:solidFill>
+          <a:ln w="12700">
+            <a:solidFill>
+              <a:srgbClr val="405394">
+                <a:alpha val="0"/>
+              </a:srgbClr>
+            </a:solidFill>
+            <a:prstDash val="solid"/>
+          </a:ln>
+        </p:spPr>
+      </p:sp>
+      <p:sp>
+        <p:nvSpPr>
+          <p:cNvPr id="19" name="Text 16"/>
+          <p:cNvSpPr/>
+          <p:nvPr/>
+        </p:nvSpPr>
+        <p:spPr>
+          <a:xfrm>
+            <a:off x="6510528" y="2276856"/>
+            <a:ext cx="2048256" cy="438912"/>
+          </a:xfrm>
+          <a:prstGeom prst="rect">
+            <a:avLst/>
+          </a:prstGeom>
+          <a:noFill/>
+          <a:ln/>
+        </p:spPr>
+        <p:txBody>
+          <a:bodyPr wrap="square" lIns="0" tIns="0" rIns="0" bIns="0" rtlCol="0" anchor="ctr"/>
+          <a:lstStyle/>
+          <a:p>
+            <a:pPr algn="ctr" indent="0" marL="0">
+              <a:buNone/>
+            </a:pPr>
+            <a:r>
+              <a:rPr lang="en-US" sz="2200" b="1" dirty="0">
+                <a:solidFill>
+                  <a:srgbClr val="FFFFFF"/>
+                </a:solidFill>
+                <a:latin typeface="Apple SD Gothic Neo" pitchFamily="34" charset="0"/>
+                <a:ea typeface="Apple SD Gothic Neo" pitchFamily="34" charset="-122"/>
+                <a:cs typeface="Apple SD Gothic Neo" pitchFamily="34" charset="-120"/>
+              </a:rPr>
+              <a:t>SpeechBridge</a:t>
+            </a:r>
+            <a:endParaRPr lang="en-US" sz="2200" dirty="0"/>
+          </a:p>
+        </p:txBody>
+      </p:sp>
+      <p:sp>
+        <p:nvSpPr>
+          <p:cNvPr id="20" name="Text 17"/>
+          <p:cNvSpPr/>
+          <p:nvPr/>
+        </p:nvSpPr>
+        <p:spPr>
+          <a:xfrm>
+            <a:off x="6510528" y="2862072"/>
+            <a:ext cx="2048256" cy="539496"/>
+          </a:xfrm>
+          <a:prstGeom prst="rect">
+            <a:avLst/>
+          </a:prstGeom>
+          <a:noFill/>
+          <a:ln/>
+        </p:spPr>
+        <p:txBody>
+          <a:bodyPr wrap="square" lIns="0" tIns="0" rIns="0" bIns="0" rtlCol="0" anchor="ctr"/>
+          <a:lstStyle/>
+          <a:p>
+            <a:pPr algn="ctr" indent="0" marL="0">
+              <a:buNone/>
+            </a:pPr>
+            <a:r>
+              <a:rPr lang="en-US" sz="3600" b="1" dirty="0">
+                <a:solidFill>
+                  <a:srgbClr val="FFFFFF"/>
+                </a:solidFill>
+                <a:latin typeface="Apple SD Gothic Neo" pitchFamily="34" charset="0"/>
+                <a:ea typeface="Apple SD Gothic Neo" pitchFamily="34" charset="-122"/>
+                <a:cs typeface="Apple SD Gothic Neo" pitchFamily="34" charset="-120"/>
+              </a:rPr>
+              <a:t>서버</a:t>
+            </a:r>
+            <a:endParaRPr lang="en-US" sz="3600" dirty="0"/>
+          </a:p>
+        </p:txBody>
+      </p:sp>
+      <p:sp>
+        <p:nvSpPr>
+          <p:cNvPr id="21" name="Text 18"/>
+          <p:cNvSpPr/>
+          <p:nvPr/>
+        </p:nvSpPr>
+        <p:spPr>
+          <a:xfrm>
+            <a:off x="6510528" y="3712464"/>
+            <a:ext cx="2048256" cy="429768"/>
+          </a:xfrm>
+          <a:prstGeom prst="rect">
+            <a:avLst/>
+          </a:prstGeom>
+          <a:noFill/>
+          <a:ln/>
+        </p:spPr>
+        <p:txBody>
+          <a:bodyPr wrap="square" lIns="0" tIns="0" rIns="0" bIns="0" rtlCol="0" anchor="ctr"/>
+          <a:lstStyle/>
+          <a:p>
+            <a:pPr algn="ctr" indent="0" marL="0">
+              <a:buNone/>
+            </a:pPr>
+            <a:r>
+              <a:rPr lang="en-US" sz="2800" dirty="0">
+                <a:solidFill>
+                  <a:srgbClr val="FFFFFF"/>
+                </a:solidFill>
+                <a:latin typeface="Apple SD Gothic Neo" pitchFamily="34" charset="0"/>
+                <a:ea typeface="Apple SD Gothic Neo" pitchFamily="34" charset="-122"/>
+                <a:cs typeface="Apple SD Gothic Neo" pitchFamily="34" charset="-120"/>
+              </a:rPr>
+              <a:t>MacBook</a:t>
+            </a:r>
+            <a:endParaRPr lang="en-US" sz="2800" dirty="0"/>
+          </a:p>
+        </p:txBody>
+      </p:sp>
+      <p:sp>
+        <p:nvSpPr>
+          <p:cNvPr id="22" name="Shape 19"/>
+          <p:cNvSpPr/>
+          <p:nvPr/>
+        </p:nvSpPr>
+        <p:spPr>
+          <a:xfrm>
+            <a:off x="6556248" y="4553712"/>
+            <a:ext cx="1956816" cy="877824"/>
+          </a:xfrm>
+          <a:prstGeom prst="roundRect">
+            <a:avLst>
+              <a:gd name="adj" fmla="val 20833"/>
             </a:avLst>
           </a:prstGeom>
           <a:solidFill>
@@ -3458,109 +3998,83 @@
           </a:ln>
         </p:spPr>
       </p:sp>
-      <p:sp>
-        <p:nvSpPr>
-          <p:cNvPr id="9" name="Shape 6"/>
-          <p:cNvSpPr/>
-          <p:nvPr/>
-        </p:nvSpPr>
-        <p:spPr>
-          <a:xfrm>
-            <a:off x="1207008" y="3072384"/>
-            <a:ext cx="530352" cy="731520"/>
+      <p:pic>
+        <p:nvPicPr>
+          <p:cNvPr id="23" name="Image 0" descr="nodejs">    </p:cNvPr>
+          <p:cNvPicPr>
+            <a:picLocks noChangeAspect="1"/>
+          </p:cNvPicPr>
+          <p:nvPr/>
+        </p:nvPicPr>
+        <p:blipFill>
+          <a:blip r:embed="rId1"/>
+          <a:stretch>
+            <a:fillRect/>
+          </a:stretch>
+        </p:blipFill>
+        <p:spPr>
+          <a:xfrm>
+            <a:off x="6766560" y="4762816"/>
+            <a:ext cx="1536192" cy="459615"/>
+          </a:xfrm>
+          <a:prstGeom prst="rect">
+            <a:avLst/>
+          </a:prstGeom>
+        </p:spPr>
+      </p:pic>
+      <p:sp>
+        <p:nvSpPr>
+          <p:cNvPr id="24" name="Text 20"/>
+          <p:cNvSpPr/>
+          <p:nvPr/>
+        </p:nvSpPr>
+        <p:spPr>
+          <a:xfrm>
+            <a:off x="9445752" y="1417320"/>
+            <a:ext cx="2066544" cy="256032"/>
+          </a:xfrm>
+          <a:prstGeom prst="rect">
+            <a:avLst/>
+          </a:prstGeom>
+          <a:noFill/>
+          <a:ln/>
+        </p:spPr>
+        <p:txBody>
+          <a:bodyPr wrap="square" lIns="0" tIns="0" rIns="0" bIns="0" rtlCol="0" anchor="ctr"/>
+          <a:lstStyle/>
+          <a:p>
+            <a:pPr algn="ctr" indent="0" marL="0">
+              <a:buNone/>
+            </a:pPr>
+            <a:r>
+              <a:rPr lang="en-US" sz="1600" dirty="0">
+                <a:solidFill>
+                  <a:srgbClr val="626B80"/>
+                </a:solidFill>
+                <a:latin typeface="Apple SD Gothic Neo" pitchFamily="34" charset="0"/>
+                <a:ea typeface="Apple SD Gothic Neo" pitchFamily="34" charset="-122"/>
+                <a:cs typeface="Apple SD Gothic Neo" pitchFamily="34" charset="-120"/>
+              </a:rPr>
+              <a:t>MacBook 내부</a:t>
+            </a:r>
+            <a:endParaRPr lang="en-US" sz="1600" dirty="0"/>
+          </a:p>
+        </p:txBody>
+      </p:sp>
+      <p:sp>
+        <p:nvSpPr>
+          <p:cNvPr id="25" name="Shape 21"/>
+          <p:cNvSpPr/>
+          <p:nvPr/>
+        </p:nvSpPr>
+        <p:spPr>
+          <a:xfrm>
+            <a:off x="9354312" y="1828800"/>
+            <a:ext cx="2249424" cy="1783080"/>
           </a:xfrm>
           <a:prstGeom prst="roundRect">
             <a:avLst>
-              <a:gd name="adj" fmla="val 13793"/>
-            </a:avLst>
-          </a:prstGeom>
-          <a:solidFill>
-            <a:srgbClr val="FFFFFF"/>
-          </a:solidFill>
-          <a:ln w="25400">
-            <a:solidFill>
-              <a:srgbClr val="405394"/>
-            </a:solidFill>
-            <a:prstDash val="solid"/>
-          </a:ln>
-        </p:spPr>
-      </p:sp>
-      <p:sp>
-        <p:nvSpPr>
-          <p:cNvPr id="10" name="Shape 7"/>
-          <p:cNvSpPr/>
-          <p:nvPr/>
-        </p:nvSpPr>
-        <p:spPr>
-          <a:xfrm>
-            <a:off x="1362456" y="3694176"/>
-            <a:ext cx="219456" cy="0"/>
-          </a:xfrm>
-          <a:prstGeom prst="line">
-            <a:avLst/>
-          </a:prstGeom>
-          <a:noFill/>
-          <a:ln w="25400">
-            <a:solidFill>
-              <a:srgbClr val="405394"/>
-            </a:solidFill>
-            <a:prstDash val="solid"/>
-          </a:ln>
-        </p:spPr>
-      </p:sp>
-      <p:sp>
-        <p:nvSpPr>
-          <p:cNvPr id="11" name="Text 8"/>
-          <p:cNvSpPr/>
-          <p:nvPr/>
-        </p:nvSpPr>
-        <p:spPr>
-          <a:xfrm>
-            <a:off x="777240" y="4005072"/>
-            <a:ext cx="1417320" cy="365760"/>
-          </a:xfrm>
-          <a:prstGeom prst="rect">
-            <a:avLst/>
-          </a:prstGeom>
-          <a:noFill/>
-          <a:ln/>
-        </p:spPr>
-        <p:txBody>
-          <a:bodyPr wrap="square" lIns="0" tIns="0" rIns="0" bIns="0" rtlCol="0" anchor="ctr"/>
-          <a:lstStyle/>
-          <a:p>
-            <a:pPr indent="0" marL="0">
-              <a:buNone/>
-            </a:pPr>
-            <a:r>
-              <a:rPr lang="en-US" sz="2400" b="1" dirty="0">
-                <a:solidFill>
-                  <a:srgbClr val="405394"/>
-                </a:solidFill>
-                <a:latin typeface="Apple SD Gothic Neo" pitchFamily="34" charset="0"/>
-                <a:ea typeface="Apple SD Gothic Neo" pitchFamily="34" charset="-122"/>
-                <a:cs typeface="Apple SD Gothic Neo" pitchFamily="34" charset="-120"/>
-              </a:rPr>
-              <a:t>모바일 앱</a:t>
-            </a:r>
-            <a:endParaRPr lang="en-US" sz="2400" dirty="0"/>
-          </a:p>
-        </p:txBody>
-      </p:sp>
-      <p:sp>
-        <p:nvSpPr>
-          <p:cNvPr id="12" name="Shape 9"/>
-          <p:cNvSpPr/>
-          <p:nvPr/>
-        </p:nvSpPr>
-        <p:spPr>
-          <a:xfrm>
-            <a:off x="3328416" y="2304288"/>
-            <a:ext cx="3767328" cy="3648456"/>
-          </a:xfrm>
-          <a:prstGeom prst="roundRect">
-            <a:avLst>
-              <a:gd name="adj" fmla="val 5013"/>
+              <a:gd name="adj" fmla="val 10256"/>
             </a:avLst>
           </a:prstGeom>
           <a:solidFill>
@@ -3576,56 +4090,32 @@
           </a:ln>
         </p:spPr>
       </p:sp>
-      <p:pic>
-        <p:nvPicPr>
-          <p:cNvPr id="13" name="Image 0" descr="nodejs">    </p:cNvPr>
-          <p:cNvPicPr>
-            <a:picLocks noChangeAspect="1"/>
-          </p:cNvPicPr>
-          <p:nvPr/>
-        </p:nvPicPr>
-        <p:blipFill>
-          <a:blip r:embed="rId1"/>
-          <a:stretch>
-            <a:fillRect/>
-          </a:stretch>
-        </p:blipFill>
-        <p:spPr>
-          <a:xfrm>
-            <a:off x="3602736" y="2665057"/>
-            <a:ext cx="1225296" cy="366598"/>
-          </a:xfrm>
-          <a:prstGeom prst="rect">
-            <a:avLst/>
-          </a:prstGeom>
-        </p:spPr>
-      </p:pic>
-      <p:sp>
-        <p:nvSpPr>
-          <p:cNvPr id="14" name="Text 10"/>
-          <p:cNvSpPr/>
-          <p:nvPr/>
-        </p:nvSpPr>
-        <p:spPr>
-          <a:xfrm>
-            <a:off x="5102352" y="2606040"/>
-            <a:ext cx="1673352" cy="365760"/>
-          </a:xfrm>
-          <a:prstGeom prst="rect">
-            <a:avLst/>
-          </a:prstGeom>
-          <a:noFill/>
-          <a:ln/>
-        </p:spPr>
-        <p:txBody>
-          <a:bodyPr wrap="square" lIns="0" tIns="0" rIns="0" bIns="0" rtlCol="0" anchor="ctr"/>
-          <a:lstStyle/>
-          <a:p>
-            <a:pPr indent="0" marL="0">
-              <a:buNone/>
-            </a:pPr>
-            <a:r>
-              <a:rPr lang="en-US" sz="2500" b="1" dirty="0">
+      <p:sp>
+        <p:nvSpPr>
+          <p:cNvPr id="26" name="Text 22"/>
+          <p:cNvSpPr/>
+          <p:nvPr/>
+        </p:nvSpPr>
+        <p:spPr>
+          <a:xfrm>
+            <a:off x="9546336" y="2039112"/>
+            <a:ext cx="1865376" cy="365760"/>
+          </a:xfrm>
+          <a:prstGeom prst="rect">
+            <a:avLst/>
+          </a:prstGeom>
+          <a:noFill/>
+          <a:ln/>
+        </p:spPr>
+        <p:txBody>
+          <a:bodyPr wrap="square" lIns="0" tIns="0" rIns="0" bIns="0" rtlCol="0" anchor="ctr"/>
+          <a:lstStyle/>
+          <a:p>
+            <a:pPr algn="ctr" indent="0" marL="0">
+              <a:buNone/>
+            </a:pPr>
+            <a:r>
+              <a:rPr lang="en-US" sz="2600" b="1" dirty="0">
                 <a:solidFill>
                   <a:srgbClr val="405394"/>
                 </a:solidFill>
@@ -3633,38 +4123,38 @@
                 <a:ea typeface="Apple SD Gothic Neo" pitchFamily="34" charset="-122"/>
                 <a:cs typeface="Apple SD Gothic Neo" pitchFamily="34" charset="-120"/>
               </a:rPr>
-              <a:t>API 서버</a:t>
-            </a:r>
-            <a:endParaRPr lang="en-US" sz="2500" dirty="0"/>
-          </a:p>
-        </p:txBody>
-      </p:sp>
-      <p:sp>
-        <p:nvSpPr>
-          <p:cNvPr id="15" name="Text 11"/>
-          <p:cNvSpPr/>
-          <p:nvPr/>
-        </p:nvSpPr>
-        <p:spPr>
-          <a:xfrm>
-            <a:off x="3630168" y="3337560"/>
-            <a:ext cx="3200400" cy="329184"/>
-          </a:xfrm>
-          <a:prstGeom prst="rect">
-            <a:avLst/>
-          </a:prstGeom>
-          <a:noFill/>
-          <a:ln/>
-        </p:spPr>
-        <p:txBody>
-          <a:bodyPr wrap="square" lIns="0" tIns="0" rIns="0" bIns="0" rtlCol="0" anchor="ctr"/>
-          <a:lstStyle/>
-          <a:p>
-            <a:pPr indent="0" marL="0">
-              <a:buNone/>
-            </a:pPr>
-            <a:r>
-              <a:rPr lang="en-US" sz="2300" b="1" dirty="0">
+              <a:t>로컬 AI</a:t>
+            </a:r>
+            <a:endParaRPr lang="en-US" sz="2600" dirty="0"/>
+          </a:p>
+        </p:txBody>
+      </p:sp>
+      <p:sp>
+        <p:nvSpPr>
+          <p:cNvPr id="27" name="Text 23"/>
+          <p:cNvSpPr/>
+          <p:nvPr/>
+        </p:nvSpPr>
+        <p:spPr>
+          <a:xfrm>
+            <a:off x="9546336" y="2688336"/>
+            <a:ext cx="1865376" cy="713232"/>
+          </a:xfrm>
+          <a:prstGeom prst="rect">
+            <a:avLst/>
+          </a:prstGeom>
+          <a:noFill/>
+          <a:ln/>
+        </p:spPr>
+        <p:txBody>
+          <a:bodyPr wrap="square" lIns="0" tIns="0" rIns="0" bIns="0" rtlCol="0" anchor="ctr"/>
+          <a:lstStyle/>
+          <a:p>
+            <a:pPr algn="ctr" indent="0" marL="0">
+              <a:buNone/>
+            </a:pPr>
+            <a:r>
+              <a:rPr lang="en-US" sz="1800" dirty="0">
                 <a:solidFill>
                   <a:srgbClr val="242938"/>
                 </a:solidFill>
@@ -3672,38 +4162,16 @@
                 <a:ea typeface="Apple SD Gothic Neo" pitchFamily="34" charset="-122"/>
                 <a:cs typeface="Apple SD Gothic Neo" pitchFamily="34" charset="-120"/>
               </a:rPr>
-              <a:t>HTTP API</a:t>
-            </a:r>
-            <a:endParaRPr lang="en-US" sz="2300" dirty="0"/>
-          </a:p>
-        </p:txBody>
-      </p:sp>
-      <p:sp>
-        <p:nvSpPr>
-          <p:cNvPr id="16" name="Text 12"/>
-          <p:cNvSpPr/>
-          <p:nvPr/>
-        </p:nvSpPr>
-        <p:spPr>
-          <a:xfrm>
-            <a:off x="3630168" y="3977640"/>
-            <a:ext cx="3200400" cy="237744"/>
-          </a:xfrm>
-          <a:prstGeom prst="rect">
-            <a:avLst/>
-          </a:prstGeom>
-          <a:noFill/>
-          <a:ln/>
-        </p:spPr>
-        <p:txBody>
-          <a:bodyPr wrap="square" lIns="0" tIns="0" rIns="0" bIns="0" rtlCol="0" anchor="ctr"/>
-          <a:lstStyle/>
-          <a:p>
-            <a:pPr indent="0" marL="0">
-              <a:buNone/>
-            </a:pPr>
-            <a:r>
-              <a:rPr lang="en-US" sz="1900" dirty="0">
+              <a:t>Ollama API</a:t>
+            </a:r>
+            <a:endParaRPr lang="en-US" sz="1800" dirty="0"/>
+          </a:p>
+          <a:p>
+            <a:pPr algn="ctr" indent="0" marL="0">
+              <a:buNone/>
+            </a:pPr>
+            <a:r>
+              <a:rPr lang="en-US" sz="1800" dirty="0">
                 <a:solidFill>
                   <a:srgbClr val="242938"/>
                 </a:solidFill>
@@ -3711,38 +4179,16 @@
                 <a:ea typeface="Apple SD Gothic Neo" pitchFamily="34" charset="-122"/>
                 <a:cs typeface="Apple SD Gothic Neo" pitchFamily="34" charset="-120"/>
               </a:rPr>
-              <a:t>회원 인증 API</a:t>
-            </a:r>
-            <a:endParaRPr lang="en-US" sz="1900" dirty="0"/>
-          </a:p>
-        </p:txBody>
-      </p:sp>
-      <p:sp>
-        <p:nvSpPr>
-          <p:cNvPr id="17" name="Text 13"/>
-          <p:cNvSpPr/>
-          <p:nvPr/>
-        </p:nvSpPr>
-        <p:spPr>
-          <a:xfrm>
-            <a:off x="3630168" y="4288536"/>
-            <a:ext cx="3200400" cy="237744"/>
-          </a:xfrm>
-          <a:prstGeom prst="rect">
-            <a:avLst/>
-          </a:prstGeom>
-          <a:noFill/>
-          <a:ln/>
-        </p:spPr>
-        <p:txBody>
-          <a:bodyPr wrap="square" lIns="0" tIns="0" rIns="0" bIns="0" rtlCol="0" anchor="ctr"/>
-          <a:lstStyle/>
-          <a:p>
-            <a:pPr indent="0" marL="0">
-              <a:buNone/>
-            </a:pPr>
-            <a:r>
-              <a:rPr lang="en-US" sz="1900" dirty="0">
+              <a:t>NeMo-Speech.cpp</a:t>
+            </a:r>
+            <a:endParaRPr lang="en-US" sz="1800" dirty="0"/>
+          </a:p>
+          <a:p>
+            <a:pPr algn="ctr" indent="0" marL="0">
+              <a:buNone/>
+            </a:pPr>
+            <a:r>
+              <a:rPr lang="en-US" sz="1800" dirty="0">
                 <a:solidFill>
                   <a:srgbClr val="242938"/>
                 </a:solidFill>
@@ -3750,182 +4196,26 @@
                 <a:ea typeface="Apple SD Gothic Neo" pitchFamily="34" charset="-122"/>
                 <a:cs typeface="Apple SD Gothic Neo" pitchFamily="34" charset="-120"/>
               </a:rPr>
-              <a:t>음성 인식 API</a:t>
-            </a:r>
-            <a:endParaRPr lang="en-US" sz="1900" dirty="0"/>
-          </a:p>
-        </p:txBody>
-      </p:sp>
-      <p:sp>
-        <p:nvSpPr>
-          <p:cNvPr id="18" name="Text 14"/>
-          <p:cNvSpPr/>
-          <p:nvPr/>
-        </p:nvSpPr>
-        <p:spPr>
-          <a:xfrm>
-            <a:off x="3630168" y="4599432"/>
-            <a:ext cx="3200400" cy="237744"/>
-          </a:xfrm>
-          <a:prstGeom prst="rect">
-            <a:avLst/>
-          </a:prstGeom>
-          <a:noFill/>
-          <a:ln/>
-        </p:spPr>
-        <p:txBody>
-          <a:bodyPr wrap="square" lIns="0" tIns="0" rIns="0" bIns="0" rtlCol="0" anchor="ctr"/>
-          <a:lstStyle/>
-          <a:p>
-            <a:pPr indent="0" marL="0">
-              <a:buNone/>
-            </a:pPr>
-            <a:r>
-              <a:rPr lang="en-US" sz="1900" dirty="0">
-                <a:solidFill>
-                  <a:srgbClr val="242938"/>
-                </a:solidFill>
-                <a:latin typeface="Apple SD Gothic Neo" pitchFamily="34" charset="0"/>
-                <a:ea typeface="Apple SD Gothic Neo" pitchFamily="34" charset="-122"/>
-                <a:cs typeface="Apple SD Gothic Neo" pitchFamily="34" charset="-120"/>
-              </a:rPr>
-              <a:t>번역 API</a:t>
-            </a:r>
-            <a:endParaRPr lang="en-US" sz="1900" dirty="0"/>
-          </a:p>
-        </p:txBody>
-      </p:sp>
-      <p:sp>
-        <p:nvSpPr>
-          <p:cNvPr id="19" name="Text 15"/>
-          <p:cNvSpPr/>
-          <p:nvPr/>
-        </p:nvSpPr>
-        <p:spPr>
-          <a:xfrm>
-            <a:off x="3630168" y="4910328"/>
-            <a:ext cx="3200400" cy="237744"/>
-          </a:xfrm>
-          <a:prstGeom prst="rect">
-            <a:avLst/>
-          </a:prstGeom>
-          <a:noFill/>
-          <a:ln/>
-        </p:spPr>
-        <p:txBody>
-          <a:bodyPr wrap="square" lIns="0" tIns="0" rIns="0" bIns="0" rtlCol="0" anchor="ctr"/>
-          <a:lstStyle/>
-          <a:p>
-            <a:pPr indent="0" marL="0">
-              <a:buNone/>
-            </a:pPr>
-            <a:r>
-              <a:rPr lang="en-US" sz="1900" dirty="0">
-                <a:solidFill>
-                  <a:srgbClr val="242938"/>
-                </a:solidFill>
-                <a:latin typeface="Apple SD Gothic Neo" pitchFamily="34" charset="0"/>
-                <a:ea typeface="Apple SD Gothic Neo" pitchFamily="34" charset="-122"/>
-                <a:cs typeface="Apple SD Gothic Neo" pitchFamily="34" charset="-120"/>
-              </a:rPr>
-              <a:t>음성 합성 API</a:t>
-            </a:r>
-            <a:endParaRPr lang="en-US" sz="1900" dirty="0"/>
-          </a:p>
-        </p:txBody>
-      </p:sp>
-      <p:sp>
-        <p:nvSpPr>
-          <p:cNvPr id="20" name="Text 16"/>
-          <p:cNvSpPr/>
-          <p:nvPr/>
-        </p:nvSpPr>
-        <p:spPr>
-          <a:xfrm>
-            <a:off x="3630168" y="5221224"/>
-            <a:ext cx="3200400" cy="237744"/>
-          </a:xfrm>
-          <a:prstGeom prst="rect">
-            <a:avLst/>
-          </a:prstGeom>
-          <a:noFill/>
-          <a:ln/>
-        </p:spPr>
-        <p:txBody>
-          <a:bodyPr wrap="square" lIns="0" tIns="0" rIns="0" bIns="0" rtlCol="0" anchor="ctr"/>
-          <a:lstStyle/>
-          <a:p>
-            <a:pPr indent="0" marL="0">
-              <a:buNone/>
-            </a:pPr>
-            <a:r>
-              <a:rPr lang="en-US" sz="1900" dirty="0">
-                <a:solidFill>
-                  <a:srgbClr val="242938"/>
-                </a:solidFill>
-                <a:latin typeface="Apple SD Gothic Neo" pitchFamily="34" charset="0"/>
-                <a:ea typeface="Apple SD Gothic Neo" pitchFamily="34" charset="-122"/>
-                <a:cs typeface="Apple SD Gothic Neo" pitchFamily="34" charset="-120"/>
-              </a:rPr>
-              <a:t>할 일 추출 API</a:t>
-            </a:r>
-            <a:endParaRPr lang="en-US" sz="1900" dirty="0"/>
-          </a:p>
-        </p:txBody>
-      </p:sp>
-      <p:sp>
-        <p:nvSpPr>
-          <p:cNvPr id="21" name="Text 17"/>
-          <p:cNvSpPr/>
-          <p:nvPr/>
-        </p:nvSpPr>
-        <p:spPr>
-          <a:xfrm>
-            <a:off x="3630168" y="5532120"/>
-            <a:ext cx="3200400" cy="237744"/>
-          </a:xfrm>
-          <a:prstGeom prst="rect">
-            <a:avLst/>
-          </a:prstGeom>
-          <a:noFill/>
-          <a:ln/>
-        </p:spPr>
-        <p:txBody>
-          <a:bodyPr wrap="square" lIns="0" tIns="0" rIns="0" bIns="0" rtlCol="0" anchor="ctr"/>
-          <a:lstStyle/>
-          <a:p>
-            <a:pPr indent="0" marL="0">
-              <a:buNone/>
-            </a:pPr>
-            <a:r>
-              <a:rPr lang="en-US" sz="1900" dirty="0">
-                <a:solidFill>
-                  <a:srgbClr val="242938"/>
-                </a:solidFill>
-                <a:latin typeface="Apple SD Gothic Neo" pitchFamily="34" charset="0"/>
-                <a:ea typeface="Apple SD Gothic Neo" pitchFamily="34" charset="-122"/>
-                <a:cs typeface="Apple SD Gothic Neo" pitchFamily="34" charset="-120"/>
-              </a:rPr>
-              <a:t>기록 동기화 API</a:t>
-            </a:r>
-            <a:endParaRPr lang="en-US" sz="1900" dirty="0"/>
-          </a:p>
-        </p:txBody>
-      </p:sp>
-      <p:sp>
-        <p:nvSpPr>
-          <p:cNvPr id="22" name="Shape 18"/>
-          <p:cNvSpPr/>
-          <p:nvPr/>
-        </p:nvSpPr>
-        <p:spPr>
-          <a:xfrm>
-            <a:off x="8449056" y="2304288"/>
-            <a:ext cx="2807208" cy="987552"/>
+              <a:t>Python · MLX</a:t>
+            </a:r>
+            <a:endParaRPr lang="en-US" sz="1800" dirty="0"/>
+          </a:p>
+        </p:txBody>
+      </p:sp>
+      <p:sp>
+        <p:nvSpPr>
+          <p:cNvPr id="28" name="Shape 24"/>
+          <p:cNvSpPr/>
+          <p:nvPr/>
+        </p:nvSpPr>
+        <p:spPr>
+          <a:xfrm>
+            <a:off x="9354312" y="4069080"/>
+            <a:ext cx="2249424" cy="1783080"/>
           </a:xfrm>
           <a:prstGeom prst="roundRect">
             <a:avLst>
-              <a:gd name="adj" fmla="val 18519"/>
+              <a:gd name="adj" fmla="val 10256"/>
             </a:avLst>
           </a:prstGeom>
           <a:solidFill>
@@ -3941,184 +4231,9 @@
           </a:ln>
         </p:spPr>
       </p:sp>
-      <p:sp>
-        <p:nvSpPr>
-          <p:cNvPr id="23" name="Text 19"/>
-          <p:cNvSpPr/>
-          <p:nvPr/>
-        </p:nvSpPr>
-        <p:spPr>
-          <a:xfrm>
-            <a:off x="8677656" y="2624328"/>
-            <a:ext cx="2359152" cy="356616"/>
-          </a:xfrm>
-          <a:prstGeom prst="rect">
-            <a:avLst/>
-          </a:prstGeom>
-          <a:noFill/>
-          <a:ln/>
-        </p:spPr>
-        <p:txBody>
-          <a:bodyPr wrap="square" lIns="0" tIns="0" rIns="0" bIns="0" rtlCol="0" anchor="ctr"/>
-          <a:lstStyle/>
-          <a:p>
-            <a:pPr indent="0" marL="0">
-              <a:buNone/>
-            </a:pPr>
-            <a:r>
-              <a:rPr lang="en-US" sz="2500" b="1" dirty="0">
-                <a:solidFill>
-                  <a:srgbClr val="405394"/>
-                </a:solidFill>
-                <a:latin typeface="Apple SD Gothic Neo" pitchFamily="34" charset="0"/>
-                <a:ea typeface="Apple SD Gothic Neo" pitchFamily="34" charset="-122"/>
-                <a:cs typeface="Apple SD Gothic Neo" pitchFamily="34" charset="-120"/>
-              </a:rPr>
-              <a:t>Ollama API</a:t>
-            </a:r>
-            <a:endParaRPr lang="en-US" sz="2500" dirty="0"/>
-          </a:p>
-        </p:txBody>
-      </p:sp>
-      <p:sp>
-        <p:nvSpPr>
-          <p:cNvPr id="24" name="Shape 20"/>
-          <p:cNvSpPr/>
-          <p:nvPr/>
-        </p:nvSpPr>
-        <p:spPr>
-          <a:xfrm>
-            <a:off x="8449056" y="3630168"/>
-            <a:ext cx="2807208" cy="987552"/>
-          </a:xfrm>
-          <a:prstGeom prst="roundRect">
-            <a:avLst>
-              <a:gd name="adj" fmla="val 18519"/>
-            </a:avLst>
-          </a:prstGeom>
-          <a:solidFill>
-            <a:srgbClr val="FFFFFF"/>
-          </a:solidFill>
-          <a:ln w="12700">
-            <a:solidFill>
-              <a:srgbClr val="FFFFFF">
-                <a:alpha val="0"/>
-              </a:srgbClr>
-            </a:solidFill>
-            <a:prstDash val="solid"/>
-          </a:ln>
-        </p:spPr>
-      </p:sp>
-      <p:sp>
-        <p:nvSpPr>
-          <p:cNvPr id="25" name="Text 21"/>
-          <p:cNvSpPr/>
-          <p:nvPr/>
-        </p:nvSpPr>
-        <p:spPr>
-          <a:xfrm>
-            <a:off x="8677656" y="3785616"/>
-            <a:ext cx="2359152" cy="274320"/>
-          </a:xfrm>
-          <a:prstGeom prst="rect">
-            <a:avLst/>
-          </a:prstGeom>
-          <a:noFill/>
-          <a:ln/>
-        </p:spPr>
-        <p:txBody>
-          <a:bodyPr wrap="square" lIns="0" tIns="0" rIns="0" bIns="0" rtlCol="0" anchor="ctr"/>
-          <a:lstStyle/>
-          <a:p>
-            <a:pPr indent="0" marL="0">
-              <a:buNone/>
-            </a:pPr>
-            <a:r>
-              <a:rPr lang="en-US" sz="2000" b="1" dirty="0">
-                <a:solidFill>
-                  <a:srgbClr val="405394"/>
-                </a:solidFill>
-                <a:latin typeface="Apple SD Gothic Neo" pitchFamily="34" charset="0"/>
-                <a:ea typeface="Apple SD Gothic Neo" pitchFamily="34" charset="-122"/>
-                <a:cs typeface="Apple SD Gothic Neo" pitchFamily="34" charset="-120"/>
-              </a:rPr>
-              <a:t>NeMo-Speech.cpp</a:t>
-            </a:r>
-            <a:endParaRPr lang="en-US" sz="2000" dirty="0"/>
-          </a:p>
-        </p:txBody>
-      </p:sp>
-      <p:sp>
-        <p:nvSpPr>
-          <p:cNvPr id="26" name="Text 22"/>
-          <p:cNvSpPr/>
-          <p:nvPr/>
-        </p:nvSpPr>
-        <p:spPr>
-          <a:xfrm>
-            <a:off x="8677656" y="4178808"/>
-            <a:ext cx="2359152" cy="265176"/>
-          </a:xfrm>
-          <a:prstGeom prst="rect">
-            <a:avLst/>
-          </a:prstGeom>
-          <a:noFill/>
-          <a:ln/>
-        </p:spPr>
-        <p:txBody>
-          <a:bodyPr wrap="square" lIns="0" tIns="0" rIns="0" bIns="0" rtlCol="0" anchor="ctr"/>
-          <a:lstStyle/>
-          <a:p>
-            <a:pPr indent="0" marL="0">
-              <a:buNone/>
-            </a:pPr>
-            <a:r>
-              <a:rPr lang="en-US" sz="2000" dirty="0">
-                <a:solidFill>
-                  <a:srgbClr val="242938"/>
-                </a:solidFill>
-                <a:latin typeface="Apple SD Gothic Neo" pitchFamily="34" charset="0"/>
-                <a:ea typeface="Apple SD Gothic Neo" pitchFamily="34" charset="-122"/>
-                <a:cs typeface="Apple SD Gothic Neo" pitchFamily="34" charset="-120"/>
-              </a:rPr>
-              <a:t>Python · MLX</a:t>
-            </a:r>
-            <a:endParaRPr lang="en-US" sz="2000" dirty="0"/>
-          </a:p>
-        </p:txBody>
-      </p:sp>
-      <p:sp>
-        <p:nvSpPr>
-          <p:cNvPr id="27" name="Shape 23"/>
-          <p:cNvSpPr/>
-          <p:nvPr/>
-        </p:nvSpPr>
-        <p:spPr>
-          <a:xfrm>
-            <a:off x="8449056" y="4956048"/>
-            <a:ext cx="2807208" cy="996696"/>
-          </a:xfrm>
-          <a:prstGeom prst="roundRect">
-            <a:avLst>
-              <a:gd name="adj" fmla="val 18349"/>
-            </a:avLst>
-          </a:prstGeom>
-          <a:solidFill>
-            <a:srgbClr val="FFFFFF"/>
-          </a:solidFill>
-          <a:ln w="12700">
-            <a:solidFill>
-              <a:srgbClr val="FFFFFF">
-                <a:alpha val="0"/>
-              </a:srgbClr>
-            </a:solidFill>
-            <a:prstDash val="solid"/>
-          </a:ln>
-        </p:spPr>
-      </p:sp>
       <p:pic>
         <p:nvPicPr>
-          <p:cNvPr id="28" name="Image 1" descr="postgresql">    </p:cNvPr>
+          <p:cNvPr id="29" name="Image 1" descr="postgresql">    </p:cNvPr>
           <p:cNvPicPr>
             <a:picLocks noChangeAspect="1"/>
           </p:cNvPicPr>
@@ -4132,8 +4247,8 @@
         </p:blipFill>
         <p:spPr>
           <a:xfrm>
-            <a:off x="8642402" y="5111496"/>
-            <a:ext cx="664869" cy="685800"/>
+            <a:off x="9991453" y="4334256"/>
+            <a:ext cx="975141" cy="1005840"/>
           </a:xfrm>
           <a:prstGeom prst="rect">
             <a:avLst/>
@@ -4142,32 +4257,32 @@
       </p:pic>
       <p:sp>
         <p:nvSpPr>
-          <p:cNvPr id="29" name="Text 24"/>
-          <p:cNvSpPr/>
-          <p:nvPr/>
-        </p:nvSpPr>
-        <p:spPr>
-          <a:xfrm>
-            <a:off x="9500616" y="5276088"/>
-            <a:ext cx="1572768" cy="338328"/>
-          </a:xfrm>
-          <a:prstGeom prst="rect">
-            <a:avLst/>
-          </a:prstGeom>
-          <a:noFill/>
-          <a:ln/>
-        </p:spPr>
-        <p:txBody>
-          <a:bodyPr wrap="square" lIns="0" tIns="0" rIns="0" bIns="0" rtlCol="0" anchor="ctr"/>
-          <a:lstStyle/>
-          <a:p>
-            <a:pPr indent="0" marL="0">
-              <a:buNone/>
-            </a:pPr>
-            <a:r>
-              <a:rPr lang="en-US" sz="2100" b="1" dirty="0">
-                <a:solidFill>
-                  <a:srgbClr val="242938"/>
+          <p:cNvPr id="30" name="Text 25"/>
+          <p:cNvSpPr/>
+          <p:nvPr/>
+        </p:nvSpPr>
+        <p:spPr>
+          <a:xfrm>
+            <a:off x="9546336" y="5422392"/>
+            <a:ext cx="1865376" cy="320040"/>
+          </a:xfrm>
+          <a:prstGeom prst="rect">
+            <a:avLst/>
+          </a:prstGeom>
+          <a:noFill/>
+          <a:ln/>
+        </p:spPr>
+        <p:txBody>
+          <a:bodyPr wrap="square" lIns="0" tIns="0" rIns="0" bIns="0" rtlCol="0" anchor="ctr"/>
+          <a:lstStyle/>
+          <a:p>
+            <a:pPr algn="ctr" indent="0" marL="0">
+              <a:buNone/>
+            </a:pPr>
+            <a:r>
+              <a:rPr lang="en-US" sz="2300" b="1" dirty="0">
+                <a:solidFill>
+                  <a:srgbClr val="405394"/>
                 </a:solidFill>
                 <a:latin typeface="Apple SD Gothic Neo" pitchFamily="34" charset="0"/>
                 <a:ea typeface="Apple SD Gothic Neo" pitchFamily="34" charset="-122"/>
@@ -4175,20 +4290,20 @@
               </a:rPr>
               <a:t>PostgreSQL</a:t>
             </a:r>
-            <a:endParaRPr lang="en-US" sz="2100" dirty="0"/>
-          </a:p>
-        </p:txBody>
-      </p:sp>
-      <p:sp>
-        <p:nvSpPr>
-          <p:cNvPr id="30" name="Shape 25"/>
-          <p:cNvSpPr/>
-          <p:nvPr/>
-        </p:nvSpPr>
-        <p:spPr>
-          <a:xfrm>
-            <a:off x="2459736" y="3694176"/>
-            <a:ext cx="832104" cy="0"/>
+            <a:endParaRPr lang="en-US" sz="2300" dirty="0"/>
+          </a:p>
+        </p:txBody>
+      </p:sp>
+      <p:sp>
+        <p:nvSpPr>
+          <p:cNvPr id="31" name="Shape 26"/>
+          <p:cNvSpPr/>
+          <p:nvPr/>
+        </p:nvSpPr>
+        <p:spPr>
+          <a:xfrm>
+            <a:off x="2862072" y="2724912"/>
+            <a:ext cx="429768" cy="0"/>
           </a:xfrm>
           <a:prstGeom prst="line">
             <a:avLst/>
@@ -4206,53 +4321,14 @@
       </p:sp>
       <p:sp>
         <p:nvSpPr>
-          <p:cNvPr id="31" name="Text 26"/>
-          <p:cNvSpPr/>
-          <p:nvPr/>
-        </p:nvSpPr>
-        <p:spPr>
-          <a:xfrm>
-            <a:off x="2468880" y="3310128"/>
-            <a:ext cx="813816" cy="228600"/>
-          </a:xfrm>
-          <a:prstGeom prst="rect">
-            <a:avLst/>
-          </a:prstGeom>
-          <a:noFill/>
-          <a:ln/>
-        </p:spPr>
-        <p:txBody>
-          <a:bodyPr wrap="square" lIns="0" tIns="0" rIns="0" bIns="0" rtlCol="0" anchor="ctr"/>
-          <a:lstStyle/>
-          <a:p>
-            <a:pPr indent="0" marL="0">
-              <a:buNone/>
-            </a:pPr>
-            <a:r>
-              <a:rPr lang="en-US" sz="1300" dirty="0">
-                <a:solidFill>
-                  <a:srgbClr val="405394"/>
-                </a:solidFill>
-                <a:latin typeface="Apple SD Gothic Neo" pitchFamily="34" charset="0"/>
-                <a:ea typeface="Apple SD Gothic Neo" pitchFamily="34" charset="-122"/>
-                <a:cs typeface="Apple SD Gothic Neo" pitchFamily="34" charset="-120"/>
-              </a:rPr>
-              <a:t>HTTPS</a:t>
-            </a:r>
-            <a:endParaRPr lang="en-US" sz="1300" dirty="0"/>
-          </a:p>
-        </p:txBody>
-      </p:sp>
-      <p:sp>
-        <p:nvSpPr>
           <p:cNvPr id="32" name="Shape 27"/>
           <p:cNvSpPr/>
           <p:nvPr/>
         </p:nvSpPr>
         <p:spPr>
           <a:xfrm>
-            <a:off x="7141464" y="2798064"/>
-            <a:ext cx="1261872" cy="0"/>
+            <a:off x="5724144" y="2724912"/>
+            <a:ext cx="566928" cy="0"/>
           </a:xfrm>
           <a:prstGeom prst="line">
             <a:avLst/>
@@ -4270,53 +4346,14 @@
       </p:sp>
       <p:sp>
         <p:nvSpPr>
-          <p:cNvPr id="33" name="Text 28"/>
-          <p:cNvSpPr/>
-          <p:nvPr/>
-        </p:nvSpPr>
-        <p:spPr>
-          <a:xfrm>
-            <a:off x="7196328" y="2441448"/>
-            <a:ext cx="1143000" cy="228600"/>
-          </a:xfrm>
-          <a:prstGeom prst="rect">
-            <a:avLst/>
-          </a:prstGeom>
-          <a:noFill/>
-          <a:ln/>
-        </p:spPr>
-        <p:txBody>
-          <a:bodyPr wrap="square" lIns="0" tIns="0" rIns="0" bIns="0" rtlCol="0" anchor="ctr"/>
-          <a:lstStyle/>
-          <a:p>
-            <a:pPr indent="0" marL="0">
-              <a:buNone/>
-            </a:pPr>
-            <a:r>
-              <a:rPr lang="en-US" sz="1200" dirty="0">
-                <a:solidFill>
-                  <a:srgbClr val="405394"/>
-                </a:solidFill>
-                <a:latin typeface="Apple SD Gothic Neo" pitchFamily="34" charset="0"/>
-                <a:ea typeface="Apple SD Gothic Neo" pitchFamily="34" charset="-122"/>
-                <a:cs typeface="Apple SD Gothic Neo" pitchFamily="34" charset="-120"/>
-              </a:rPr>
-              <a:t>텍스트 · 결과</a:t>
-            </a:r>
-            <a:endParaRPr lang="en-US" sz="1200" dirty="0"/>
-          </a:p>
-        </p:txBody>
-      </p:sp>
-      <p:sp>
-        <p:nvSpPr>
-          <p:cNvPr id="34" name="Shape 29"/>
-          <p:cNvSpPr/>
-          <p:nvPr/>
-        </p:nvSpPr>
-        <p:spPr>
-          <a:xfrm>
-            <a:off x="7141464" y="4123944"/>
-            <a:ext cx="1261872" cy="0"/>
+          <p:cNvPr id="33" name="Shape 28"/>
+          <p:cNvSpPr/>
+          <p:nvPr/>
+        </p:nvSpPr>
+        <p:spPr>
+          <a:xfrm>
+            <a:off x="8778240" y="2724912"/>
+            <a:ext cx="548640" cy="0"/>
           </a:xfrm>
           <a:prstGeom prst="line">
             <a:avLst/>
@@ -4334,53 +4371,14 @@
       </p:sp>
       <p:sp>
         <p:nvSpPr>
-          <p:cNvPr id="35" name="Text 30"/>
-          <p:cNvSpPr/>
-          <p:nvPr/>
-        </p:nvSpPr>
-        <p:spPr>
-          <a:xfrm>
-            <a:off x="7196328" y="3767328"/>
-            <a:ext cx="1143000" cy="228600"/>
-          </a:xfrm>
-          <a:prstGeom prst="rect">
-            <a:avLst/>
-          </a:prstGeom>
-          <a:noFill/>
-          <a:ln/>
-        </p:spPr>
-        <p:txBody>
-          <a:bodyPr wrap="square" lIns="0" tIns="0" rIns="0" bIns="0" rtlCol="0" anchor="ctr"/>
-          <a:lstStyle/>
-          <a:p>
-            <a:pPr indent="0" marL="0">
-              <a:buNone/>
-            </a:pPr>
-            <a:r>
-              <a:rPr lang="en-US" sz="1200" dirty="0">
-                <a:solidFill>
-                  <a:srgbClr val="405394"/>
-                </a:solidFill>
-                <a:latin typeface="Apple SD Gothic Neo" pitchFamily="34" charset="0"/>
-                <a:ea typeface="Apple SD Gothic Neo" pitchFamily="34" charset="-122"/>
-                <a:cs typeface="Apple SD Gothic Neo" pitchFamily="34" charset="-120"/>
-              </a:rPr>
-              <a:t>음성 · 텍스트</a:t>
-            </a:r>
-            <a:endParaRPr lang="en-US" sz="1200" dirty="0"/>
-          </a:p>
-        </p:txBody>
-      </p:sp>
-      <p:sp>
-        <p:nvSpPr>
-          <p:cNvPr id="36" name="Shape 31"/>
-          <p:cNvSpPr/>
-          <p:nvPr/>
-        </p:nvSpPr>
-        <p:spPr>
-          <a:xfrm>
-            <a:off x="7141464" y="5449824"/>
-            <a:ext cx="1261872" cy="0"/>
+          <p:cNvPr id="34" name="Shape 29"/>
+          <p:cNvSpPr/>
+          <p:nvPr/>
+        </p:nvSpPr>
+        <p:spPr>
+          <a:xfrm>
+            <a:off x="2862072" y="4965192"/>
+            <a:ext cx="429768" cy="0"/>
           </a:xfrm>
           <a:prstGeom prst="line">
             <a:avLst/>
@@ -4398,42 +4396,53 @@
       </p:sp>
       <p:sp>
         <p:nvSpPr>
-          <p:cNvPr id="37" name="Text 32"/>
-          <p:cNvSpPr/>
-          <p:nvPr/>
-        </p:nvSpPr>
-        <p:spPr>
-          <a:xfrm>
-            <a:off x="7196328" y="5093208"/>
-            <a:ext cx="1143000" cy="228600"/>
-          </a:xfrm>
-          <a:prstGeom prst="rect">
-            <a:avLst/>
-          </a:prstGeom>
-          <a:noFill/>
-          <a:ln/>
-        </p:spPr>
-        <p:txBody>
-          <a:bodyPr wrap="square" lIns="0" tIns="0" rIns="0" bIns="0" rtlCol="0" anchor="ctr"/>
-          <a:lstStyle/>
-          <a:p>
-            <a:pPr indent="0" marL="0">
-              <a:buNone/>
-            </a:pPr>
-            <a:r>
-              <a:rPr lang="en-US" sz="1200" dirty="0">
-                <a:solidFill>
-                  <a:srgbClr val="405394"/>
-                </a:solidFill>
-                <a:latin typeface="Apple SD Gothic Neo" pitchFamily="34" charset="0"/>
-                <a:ea typeface="Apple SD Gothic Neo" pitchFamily="34" charset="-122"/>
-                <a:cs typeface="Apple SD Gothic Neo" pitchFamily="34" charset="-120"/>
-              </a:rPr>
-              <a:t>계정 · 기록</a:t>
-            </a:r>
-            <a:endParaRPr lang="en-US" sz="1200" dirty="0"/>
-          </a:p>
-        </p:txBody>
+          <p:cNvPr id="35" name="Shape 30"/>
+          <p:cNvSpPr/>
+          <p:nvPr/>
+        </p:nvSpPr>
+        <p:spPr>
+          <a:xfrm>
+            <a:off x="5724144" y="4965192"/>
+            <a:ext cx="566928" cy="0"/>
+          </a:xfrm>
+          <a:prstGeom prst="line">
+            <a:avLst/>
+          </a:prstGeom>
+          <a:noFill/>
+          <a:ln w="20320">
+            <a:solidFill>
+              <a:srgbClr val="405394"/>
+            </a:solidFill>
+            <a:prstDash val="solid"/>
+            <a:headEnd type="triangle"/>
+            <a:tailEnd type="triangle"/>
+          </a:ln>
+        </p:spPr>
+      </p:sp>
+      <p:sp>
+        <p:nvSpPr>
+          <p:cNvPr id="36" name="Shape 31"/>
+          <p:cNvSpPr/>
+          <p:nvPr/>
+        </p:nvSpPr>
+        <p:spPr>
+          <a:xfrm>
+            <a:off x="8778240" y="4965192"/>
+            <a:ext cx="548640" cy="0"/>
+          </a:xfrm>
+          <a:prstGeom prst="line">
+            <a:avLst/>
+          </a:prstGeom>
+          <a:noFill/>
+          <a:ln w="20320">
+            <a:solidFill>
+              <a:srgbClr val="405394"/>
+            </a:solidFill>
+            <a:prstDash val="solid"/>
+            <a:headEnd type="triangle"/>
+            <a:tailEnd type="triangle"/>
+          </a:ln>
+        </p:spPr>
       </p:sp>
     </p:spTree>
   </p:cSld>

</xml_diff>

<commit_message>
docs: show AI and data services within server architecture
</commit_message>
<xml_diff>
--- a/presentation/SpeechBridge.pptx
+++ b/presentation/SpeechBridge.pptx
@@ -948,7 +948,7 @@
           <a:p>
             <a:r>
               <a:rPr lang="en-US" dirty="0"/>
-              <a:t>모바일 앱 · HTTP API · SpeechBridge MacBook 서버(Node.js) · 로컬 AI · PostgreSQL.</a:t>
+              <a:t>모바일 앱 ↔ 서버의 Node.js HTTP API ↔ 서버 내부 AI 처리·PostgreSQL.</a:t>
             </a:r>
             <a:endParaRPr lang="en-US" dirty="0"/>
           </a:p>
@@ -3369,12 +3369,80 @@
         </p:nvSpPr>
         <p:spPr>
           <a:xfrm>
-            <a:off x="594360" y="1828800"/>
-            <a:ext cx="2240280" cy="1783080"/>
+            <a:off x="3090672" y="1536192"/>
+            <a:ext cx="8503920" cy="4608576"/>
           </a:xfrm>
           <a:prstGeom prst="roundRect">
             <a:avLst>
-              <a:gd name="adj" fmla="val 10256"/>
+              <a:gd name="adj" fmla="val 3968"/>
+            </a:avLst>
+          </a:prstGeom>
+          <a:solidFill>
+            <a:srgbClr val="DFE5FF"/>
+          </a:solidFill>
+          <a:ln w="12700">
+            <a:solidFill>
+              <a:srgbClr val="DFE5FF">
+                <a:alpha val="0"/>
+              </a:srgbClr>
+            </a:solidFill>
+            <a:prstDash val="solid"/>
+          </a:ln>
+        </p:spPr>
+      </p:sp>
+      <p:sp>
+        <p:nvSpPr>
+          <p:cNvPr id="7" name="Text 4"/>
+          <p:cNvSpPr/>
+          <p:nvPr/>
+        </p:nvSpPr>
+        <p:spPr>
+          <a:xfrm>
+            <a:off x="3429000" y="1792224"/>
+            <a:ext cx="7680960" cy="393192"/>
+          </a:xfrm>
+          <a:prstGeom prst="rect">
+            <a:avLst/>
+          </a:prstGeom>
+          <a:noFill/>
+          <a:ln/>
+        </p:spPr>
+        <p:txBody>
+          <a:bodyPr wrap="square" lIns="0" tIns="0" rIns="0" bIns="0" rtlCol="0" anchor="ctr"/>
+          <a:lstStyle/>
+          <a:p>
+            <a:pPr indent="0" marL="0">
+              <a:buNone/>
+            </a:pPr>
+            <a:r>
+              <a:rPr lang="en-US" sz="2800" b="1" dirty="0">
+                <a:solidFill>
+                  <a:srgbClr val="405394"/>
+                </a:solidFill>
+                <a:latin typeface="Apple SD Gothic Neo" pitchFamily="34" charset="0"/>
+                <a:ea typeface="Apple SD Gothic Neo" pitchFamily="34" charset="-122"/>
+                <a:cs typeface="Apple SD Gothic Neo" pitchFamily="34" charset="-120"/>
+              </a:rPr>
+              <a:t>SpeechBridge 서버</a:t>
+            </a:r>
+            <a:endParaRPr lang="en-US" sz="2800" dirty="0"/>
+          </a:p>
+        </p:txBody>
+      </p:sp>
+      <p:sp>
+        <p:nvSpPr>
+          <p:cNvPr id="8" name="Shape 5"/>
+          <p:cNvSpPr/>
+          <p:nvPr/>
+        </p:nvSpPr>
+        <p:spPr>
+          <a:xfrm>
+            <a:off x="594360" y="2359152"/>
+            <a:ext cx="1883664" cy="2770632"/>
+          </a:xfrm>
+          <a:prstGeom prst="roundRect">
+            <a:avLst>
+              <a:gd name="adj" fmla="val 9709"/>
             </a:avLst>
           </a:prstGeom>
           <a:solidFill>
@@ -3392,18 +3460,214 @@
       </p:sp>
       <p:sp>
         <p:nvSpPr>
-          <p:cNvPr id="7" name="Shape 4"/>
-          <p:cNvSpPr/>
-          <p:nvPr/>
-        </p:nvSpPr>
-        <p:spPr>
-          <a:xfrm>
-            <a:off x="594360" y="4069080"/>
-            <a:ext cx="2240280" cy="1783080"/>
+          <p:cNvPr id="9" name="Shape 6"/>
+          <p:cNvSpPr/>
+          <p:nvPr/>
+        </p:nvSpPr>
+        <p:spPr>
+          <a:xfrm>
+            <a:off x="1261872" y="2688336"/>
+            <a:ext cx="548640" cy="795528"/>
           </a:xfrm>
           <a:prstGeom prst="roundRect">
             <a:avLst>
-              <a:gd name="adj" fmla="val 10256"/>
+              <a:gd name="adj" fmla="val 11667"/>
+            </a:avLst>
+          </a:prstGeom>
+          <a:solidFill>
+            <a:srgbClr val="FFFFFF"/>
+          </a:solidFill>
+          <a:ln w="25400">
+            <a:solidFill>
+              <a:srgbClr val="405394"/>
+            </a:solidFill>
+            <a:prstDash val="solid"/>
+          </a:ln>
+        </p:spPr>
+      </p:sp>
+      <p:sp>
+        <p:nvSpPr>
+          <p:cNvPr id="10" name="Shape 7"/>
+          <p:cNvSpPr/>
+          <p:nvPr/>
+        </p:nvSpPr>
+        <p:spPr>
+          <a:xfrm>
+            <a:off x="1426464" y="3364992"/>
+            <a:ext cx="219456" cy="0"/>
+          </a:xfrm>
+          <a:prstGeom prst="line">
+            <a:avLst/>
+          </a:prstGeom>
+          <a:noFill/>
+          <a:ln w="25400">
+            <a:solidFill>
+              <a:srgbClr val="405394"/>
+            </a:solidFill>
+            <a:prstDash val="solid"/>
+          </a:ln>
+        </p:spPr>
+      </p:sp>
+      <p:sp>
+        <p:nvSpPr>
+          <p:cNvPr id="11" name="Text 8"/>
+          <p:cNvSpPr/>
+          <p:nvPr/>
+        </p:nvSpPr>
+        <p:spPr>
+          <a:xfrm>
+            <a:off x="758952" y="3675888"/>
+            <a:ext cx="1554480" cy="402336"/>
+          </a:xfrm>
+          <a:prstGeom prst="rect">
+            <a:avLst/>
+          </a:prstGeom>
+          <a:noFill/>
+          <a:ln/>
+        </p:spPr>
+        <p:txBody>
+          <a:bodyPr wrap="square" lIns="0" tIns="0" rIns="0" bIns="0" rtlCol="0" anchor="ctr"/>
+          <a:lstStyle/>
+          <a:p>
+            <a:pPr algn="ctr" indent="0" marL="0">
+              <a:buNone/>
+            </a:pPr>
+            <a:r>
+              <a:rPr lang="en-US" sz="2500" b="1" dirty="0">
+                <a:solidFill>
+                  <a:srgbClr val="405394"/>
+                </a:solidFill>
+                <a:latin typeface="Apple SD Gothic Neo" pitchFamily="34" charset="0"/>
+                <a:ea typeface="Apple SD Gothic Neo" pitchFamily="34" charset="-122"/>
+                <a:cs typeface="Apple SD Gothic Neo" pitchFamily="34" charset="-120"/>
+              </a:rPr>
+              <a:t>모바일 앱</a:t>
+            </a:r>
+            <a:endParaRPr lang="en-US" sz="2500" dirty="0"/>
+          </a:p>
+        </p:txBody>
+      </p:sp>
+      <p:sp>
+        <p:nvSpPr>
+          <p:cNvPr id="12" name="Text 9"/>
+          <p:cNvSpPr/>
+          <p:nvPr/>
+        </p:nvSpPr>
+        <p:spPr>
+          <a:xfrm>
+            <a:off x="758952" y="4261104"/>
+            <a:ext cx="1554480" cy="283464"/>
+          </a:xfrm>
+          <a:prstGeom prst="rect">
+            <a:avLst/>
+          </a:prstGeom>
+          <a:noFill/>
+          <a:ln/>
+        </p:spPr>
+        <p:txBody>
+          <a:bodyPr wrap="square" lIns="0" tIns="0" rIns="0" bIns="0" rtlCol="0" anchor="ctr"/>
+          <a:lstStyle/>
+          <a:p>
+            <a:pPr algn="ctr" indent="0" marL="0">
+              <a:buNone/>
+            </a:pPr>
+            <a:r>
+              <a:rPr lang="en-US" sz="1800" dirty="0">
+                <a:solidFill>
+                  <a:srgbClr val="242938"/>
+                </a:solidFill>
+                <a:latin typeface="Apple SD Gothic Neo" pitchFamily="34" charset="0"/>
+                <a:ea typeface="Apple SD Gothic Neo" pitchFamily="34" charset="-122"/>
+                <a:cs typeface="Apple SD Gothic Neo" pitchFamily="34" charset="-120"/>
+              </a:rPr>
+              <a:t>음성 · 텍스트</a:t>
+            </a:r>
+            <a:endParaRPr lang="en-US" sz="1800" dirty="0"/>
+          </a:p>
+        </p:txBody>
+      </p:sp>
+      <p:sp>
+        <p:nvSpPr>
+          <p:cNvPr id="13" name="Text 10"/>
+          <p:cNvSpPr/>
+          <p:nvPr/>
+        </p:nvSpPr>
+        <p:spPr>
+          <a:xfrm>
+            <a:off x="731520" y="4681728"/>
+            <a:ext cx="1609344" cy="228600"/>
+          </a:xfrm>
+          <a:prstGeom prst="rect">
+            <a:avLst/>
+          </a:prstGeom>
+          <a:noFill/>
+          <a:ln/>
+        </p:spPr>
+        <p:txBody>
+          <a:bodyPr wrap="square" lIns="0" tIns="0" rIns="0" bIns="0" rtlCol="0" anchor="ctr"/>
+          <a:lstStyle/>
+          <a:p>
+            <a:pPr algn="ctr" indent="0" marL="0">
+              <a:buNone/>
+            </a:pPr>
+            <a:r>
+              <a:rPr lang="en-US" sz="1500" dirty="0">
+                <a:solidFill>
+                  <a:srgbClr val="626B80"/>
+                </a:solidFill>
+                <a:latin typeface="Apple SD Gothic Neo" pitchFamily="34" charset="0"/>
+                <a:ea typeface="Apple SD Gothic Neo" pitchFamily="34" charset="-122"/>
+                <a:cs typeface="Apple SD Gothic Neo" pitchFamily="34" charset="-120"/>
+              </a:rPr>
+              <a:t>번역 · 기록 · 할 일</a:t>
+            </a:r>
+            <a:endParaRPr lang="en-US" sz="1500" dirty="0"/>
+          </a:p>
+        </p:txBody>
+      </p:sp>
+      <p:sp>
+        <p:nvSpPr>
+          <p:cNvPr id="14" name="Shape 11"/>
+          <p:cNvSpPr/>
+          <p:nvPr/>
+        </p:nvSpPr>
+        <p:spPr>
+          <a:xfrm>
+            <a:off x="3447288" y="2459736"/>
+            <a:ext cx="7781544" cy="1289304"/>
+          </a:xfrm>
+          <a:prstGeom prst="roundRect">
+            <a:avLst>
+              <a:gd name="adj" fmla="val 14184"/>
+            </a:avLst>
+          </a:prstGeom>
+          <a:solidFill>
+            <a:srgbClr val="405394"/>
+          </a:solidFill>
+          <a:ln w="12700">
+            <a:solidFill>
+              <a:srgbClr val="405394">
+                <a:alpha val="0"/>
+              </a:srgbClr>
+            </a:solidFill>
+            <a:prstDash val="solid"/>
+          </a:ln>
+        </p:spPr>
+      </p:sp>
+      <p:sp>
+        <p:nvSpPr>
+          <p:cNvPr id="15" name="Shape 12"/>
+          <p:cNvSpPr/>
+          <p:nvPr/>
+        </p:nvSpPr>
+        <p:spPr>
+          <a:xfrm>
+            <a:off x="3685032" y="2633472"/>
+            <a:ext cx="1536192" cy="502920"/>
+          </a:xfrm>
+          <a:prstGeom prst="roundRect">
+            <a:avLst>
+              <a:gd name="adj" fmla="val 36364"/>
             </a:avLst>
           </a:prstGeom>
           <a:solidFill>
@@ -3419,16 +3683,40 @@
           </a:ln>
         </p:spPr>
       </p:sp>
-      <p:sp>
-        <p:nvSpPr>
-          <p:cNvPr id="8" name="Text 5"/>
-          <p:cNvSpPr/>
-          <p:nvPr/>
-        </p:nvSpPr>
-        <p:spPr>
-          <a:xfrm>
-            <a:off x="804672" y="2267712"/>
-            <a:ext cx="1828800" cy="457200"/>
+      <p:pic>
+        <p:nvPicPr>
+          <p:cNvPr id="16" name="Image 0" descr="nodejs">    </p:cNvPr>
+          <p:cNvPicPr>
+            <a:picLocks noChangeAspect="1"/>
+          </p:cNvPicPr>
+          <p:nvPr/>
+        </p:nvPicPr>
+        <p:blipFill>
+          <a:blip r:embed="rId1"/>
+          <a:stretch>
+            <a:fillRect/>
+          </a:stretch>
+        </p:blipFill>
+        <p:spPr>
+          <a:xfrm>
+            <a:off x="3903005" y="2715768"/>
+            <a:ext cx="1100246" cy="329184"/>
+          </a:xfrm>
+          <a:prstGeom prst="rect">
+            <a:avLst/>
+          </a:prstGeom>
+        </p:spPr>
+      </p:pic>
+      <p:sp>
+        <p:nvSpPr>
+          <p:cNvPr id="17" name="Text 13"/>
+          <p:cNvSpPr/>
+          <p:nvPr/>
+        </p:nvSpPr>
+        <p:spPr>
+          <a:xfrm>
+            <a:off x="3657600" y="3264408"/>
+            <a:ext cx="1591056" cy="283464"/>
           </a:xfrm>
           <a:prstGeom prst="rect">
             <a:avLst/>
@@ -3444,7 +3732,149 @@
               <a:buNone/>
             </a:pPr>
             <a:r>
-              <a:rPr lang="en-US" sz="2800" b="1" dirty="0">
+              <a:rPr lang="en-US" sz="2200" b="1" dirty="0">
+                <a:solidFill>
+                  <a:srgbClr val="FFFFFF"/>
+                </a:solidFill>
+                <a:latin typeface="Apple SD Gothic Neo" pitchFamily="34" charset="0"/>
+                <a:ea typeface="Apple SD Gothic Neo" pitchFamily="34" charset="-122"/>
+                <a:cs typeface="Apple SD Gothic Neo" pitchFamily="34" charset="-120"/>
+              </a:rPr>
+              <a:t>HTTP API</a:t>
+            </a:r>
+            <a:endParaRPr lang="en-US" sz="2200" dirty="0"/>
+          </a:p>
+        </p:txBody>
+      </p:sp>
+      <p:sp>
+        <p:nvSpPr>
+          <p:cNvPr id="18" name="Text 14"/>
+          <p:cNvSpPr/>
+          <p:nvPr/>
+        </p:nvSpPr>
+        <p:spPr>
+          <a:xfrm>
+            <a:off x="5596128" y="2706624"/>
+            <a:ext cx="5303520" cy="365760"/>
+          </a:xfrm>
+          <a:prstGeom prst="rect">
+            <a:avLst/>
+          </a:prstGeom>
+          <a:noFill/>
+          <a:ln/>
+        </p:spPr>
+        <p:txBody>
+          <a:bodyPr wrap="square" lIns="0" tIns="0" rIns="0" bIns="0" rtlCol="0" anchor="ctr"/>
+          <a:lstStyle/>
+          <a:p>
+            <a:pPr indent="0" marL="0">
+              <a:buNone/>
+            </a:pPr>
+            <a:r>
+              <a:rPr lang="en-US" sz="2300" b="1" dirty="0">
+                <a:solidFill>
+                  <a:srgbClr val="FFFFFF"/>
+                </a:solidFill>
+                <a:latin typeface="Apple SD Gothic Neo" pitchFamily="34" charset="0"/>
+                <a:ea typeface="Apple SD Gothic Neo" pitchFamily="34" charset="-122"/>
+                <a:cs typeface="Apple SD Gothic Neo" pitchFamily="34" charset="-120"/>
+              </a:rPr>
+              <a:t>음성 인식 · 번역 · 음성 합성</a:t>
+            </a:r>
+            <a:endParaRPr lang="en-US" sz="2300" dirty="0"/>
+          </a:p>
+        </p:txBody>
+      </p:sp>
+      <p:sp>
+        <p:nvSpPr>
+          <p:cNvPr id="19" name="Text 15"/>
+          <p:cNvSpPr/>
+          <p:nvPr/>
+        </p:nvSpPr>
+        <p:spPr>
+          <a:xfrm>
+            <a:off x="5596128" y="3264408"/>
+            <a:ext cx="5303520" cy="274320"/>
+          </a:xfrm>
+          <a:prstGeom prst="rect">
+            <a:avLst/>
+          </a:prstGeom>
+          <a:noFill/>
+          <a:ln/>
+        </p:spPr>
+        <p:txBody>
+          <a:bodyPr wrap="square" lIns="0" tIns="0" rIns="0" bIns="0" rtlCol="0" anchor="ctr"/>
+          <a:lstStyle/>
+          <a:p>
+            <a:pPr indent="0" marL="0">
+              <a:buNone/>
+            </a:pPr>
+            <a:r>
+              <a:rPr lang="en-US" sz="2000" dirty="0">
+                <a:solidFill>
+                  <a:srgbClr val="FFFFFF"/>
+                </a:solidFill>
+                <a:latin typeface="Apple SD Gothic Neo" pitchFamily="34" charset="0"/>
+                <a:ea typeface="Apple SD Gothic Neo" pitchFamily="34" charset="-122"/>
+                <a:cs typeface="Apple SD Gothic Neo" pitchFamily="34" charset="-120"/>
+              </a:rPr>
+              <a:t>회원 인증 · 기록 동기화 · 할 일 추출</a:t>
+            </a:r>
+            <a:endParaRPr lang="en-US" sz="2000" dirty="0"/>
+          </a:p>
+        </p:txBody>
+      </p:sp>
+      <p:sp>
+        <p:nvSpPr>
+          <p:cNvPr id="20" name="Shape 16"/>
+          <p:cNvSpPr/>
+          <p:nvPr/>
+        </p:nvSpPr>
+        <p:spPr>
+          <a:xfrm>
+            <a:off x="2523744" y="3118104"/>
+            <a:ext cx="877824" cy="0"/>
+          </a:xfrm>
+          <a:prstGeom prst="line">
+            <a:avLst/>
+          </a:prstGeom>
+          <a:noFill/>
+          <a:ln w="20320">
+            <a:solidFill>
+              <a:srgbClr val="405394"/>
+            </a:solidFill>
+            <a:prstDash val="solid"/>
+            <a:headEnd type="triangle"/>
+            <a:tailEnd type="triangle"/>
+          </a:ln>
+        </p:spPr>
+      </p:sp>
+      <p:sp>
+        <p:nvSpPr>
+          <p:cNvPr id="21" name="Text 17"/>
+          <p:cNvSpPr/>
+          <p:nvPr/>
+        </p:nvSpPr>
+        <p:spPr>
+          <a:xfrm>
+            <a:off x="2532888" y="2761488"/>
+            <a:ext cx="859536" cy="210312"/>
+          </a:xfrm>
+          <a:prstGeom prst="rect">
+            <a:avLst/>
+          </a:prstGeom>
+          <a:noFill/>
+          <a:ln/>
+        </p:spPr>
+        <p:txBody>
+          <a:bodyPr wrap="square" lIns="0" tIns="0" rIns="0" bIns="0" rtlCol="0" anchor="ctr"/>
+          <a:lstStyle/>
+          <a:p>
+            <a:pPr algn="ctr" indent="0" marL="0">
+              <a:buNone/>
+            </a:pPr>
+            <a:r>
+              <a:rPr lang="en-US" sz="1200" dirty="0">
                 <a:solidFill>
                   <a:srgbClr val="405394"/>
                 </a:solidFill>
@@ -3452,22 +3882,22 @@
                 <a:ea typeface="Apple SD Gothic Neo" pitchFamily="34" charset="-122"/>
                 <a:cs typeface="Apple SD Gothic Neo" pitchFamily="34" charset="-120"/>
               </a:rPr>
-              <a:t>모바일 앱</a:t>
-            </a:r>
-            <a:endParaRPr lang="en-US" sz="2800" dirty="0"/>
-          </a:p>
-        </p:txBody>
-      </p:sp>
-      <p:sp>
-        <p:nvSpPr>
-          <p:cNvPr id="9" name="Text 6"/>
-          <p:cNvSpPr/>
-          <p:nvPr/>
-        </p:nvSpPr>
-        <p:spPr>
-          <a:xfrm>
-            <a:off x="804672" y="2889504"/>
-            <a:ext cx="1828800" cy="365760"/>
+              <a:t>HTTPS</a:t>
+            </a:r>
+            <a:endParaRPr lang="en-US" sz="1200" dirty="0"/>
+          </a:p>
+        </p:txBody>
+      </p:sp>
+      <p:sp>
+        <p:nvSpPr>
+          <p:cNvPr id="22" name="Text 18"/>
+          <p:cNvSpPr/>
+          <p:nvPr/>
+        </p:nvSpPr>
+        <p:spPr>
+          <a:xfrm>
+            <a:off x="2514600" y="3337560"/>
+            <a:ext cx="896112" cy="210312"/>
           </a:xfrm>
           <a:prstGeom prst="rect">
             <a:avLst/>
@@ -3483,9 +3913,73 @@
               <a:buNone/>
             </a:pPr>
             <a:r>
-              <a:rPr lang="en-US" sz="2300" dirty="0">
-                <a:solidFill>
-                  <a:srgbClr val="242938"/>
+              <a:rPr lang="en-US" sz="1100" dirty="0">
+                <a:solidFill>
+                  <a:srgbClr val="626B80"/>
+                </a:solidFill>
+                <a:latin typeface="Apple SD Gothic Neo" pitchFamily="34" charset="0"/>
+                <a:ea typeface="Apple SD Gothic Neo" pitchFamily="34" charset="-122"/>
+                <a:cs typeface="Apple SD Gothic Neo" pitchFamily="34" charset="-120"/>
+              </a:rPr>
+              <a:t>요청 · 응답</a:t>
+            </a:r>
+            <a:endParaRPr lang="en-US" sz="1100" dirty="0"/>
+          </a:p>
+        </p:txBody>
+      </p:sp>
+      <p:sp>
+        <p:nvSpPr>
+          <p:cNvPr id="23" name="Shape 19"/>
+          <p:cNvSpPr/>
+          <p:nvPr/>
+        </p:nvSpPr>
+        <p:spPr>
+          <a:xfrm>
+            <a:off x="4590288" y="3794760"/>
+            <a:ext cx="0" cy="749808"/>
+          </a:xfrm>
+          <a:prstGeom prst="line">
+            <a:avLst/>
+          </a:prstGeom>
+          <a:noFill/>
+          <a:ln w="20320">
+            <a:solidFill>
+              <a:srgbClr val="405394"/>
+            </a:solidFill>
+            <a:prstDash val="solid"/>
+            <a:headEnd type="triangle"/>
+            <a:tailEnd type="triangle"/>
+          </a:ln>
+        </p:spPr>
+      </p:sp>
+      <p:sp>
+        <p:nvSpPr>
+          <p:cNvPr id="24" name="Text 20"/>
+          <p:cNvSpPr/>
+          <p:nvPr/>
+        </p:nvSpPr>
+        <p:spPr>
+          <a:xfrm>
+            <a:off x="4727448" y="4105656"/>
+            <a:ext cx="1207008" cy="201168"/>
+          </a:xfrm>
+          <a:prstGeom prst="rect">
+            <a:avLst/>
+          </a:prstGeom>
+          <a:noFill/>
+          <a:ln/>
+        </p:spPr>
+        <p:txBody>
+          <a:bodyPr wrap="square" lIns="0" tIns="0" rIns="0" bIns="0" rtlCol="0" anchor="ctr"/>
+          <a:lstStyle/>
+          <a:p>
+            <a:pPr indent="0" marL="0">
+              <a:buNone/>
+            </a:pPr>
+            <a:r>
+              <a:rPr lang="en-US" sz="1100" dirty="0">
+                <a:solidFill>
+                  <a:srgbClr val="405394"/>
                 </a:solidFill>
                 <a:latin typeface="Apple SD Gothic Neo" pitchFamily="34" charset="0"/>
                 <a:ea typeface="Apple SD Gothic Neo" pitchFamily="34" charset="-122"/>
@@ -3493,496 +3987,24 @@
               </a:rPr>
               <a:t>음성 · 텍스트</a:t>
             </a:r>
-            <a:endParaRPr lang="en-US" sz="2300" dirty="0"/>
-          </a:p>
-        </p:txBody>
-      </p:sp>
-      <p:sp>
-        <p:nvSpPr>
-          <p:cNvPr id="10" name="Text 7"/>
-          <p:cNvSpPr/>
-          <p:nvPr/>
-        </p:nvSpPr>
-        <p:spPr>
-          <a:xfrm>
-            <a:off x="804672" y="4517136"/>
-            <a:ext cx="1828800" cy="457200"/>
-          </a:xfrm>
-          <a:prstGeom prst="rect">
-            <a:avLst/>
-          </a:prstGeom>
-          <a:noFill/>
-          <a:ln/>
-        </p:spPr>
-        <p:txBody>
-          <a:bodyPr wrap="square" lIns="0" tIns="0" rIns="0" bIns="0" rtlCol="0" anchor="ctr"/>
-          <a:lstStyle/>
-          <a:p>
-            <a:pPr algn="ctr" indent="0" marL="0">
-              <a:buNone/>
-            </a:pPr>
-            <a:r>
-              <a:rPr lang="en-US" sz="2800" b="1" dirty="0">
-                <a:solidFill>
-                  <a:srgbClr val="405394"/>
-                </a:solidFill>
-                <a:latin typeface="Apple SD Gothic Neo" pitchFamily="34" charset="0"/>
-                <a:ea typeface="Apple SD Gothic Neo" pitchFamily="34" charset="-122"/>
-                <a:cs typeface="Apple SD Gothic Neo" pitchFamily="34" charset="-120"/>
-              </a:rPr>
-              <a:t>기록 · 할 일</a:t>
-            </a:r>
-            <a:endParaRPr lang="en-US" sz="2800" dirty="0"/>
-          </a:p>
-        </p:txBody>
-      </p:sp>
-      <p:sp>
-        <p:nvSpPr>
-          <p:cNvPr id="11" name="Text 8"/>
-          <p:cNvSpPr/>
-          <p:nvPr/>
-        </p:nvSpPr>
-        <p:spPr>
-          <a:xfrm>
-            <a:off x="804672" y="5138928"/>
-            <a:ext cx="1828800" cy="365760"/>
-          </a:xfrm>
-          <a:prstGeom prst="rect">
-            <a:avLst/>
-          </a:prstGeom>
-          <a:noFill/>
-          <a:ln/>
-        </p:spPr>
-        <p:txBody>
-          <a:bodyPr wrap="square" lIns="0" tIns="0" rIns="0" bIns="0" rtlCol="0" anchor="ctr"/>
-          <a:lstStyle/>
-          <a:p>
-            <a:pPr algn="ctr" indent="0" marL="0">
-              <a:buNone/>
-            </a:pPr>
-            <a:r>
-              <a:rPr lang="en-US" sz="2300" dirty="0">
-                <a:solidFill>
-                  <a:srgbClr val="242938"/>
-                </a:solidFill>
-                <a:latin typeface="Apple SD Gothic Neo" pitchFamily="34" charset="0"/>
-                <a:ea typeface="Apple SD Gothic Neo" pitchFamily="34" charset="-122"/>
-                <a:cs typeface="Apple SD Gothic Neo" pitchFamily="34" charset="-120"/>
-              </a:rPr>
-              <a:t>조회 · 수정</a:t>
-            </a:r>
-            <a:endParaRPr lang="en-US" sz="2300" dirty="0"/>
-          </a:p>
-        </p:txBody>
-      </p:sp>
-      <p:sp>
-        <p:nvSpPr>
-          <p:cNvPr id="12" name="Shape 9"/>
-          <p:cNvSpPr/>
-          <p:nvPr/>
-        </p:nvSpPr>
-        <p:spPr>
-          <a:xfrm>
-            <a:off x="3319272" y="1828800"/>
-            <a:ext cx="2377440" cy="1783080"/>
+            <a:endParaRPr lang="en-US" sz="1100" dirty="0"/>
+          </a:p>
+        </p:txBody>
+      </p:sp>
+      <p:sp>
+        <p:nvSpPr>
+          <p:cNvPr id="25" name="Shape 21"/>
+          <p:cNvSpPr/>
+          <p:nvPr/>
+        </p:nvSpPr>
+        <p:spPr>
+          <a:xfrm>
+            <a:off x="3447288" y="4590288"/>
+            <a:ext cx="2276856" cy="1225296"/>
           </a:xfrm>
           <a:prstGeom prst="roundRect">
             <a:avLst>
-              <a:gd name="adj" fmla="val 10256"/>
-            </a:avLst>
-          </a:prstGeom>
-          <a:solidFill>
-            <a:srgbClr val="DFE5FF"/>
-          </a:solidFill>
-          <a:ln w="12700">
-            <a:solidFill>
-              <a:srgbClr val="DFE5FF">
-                <a:alpha val="0"/>
-              </a:srgbClr>
-            </a:solidFill>
-            <a:prstDash val="solid"/>
-          </a:ln>
-        </p:spPr>
-      </p:sp>
-      <p:sp>
-        <p:nvSpPr>
-          <p:cNvPr id="13" name="Shape 10"/>
-          <p:cNvSpPr/>
-          <p:nvPr/>
-        </p:nvSpPr>
-        <p:spPr>
-          <a:xfrm>
-            <a:off x="3319272" y="4069080"/>
-            <a:ext cx="2377440" cy="1783080"/>
-          </a:xfrm>
-          <a:prstGeom prst="roundRect">
-            <a:avLst>
-              <a:gd name="adj" fmla="val 10256"/>
-            </a:avLst>
-          </a:prstGeom>
-          <a:solidFill>
-            <a:srgbClr val="DFE5FF"/>
-          </a:solidFill>
-          <a:ln w="12700">
-            <a:solidFill>
-              <a:srgbClr val="DFE5FF">
-                <a:alpha val="0"/>
-              </a:srgbClr>
-            </a:solidFill>
-            <a:prstDash val="solid"/>
-          </a:ln>
-        </p:spPr>
-      </p:sp>
-      <p:sp>
-        <p:nvSpPr>
-          <p:cNvPr id="14" name="Text 11"/>
-          <p:cNvSpPr/>
-          <p:nvPr/>
-        </p:nvSpPr>
-        <p:spPr>
-          <a:xfrm>
-            <a:off x="3529584" y="2121408"/>
-            <a:ext cx="1956816" cy="438912"/>
-          </a:xfrm>
-          <a:prstGeom prst="rect">
-            <a:avLst/>
-          </a:prstGeom>
-          <a:noFill/>
-          <a:ln/>
-        </p:spPr>
-        <p:txBody>
-          <a:bodyPr wrap="square" lIns="0" tIns="0" rIns="0" bIns="0" rtlCol="0" anchor="ctr"/>
-          <a:lstStyle/>
-          <a:p>
-            <a:pPr algn="ctr" indent="0" marL="0">
-              <a:buNone/>
-            </a:pPr>
-            <a:r>
-              <a:rPr lang="en-US" sz="2800" b="1" dirty="0">
-                <a:solidFill>
-                  <a:srgbClr val="405394"/>
-                </a:solidFill>
-                <a:latin typeface="Apple SD Gothic Neo" pitchFamily="34" charset="0"/>
-                <a:ea typeface="Apple SD Gothic Neo" pitchFamily="34" charset="-122"/>
-                <a:cs typeface="Apple SD Gothic Neo" pitchFamily="34" charset="-120"/>
-              </a:rPr>
-              <a:t>HTTP API</a:t>
-            </a:r>
-            <a:endParaRPr lang="en-US" sz="2800" dirty="0"/>
-          </a:p>
-        </p:txBody>
-      </p:sp>
-      <p:sp>
-        <p:nvSpPr>
-          <p:cNvPr id="15" name="Text 12"/>
-          <p:cNvSpPr/>
-          <p:nvPr/>
-        </p:nvSpPr>
-        <p:spPr>
-          <a:xfrm>
-            <a:off x="3529584" y="2770632"/>
-            <a:ext cx="1956816" cy="603504"/>
-          </a:xfrm>
-          <a:prstGeom prst="rect">
-            <a:avLst/>
-          </a:prstGeom>
-          <a:noFill/>
-          <a:ln/>
-        </p:spPr>
-        <p:txBody>
-          <a:bodyPr wrap="square" lIns="0" tIns="0" rIns="0" bIns="0" rtlCol="0" anchor="ctr"/>
-          <a:lstStyle/>
-          <a:p>
-            <a:pPr algn="ctr" indent="0" marL="0">
-              <a:buNone/>
-            </a:pPr>
-            <a:r>
-              <a:rPr lang="en-US" sz="2100" dirty="0">
-                <a:solidFill>
-                  <a:srgbClr val="242938"/>
-                </a:solidFill>
-                <a:latin typeface="Apple SD Gothic Neo" pitchFamily="34" charset="0"/>
-                <a:ea typeface="Apple SD Gothic Neo" pitchFamily="34" charset="-122"/>
-                <a:cs typeface="Apple SD Gothic Neo" pitchFamily="34" charset="-120"/>
-              </a:rPr>
-              <a:t>음성 인식 · 번역</a:t>
-            </a:r>
-            <a:endParaRPr lang="en-US" sz="2100" dirty="0"/>
-          </a:p>
-          <a:p>
-            <a:pPr algn="ctr" indent="0" marL="0">
-              <a:buNone/>
-            </a:pPr>
-            <a:r>
-              <a:rPr lang="en-US" sz="2100" dirty="0">
-                <a:solidFill>
-                  <a:srgbClr val="242938"/>
-                </a:solidFill>
-                <a:latin typeface="Apple SD Gothic Neo" pitchFamily="34" charset="0"/>
-                <a:ea typeface="Apple SD Gothic Neo" pitchFamily="34" charset="-122"/>
-                <a:cs typeface="Apple SD Gothic Neo" pitchFamily="34" charset="-120"/>
-              </a:rPr>
-              <a:t>음성 합성</a:t>
-            </a:r>
-            <a:endParaRPr lang="en-US" sz="2100" dirty="0"/>
-          </a:p>
-        </p:txBody>
-      </p:sp>
-      <p:sp>
-        <p:nvSpPr>
-          <p:cNvPr id="16" name="Text 13"/>
-          <p:cNvSpPr/>
-          <p:nvPr/>
-        </p:nvSpPr>
-        <p:spPr>
-          <a:xfrm>
-            <a:off x="3529584" y="4361688"/>
-            <a:ext cx="1956816" cy="438912"/>
-          </a:xfrm>
-          <a:prstGeom prst="rect">
-            <a:avLst/>
-          </a:prstGeom>
-          <a:noFill/>
-          <a:ln/>
-        </p:spPr>
-        <p:txBody>
-          <a:bodyPr wrap="square" lIns="0" tIns="0" rIns="0" bIns="0" rtlCol="0" anchor="ctr"/>
-          <a:lstStyle/>
-          <a:p>
-            <a:pPr algn="ctr" indent="0" marL="0">
-              <a:buNone/>
-            </a:pPr>
-            <a:r>
-              <a:rPr lang="en-US" sz="2800" b="1" dirty="0">
-                <a:solidFill>
-                  <a:srgbClr val="405394"/>
-                </a:solidFill>
-                <a:latin typeface="Apple SD Gothic Neo" pitchFamily="34" charset="0"/>
-                <a:ea typeface="Apple SD Gothic Neo" pitchFamily="34" charset="-122"/>
-                <a:cs typeface="Apple SD Gothic Neo" pitchFamily="34" charset="-120"/>
-              </a:rPr>
-              <a:t>HTTP API</a:t>
-            </a:r>
-            <a:endParaRPr lang="en-US" sz="2800" dirty="0"/>
-          </a:p>
-        </p:txBody>
-      </p:sp>
-      <p:sp>
-        <p:nvSpPr>
-          <p:cNvPr id="17" name="Text 14"/>
-          <p:cNvSpPr/>
-          <p:nvPr/>
-        </p:nvSpPr>
-        <p:spPr>
-          <a:xfrm>
-            <a:off x="3529584" y="5010912"/>
-            <a:ext cx="1956816" cy="603504"/>
-          </a:xfrm>
-          <a:prstGeom prst="rect">
-            <a:avLst/>
-          </a:prstGeom>
-          <a:noFill/>
-          <a:ln/>
-        </p:spPr>
-        <p:txBody>
-          <a:bodyPr wrap="square" lIns="0" tIns="0" rIns="0" bIns="0" rtlCol="0" anchor="ctr"/>
-          <a:lstStyle/>
-          <a:p>
-            <a:pPr algn="ctr" indent="0" marL="0">
-              <a:buNone/>
-            </a:pPr>
-            <a:r>
-              <a:rPr lang="en-US" sz="2100" dirty="0">
-                <a:solidFill>
-                  <a:srgbClr val="242938"/>
-                </a:solidFill>
-                <a:latin typeface="Apple SD Gothic Neo" pitchFamily="34" charset="0"/>
-                <a:ea typeface="Apple SD Gothic Neo" pitchFamily="34" charset="-122"/>
-                <a:cs typeface="Apple SD Gothic Neo" pitchFamily="34" charset="-120"/>
-              </a:rPr>
-              <a:t>회원 인증 · 동기화</a:t>
-            </a:r>
-            <a:endParaRPr lang="en-US" sz="2100" dirty="0"/>
-          </a:p>
-          <a:p>
-            <a:pPr algn="ctr" indent="0" marL="0">
-              <a:buNone/>
-            </a:pPr>
-            <a:r>
-              <a:rPr lang="en-US" sz="2100" dirty="0">
-                <a:solidFill>
-                  <a:srgbClr val="242938"/>
-                </a:solidFill>
-                <a:latin typeface="Apple SD Gothic Neo" pitchFamily="34" charset="0"/>
-                <a:ea typeface="Apple SD Gothic Neo" pitchFamily="34" charset="-122"/>
-                <a:cs typeface="Apple SD Gothic Neo" pitchFamily="34" charset="-120"/>
-              </a:rPr>
-              <a:t>할 일 추출</a:t>
-            </a:r>
-            <a:endParaRPr lang="en-US" sz="2100" dirty="0"/>
-          </a:p>
-        </p:txBody>
-      </p:sp>
-      <p:sp>
-        <p:nvSpPr>
-          <p:cNvPr id="18" name="Shape 15"/>
-          <p:cNvSpPr/>
-          <p:nvPr/>
-        </p:nvSpPr>
-        <p:spPr>
-          <a:xfrm>
-            <a:off x="6318504" y="1828800"/>
-            <a:ext cx="2432304" cy="4023360"/>
-          </a:xfrm>
-          <a:prstGeom prst="roundRect">
-            <a:avLst>
-              <a:gd name="adj" fmla="val 7519"/>
-            </a:avLst>
-          </a:prstGeom>
-          <a:solidFill>
-            <a:srgbClr val="405394"/>
-          </a:solidFill>
-          <a:ln w="12700">
-            <a:solidFill>
-              <a:srgbClr val="405394">
-                <a:alpha val="0"/>
-              </a:srgbClr>
-            </a:solidFill>
-            <a:prstDash val="solid"/>
-          </a:ln>
-        </p:spPr>
-      </p:sp>
-      <p:sp>
-        <p:nvSpPr>
-          <p:cNvPr id="19" name="Text 16"/>
-          <p:cNvSpPr/>
-          <p:nvPr/>
-        </p:nvSpPr>
-        <p:spPr>
-          <a:xfrm>
-            <a:off x="6510528" y="2276856"/>
-            <a:ext cx="2048256" cy="438912"/>
-          </a:xfrm>
-          <a:prstGeom prst="rect">
-            <a:avLst/>
-          </a:prstGeom>
-          <a:noFill/>
-          <a:ln/>
-        </p:spPr>
-        <p:txBody>
-          <a:bodyPr wrap="square" lIns="0" tIns="0" rIns="0" bIns="0" rtlCol="0" anchor="ctr"/>
-          <a:lstStyle/>
-          <a:p>
-            <a:pPr algn="ctr" indent="0" marL="0">
-              <a:buNone/>
-            </a:pPr>
-            <a:r>
-              <a:rPr lang="en-US" sz="2200" b="1" dirty="0">
-                <a:solidFill>
-                  <a:srgbClr val="FFFFFF"/>
-                </a:solidFill>
-                <a:latin typeface="Apple SD Gothic Neo" pitchFamily="34" charset="0"/>
-                <a:ea typeface="Apple SD Gothic Neo" pitchFamily="34" charset="-122"/>
-                <a:cs typeface="Apple SD Gothic Neo" pitchFamily="34" charset="-120"/>
-              </a:rPr>
-              <a:t>SpeechBridge</a:t>
-            </a:r>
-            <a:endParaRPr lang="en-US" sz="2200" dirty="0"/>
-          </a:p>
-        </p:txBody>
-      </p:sp>
-      <p:sp>
-        <p:nvSpPr>
-          <p:cNvPr id="20" name="Text 17"/>
-          <p:cNvSpPr/>
-          <p:nvPr/>
-        </p:nvSpPr>
-        <p:spPr>
-          <a:xfrm>
-            <a:off x="6510528" y="2862072"/>
-            <a:ext cx="2048256" cy="539496"/>
-          </a:xfrm>
-          <a:prstGeom prst="rect">
-            <a:avLst/>
-          </a:prstGeom>
-          <a:noFill/>
-          <a:ln/>
-        </p:spPr>
-        <p:txBody>
-          <a:bodyPr wrap="square" lIns="0" tIns="0" rIns="0" bIns="0" rtlCol="0" anchor="ctr"/>
-          <a:lstStyle/>
-          <a:p>
-            <a:pPr algn="ctr" indent="0" marL="0">
-              <a:buNone/>
-            </a:pPr>
-            <a:r>
-              <a:rPr lang="en-US" sz="3600" b="1" dirty="0">
-                <a:solidFill>
-                  <a:srgbClr val="FFFFFF"/>
-                </a:solidFill>
-                <a:latin typeface="Apple SD Gothic Neo" pitchFamily="34" charset="0"/>
-                <a:ea typeface="Apple SD Gothic Neo" pitchFamily="34" charset="-122"/>
-                <a:cs typeface="Apple SD Gothic Neo" pitchFamily="34" charset="-120"/>
-              </a:rPr>
-              <a:t>서버</a:t>
-            </a:r>
-            <a:endParaRPr lang="en-US" sz="3600" dirty="0"/>
-          </a:p>
-        </p:txBody>
-      </p:sp>
-      <p:sp>
-        <p:nvSpPr>
-          <p:cNvPr id="21" name="Text 18"/>
-          <p:cNvSpPr/>
-          <p:nvPr/>
-        </p:nvSpPr>
-        <p:spPr>
-          <a:xfrm>
-            <a:off x="6510528" y="3712464"/>
-            <a:ext cx="2048256" cy="429768"/>
-          </a:xfrm>
-          <a:prstGeom prst="rect">
-            <a:avLst/>
-          </a:prstGeom>
-          <a:noFill/>
-          <a:ln/>
-        </p:spPr>
-        <p:txBody>
-          <a:bodyPr wrap="square" lIns="0" tIns="0" rIns="0" bIns="0" rtlCol="0" anchor="ctr"/>
-          <a:lstStyle/>
-          <a:p>
-            <a:pPr algn="ctr" indent="0" marL="0">
-              <a:buNone/>
-            </a:pPr>
-            <a:r>
-              <a:rPr lang="en-US" sz="2800" dirty="0">
-                <a:solidFill>
-                  <a:srgbClr val="FFFFFF"/>
-                </a:solidFill>
-                <a:latin typeface="Apple SD Gothic Neo" pitchFamily="34" charset="0"/>
-                <a:ea typeface="Apple SD Gothic Neo" pitchFamily="34" charset="-122"/>
-                <a:cs typeface="Apple SD Gothic Neo" pitchFamily="34" charset="-120"/>
-              </a:rPr>
-              <a:t>MacBook</a:t>
-            </a:r>
-            <a:endParaRPr lang="en-US" sz="2800" dirty="0"/>
-          </a:p>
-        </p:txBody>
-      </p:sp>
-      <p:sp>
-        <p:nvSpPr>
-          <p:cNvPr id="22" name="Shape 19"/>
-          <p:cNvSpPr/>
-          <p:nvPr/>
-        </p:nvSpPr>
-        <p:spPr>
-          <a:xfrm>
-            <a:off x="6556248" y="4553712"/>
-            <a:ext cx="1956816" cy="877824"/>
-          </a:xfrm>
-          <a:prstGeom prst="roundRect">
-            <a:avLst>
-              <a:gd name="adj" fmla="val 20833"/>
+              <a:gd name="adj" fmla="val 14925"/>
             </a:avLst>
           </a:prstGeom>
           <a:solidFill>
@@ -3998,83 +4020,84 @@
           </a:ln>
         </p:spPr>
       </p:sp>
-      <p:pic>
-        <p:nvPicPr>
-          <p:cNvPr id="23" name="Image 0" descr="nodejs">    </p:cNvPr>
-          <p:cNvPicPr>
-            <a:picLocks noChangeAspect="1"/>
-          </p:cNvPicPr>
-          <p:nvPr/>
-        </p:nvPicPr>
-        <p:blipFill>
-          <a:blip r:embed="rId1"/>
-          <a:stretch>
-            <a:fillRect/>
-          </a:stretch>
-        </p:blipFill>
-        <p:spPr>
-          <a:xfrm>
-            <a:off x="6766560" y="4762816"/>
-            <a:ext cx="1536192" cy="459615"/>
-          </a:xfrm>
-          <a:prstGeom prst="rect">
-            <a:avLst/>
-          </a:prstGeom>
-        </p:spPr>
-      </p:pic>
-      <p:sp>
-        <p:nvSpPr>
-          <p:cNvPr id="24" name="Text 20"/>
-          <p:cNvSpPr/>
-          <p:nvPr/>
-        </p:nvSpPr>
-        <p:spPr>
-          <a:xfrm>
-            <a:off x="9445752" y="1417320"/>
-            <a:ext cx="2066544" cy="256032"/>
-          </a:xfrm>
-          <a:prstGeom prst="rect">
-            <a:avLst/>
-          </a:prstGeom>
-          <a:noFill/>
-          <a:ln/>
-        </p:spPr>
-        <p:txBody>
-          <a:bodyPr wrap="square" lIns="0" tIns="0" rIns="0" bIns="0" rtlCol="0" anchor="ctr"/>
-          <a:lstStyle/>
-          <a:p>
-            <a:pPr algn="ctr" indent="0" marL="0">
-              <a:buNone/>
-            </a:pPr>
-            <a:r>
-              <a:rPr lang="en-US" sz="1600" dirty="0">
-                <a:solidFill>
-                  <a:srgbClr val="626B80"/>
-                </a:solidFill>
-                <a:latin typeface="Apple SD Gothic Neo" pitchFamily="34" charset="0"/>
-                <a:ea typeface="Apple SD Gothic Neo" pitchFamily="34" charset="-122"/>
-                <a:cs typeface="Apple SD Gothic Neo" pitchFamily="34" charset="-120"/>
-              </a:rPr>
-              <a:t>MacBook 내부</a:t>
-            </a:r>
-            <a:endParaRPr lang="en-US" sz="1600" dirty="0"/>
-          </a:p>
-        </p:txBody>
-      </p:sp>
-      <p:sp>
-        <p:nvSpPr>
-          <p:cNvPr id="25" name="Shape 21"/>
-          <p:cNvSpPr/>
-          <p:nvPr/>
-        </p:nvSpPr>
-        <p:spPr>
-          <a:xfrm>
-            <a:off x="9354312" y="1828800"/>
-            <a:ext cx="2249424" cy="1783080"/>
+      <p:sp>
+        <p:nvSpPr>
+          <p:cNvPr id="26" name="Shape 22"/>
+          <p:cNvSpPr/>
+          <p:nvPr/>
+        </p:nvSpPr>
+        <p:spPr>
+          <a:xfrm>
+            <a:off x="7342632" y="3794760"/>
+            <a:ext cx="0" cy="749808"/>
+          </a:xfrm>
+          <a:prstGeom prst="line">
+            <a:avLst/>
+          </a:prstGeom>
+          <a:noFill/>
+          <a:ln w="20320">
+            <a:solidFill>
+              <a:srgbClr val="405394"/>
+            </a:solidFill>
+            <a:prstDash val="solid"/>
+            <a:headEnd type="triangle"/>
+            <a:tailEnd type="triangle"/>
+          </a:ln>
+        </p:spPr>
+      </p:sp>
+      <p:sp>
+        <p:nvSpPr>
+          <p:cNvPr id="27" name="Text 23"/>
+          <p:cNvSpPr/>
+          <p:nvPr/>
+        </p:nvSpPr>
+        <p:spPr>
+          <a:xfrm>
+            <a:off x="7479792" y="4105656"/>
+            <a:ext cx="1207008" cy="201168"/>
+          </a:xfrm>
+          <a:prstGeom prst="rect">
+            <a:avLst/>
+          </a:prstGeom>
+          <a:noFill/>
+          <a:ln/>
+        </p:spPr>
+        <p:txBody>
+          <a:bodyPr wrap="square" lIns="0" tIns="0" rIns="0" bIns="0" rtlCol="0" anchor="ctr"/>
+          <a:lstStyle/>
+          <a:p>
+            <a:pPr indent="0" marL="0">
+              <a:buNone/>
+            </a:pPr>
+            <a:r>
+              <a:rPr lang="en-US" sz="1100" dirty="0">
+                <a:solidFill>
+                  <a:srgbClr val="405394"/>
+                </a:solidFill>
+                <a:latin typeface="Apple SD Gothic Neo" pitchFamily="34" charset="0"/>
+                <a:ea typeface="Apple SD Gothic Neo" pitchFamily="34" charset="-122"/>
+                <a:cs typeface="Apple SD Gothic Neo" pitchFamily="34" charset="-120"/>
+              </a:rPr>
+              <a:t>텍스트 · AI 결과</a:t>
+            </a:r>
+            <a:endParaRPr lang="en-US" sz="1100" dirty="0"/>
+          </a:p>
+        </p:txBody>
+      </p:sp>
+      <p:sp>
+        <p:nvSpPr>
+          <p:cNvPr id="28" name="Shape 24"/>
+          <p:cNvSpPr/>
+          <p:nvPr/>
+        </p:nvSpPr>
+        <p:spPr>
+          <a:xfrm>
+            <a:off x="6199632" y="4590288"/>
+            <a:ext cx="2276856" cy="1225296"/>
           </a:xfrm>
           <a:prstGeom prst="roundRect">
             <a:avLst>
-              <a:gd name="adj" fmla="val 10256"/>
+              <a:gd name="adj" fmla="val 14925"/>
             </a:avLst>
           </a:prstGeom>
           <a:solidFill>
@@ -4092,30 +4115,55 @@
       </p:sp>
       <p:sp>
         <p:nvSpPr>
-          <p:cNvPr id="26" name="Text 22"/>
-          <p:cNvSpPr/>
-          <p:nvPr/>
-        </p:nvSpPr>
-        <p:spPr>
-          <a:xfrm>
-            <a:off x="9546336" y="2039112"/>
-            <a:ext cx="1865376" cy="365760"/>
-          </a:xfrm>
-          <a:prstGeom prst="rect">
-            <a:avLst/>
-          </a:prstGeom>
-          <a:noFill/>
-          <a:ln/>
-        </p:spPr>
-        <p:txBody>
-          <a:bodyPr wrap="square" lIns="0" tIns="0" rIns="0" bIns="0" rtlCol="0" anchor="ctr"/>
-          <a:lstStyle/>
-          <a:p>
-            <a:pPr algn="ctr" indent="0" marL="0">
-              <a:buNone/>
-            </a:pPr>
-            <a:r>
-              <a:rPr lang="en-US" sz="2600" b="1" dirty="0">
+          <p:cNvPr id="29" name="Shape 25"/>
+          <p:cNvSpPr/>
+          <p:nvPr/>
+        </p:nvSpPr>
+        <p:spPr>
+          <a:xfrm>
+            <a:off x="10094976" y="3794760"/>
+            <a:ext cx="0" cy="749808"/>
+          </a:xfrm>
+          <a:prstGeom prst="line">
+            <a:avLst/>
+          </a:prstGeom>
+          <a:noFill/>
+          <a:ln w="20320">
+            <a:solidFill>
+              <a:srgbClr val="405394"/>
+            </a:solidFill>
+            <a:prstDash val="solid"/>
+            <a:headEnd type="triangle"/>
+            <a:tailEnd type="triangle"/>
+          </a:ln>
+        </p:spPr>
+      </p:sp>
+      <p:sp>
+        <p:nvSpPr>
+          <p:cNvPr id="30" name="Text 26"/>
+          <p:cNvSpPr/>
+          <p:nvPr/>
+        </p:nvSpPr>
+        <p:spPr>
+          <a:xfrm>
+            <a:off x="10232136" y="4105656"/>
+            <a:ext cx="1207008" cy="201168"/>
+          </a:xfrm>
+          <a:prstGeom prst="rect">
+            <a:avLst/>
+          </a:prstGeom>
+          <a:noFill/>
+          <a:ln/>
+        </p:spPr>
+        <p:txBody>
+          <a:bodyPr wrap="square" lIns="0" tIns="0" rIns="0" bIns="0" rtlCol="0" anchor="ctr"/>
+          <a:lstStyle/>
+          <a:p>
+            <a:pPr indent="0" marL="0">
+              <a:buNone/>
+            </a:pPr>
+            <a:r>
+              <a:rPr lang="en-US" sz="1100" dirty="0">
                 <a:solidFill>
                   <a:srgbClr val="405394"/>
                 </a:solidFill>
@@ -4123,99 +4171,26 @@
                 <a:ea typeface="Apple SD Gothic Neo" pitchFamily="34" charset="-122"/>
                 <a:cs typeface="Apple SD Gothic Neo" pitchFamily="34" charset="-120"/>
               </a:rPr>
-              <a:t>로컬 AI</a:t>
-            </a:r>
-            <a:endParaRPr lang="en-US" sz="2600" dirty="0"/>
-          </a:p>
-        </p:txBody>
-      </p:sp>
-      <p:sp>
-        <p:nvSpPr>
-          <p:cNvPr id="27" name="Text 23"/>
-          <p:cNvSpPr/>
-          <p:nvPr/>
-        </p:nvSpPr>
-        <p:spPr>
-          <a:xfrm>
-            <a:off x="9546336" y="2688336"/>
-            <a:ext cx="1865376" cy="713232"/>
-          </a:xfrm>
-          <a:prstGeom prst="rect">
-            <a:avLst/>
-          </a:prstGeom>
-          <a:noFill/>
-          <a:ln/>
-        </p:spPr>
-        <p:txBody>
-          <a:bodyPr wrap="square" lIns="0" tIns="0" rIns="0" bIns="0" rtlCol="0" anchor="ctr"/>
-          <a:lstStyle/>
-          <a:p>
-            <a:pPr algn="ctr" indent="0" marL="0">
-              <a:buNone/>
-            </a:pPr>
-            <a:r>
-              <a:rPr lang="en-US" sz="1800" dirty="0">
-                <a:solidFill>
-                  <a:srgbClr val="242938"/>
-                </a:solidFill>
-                <a:latin typeface="Apple SD Gothic Neo" pitchFamily="34" charset="0"/>
-                <a:ea typeface="Apple SD Gothic Neo" pitchFamily="34" charset="-122"/>
-                <a:cs typeface="Apple SD Gothic Neo" pitchFamily="34" charset="-120"/>
-              </a:rPr>
-              <a:t>Ollama API</a:t>
-            </a:r>
-            <a:endParaRPr lang="en-US" sz="1800" dirty="0"/>
-          </a:p>
-          <a:p>
-            <a:pPr algn="ctr" indent="0" marL="0">
-              <a:buNone/>
-            </a:pPr>
-            <a:r>
-              <a:rPr lang="en-US" sz="1800" dirty="0">
-                <a:solidFill>
-                  <a:srgbClr val="242938"/>
-                </a:solidFill>
-                <a:latin typeface="Apple SD Gothic Neo" pitchFamily="34" charset="0"/>
-                <a:ea typeface="Apple SD Gothic Neo" pitchFamily="34" charset="-122"/>
-                <a:cs typeface="Apple SD Gothic Neo" pitchFamily="34" charset="-120"/>
-              </a:rPr>
-              <a:t>NeMo-Speech.cpp</a:t>
-            </a:r>
-            <a:endParaRPr lang="en-US" sz="1800" dirty="0"/>
-          </a:p>
-          <a:p>
-            <a:pPr algn="ctr" indent="0" marL="0">
-              <a:buNone/>
-            </a:pPr>
-            <a:r>
-              <a:rPr lang="en-US" sz="1800" dirty="0">
-                <a:solidFill>
-                  <a:srgbClr val="242938"/>
-                </a:solidFill>
-                <a:latin typeface="Apple SD Gothic Neo" pitchFamily="34" charset="0"/>
-                <a:ea typeface="Apple SD Gothic Neo" pitchFamily="34" charset="-122"/>
-                <a:cs typeface="Apple SD Gothic Neo" pitchFamily="34" charset="-120"/>
-              </a:rPr>
-              <a:t>Python · MLX</a:t>
-            </a:r>
-            <a:endParaRPr lang="en-US" sz="1800" dirty="0"/>
-          </a:p>
-        </p:txBody>
-      </p:sp>
-      <p:sp>
-        <p:nvSpPr>
-          <p:cNvPr id="28" name="Shape 24"/>
-          <p:cNvSpPr/>
-          <p:nvPr/>
-        </p:nvSpPr>
-        <p:spPr>
-          <a:xfrm>
-            <a:off x="9354312" y="4069080"/>
-            <a:ext cx="2249424" cy="1783080"/>
+              <a:t>계정 · 기록</a:t>
+            </a:r>
+            <a:endParaRPr lang="en-US" sz="1100" dirty="0"/>
+          </a:p>
+        </p:txBody>
+      </p:sp>
+      <p:sp>
+        <p:nvSpPr>
+          <p:cNvPr id="31" name="Shape 27"/>
+          <p:cNvSpPr/>
+          <p:nvPr/>
+        </p:nvSpPr>
+        <p:spPr>
+          <a:xfrm>
+            <a:off x="8951976" y="4590288"/>
+            <a:ext cx="2276856" cy="1225296"/>
           </a:xfrm>
           <a:prstGeom prst="roundRect">
             <a:avLst>
-              <a:gd name="adj" fmla="val 10256"/>
+              <a:gd name="adj" fmla="val 14925"/>
             </a:avLst>
           </a:prstGeom>
           <a:solidFill>
@@ -4231,9 +4206,182 @@
           </a:ln>
         </p:spPr>
       </p:sp>
+      <p:sp>
+        <p:nvSpPr>
+          <p:cNvPr id="32" name="Text 28"/>
+          <p:cNvSpPr/>
+          <p:nvPr/>
+        </p:nvSpPr>
+        <p:spPr>
+          <a:xfrm>
+            <a:off x="3630168" y="4754880"/>
+            <a:ext cx="1911096" cy="292608"/>
+          </a:xfrm>
+          <a:prstGeom prst="rect">
+            <a:avLst/>
+          </a:prstGeom>
+          <a:noFill/>
+          <a:ln/>
+        </p:spPr>
+        <p:txBody>
+          <a:bodyPr wrap="square" lIns="0" tIns="0" rIns="0" bIns="0" rtlCol="0" anchor="ctr"/>
+          <a:lstStyle/>
+          <a:p>
+            <a:pPr algn="ctr" indent="0" marL="0">
+              <a:buNone/>
+            </a:pPr>
+            <a:r>
+              <a:rPr lang="en-US" sz="2300" b="1" dirty="0">
+                <a:solidFill>
+                  <a:srgbClr val="405394"/>
+                </a:solidFill>
+                <a:latin typeface="Apple SD Gothic Neo" pitchFamily="34" charset="0"/>
+                <a:ea typeface="Apple SD Gothic Neo" pitchFamily="34" charset="-122"/>
+                <a:cs typeface="Apple SD Gothic Neo" pitchFamily="34" charset="-120"/>
+              </a:rPr>
+              <a:t>음성 AI</a:t>
+            </a:r>
+            <a:endParaRPr lang="en-US" sz="2300" dirty="0"/>
+          </a:p>
+        </p:txBody>
+      </p:sp>
+      <p:sp>
+        <p:nvSpPr>
+          <p:cNvPr id="33" name="Text 29"/>
+          <p:cNvSpPr/>
+          <p:nvPr/>
+        </p:nvSpPr>
+        <p:spPr>
+          <a:xfrm>
+            <a:off x="3630168" y="5221224"/>
+            <a:ext cx="1911096" cy="411480"/>
+          </a:xfrm>
+          <a:prstGeom prst="rect">
+            <a:avLst/>
+          </a:prstGeom>
+          <a:noFill/>
+          <a:ln/>
+        </p:spPr>
+        <p:txBody>
+          <a:bodyPr wrap="square" lIns="0" tIns="0" rIns="0" bIns="0" rtlCol="0" anchor="ctr"/>
+          <a:lstStyle/>
+          <a:p>
+            <a:pPr algn="ctr" indent="0" marL="0">
+              <a:buNone/>
+            </a:pPr>
+            <a:r>
+              <a:rPr lang="en-US" sz="1600" dirty="0">
+                <a:solidFill>
+                  <a:srgbClr val="242938"/>
+                </a:solidFill>
+                <a:latin typeface="Apple SD Gothic Neo" pitchFamily="34" charset="0"/>
+                <a:ea typeface="Apple SD Gothic Neo" pitchFamily="34" charset="-122"/>
+                <a:cs typeface="Apple SD Gothic Neo" pitchFamily="34" charset="-120"/>
+              </a:rPr>
+              <a:t>NeMo-Speech.cpp</a:t>
+            </a:r>
+            <a:endParaRPr lang="en-US" sz="1600" dirty="0"/>
+          </a:p>
+          <a:p>
+            <a:pPr algn="ctr" indent="0" marL="0">
+              <a:buNone/>
+            </a:pPr>
+            <a:r>
+              <a:rPr lang="en-US" sz="1600" dirty="0">
+                <a:solidFill>
+                  <a:srgbClr val="242938"/>
+                </a:solidFill>
+                <a:latin typeface="Apple SD Gothic Neo" pitchFamily="34" charset="0"/>
+                <a:ea typeface="Apple SD Gothic Neo" pitchFamily="34" charset="-122"/>
+                <a:cs typeface="Apple SD Gothic Neo" pitchFamily="34" charset="-120"/>
+              </a:rPr>
+              <a:t>Python · MLX</a:t>
+            </a:r>
+            <a:endParaRPr lang="en-US" sz="1600" dirty="0"/>
+          </a:p>
+        </p:txBody>
+      </p:sp>
+      <p:sp>
+        <p:nvSpPr>
+          <p:cNvPr id="34" name="Text 30"/>
+          <p:cNvSpPr/>
+          <p:nvPr/>
+        </p:nvSpPr>
+        <p:spPr>
+          <a:xfrm>
+            <a:off x="6382512" y="4754880"/>
+            <a:ext cx="1911096" cy="292608"/>
+          </a:xfrm>
+          <a:prstGeom prst="rect">
+            <a:avLst/>
+          </a:prstGeom>
+          <a:noFill/>
+          <a:ln/>
+        </p:spPr>
+        <p:txBody>
+          <a:bodyPr wrap="square" lIns="0" tIns="0" rIns="0" bIns="0" rtlCol="0" anchor="ctr"/>
+          <a:lstStyle/>
+          <a:p>
+            <a:pPr algn="ctr" indent="0" marL="0">
+              <a:buNone/>
+            </a:pPr>
+            <a:r>
+              <a:rPr lang="en-US" sz="2300" b="1" dirty="0">
+                <a:solidFill>
+                  <a:srgbClr val="405394"/>
+                </a:solidFill>
+                <a:latin typeface="Apple SD Gothic Neo" pitchFamily="34" charset="0"/>
+                <a:ea typeface="Apple SD Gothic Neo" pitchFamily="34" charset="-122"/>
+                <a:cs typeface="Apple SD Gothic Neo" pitchFamily="34" charset="-120"/>
+              </a:rPr>
+              <a:t>텍스트 AI</a:t>
+            </a:r>
+            <a:endParaRPr lang="en-US" sz="2300" dirty="0"/>
+          </a:p>
+        </p:txBody>
+      </p:sp>
+      <p:sp>
+        <p:nvSpPr>
+          <p:cNvPr id="35" name="Text 31"/>
+          <p:cNvSpPr/>
+          <p:nvPr/>
+        </p:nvSpPr>
+        <p:spPr>
+          <a:xfrm>
+            <a:off x="6382512" y="5312664"/>
+            <a:ext cx="1911096" cy="292608"/>
+          </a:xfrm>
+          <a:prstGeom prst="rect">
+            <a:avLst/>
+          </a:prstGeom>
+          <a:noFill/>
+          <a:ln/>
+        </p:spPr>
+        <p:txBody>
+          <a:bodyPr wrap="square" lIns="0" tIns="0" rIns="0" bIns="0" rtlCol="0" anchor="ctr"/>
+          <a:lstStyle/>
+          <a:p>
+            <a:pPr algn="ctr" indent="0" marL="0">
+              <a:buNone/>
+            </a:pPr>
+            <a:r>
+              <a:rPr lang="en-US" sz="2300" dirty="0">
+                <a:solidFill>
+                  <a:srgbClr val="242938"/>
+                </a:solidFill>
+                <a:latin typeface="Apple SD Gothic Neo" pitchFamily="34" charset="0"/>
+                <a:ea typeface="Apple SD Gothic Neo" pitchFamily="34" charset="-122"/>
+                <a:cs typeface="Apple SD Gothic Neo" pitchFamily="34" charset="-120"/>
+              </a:rPr>
+              <a:t>Ollama API</a:t>
+            </a:r>
+            <a:endParaRPr lang="en-US" sz="2300" dirty="0"/>
+          </a:p>
+        </p:txBody>
+      </p:sp>
       <p:pic>
         <p:nvPicPr>
-          <p:cNvPr id="29" name="Image 1" descr="postgresql">    </p:cNvPr>
+          <p:cNvPr id="36" name="Image 1" descr="postgresql">    </p:cNvPr>
           <p:cNvPicPr>
             <a:picLocks noChangeAspect="1"/>
           </p:cNvPicPr>
@@ -4247,8 +4395,8 @@
         </p:blipFill>
         <p:spPr>
           <a:xfrm>
-            <a:off x="9991453" y="4334256"/>
-            <a:ext cx="975141" cy="1005840"/>
+            <a:off x="9771267" y="4718304"/>
+            <a:ext cx="638274" cy="658368"/>
           </a:xfrm>
           <a:prstGeom prst="rect">
             <a:avLst/>
@@ -4257,14 +4405,14 @@
       </p:pic>
       <p:sp>
         <p:nvSpPr>
-          <p:cNvPr id="30" name="Text 25"/>
-          <p:cNvSpPr/>
-          <p:nvPr/>
-        </p:nvSpPr>
-        <p:spPr>
-          <a:xfrm>
-            <a:off x="9546336" y="5422392"/>
-            <a:ext cx="1865376" cy="320040"/>
+          <p:cNvPr id="37" name="Text 32"/>
+          <p:cNvSpPr/>
+          <p:nvPr/>
+        </p:nvSpPr>
+        <p:spPr>
+          <a:xfrm>
+            <a:off x="9134856" y="5468112"/>
+            <a:ext cx="1911096" cy="274320"/>
           </a:xfrm>
           <a:prstGeom prst="rect">
             <a:avLst/>
@@ -4280,7 +4428,7 @@
               <a:buNone/>
             </a:pPr>
             <a:r>
-              <a:rPr lang="en-US" sz="2300" b="1" dirty="0">
+              <a:rPr lang="en-US" sz="2100" b="1" dirty="0">
                 <a:solidFill>
                   <a:srgbClr val="405394"/>
                 </a:solidFill>
@@ -4290,159 +4438,9 @@
               </a:rPr>
               <a:t>PostgreSQL</a:t>
             </a:r>
-            <a:endParaRPr lang="en-US" sz="2300" dirty="0"/>
-          </a:p>
-        </p:txBody>
-      </p:sp>
-      <p:sp>
-        <p:nvSpPr>
-          <p:cNvPr id="31" name="Shape 26"/>
-          <p:cNvSpPr/>
-          <p:nvPr/>
-        </p:nvSpPr>
-        <p:spPr>
-          <a:xfrm>
-            <a:off x="2862072" y="2724912"/>
-            <a:ext cx="429768" cy="0"/>
-          </a:xfrm>
-          <a:prstGeom prst="line">
-            <a:avLst/>
-          </a:prstGeom>
-          <a:noFill/>
-          <a:ln w="20320">
-            <a:solidFill>
-              <a:srgbClr val="405394"/>
-            </a:solidFill>
-            <a:prstDash val="solid"/>
-            <a:headEnd type="triangle"/>
-            <a:tailEnd type="triangle"/>
-          </a:ln>
-        </p:spPr>
-      </p:sp>
-      <p:sp>
-        <p:nvSpPr>
-          <p:cNvPr id="32" name="Shape 27"/>
-          <p:cNvSpPr/>
-          <p:nvPr/>
-        </p:nvSpPr>
-        <p:spPr>
-          <a:xfrm>
-            <a:off x="5724144" y="2724912"/>
-            <a:ext cx="566928" cy="0"/>
-          </a:xfrm>
-          <a:prstGeom prst="line">
-            <a:avLst/>
-          </a:prstGeom>
-          <a:noFill/>
-          <a:ln w="20320">
-            <a:solidFill>
-              <a:srgbClr val="405394"/>
-            </a:solidFill>
-            <a:prstDash val="solid"/>
-            <a:headEnd type="triangle"/>
-            <a:tailEnd type="triangle"/>
-          </a:ln>
-        </p:spPr>
-      </p:sp>
-      <p:sp>
-        <p:nvSpPr>
-          <p:cNvPr id="33" name="Shape 28"/>
-          <p:cNvSpPr/>
-          <p:nvPr/>
-        </p:nvSpPr>
-        <p:spPr>
-          <a:xfrm>
-            <a:off x="8778240" y="2724912"/>
-            <a:ext cx="548640" cy="0"/>
-          </a:xfrm>
-          <a:prstGeom prst="line">
-            <a:avLst/>
-          </a:prstGeom>
-          <a:noFill/>
-          <a:ln w="20320">
-            <a:solidFill>
-              <a:srgbClr val="405394"/>
-            </a:solidFill>
-            <a:prstDash val="solid"/>
-            <a:headEnd type="triangle"/>
-            <a:tailEnd type="triangle"/>
-          </a:ln>
-        </p:spPr>
-      </p:sp>
-      <p:sp>
-        <p:nvSpPr>
-          <p:cNvPr id="34" name="Shape 29"/>
-          <p:cNvSpPr/>
-          <p:nvPr/>
-        </p:nvSpPr>
-        <p:spPr>
-          <a:xfrm>
-            <a:off x="2862072" y="4965192"/>
-            <a:ext cx="429768" cy="0"/>
-          </a:xfrm>
-          <a:prstGeom prst="line">
-            <a:avLst/>
-          </a:prstGeom>
-          <a:noFill/>
-          <a:ln w="20320">
-            <a:solidFill>
-              <a:srgbClr val="405394"/>
-            </a:solidFill>
-            <a:prstDash val="solid"/>
-            <a:headEnd type="triangle"/>
-            <a:tailEnd type="triangle"/>
-          </a:ln>
-        </p:spPr>
-      </p:sp>
-      <p:sp>
-        <p:nvSpPr>
-          <p:cNvPr id="35" name="Shape 30"/>
-          <p:cNvSpPr/>
-          <p:nvPr/>
-        </p:nvSpPr>
-        <p:spPr>
-          <a:xfrm>
-            <a:off x="5724144" y="4965192"/>
-            <a:ext cx="566928" cy="0"/>
-          </a:xfrm>
-          <a:prstGeom prst="line">
-            <a:avLst/>
-          </a:prstGeom>
-          <a:noFill/>
-          <a:ln w="20320">
-            <a:solidFill>
-              <a:srgbClr val="405394"/>
-            </a:solidFill>
-            <a:prstDash val="solid"/>
-            <a:headEnd type="triangle"/>
-            <a:tailEnd type="triangle"/>
-          </a:ln>
-        </p:spPr>
-      </p:sp>
-      <p:sp>
-        <p:nvSpPr>
-          <p:cNvPr id="36" name="Shape 31"/>
-          <p:cNvSpPr/>
-          <p:nvPr/>
-        </p:nvSpPr>
-        <p:spPr>
-          <a:xfrm>
-            <a:off x="8778240" y="4965192"/>
-            <a:ext cx="548640" cy="0"/>
-          </a:xfrm>
-          <a:prstGeom prst="line">
-            <a:avLst/>
-          </a:prstGeom>
-          <a:noFill/>
-          <a:ln w="20320">
-            <a:solidFill>
-              <a:srgbClr val="405394"/>
-            </a:solidFill>
-            <a:prstDash val="solid"/>
-            <a:headEnd type="triangle"/>
-            <a:tailEnd type="triangle"/>
-          </a:ln>
-        </p:spPr>
+            <a:endParaRPr lang="en-US" sz="2100" dirty="0"/>
+          </a:p>
+        </p:txBody>
       </p:sp>
     </p:spTree>
   </p:cSld>

</xml_diff>

<commit_message>
feat: show live voice previews and measured recording durations
</commit_message>
<xml_diff>
--- a/presentation/SpeechBridge.pptx
+++ b/presentation/SpeechBridge.pptx
@@ -596,7 +596,7 @@
           <a:p>
             <a:r>
               <a:rPr lang="en-US" dirty="0"/>
-              <a:t>언어를 선택하고 마이크로 녹음한 뒤 번역합니다. 한국어·영어·일본어를 지원합니다. 새 번역은 자동으로 읽어줍니다. 자동 읽기는 설정에서 끌 수 있습니다. 오른쪽 화면은 직접 입력한 문장의 번역 결과입니다.</a:t>
+              <a:t>녹음 중 인식 원문과 번역을 확인합니다. 입력 언어는 자동으로 감지하고 번역 대상은 바꿀 수 있습니다. 한국어·영어·일본어를 지원합니다. 새 번역은 자동으로 읽어줍니다. 자동 읽기는 설정에서 끌 수 있습니다. 오른쪽 화면은 합성 음성을 인식하고 번역한 결과입니다.</a:t>
             </a:r>
             <a:endParaRPr lang="en-US" dirty="0"/>
           </a:p>
@@ -684,7 +684,7 @@
           <a:p>
             <a:r>
               <a:rPr lang="en-US" dirty="0"/>
-              <a:t>대화는 자동으로 저장됩니다. 대화가 끝나면 AI가 제목을 붙이고 분류와 요약을 정리합니다. 이후에는 사용자가 직접 수정합니다. 일상·업무·업무 폴더로 기록을 찾을 수 있습니다.</a:t>
+              <a:t>대화는 자동으로 저장됩니다. 대화가 끝나면 AI가 제목을 붙이고 분류와 요약을 정리합니다. 이후에는 사용자가 직접 수정합니다. 일상·업무·업무 폴더로 기록을 찾고 녹음 길이를 확인할 수 있습니다.</a:t>
             </a:r>
             <a:endParaRPr lang="en-US" dirty="0"/>
           </a:p>
@@ -1888,7 +1888,7 @@
                 <a:ea typeface="Apple SD Gothic Neo" pitchFamily="34" charset="-122"/>
                 <a:cs typeface="Apple SD Gothic Neo" pitchFamily="34" charset="-120"/>
               </a:rPr>
-              <a:t>음성 중심 입력</a:t>
+              <a:t>음성 인식·번역 미리보기</a:t>
             </a:r>
             <a:endParaRPr lang="en-US" sz="2400" dirty="0"/>
           </a:p>

</xml_diff>